<commit_message>
All India report and deck: All India only
The overall report and deck no longer carry Bihar and Hyderabad parts; those
have their own reports and decks.

Co-Authored-By: Claude Opus 5.5 <noreply@anthropic.com>
Claude-Session: https://claude.ai/code/session_01FWx24PCx3Jw4SUDQC6oU7o
</commit_message>
<xml_diff>
--- a/reports/sir-india-deck.pptx
+++ b/reports/sir-india-deck.pptx
@@ -19,11 +19,9 @@
     <p:sldId id="267" r:id="rId13"/>
     <p:sldId id="268" r:id="rId14"/>
     <p:sldId id="269" r:id="rId15"/>
-    <p:sldId id="270" r:id="rId16"/>
-    <p:sldId id="271" r:id="rId17"/>
   </p:sldIdLst>
   <p:notesMasterIdLst>
-    <p:notesMasterId r:id="rId18"/>
+    <p:notesMasterId r:id="rId16"/>
   </p:notesMasterIdLst>
   <p:sldSz cx="12192000" cy="6858000"/>
   <p:notesSz cx="6858000" cy="12192000"/>
@@ -3518,182 +3516,6 @@
 </p:notes>
 </file>
 
-<file path=ppt/notesSlides/notesSlide15.xml><?xml version="1.0" encoding="utf-8"?>
-<p:notes xmlns:a="http://schemas.openxmlformats.org/drawingml/2006/main" xmlns:r="http://schemas.openxmlformats.org/officeDocument/2006/relationships" xmlns:p="http://schemas.openxmlformats.org/presentationml/2006/main">
-  <p:cSld>
-    <p:spTree>
-      <p:nvGrpSpPr>
-        <p:cNvPr id="1" name=""/>
-        <p:cNvGrpSpPr/>
-        <p:nvPr/>
-      </p:nvGrpSpPr>
-      <p:grpSpPr>
-        <a:xfrm>
-          <a:off x="0" y="0"/>
-          <a:ext cx="0" cy="0"/>
-          <a:chOff x="0" y="0"/>
-          <a:chExt cx="0" cy="0"/>
-        </a:xfrm>
-      </p:grpSpPr>
-      <p:sp>
-        <p:nvSpPr>
-          <p:cNvPr id="2" name="Slide Image Placeholder 1"/>
-          <p:cNvSpPr>
-            <a:spLocks noGrp="1" noRot="1" noChangeAspect="1"/>
-          </p:cNvSpPr>
-          <p:nvPr>
-            <p:ph type="sldImg"/>
-          </p:nvPr>
-        </p:nvSpPr>
-        <p:spPr/>
-      </p:sp>
-      <p:sp>
-        <p:nvSpPr>
-          <p:cNvPr id="3" name="Notes Placeholder 2"/>
-          <p:cNvSpPr>
-            <a:spLocks noGrp="1"/>
-          </p:cNvSpPr>
-          <p:nvPr>
-            <p:ph type="body" idx="1"/>
-          </p:nvPr>
-        </p:nvSpPr>
-        <p:spPr/>
-        <p:txBody>
-          <a:bodyPr/>
-          <a:lstStyle/>
-          <a:p>
-            <a:r>
-              <a:rPr lang="en-US" dirty="0"/>
-              <a:t/>
-            </a:r>
-            <a:endParaRPr lang="en-US" dirty="0"/>
-          </a:p>
-        </p:txBody>
-      </p:sp>
-      <p:sp>
-        <p:nvSpPr>
-          <p:cNvPr id="4" name="Slide Number Placeholder 3"/>
-          <p:cNvSpPr>
-            <a:spLocks noGrp="1"/>
-          </p:cNvSpPr>
-          <p:nvPr>
-            <p:ph type="sldNum" sz="quarter" idx="10"/>
-          </p:nvPr>
-        </p:nvSpPr>
-        <p:spPr/>
-        <p:txBody>
-          <a:bodyPr/>
-          <a:lstStyle/>
-          <a:p>
-            <a:fld id="{F7021451-1387-4CA6-816F-3879F97B5CBC}" type="slidenum">
-              <a:rPr lang="en-US"/>
-              <a:t>15</a:t>
-            </a:fld>
-            <a:endParaRPr lang="en-US"/>
-          </a:p>
-        </p:txBody>
-      </p:sp>
-    </p:spTree>
-    <p:extLst>
-      <p:ext uri="{BB962C8B-B14F-4D97-AF65-F5344CB8AC3E}">
-        <p14:creationId xmlns:p14="http://schemas.microsoft.com/office/powerpoint/2010/main" val="1024086991"/>
-      </p:ext>
-    </p:extLst>
-  </p:cSld>
-  <p:clrMapOvr>
-    <a:masterClrMapping/>
-  </p:clrMapOvr>
-</p:notes>
-</file>
-
-<file path=ppt/notesSlides/notesSlide16.xml><?xml version="1.0" encoding="utf-8"?>
-<p:notes xmlns:a="http://schemas.openxmlformats.org/drawingml/2006/main" xmlns:r="http://schemas.openxmlformats.org/officeDocument/2006/relationships" xmlns:p="http://schemas.openxmlformats.org/presentationml/2006/main">
-  <p:cSld>
-    <p:spTree>
-      <p:nvGrpSpPr>
-        <p:cNvPr id="1" name=""/>
-        <p:cNvGrpSpPr/>
-        <p:nvPr/>
-      </p:nvGrpSpPr>
-      <p:grpSpPr>
-        <a:xfrm>
-          <a:off x="0" y="0"/>
-          <a:ext cx="0" cy="0"/>
-          <a:chOff x="0" y="0"/>
-          <a:chExt cx="0" cy="0"/>
-        </a:xfrm>
-      </p:grpSpPr>
-      <p:sp>
-        <p:nvSpPr>
-          <p:cNvPr id="2" name="Slide Image Placeholder 1"/>
-          <p:cNvSpPr>
-            <a:spLocks noGrp="1" noRot="1" noChangeAspect="1"/>
-          </p:cNvSpPr>
-          <p:nvPr>
-            <p:ph type="sldImg"/>
-          </p:nvPr>
-        </p:nvSpPr>
-        <p:spPr/>
-      </p:sp>
-      <p:sp>
-        <p:nvSpPr>
-          <p:cNvPr id="3" name="Notes Placeholder 2"/>
-          <p:cNvSpPr>
-            <a:spLocks noGrp="1"/>
-          </p:cNvSpPr>
-          <p:nvPr>
-            <p:ph type="body" idx="1"/>
-          </p:nvPr>
-        </p:nvSpPr>
-        <p:spPr/>
-        <p:txBody>
-          <a:bodyPr/>
-          <a:lstStyle/>
-          <a:p>
-            <a:r>
-              <a:rPr lang="en-US" dirty="0"/>
-              <a:t/>
-            </a:r>
-            <a:endParaRPr lang="en-US" dirty="0"/>
-          </a:p>
-        </p:txBody>
-      </p:sp>
-      <p:sp>
-        <p:nvSpPr>
-          <p:cNvPr id="4" name="Slide Number Placeholder 3"/>
-          <p:cNvSpPr>
-            <a:spLocks noGrp="1"/>
-          </p:cNvSpPr>
-          <p:nvPr>
-            <p:ph type="sldNum" sz="quarter" idx="10"/>
-          </p:nvPr>
-        </p:nvSpPr>
-        <p:spPr/>
-        <p:txBody>
-          <a:bodyPr/>
-          <a:lstStyle/>
-          <a:p>
-            <a:fld id="{F7021451-1387-4CA6-816F-3879F97B5CBC}" type="slidenum">
-              <a:rPr lang="en-US"/>
-              <a:t>16</a:t>
-            </a:fld>
-            <a:endParaRPr lang="en-US"/>
-          </a:p>
-        </p:txBody>
-      </p:sp>
-    </p:spTree>
-    <p:extLst>
-      <p:ext uri="{BB962C8B-B14F-4D97-AF65-F5344CB8AC3E}">
-        <p14:creationId xmlns:p14="http://schemas.microsoft.com/office/powerpoint/2010/main" val="1024086991"/>
-      </p:ext>
-    </p:extLst>
-  </p:cSld>
-  <p:clrMapOvr>
-    <a:masterClrMapping/>
-  </p:clrMapOvr>
-</p:notes>
-</file>
-
 <file path=ppt/notesSlides/notesSlide2.xml><?xml version="1.0" encoding="utf-8"?>
 <p:notes xmlns:a="http://schemas.openxmlformats.org/drawingml/2006/main" xmlns:r="http://schemas.openxmlformats.org/officeDocument/2006/relationships" xmlns:p="http://schemas.openxmlformats.org/presentationml/2006/main">
   <p:cSld>
@@ -4842,7 +4664,7 @@
                 <a:ea typeface="Calibri" pitchFamily="34" charset="-122"/>
                 <a:cs typeface="Calibri" pitchFamily="34" charset="-120"/>
               </a:rPr>
-              <a:t>The reason recorded for every removal, state by state, with the list-level findings for Bihar and Hyderabad Old City</a:t>
+              <a:t>The reason recorded for every removal, state by state: women among the removed, and what goes with the removal rate</a:t>
             </a:r>
             <a:endParaRPr lang="en-US" sz="1700" dirty="0"/>
           </a:p>
@@ -12278,3098 +12100,6 @@
                 <a:ea typeface="Calibri" pitchFamily="34" charset="-122"/>
                 <a:cs typeface="Calibri" pitchFamily="34" charset="-120"/>
               </a:rPr>
-              <a:t>BIHAR, FROM THE LISTS</a:t>
-            </a:r>
-            <a:endParaRPr lang="en-US" sz="1100" dirty="0"/>
-          </a:p>
-        </p:txBody>
-      </p:sp>
-      <p:sp>
-        <p:nvSpPr>
-          <p:cNvPr id="3" name="Text 1"/>
-          <p:cNvSpPr txBox="1"/>
-          <p:nvPr/>
-        </p:nvSpPr>
-        <p:spPr>
-          <a:xfrm>
-            <a:off x="548640" y="530352"/>
-            <a:ext cx="11094415" cy="914400"/>
-          </a:xfrm>
-          <a:prstGeom prst="rect">
-            <a:avLst/>
-          </a:prstGeom>
-          <a:noFill/>
-          <a:ln/>
-        </p:spPr>
-        <p:txBody>
-          <a:bodyPr wrap="square" lIns="0" tIns="0" rIns="0" bIns="0" rtlCol="0" anchor="t">
-            <a:normAutofit/>
-          </a:bodyPr>
-          <a:lstStyle/>
-          <a:p>
-            <a:pPr indent="0" marL="0">
-              <a:buNone/>
-            </a:pPr>
-            <a:r>
-              <a:rPr lang="en-US" sz="2700" b="1" dirty="0">
-                <a:solidFill>
-                  <a:srgbClr val="1F4E79"/>
-                </a:solidFill>
-                <a:latin typeface="Cambria" pitchFamily="34" charset="0"/>
-                <a:ea typeface="Cambria" pitchFamily="34" charset="-122"/>
-                <a:cs typeface="Cambria" pitchFamily="34" charset="-120"/>
-              </a:rPr>
-              <a:t>In Bihar, more names were removed than the 2025 winning margin in 174 of 243 seats</a:t>
-            </a:r>
-            <a:endParaRPr lang="en-US" sz="2700" dirty="0"/>
-          </a:p>
-        </p:txBody>
-      </p:sp>
-      <p:sp>
-        <p:nvSpPr>
-          <p:cNvPr id="4" name="Text 2"/>
-          <p:cNvSpPr txBox="1"/>
-          <p:nvPr/>
-        </p:nvSpPr>
-        <p:spPr>
-          <a:xfrm>
-            <a:off x="548640" y="1463040"/>
-            <a:ext cx="11094415" cy="365760"/>
-          </a:xfrm>
-          <a:prstGeom prst="rect">
-            <a:avLst/>
-          </a:prstGeom>
-          <a:noFill/>
-          <a:ln/>
-        </p:spPr>
-        <p:txBody>
-          <a:bodyPr wrap="square" lIns="0" tIns="0" rIns="0" bIns="0" rtlCol="0" anchor="t"/>
-          <a:lstStyle/>
-          <a:p>
-            <a:pPr indent="0" marL="0">
-              <a:buNone/>
-            </a:pPr>
-            <a:r>
-              <a:rPr lang="en-US" sz="1400" dirty="0">
-                <a:solidFill>
-                  <a:srgbClr val="4D5B69"/>
-                </a:solidFill>
-                <a:latin typeface="Calibri" pitchFamily="34" charset="0"/>
-                <a:ea typeface="Calibri" pitchFamily="34" charset="-122"/>
-                <a:cs typeface="Calibri" pitchFamily="34" charset="-120"/>
-              </a:rPr>
-              <a:t>The one state where the deletion lists could be counted name by name</a:t>
-            </a:r>
-            <a:endParaRPr lang="en-US" sz="1400" dirty="0"/>
-          </a:p>
-        </p:txBody>
-      </p:sp>
-      <p:sp>
-        <p:nvSpPr>
-          <p:cNvPr id="5" name="Text 3"/>
-          <p:cNvSpPr txBox="1"/>
-          <p:nvPr/>
-        </p:nvSpPr>
-        <p:spPr>
-          <a:xfrm>
-            <a:off x="548640" y="6400800"/>
-            <a:ext cx="10180015" cy="274320"/>
-          </a:xfrm>
-          <a:prstGeom prst="rect">
-            <a:avLst/>
-          </a:prstGeom>
-          <a:noFill/>
-          <a:ln/>
-        </p:spPr>
-        <p:txBody>
-          <a:bodyPr wrap="square" lIns="0" tIns="0" rIns="0" bIns="0" rtlCol="0" anchor="ctr"/>
-          <a:lstStyle/>
-          <a:p>
-            <a:pPr indent="0" marL="0">
-              <a:buNone/>
-            </a:pPr>
-            <a:r>
-              <a:rPr lang="en-US" sz="900" dirty="0">
-                <a:solidFill>
-                  <a:srgbClr val="4D5B69"/>
-                </a:solidFill>
-                <a:latin typeface="Calibri" pitchFamily="34" charset="0"/>
-                <a:ea typeface="Calibri" pitchFamily="34" charset="-122"/>
-                <a:cs typeface="Calibri" pitchFamily="34" charset="-120"/>
-              </a:rPr>
-              <a:t>SIR 2025-26 · All India · Varna Sri Raman · aggregates only; no names or EPIC numbers</a:t>
-            </a:r>
-            <a:endParaRPr lang="en-US" sz="900" dirty="0"/>
-          </a:p>
-        </p:txBody>
-      </p:sp>
-      <p:sp>
-        <p:nvSpPr>
-          <p:cNvPr id="6" name="Text 4"/>
-          <p:cNvSpPr txBox="1"/>
-          <p:nvPr/>
-        </p:nvSpPr>
-        <p:spPr>
-          <a:xfrm>
-            <a:off x="10911535" y="6400800"/>
-            <a:ext cx="731520" cy="274320"/>
-          </a:xfrm>
-          <a:prstGeom prst="rect">
-            <a:avLst/>
-          </a:prstGeom>
-          <a:noFill/>
-          <a:ln/>
-        </p:spPr>
-        <p:txBody>
-          <a:bodyPr wrap="square" lIns="0" tIns="0" rIns="0" bIns="0" rtlCol="0" anchor="ctr"/>
-          <a:lstStyle/>
-          <a:p>
-            <a:pPr algn="r" indent="0" marL="0">
-              <a:buNone/>
-            </a:pPr>
-            <a:r>
-              <a:rPr lang="en-US" sz="900" dirty="0">
-                <a:solidFill>
-                  <a:srgbClr val="4D5B69"/>
-                </a:solidFill>
-                <a:latin typeface="Calibri" pitchFamily="34" charset="0"/>
-                <a:ea typeface="Calibri" pitchFamily="34" charset="-122"/>
-                <a:cs typeface="Calibri" pitchFamily="34" charset="-120"/>
-              </a:rPr>
-              <a:t>12</a:t>
-            </a:r>
-            <a:endParaRPr lang="en-US" sz="900" dirty="0"/>
-          </a:p>
-        </p:txBody>
-      </p:sp>
-      <p:sp>
-        <p:nvSpPr>
-          <p:cNvPr id="7" name="Shape 5"/>
-          <p:cNvSpPr/>
-          <p:nvPr/>
-        </p:nvSpPr>
-        <p:spPr>
-          <a:xfrm>
-            <a:off x="0" y="6748272"/>
-            <a:ext cx="304792" cy="109728"/>
-          </a:xfrm>
-          <a:prstGeom prst="rect">
-            <a:avLst/>
-          </a:prstGeom>
-          <a:solidFill>
-            <a:srgbClr val="C0392B"/>
-          </a:solidFill>
-          <a:ln/>
-        </p:spPr>
-      </p:sp>
-      <p:sp>
-        <p:nvSpPr>
-          <p:cNvPr id="8" name="Shape 6"/>
-          <p:cNvSpPr/>
-          <p:nvPr/>
-        </p:nvSpPr>
-        <p:spPr>
-          <a:xfrm>
-            <a:off x="304792" y="6748272"/>
-            <a:ext cx="304792" cy="109728"/>
-          </a:xfrm>
-          <a:prstGeom prst="rect">
-            <a:avLst/>
-          </a:prstGeom>
-          <a:solidFill>
-            <a:srgbClr val="E67E22"/>
-          </a:solidFill>
-          <a:ln/>
-        </p:spPr>
-      </p:sp>
-      <p:sp>
-        <p:nvSpPr>
-          <p:cNvPr id="9" name="Shape 7"/>
-          <p:cNvSpPr/>
-          <p:nvPr/>
-        </p:nvSpPr>
-        <p:spPr>
-          <a:xfrm>
-            <a:off x="609585" y="6748272"/>
-            <a:ext cx="304792" cy="109728"/>
-          </a:xfrm>
-          <a:prstGeom prst="rect">
-            <a:avLst/>
-          </a:prstGeom>
-          <a:solidFill>
-            <a:srgbClr val="27AE60"/>
-          </a:solidFill>
-          <a:ln/>
-        </p:spPr>
-      </p:sp>
-      <p:sp>
-        <p:nvSpPr>
-          <p:cNvPr id="10" name="Shape 8"/>
-          <p:cNvSpPr/>
-          <p:nvPr/>
-        </p:nvSpPr>
-        <p:spPr>
-          <a:xfrm>
-            <a:off x="914377" y="6748272"/>
-            <a:ext cx="304792" cy="109728"/>
-          </a:xfrm>
-          <a:prstGeom prst="rect">
-            <a:avLst/>
-          </a:prstGeom>
-          <a:solidFill>
-            <a:srgbClr val="1F618D"/>
-          </a:solidFill>
-          <a:ln/>
-        </p:spPr>
-      </p:sp>
-      <p:sp>
-        <p:nvSpPr>
-          <p:cNvPr id="11" name="Shape 9"/>
-          <p:cNvSpPr/>
-          <p:nvPr/>
-        </p:nvSpPr>
-        <p:spPr>
-          <a:xfrm>
-            <a:off x="1219170" y="6748272"/>
-            <a:ext cx="304792" cy="109728"/>
-          </a:xfrm>
-          <a:prstGeom prst="rect">
-            <a:avLst/>
-          </a:prstGeom>
-          <a:solidFill>
-            <a:srgbClr val="8E44AD"/>
-          </a:solidFill>
-          <a:ln/>
-        </p:spPr>
-      </p:sp>
-      <p:sp>
-        <p:nvSpPr>
-          <p:cNvPr id="12" name="Shape 10"/>
-          <p:cNvSpPr/>
-          <p:nvPr/>
-        </p:nvSpPr>
-        <p:spPr>
-          <a:xfrm>
-            <a:off x="1523962" y="6748272"/>
-            <a:ext cx="304792" cy="109728"/>
-          </a:xfrm>
-          <a:prstGeom prst="rect">
-            <a:avLst/>
-          </a:prstGeom>
-          <a:solidFill>
-            <a:srgbClr val="C0392B"/>
-          </a:solidFill>
-          <a:ln/>
-        </p:spPr>
-      </p:sp>
-      <p:sp>
-        <p:nvSpPr>
-          <p:cNvPr id="13" name="Shape 11"/>
-          <p:cNvSpPr/>
-          <p:nvPr/>
-        </p:nvSpPr>
-        <p:spPr>
-          <a:xfrm>
-            <a:off x="1828754" y="6748272"/>
-            <a:ext cx="304792" cy="109728"/>
-          </a:xfrm>
-          <a:prstGeom prst="rect">
-            <a:avLst/>
-          </a:prstGeom>
-          <a:solidFill>
-            <a:srgbClr val="E67E22"/>
-          </a:solidFill>
-          <a:ln/>
-        </p:spPr>
-      </p:sp>
-      <p:sp>
-        <p:nvSpPr>
-          <p:cNvPr id="14" name="Shape 12"/>
-          <p:cNvSpPr/>
-          <p:nvPr/>
-        </p:nvSpPr>
-        <p:spPr>
-          <a:xfrm>
-            <a:off x="2133547" y="6748272"/>
-            <a:ext cx="304792" cy="109728"/>
-          </a:xfrm>
-          <a:prstGeom prst="rect">
-            <a:avLst/>
-          </a:prstGeom>
-          <a:solidFill>
-            <a:srgbClr val="27AE60"/>
-          </a:solidFill>
-          <a:ln/>
-        </p:spPr>
-      </p:sp>
-      <p:sp>
-        <p:nvSpPr>
-          <p:cNvPr id="15" name="Shape 13"/>
-          <p:cNvSpPr/>
-          <p:nvPr/>
-        </p:nvSpPr>
-        <p:spPr>
-          <a:xfrm>
-            <a:off x="2438339" y="6748272"/>
-            <a:ext cx="304792" cy="109728"/>
-          </a:xfrm>
-          <a:prstGeom prst="rect">
-            <a:avLst/>
-          </a:prstGeom>
-          <a:solidFill>
-            <a:srgbClr val="1F618D"/>
-          </a:solidFill>
-          <a:ln/>
-        </p:spPr>
-      </p:sp>
-      <p:sp>
-        <p:nvSpPr>
-          <p:cNvPr id="16" name="Shape 14"/>
-          <p:cNvSpPr/>
-          <p:nvPr/>
-        </p:nvSpPr>
-        <p:spPr>
-          <a:xfrm>
-            <a:off x="2743131" y="6748272"/>
-            <a:ext cx="304792" cy="109728"/>
-          </a:xfrm>
-          <a:prstGeom prst="rect">
-            <a:avLst/>
-          </a:prstGeom>
-          <a:solidFill>
-            <a:srgbClr val="8E44AD"/>
-          </a:solidFill>
-          <a:ln/>
-        </p:spPr>
-      </p:sp>
-      <p:sp>
-        <p:nvSpPr>
-          <p:cNvPr id="17" name="Shape 15"/>
-          <p:cNvSpPr/>
-          <p:nvPr/>
-        </p:nvSpPr>
-        <p:spPr>
-          <a:xfrm>
-            <a:off x="3047924" y="6748272"/>
-            <a:ext cx="304792" cy="109728"/>
-          </a:xfrm>
-          <a:prstGeom prst="rect">
-            <a:avLst/>
-          </a:prstGeom>
-          <a:solidFill>
-            <a:srgbClr val="C0392B"/>
-          </a:solidFill>
-          <a:ln/>
-        </p:spPr>
-      </p:sp>
-      <p:sp>
-        <p:nvSpPr>
-          <p:cNvPr id="18" name="Shape 16"/>
-          <p:cNvSpPr/>
-          <p:nvPr/>
-        </p:nvSpPr>
-        <p:spPr>
-          <a:xfrm>
-            <a:off x="3352716" y="6748272"/>
-            <a:ext cx="304792" cy="109728"/>
-          </a:xfrm>
-          <a:prstGeom prst="rect">
-            <a:avLst/>
-          </a:prstGeom>
-          <a:solidFill>
-            <a:srgbClr val="E67E22"/>
-          </a:solidFill>
-          <a:ln/>
-        </p:spPr>
-      </p:sp>
-      <p:sp>
-        <p:nvSpPr>
-          <p:cNvPr id="19" name="Shape 17"/>
-          <p:cNvSpPr/>
-          <p:nvPr/>
-        </p:nvSpPr>
-        <p:spPr>
-          <a:xfrm>
-            <a:off x="3657509" y="6748272"/>
-            <a:ext cx="304792" cy="109728"/>
-          </a:xfrm>
-          <a:prstGeom prst="rect">
-            <a:avLst/>
-          </a:prstGeom>
-          <a:solidFill>
-            <a:srgbClr val="27AE60"/>
-          </a:solidFill>
-          <a:ln/>
-        </p:spPr>
-      </p:sp>
-      <p:sp>
-        <p:nvSpPr>
-          <p:cNvPr id="20" name="Shape 18"/>
-          <p:cNvSpPr/>
-          <p:nvPr/>
-        </p:nvSpPr>
-        <p:spPr>
-          <a:xfrm>
-            <a:off x="3962301" y="6748272"/>
-            <a:ext cx="304792" cy="109728"/>
-          </a:xfrm>
-          <a:prstGeom prst="rect">
-            <a:avLst/>
-          </a:prstGeom>
-          <a:solidFill>
-            <a:srgbClr val="1F618D"/>
-          </a:solidFill>
-          <a:ln/>
-        </p:spPr>
-      </p:sp>
-      <p:sp>
-        <p:nvSpPr>
-          <p:cNvPr id="21" name="Shape 19"/>
-          <p:cNvSpPr/>
-          <p:nvPr/>
-        </p:nvSpPr>
-        <p:spPr>
-          <a:xfrm>
-            <a:off x="4267093" y="6748272"/>
-            <a:ext cx="304792" cy="109728"/>
-          </a:xfrm>
-          <a:prstGeom prst="rect">
-            <a:avLst/>
-          </a:prstGeom>
-          <a:solidFill>
-            <a:srgbClr val="8E44AD"/>
-          </a:solidFill>
-          <a:ln/>
-        </p:spPr>
-      </p:sp>
-      <p:sp>
-        <p:nvSpPr>
-          <p:cNvPr id="22" name="Shape 20"/>
-          <p:cNvSpPr/>
-          <p:nvPr/>
-        </p:nvSpPr>
-        <p:spPr>
-          <a:xfrm>
-            <a:off x="4571886" y="6748272"/>
-            <a:ext cx="304792" cy="109728"/>
-          </a:xfrm>
-          <a:prstGeom prst="rect">
-            <a:avLst/>
-          </a:prstGeom>
-          <a:solidFill>
-            <a:srgbClr val="C0392B"/>
-          </a:solidFill>
-          <a:ln/>
-        </p:spPr>
-      </p:sp>
-      <p:sp>
-        <p:nvSpPr>
-          <p:cNvPr id="23" name="Shape 21"/>
-          <p:cNvSpPr/>
-          <p:nvPr/>
-        </p:nvSpPr>
-        <p:spPr>
-          <a:xfrm>
-            <a:off x="4876678" y="6748272"/>
-            <a:ext cx="304792" cy="109728"/>
-          </a:xfrm>
-          <a:prstGeom prst="rect">
-            <a:avLst/>
-          </a:prstGeom>
-          <a:solidFill>
-            <a:srgbClr val="E67E22"/>
-          </a:solidFill>
-          <a:ln/>
-        </p:spPr>
-      </p:sp>
-      <p:sp>
-        <p:nvSpPr>
-          <p:cNvPr id="24" name="Shape 22"/>
-          <p:cNvSpPr/>
-          <p:nvPr/>
-        </p:nvSpPr>
-        <p:spPr>
-          <a:xfrm>
-            <a:off x="5181470" y="6748272"/>
-            <a:ext cx="304792" cy="109728"/>
-          </a:xfrm>
-          <a:prstGeom prst="rect">
-            <a:avLst/>
-          </a:prstGeom>
-          <a:solidFill>
-            <a:srgbClr val="27AE60"/>
-          </a:solidFill>
-          <a:ln/>
-        </p:spPr>
-      </p:sp>
-      <p:sp>
-        <p:nvSpPr>
-          <p:cNvPr id="25" name="Shape 23"/>
-          <p:cNvSpPr/>
-          <p:nvPr/>
-        </p:nvSpPr>
-        <p:spPr>
-          <a:xfrm>
-            <a:off x="5486263" y="6748272"/>
-            <a:ext cx="304792" cy="109728"/>
-          </a:xfrm>
-          <a:prstGeom prst="rect">
-            <a:avLst/>
-          </a:prstGeom>
-          <a:solidFill>
-            <a:srgbClr val="1F618D"/>
-          </a:solidFill>
-          <a:ln/>
-        </p:spPr>
-      </p:sp>
-      <p:sp>
-        <p:nvSpPr>
-          <p:cNvPr id="26" name="Shape 24"/>
-          <p:cNvSpPr/>
-          <p:nvPr/>
-        </p:nvSpPr>
-        <p:spPr>
-          <a:xfrm>
-            <a:off x="5791055" y="6748272"/>
-            <a:ext cx="304792" cy="109728"/>
-          </a:xfrm>
-          <a:prstGeom prst="rect">
-            <a:avLst/>
-          </a:prstGeom>
-          <a:solidFill>
-            <a:srgbClr val="8E44AD"/>
-          </a:solidFill>
-          <a:ln/>
-        </p:spPr>
-      </p:sp>
-      <p:sp>
-        <p:nvSpPr>
-          <p:cNvPr id="27" name="Shape 25"/>
-          <p:cNvSpPr/>
-          <p:nvPr/>
-        </p:nvSpPr>
-        <p:spPr>
-          <a:xfrm>
-            <a:off x="6095848" y="6748272"/>
-            <a:ext cx="304792" cy="109728"/>
-          </a:xfrm>
-          <a:prstGeom prst="rect">
-            <a:avLst/>
-          </a:prstGeom>
-          <a:solidFill>
-            <a:srgbClr val="C0392B"/>
-          </a:solidFill>
-          <a:ln/>
-        </p:spPr>
-      </p:sp>
-      <p:sp>
-        <p:nvSpPr>
-          <p:cNvPr id="28" name="Shape 26"/>
-          <p:cNvSpPr/>
-          <p:nvPr/>
-        </p:nvSpPr>
-        <p:spPr>
-          <a:xfrm>
-            <a:off x="6400640" y="6748272"/>
-            <a:ext cx="304792" cy="109728"/>
-          </a:xfrm>
-          <a:prstGeom prst="rect">
-            <a:avLst/>
-          </a:prstGeom>
-          <a:solidFill>
-            <a:srgbClr val="E67E22"/>
-          </a:solidFill>
-          <a:ln/>
-        </p:spPr>
-      </p:sp>
-      <p:sp>
-        <p:nvSpPr>
-          <p:cNvPr id="29" name="Shape 27"/>
-          <p:cNvSpPr/>
-          <p:nvPr/>
-        </p:nvSpPr>
-        <p:spPr>
-          <a:xfrm>
-            <a:off x="6705432" y="6748272"/>
-            <a:ext cx="304792" cy="109728"/>
-          </a:xfrm>
-          <a:prstGeom prst="rect">
-            <a:avLst/>
-          </a:prstGeom>
-          <a:solidFill>
-            <a:srgbClr val="27AE60"/>
-          </a:solidFill>
-          <a:ln/>
-        </p:spPr>
-      </p:sp>
-      <p:sp>
-        <p:nvSpPr>
-          <p:cNvPr id="30" name="Shape 28"/>
-          <p:cNvSpPr/>
-          <p:nvPr/>
-        </p:nvSpPr>
-        <p:spPr>
-          <a:xfrm>
-            <a:off x="7010225" y="6748272"/>
-            <a:ext cx="304792" cy="109728"/>
-          </a:xfrm>
-          <a:prstGeom prst="rect">
-            <a:avLst/>
-          </a:prstGeom>
-          <a:solidFill>
-            <a:srgbClr val="1F618D"/>
-          </a:solidFill>
-          <a:ln/>
-        </p:spPr>
-      </p:sp>
-      <p:sp>
-        <p:nvSpPr>
-          <p:cNvPr id="31" name="Shape 29"/>
-          <p:cNvSpPr/>
-          <p:nvPr/>
-        </p:nvSpPr>
-        <p:spPr>
-          <a:xfrm>
-            <a:off x="7315017" y="6748272"/>
-            <a:ext cx="304792" cy="109728"/>
-          </a:xfrm>
-          <a:prstGeom prst="rect">
-            <a:avLst/>
-          </a:prstGeom>
-          <a:solidFill>
-            <a:srgbClr val="8E44AD"/>
-          </a:solidFill>
-          <a:ln/>
-        </p:spPr>
-      </p:sp>
-      <p:sp>
-        <p:nvSpPr>
-          <p:cNvPr id="32" name="Shape 30"/>
-          <p:cNvSpPr/>
-          <p:nvPr/>
-        </p:nvSpPr>
-        <p:spPr>
-          <a:xfrm>
-            <a:off x="7619809" y="6748272"/>
-            <a:ext cx="304792" cy="109728"/>
-          </a:xfrm>
-          <a:prstGeom prst="rect">
-            <a:avLst/>
-          </a:prstGeom>
-          <a:solidFill>
-            <a:srgbClr val="C0392B"/>
-          </a:solidFill>
-          <a:ln/>
-        </p:spPr>
-      </p:sp>
-      <p:sp>
-        <p:nvSpPr>
-          <p:cNvPr id="33" name="Shape 31"/>
-          <p:cNvSpPr/>
-          <p:nvPr/>
-        </p:nvSpPr>
-        <p:spPr>
-          <a:xfrm>
-            <a:off x="7924602" y="6748272"/>
-            <a:ext cx="304792" cy="109728"/>
-          </a:xfrm>
-          <a:prstGeom prst="rect">
-            <a:avLst/>
-          </a:prstGeom>
-          <a:solidFill>
-            <a:srgbClr val="E67E22"/>
-          </a:solidFill>
-          <a:ln/>
-        </p:spPr>
-      </p:sp>
-      <p:sp>
-        <p:nvSpPr>
-          <p:cNvPr id="34" name="Shape 32"/>
-          <p:cNvSpPr/>
-          <p:nvPr/>
-        </p:nvSpPr>
-        <p:spPr>
-          <a:xfrm>
-            <a:off x="8229394" y="6748272"/>
-            <a:ext cx="304792" cy="109728"/>
-          </a:xfrm>
-          <a:prstGeom prst="rect">
-            <a:avLst/>
-          </a:prstGeom>
-          <a:solidFill>
-            <a:srgbClr val="27AE60"/>
-          </a:solidFill>
-          <a:ln/>
-        </p:spPr>
-      </p:sp>
-      <p:sp>
-        <p:nvSpPr>
-          <p:cNvPr id="35" name="Shape 33"/>
-          <p:cNvSpPr/>
-          <p:nvPr/>
-        </p:nvSpPr>
-        <p:spPr>
-          <a:xfrm>
-            <a:off x="8534187" y="6748272"/>
-            <a:ext cx="304792" cy="109728"/>
-          </a:xfrm>
-          <a:prstGeom prst="rect">
-            <a:avLst/>
-          </a:prstGeom>
-          <a:solidFill>
-            <a:srgbClr val="1F618D"/>
-          </a:solidFill>
-          <a:ln/>
-        </p:spPr>
-      </p:sp>
-      <p:sp>
-        <p:nvSpPr>
-          <p:cNvPr id="36" name="Shape 34"/>
-          <p:cNvSpPr/>
-          <p:nvPr/>
-        </p:nvSpPr>
-        <p:spPr>
-          <a:xfrm>
-            <a:off x="8838979" y="6748272"/>
-            <a:ext cx="304792" cy="109728"/>
-          </a:xfrm>
-          <a:prstGeom prst="rect">
-            <a:avLst/>
-          </a:prstGeom>
-          <a:solidFill>
-            <a:srgbClr val="8E44AD"/>
-          </a:solidFill>
-          <a:ln/>
-        </p:spPr>
-      </p:sp>
-      <p:sp>
-        <p:nvSpPr>
-          <p:cNvPr id="37" name="Shape 35"/>
-          <p:cNvSpPr/>
-          <p:nvPr/>
-        </p:nvSpPr>
-        <p:spPr>
-          <a:xfrm>
-            <a:off x="9143771" y="6748272"/>
-            <a:ext cx="304792" cy="109728"/>
-          </a:xfrm>
-          <a:prstGeom prst="rect">
-            <a:avLst/>
-          </a:prstGeom>
-          <a:solidFill>
-            <a:srgbClr val="C0392B"/>
-          </a:solidFill>
-          <a:ln/>
-        </p:spPr>
-      </p:sp>
-      <p:sp>
-        <p:nvSpPr>
-          <p:cNvPr id="38" name="Shape 36"/>
-          <p:cNvSpPr/>
-          <p:nvPr/>
-        </p:nvSpPr>
-        <p:spPr>
-          <a:xfrm>
-            <a:off x="9448564" y="6748272"/>
-            <a:ext cx="304792" cy="109728"/>
-          </a:xfrm>
-          <a:prstGeom prst="rect">
-            <a:avLst/>
-          </a:prstGeom>
-          <a:solidFill>
-            <a:srgbClr val="E67E22"/>
-          </a:solidFill>
-          <a:ln/>
-        </p:spPr>
-      </p:sp>
-      <p:sp>
-        <p:nvSpPr>
-          <p:cNvPr id="39" name="Shape 37"/>
-          <p:cNvSpPr/>
-          <p:nvPr/>
-        </p:nvSpPr>
-        <p:spPr>
-          <a:xfrm>
-            <a:off x="9753356" y="6748272"/>
-            <a:ext cx="304792" cy="109728"/>
-          </a:xfrm>
-          <a:prstGeom prst="rect">
-            <a:avLst/>
-          </a:prstGeom>
-          <a:solidFill>
-            <a:srgbClr val="27AE60"/>
-          </a:solidFill>
-          <a:ln/>
-        </p:spPr>
-      </p:sp>
-      <p:sp>
-        <p:nvSpPr>
-          <p:cNvPr id="40" name="Shape 38"/>
-          <p:cNvSpPr/>
-          <p:nvPr/>
-        </p:nvSpPr>
-        <p:spPr>
-          <a:xfrm>
-            <a:off x="10058149" y="6748272"/>
-            <a:ext cx="304792" cy="109728"/>
-          </a:xfrm>
-          <a:prstGeom prst="rect">
-            <a:avLst/>
-          </a:prstGeom>
-          <a:solidFill>
-            <a:srgbClr val="1F618D"/>
-          </a:solidFill>
-          <a:ln/>
-        </p:spPr>
-      </p:sp>
-      <p:sp>
-        <p:nvSpPr>
-          <p:cNvPr id="41" name="Shape 39"/>
-          <p:cNvSpPr/>
-          <p:nvPr/>
-        </p:nvSpPr>
-        <p:spPr>
-          <a:xfrm>
-            <a:off x="10362941" y="6748272"/>
-            <a:ext cx="304792" cy="109728"/>
-          </a:xfrm>
-          <a:prstGeom prst="rect">
-            <a:avLst/>
-          </a:prstGeom>
-          <a:solidFill>
-            <a:srgbClr val="8E44AD"/>
-          </a:solidFill>
-          <a:ln/>
-        </p:spPr>
-      </p:sp>
-      <p:sp>
-        <p:nvSpPr>
-          <p:cNvPr id="42" name="Shape 40"/>
-          <p:cNvSpPr/>
-          <p:nvPr/>
-        </p:nvSpPr>
-        <p:spPr>
-          <a:xfrm>
-            <a:off x="10667733" y="6748272"/>
-            <a:ext cx="304792" cy="109728"/>
-          </a:xfrm>
-          <a:prstGeom prst="rect">
-            <a:avLst/>
-          </a:prstGeom>
-          <a:solidFill>
-            <a:srgbClr val="C0392B"/>
-          </a:solidFill>
-          <a:ln/>
-        </p:spPr>
-      </p:sp>
-      <p:sp>
-        <p:nvSpPr>
-          <p:cNvPr id="43" name="Shape 41"/>
-          <p:cNvSpPr/>
-          <p:nvPr/>
-        </p:nvSpPr>
-        <p:spPr>
-          <a:xfrm>
-            <a:off x="10972526" y="6748272"/>
-            <a:ext cx="304792" cy="109728"/>
-          </a:xfrm>
-          <a:prstGeom prst="rect">
-            <a:avLst/>
-          </a:prstGeom>
-          <a:solidFill>
-            <a:srgbClr val="E67E22"/>
-          </a:solidFill>
-          <a:ln/>
-        </p:spPr>
-      </p:sp>
-      <p:sp>
-        <p:nvSpPr>
-          <p:cNvPr id="44" name="Shape 42"/>
-          <p:cNvSpPr/>
-          <p:nvPr/>
-        </p:nvSpPr>
-        <p:spPr>
-          <a:xfrm>
-            <a:off x="11277318" y="6748272"/>
-            <a:ext cx="304792" cy="109728"/>
-          </a:xfrm>
-          <a:prstGeom prst="rect">
-            <a:avLst/>
-          </a:prstGeom>
-          <a:solidFill>
-            <a:srgbClr val="27AE60"/>
-          </a:solidFill>
-          <a:ln/>
-        </p:spPr>
-      </p:sp>
-      <p:sp>
-        <p:nvSpPr>
-          <p:cNvPr id="45" name="Shape 43"/>
-          <p:cNvSpPr/>
-          <p:nvPr/>
-        </p:nvSpPr>
-        <p:spPr>
-          <a:xfrm>
-            <a:off x="11582110" y="6748272"/>
-            <a:ext cx="304792" cy="109728"/>
-          </a:xfrm>
-          <a:prstGeom prst="rect">
-            <a:avLst/>
-          </a:prstGeom>
-          <a:solidFill>
-            <a:srgbClr val="1F618D"/>
-          </a:solidFill>
-          <a:ln/>
-        </p:spPr>
-      </p:sp>
-      <p:sp>
-        <p:nvSpPr>
-          <p:cNvPr id="46" name="Shape 44"/>
-          <p:cNvSpPr/>
-          <p:nvPr/>
-        </p:nvSpPr>
-        <p:spPr>
-          <a:xfrm>
-            <a:off x="11886903" y="6748272"/>
-            <a:ext cx="304792" cy="109728"/>
-          </a:xfrm>
-          <a:prstGeom prst="rect">
-            <a:avLst/>
-          </a:prstGeom>
-          <a:solidFill>
-            <a:srgbClr val="8E44AD"/>
-          </a:solidFill>
-          <a:ln/>
-        </p:spPr>
-      </p:sp>
-      <p:sp>
-        <p:nvSpPr>
-          <p:cNvPr id="47" name="Shape 45"/>
-          <p:cNvSpPr/>
-          <p:nvPr/>
-        </p:nvSpPr>
-        <p:spPr>
-          <a:xfrm>
-            <a:off x="548640" y="1920240"/>
-            <a:ext cx="2602154" cy="1554480"/>
-          </a:xfrm>
-          <a:prstGeom prst="roundRect">
-            <a:avLst>
-              <a:gd name="adj" fmla="val 4706"/>
-            </a:avLst>
-          </a:prstGeom>
-          <a:solidFill>
-            <a:srgbClr val="F4F6F7"/>
-          </a:solidFill>
-          <a:ln/>
-        </p:spPr>
-      </p:sp>
-      <p:sp>
-        <p:nvSpPr>
-          <p:cNvPr id="48" name="Text 46"/>
-          <p:cNvSpPr txBox="1"/>
-          <p:nvPr/>
-        </p:nvSpPr>
-        <p:spPr>
-          <a:xfrm>
-            <a:off x="731520" y="2029968"/>
-            <a:ext cx="2236394" cy="746150"/>
-          </a:xfrm>
-          <a:prstGeom prst="rect">
-            <a:avLst/>
-          </a:prstGeom>
-          <a:noFill/>
-          <a:ln/>
-        </p:spPr>
-        <p:txBody>
-          <a:bodyPr wrap="square" lIns="0" tIns="0" rIns="0" bIns="0" rtlCol="0" anchor="b">
-            <a:normAutofit/>
-          </a:bodyPr>
-          <a:lstStyle/>
-          <a:p>
-            <a:pPr indent="0" marL="0">
-              <a:buNone/>
-            </a:pPr>
-            <a:r>
-              <a:rPr lang="en-US" sz="2800" b="1" dirty="0">
-                <a:solidFill>
-                  <a:srgbClr val="1F618D"/>
-                </a:solidFill>
-                <a:latin typeface="Cambria" pitchFamily="34" charset="0"/>
-                <a:ea typeface="Cambria" pitchFamily="34" charset="-122"/>
-                <a:cs typeface="Cambria" pitchFamily="34" charset="-120"/>
-              </a:rPr>
-              <a:t>69,10,559</a:t>
-            </a:r>
-            <a:endParaRPr lang="en-US" sz="2800" dirty="0"/>
-          </a:p>
-        </p:txBody>
-      </p:sp>
-      <p:sp>
-        <p:nvSpPr>
-          <p:cNvPr id="49" name="Text 47"/>
-          <p:cNvSpPr txBox="1"/>
-          <p:nvPr/>
-        </p:nvSpPr>
-        <p:spPr>
-          <a:xfrm>
-            <a:off x="731520" y="2794406"/>
-            <a:ext cx="2236394" cy="588874"/>
-          </a:xfrm>
-          <a:prstGeom prst="rect">
-            <a:avLst/>
-          </a:prstGeom>
-          <a:noFill/>
-          <a:ln/>
-        </p:spPr>
-        <p:txBody>
-          <a:bodyPr wrap="square" lIns="0" tIns="0" rIns="0" bIns="0" rtlCol="0" anchor="t">
-            <a:normAutofit/>
-          </a:bodyPr>
-          <a:lstStyle/>
-          <a:p>
-            <a:pPr indent="0" marL="0">
-              <a:buNone/>
-            </a:pPr>
-            <a:r>
-              <a:rPr lang="en-US" sz="1200" dirty="0">
-                <a:solidFill>
-                  <a:srgbClr val="4D5B69"/>
-                </a:solidFill>
-                <a:latin typeface="Calibri" pitchFamily="34" charset="0"/>
-                <a:ea typeface="Calibri" pitchFamily="34" charset="-122"/>
-                <a:cs typeface="Calibri" pitchFamily="34" charset="-120"/>
-              </a:rPr>
-              <a:t>names removed, both phases</a:t>
-            </a:r>
-            <a:endParaRPr lang="en-US" sz="1200" dirty="0"/>
-          </a:p>
-        </p:txBody>
-      </p:sp>
-      <p:sp>
-        <p:nvSpPr>
-          <p:cNvPr id="50" name="Shape 48"/>
-          <p:cNvSpPr/>
-          <p:nvPr/>
-        </p:nvSpPr>
-        <p:spPr>
-          <a:xfrm>
-            <a:off x="3379394" y="1920240"/>
-            <a:ext cx="2602154" cy="1554480"/>
-          </a:xfrm>
-          <a:prstGeom prst="roundRect">
-            <a:avLst>
-              <a:gd name="adj" fmla="val 4706"/>
-            </a:avLst>
-          </a:prstGeom>
-          <a:solidFill>
-            <a:srgbClr val="F4F6F7"/>
-          </a:solidFill>
-          <a:ln/>
-        </p:spPr>
-      </p:sp>
-      <p:sp>
-        <p:nvSpPr>
-          <p:cNvPr id="51" name="Text 49"/>
-          <p:cNvSpPr txBox="1"/>
-          <p:nvPr/>
-        </p:nvSpPr>
-        <p:spPr>
-          <a:xfrm>
-            <a:off x="3562274" y="2029968"/>
-            <a:ext cx="2236394" cy="746150"/>
-          </a:xfrm>
-          <a:prstGeom prst="rect">
-            <a:avLst/>
-          </a:prstGeom>
-          <a:noFill/>
-          <a:ln/>
-        </p:spPr>
-        <p:txBody>
-          <a:bodyPr wrap="square" lIns="0" tIns="0" rIns="0" bIns="0" rtlCol="0" anchor="b">
-            <a:normAutofit/>
-          </a:bodyPr>
-          <a:lstStyle/>
-          <a:p>
-            <a:pPr indent="0" marL="0">
-              <a:buNone/>
-            </a:pPr>
-            <a:r>
-              <a:rPr lang="en-US" sz="2800" b="1" dirty="0">
-                <a:solidFill>
-                  <a:srgbClr val="1F618D"/>
-                </a:solidFill>
-                <a:latin typeface="Cambria" pitchFamily="34" charset="0"/>
-                <a:ea typeface="Cambria" pitchFamily="34" charset="-122"/>
-                <a:cs typeface="Cambria" pitchFamily="34" charset="-120"/>
-              </a:rPr>
-              <a:t>174 of 243</a:t>
-            </a:r>
-            <a:endParaRPr lang="en-US" sz="2800" dirty="0"/>
-          </a:p>
-        </p:txBody>
-      </p:sp>
-      <p:sp>
-        <p:nvSpPr>
-          <p:cNvPr id="52" name="Text 50"/>
-          <p:cNvSpPr txBox="1"/>
-          <p:nvPr/>
-        </p:nvSpPr>
-        <p:spPr>
-          <a:xfrm>
-            <a:off x="3562274" y="2794406"/>
-            <a:ext cx="2236394" cy="588874"/>
-          </a:xfrm>
-          <a:prstGeom prst="rect">
-            <a:avLst/>
-          </a:prstGeom>
-          <a:noFill/>
-          <a:ln/>
-        </p:spPr>
-        <p:txBody>
-          <a:bodyPr wrap="square" lIns="0" tIns="0" rIns="0" bIns="0" rtlCol="0" anchor="t">
-            <a:normAutofit/>
-          </a:bodyPr>
-          <a:lstStyle/>
-          <a:p>
-            <a:pPr indent="0" marL="0">
-              <a:buNone/>
-            </a:pPr>
-            <a:r>
-              <a:rPr lang="en-US" sz="1200" dirty="0">
-                <a:solidFill>
-                  <a:srgbClr val="4D5B69"/>
-                </a:solidFill>
-                <a:latin typeface="Calibri" pitchFamily="34" charset="0"/>
-                <a:ea typeface="Calibri" pitchFamily="34" charset="-122"/>
-                <a:cs typeface="Calibri" pitchFamily="34" charset="-120"/>
-              </a:rPr>
-              <a:t>seats where removals exceed the margin</a:t>
-            </a:r>
-            <a:endParaRPr lang="en-US" sz="1200" dirty="0"/>
-          </a:p>
-        </p:txBody>
-      </p:sp>
-      <p:sp>
-        <p:nvSpPr>
-          <p:cNvPr id="53" name="Shape 51"/>
-          <p:cNvSpPr/>
-          <p:nvPr/>
-        </p:nvSpPr>
-        <p:spPr>
-          <a:xfrm>
-            <a:off x="6210148" y="1920240"/>
-            <a:ext cx="2602154" cy="1554480"/>
-          </a:xfrm>
-          <a:prstGeom prst="roundRect">
-            <a:avLst>
-              <a:gd name="adj" fmla="val 4706"/>
-            </a:avLst>
-          </a:prstGeom>
-          <a:solidFill>
-            <a:srgbClr val="F4F6F7"/>
-          </a:solidFill>
-          <a:ln/>
-        </p:spPr>
-      </p:sp>
-      <p:sp>
-        <p:nvSpPr>
-          <p:cNvPr id="54" name="Text 52"/>
-          <p:cNvSpPr txBox="1"/>
-          <p:nvPr/>
-        </p:nvSpPr>
-        <p:spPr>
-          <a:xfrm>
-            <a:off x="6393028" y="2029968"/>
-            <a:ext cx="2236394" cy="746150"/>
-          </a:xfrm>
-          <a:prstGeom prst="rect">
-            <a:avLst/>
-          </a:prstGeom>
-          <a:noFill/>
-          <a:ln/>
-        </p:spPr>
-        <p:txBody>
-          <a:bodyPr wrap="square" lIns="0" tIns="0" rIns="0" bIns="0" rtlCol="0" anchor="b">
-            <a:normAutofit/>
-          </a:bodyPr>
-          <a:lstStyle/>
-          <a:p>
-            <a:pPr indent="0" marL="0">
-              <a:buNone/>
-            </a:pPr>
-            <a:r>
-              <a:rPr lang="en-US" sz="2800" b="1" dirty="0">
-                <a:solidFill>
-                  <a:srgbClr val="1F618D"/>
-                </a:solidFill>
-                <a:latin typeface="Cambria" pitchFamily="34" charset="0"/>
-                <a:ea typeface="Cambria" pitchFamily="34" charset="-122"/>
-                <a:cs typeface="Cambria" pitchFamily="34" charset="-120"/>
-              </a:rPr>
-              <a:t>55.5%</a:t>
-            </a:r>
-            <a:endParaRPr lang="en-US" sz="2800" dirty="0"/>
-          </a:p>
-        </p:txBody>
-      </p:sp>
-      <p:sp>
-        <p:nvSpPr>
-          <p:cNvPr id="55" name="Text 53"/>
-          <p:cNvSpPr txBox="1"/>
-          <p:nvPr/>
-        </p:nvSpPr>
-        <p:spPr>
-          <a:xfrm>
-            <a:off x="6393028" y="2794406"/>
-            <a:ext cx="2236394" cy="588874"/>
-          </a:xfrm>
-          <a:prstGeom prst="rect">
-            <a:avLst/>
-          </a:prstGeom>
-          <a:noFill/>
-          <a:ln/>
-        </p:spPr>
-        <p:txBody>
-          <a:bodyPr wrap="square" lIns="0" tIns="0" rIns="0" bIns="0" rtlCol="0" anchor="t">
-            <a:normAutofit/>
-          </a:bodyPr>
-          <a:lstStyle/>
-          <a:p>
-            <a:pPr indent="0" marL="0">
-              <a:buNone/>
-            </a:pPr>
-            <a:r>
-              <a:rPr lang="en-US" sz="1200" dirty="0">
-                <a:solidFill>
-                  <a:srgbClr val="4D5B69"/>
-                </a:solidFill>
-                <a:latin typeface="Calibri" pitchFamily="34" charset="0"/>
-                <a:ea typeface="Calibri" pitchFamily="34" charset="-122"/>
-                <a:cs typeface="Calibri" pitchFamily="34" charset="-120"/>
-              </a:rPr>
-              <a:t>of the removed are women</a:t>
-            </a:r>
-            <a:endParaRPr lang="en-US" sz="1200" dirty="0"/>
-          </a:p>
-        </p:txBody>
-      </p:sp>
-      <p:sp>
-        <p:nvSpPr>
-          <p:cNvPr id="56" name="Shape 54"/>
-          <p:cNvSpPr/>
-          <p:nvPr/>
-        </p:nvSpPr>
-        <p:spPr>
-          <a:xfrm>
-            <a:off x="9040901" y="1920240"/>
-            <a:ext cx="2602154" cy="1554480"/>
-          </a:xfrm>
-          <a:prstGeom prst="roundRect">
-            <a:avLst>
-              <a:gd name="adj" fmla="val 4706"/>
-            </a:avLst>
-          </a:prstGeom>
-          <a:solidFill>
-            <a:srgbClr val="F4F6F7"/>
-          </a:solidFill>
-          <a:ln/>
-        </p:spPr>
-      </p:sp>
-      <p:sp>
-        <p:nvSpPr>
-          <p:cNvPr id="57" name="Text 55"/>
-          <p:cNvSpPr txBox="1"/>
-          <p:nvPr/>
-        </p:nvSpPr>
-        <p:spPr>
-          <a:xfrm>
-            <a:off x="9223781" y="2029968"/>
-            <a:ext cx="2236394" cy="746150"/>
-          </a:xfrm>
-          <a:prstGeom prst="rect">
-            <a:avLst/>
-          </a:prstGeom>
-          <a:noFill/>
-          <a:ln/>
-        </p:spPr>
-        <p:txBody>
-          <a:bodyPr wrap="square" lIns="0" tIns="0" rIns="0" bIns="0" rtlCol="0" anchor="b">
-            <a:normAutofit/>
-          </a:bodyPr>
-          <a:lstStyle/>
-          <a:p>
-            <a:pPr indent="0" marL="0">
-              <a:buNone/>
-            </a:pPr>
-            <a:r>
-              <a:rPr lang="en-US" sz="2800" b="1" dirty="0">
-                <a:solidFill>
-                  <a:srgbClr val="1F618D"/>
-                </a:solidFill>
-                <a:latin typeface="Cambria" pitchFamily="34" charset="0"/>
-                <a:ea typeface="Cambria" pitchFamily="34" charset="-122"/>
-                <a:cs typeface="Cambria" pitchFamily="34" charset="-120"/>
-              </a:rPr>
-              <a:t>20 seats</a:t>
-            </a:r>
-            <a:endParaRPr lang="en-US" sz="2800" dirty="0"/>
-          </a:p>
-        </p:txBody>
-      </p:sp>
-      <p:sp>
-        <p:nvSpPr>
-          <p:cNvPr id="58" name="Text 56"/>
-          <p:cNvSpPr txBox="1"/>
-          <p:nvPr/>
-        </p:nvSpPr>
-        <p:spPr>
-          <a:xfrm>
-            <a:off x="9223781" y="2794406"/>
-            <a:ext cx="2236394" cy="588874"/>
-          </a:xfrm>
-          <a:prstGeom prst="rect">
-            <a:avLst/>
-          </a:prstGeom>
-          <a:noFill/>
-          <a:ln/>
-        </p:spPr>
-        <p:txBody>
-          <a:bodyPr wrap="square" lIns="0" tIns="0" rIns="0" bIns="0" rtlCol="0" anchor="t">
-            <a:normAutofit/>
-          </a:bodyPr>
-          <a:lstStyle/>
-          <a:p>
-            <a:pPr indent="0" marL="0">
-              <a:buNone/>
-            </a:pPr>
-            <a:r>
-              <a:rPr lang="en-US" sz="1200" dirty="0">
-                <a:solidFill>
-                  <a:srgbClr val="4D5B69"/>
-                </a:solidFill>
-                <a:latin typeface="Calibri" pitchFamily="34" charset="0"/>
-                <a:ea typeface="Calibri" pitchFamily="34" charset="-122"/>
-                <a:cs typeface="Calibri" pitchFamily="34" charset="-120"/>
-              </a:rPr>
-              <a:t>where names marked absent alone exceed the margin</a:t>
-            </a:r>
-            <a:endParaRPr lang="en-US" sz="1200" dirty="0"/>
-          </a:p>
-        </p:txBody>
-      </p:sp>
-      <p:sp>
-        <p:nvSpPr>
-          <p:cNvPr id="59" name="Text 57"/>
-          <p:cNvSpPr txBox="1"/>
-          <p:nvPr/>
-        </p:nvSpPr>
-        <p:spPr>
-          <a:xfrm>
-            <a:off x="548640" y="3840480"/>
-            <a:ext cx="11094415" cy="2377440"/>
-          </a:xfrm>
-          <a:prstGeom prst="rect">
-            <a:avLst/>
-          </a:prstGeom>
-          <a:noFill/>
-          <a:ln/>
-        </p:spPr>
-        <p:txBody>
-          <a:bodyPr wrap="square" lIns="0" tIns="0" rIns="0" bIns="0" rtlCol="0" anchor="t">
-            <a:normAutofit/>
-          </a:bodyPr>
-          <a:lstStyle/>
-          <a:p>
-            <a:pPr marL="342900" indent="-342900">
-              <a:spcAft>
-                <a:spcPts val="800"/>
-              </a:spcAft>
-              <a:buSzPct val="100000"/>
-              <a:buChar char="•"/>
-            </a:pPr>
-            <a:r>
-              <a:rPr lang="en-US" sz="1500" dirty="0">
-                <a:solidFill>
-                  <a:srgbClr val="1C2833"/>
-                </a:solidFill>
-                <a:latin typeface="Calibri" pitchFamily="34" charset="0"/>
-                <a:ea typeface="Calibri" pitchFamily="34" charset="-122"/>
-                <a:cs typeface="Calibri" pitchFamily="34" charset="-120"/>
-              </a:rPr>
-              <a:t>Phase 1 reasons: shifted 40.5%, dead 34.0%, absent 14.8%, already enrolled 10.7%.</a:t>
-            </a:r>
-            <a:endParaRPr lang="en-US" sz="1500" dirty="0"/>
-          </a:p>
-          <a:p>
-            <a:pPr marL="342900" indent="-342900">
-              <a:spcAft>
-                <a:spcPts val="800"/>
-              </a:spcAft>
-              <a:buSzPct val="100000"/>
-              <a:buChar char="•"/>
-            </a:pPr>
-            <a:r>
-              <a:rPr lang="en-US" sz="1500" dirty="0">
-                <a:solidFill>
-                  <a:srgbClr val="1C2833"/>
-                </a:solidFill>
-                <a:latin typeface="Calibri" pitchFamily="34" charset="0"/>
-                <a:ea typeface="Calibri" pitchFamily="34" charset="-122"/>
-                <a:cs typeface="Calibri" pitchFamily="34" charset="-120"/>
-              </a:rPr>
-              <a:t>5,64,439 of the 7,20,543 more women than men removed in phase 1 were entered as shifted; 72.6% of those marked shifted aged 18 to 29 are women.</a:t>
-            </a:r>
-            <a:endParaRPr lang="en-US" sz="1500" dirty="0"/>
-          </a:p>
-          <a:p>
-            <a:pPr marL="342900" indent="-342900">
-              <a:spcAft>
-                <a:spcPts val="800"/>
-              </a:spcAft>
-              <a:buSzPct val="100000"/>
-              <a:buChar char="•"/>
-            </a:pPr>
-            <a:r>
-              <a:rPr lang="en-US" sz="1500" dirty="0">
-                <a:solidFill>
-                  <a:srgbClr val="1C2833"/>
-                </a:solidFill>
-                <a:latin typeface="Calibri" pitchFamily="34" charset="0"/>
-                <a:ea typeface="Calibri" pitchFamily="34" charset="-122"/>
-                <a:cs typeface="Calibri" pitchFamily="34" charset="-120"/>
-              </a:rPr>
-              <a:t>NDA seats lost 9.58 names per 100 electors against 8.79 in INDIA seats, by the 2020 winner.</a:t>
-            </a:r>
-            <a:endParaRPr lang="en-US" sz="1500" dirty="0"/>
-          </a:p>
-          <a:p>
-            <a:pPr marL="342900" indent="-342900">
-              <a:spcAft>
-                <a:spcPts val="800"/>
-              </a:spcAft>
-              <a:buSzPct val="100000"/>
-              <a:buChar char="•"/>
-            </a:pPr>
-            <a:r>
-              <a:rPr lang="en-US" sz="1500" dirty="0">
-                <a:solidFill>
-                  <a:srgbClr val="1C2833"/>
-                </a:solidFill>
-                <a:latin typeface="Calibri" pitchFamily="34" charset="0"/>
-                <a:ea typeface="Calibri" pitchFamily="34" charset="-122"/>
-                <a:cs typeface="Calibri" pitchFamily="34" charset="-120"/>
-              </a:rPr>
-              <a:t>The full Bihar report and deck, with a chapter for each district, are published separately.</a:t>
-            </a:r>
-            <a:endParaRPr lang="en-US" sz="1500" dirty="0"/>
-          </a:p>
-        </p:txBody>
-      </p:sp>
-    </p:spTree>
-  </p:cSld>
-  <p:clrMapOvr>
-    <a:masterClrMapping/>
-  </p:clrMapOvr>
-</p:sld>
-</file>
-
-<file path=ppt/slides/slide13.xml><?xml version="1.0" encoding="utf-8"?>
-<p:sld xmlns:a="http://schemas.openxmlformats.org/drawingml/2006/main" xmlns:r="http://schemas.openxmlformats.org/officeDocument/2006/relationships" xmlns:p="http://schemas.openxmlformats.org/presentationml/2006/main">
-  <p:cSld name="Slide 13">
-    <p:spTree>
-      <p:nvGrpSpPr>
-        <p:cNvPr id="1" name=""/>
-        <p:cNvGrpSpPr/>
-        <p:nvPr/>
-      </p:nvGrpSpPr>
-      <p:grpSpPr>
-        <a:xfrm>
-          <a:off x="0" y="0"/>
-          <a:ext cx="0" cy="0"/>
-          <a:chOff x="0" y="0"/>
-          <a:chExt cx="0" cy="0"/>
-        </a:xfrm>
-      </p:grpSpPr>
-      <p:sp>
-        <p:nvSpPr>
-          <p:cNvPr id="2" name="Text 0"/>
-          <p:cNvSpPr txBox="1"/>
-          <p:nvPr/>
-        </p:nvSpPr>
-        <p:spPr>
-          <a:xfrm>
-            <a:off x="548640" y="256032"/>
-            <a:ext cx="11094415" cy="274320"/>
-          </a:xfrm>
-          <a:prstGeom prst="rect">
-            <a:avLst/>
-          </a:prstGeom>
-          <a:noFill/>
-          <a:ln/>
-        </p:spPr>
-        <p:txBody>
-          <a:bodyPr wrap="square" lIns="0" tIns="0" rIns="0" bIns="0" rtlCol="0" anchor="ctr"/>
-          <a:lstStyle/>
-          <a:p>
-            <a:pPr indent="0" marL="0">
-              <a:buNone/>
-            </a:pPr>
-            <a:r>
-              <a:rPr lang="en-US" sz="1100" b="1" spc="200" kern="0" dirty="0">
-                <a:solidFill>
-                  <a:srgbClr val="1F618D"/>
-                </a:solidFill>
-                <a:latin typeface="Calibri" pitchFamily="34" charset="0"/>
-                <a:ea typeface="Calibri" pitchFamily="34" charset="-122"/>
-                <a:cs typeface="Calibri" pitchFamily="34" charset="-120"/>
-              </a:rPr>
-              <a:t>HYDERABAD OLD CITY, FROM THE LISTS</a:t>
-            </a:r>
-            <a:endParaRPr lang="en-US" sz="1100" dirty="0"/>
-          </a:p>
-        </p:txBody>
-      </p:sp>
-      <p:sp>
-        <p:nvSpPr>
-          <p:cNvPr id="3" name="Text 1"/>
-          <p:cNvSpPr txBox="1"/>
-          <p:nvPr/>
-        </p:nvSpPr>
-        <p:spPr>
-          <a:xfrm>
-            <a:off x="548640" y="530352"/>
-            <a:ext cx="11094415" cy="914400"/>
-          </a:xfrm>
-          <a:prstGeom prst="rect">
-            <a:avLst/>
-          </a:prstGeom>
-          <a:noFill/>
-          <a:ln/>
-        </p:spPr>
-        <p:txBody>
-          <a:bodyPr wrap="square" lIns="0" tIns="0" rIns="0" bIns="0" rtlCol="0" anchor="t">
-            <a:normAutofit/>
-          </a:bodyPr>
-          <a:lstStyle/>
-          <a:p>
-            <a:pPr indent="0" marL="0">
-              <a:buNone/>
-            </a:pPr>
-            <a:r>
-              <a:rPr lang="en-US" sz="2700" b="1" dirty="0">
-                <a:solidFill>
-                  <a:srgbClr val="1F4E79"/>
-                </a:solidFill>
-                <a:latin typeface="Cambria" pitchFamily="34" charset="0"/>
-                <a:ea typeface="Cambria" pitchFamily="34" charset="-122"/>
-                <a:cs typeface="Cambria" pitchFamily="34" charset="-120"/>
-              </a:rPr>
-              <a:t>40% of electors in five Old City seats were struck off, more than the 2023 margin in all 5</a:t>
-            </a:r>
-            <a:endParaRPr lang="en-US" sz="2700" dirty="0"/>
-          </a:p>
-        </p:txBody>
-      </p:sp>
-      <p:sp>
-        <p:nvSpPr>
-          <p:cNvPr id="4" name="Text 2"/>
-          <p:cNvSpPr txBox="1"/>
-          <p:nvPr/>
-        </p:nvSpPr>
-        <p:spPr>
-          <a:xfrm>
-            <a:off x="548640" y="1463040"/>
-            <a:ext cx="11094415" cy="365760"/>
-          </a:xfrm>
-          <a:prstGeom prst="rect">
-            <a:avLst/>
-          </a:prstGeom>
-          <a:noFill/>
-          <a:ln/>
-        </p:spPr>
-        <p:txBody>
-          <a:bodyPr wrap="square" lIns="0" tIns="0" rIns="0" bIns="0" rtlCol="0" anchor="t"/>
-          <a:lstStyle/>
-          <a:p>
-            <a:pPr indent="0" marL="0">
-              <a:buNone/>
-            </a:pPr>
-            <a:r>
-              <a:rPr lang="en-US" sz="1400" dirty="0">
-                <a:solidFill>
-                  <a:srgbClr val="4D5B69"/>
-                </a:solidFill>
-                <a:latin typeface="Calibri" pitchFamily="34" charset="0"/>
-                <a:ea typeface="Calibri" pitchFamily="34" charset="-122"/>
-                <a:cs typeface="Calibri" pitchFamily="34" charset="-120"/>
-              </a:rPr>
-              <a:t>Charminar, Yakutpura, Malakpet, Chandrayangutta and Bahadurpura; the lists hold every elector, so each group has a true rate</a:t>
-            </a:r>
-            <a:endParaRPr lang="en-US" sz="1400" dirty="0"/>
-          </a:p>
-        </p:txBody>
-      </p:sp>
-      <p:sp>
-        <p:nvSpPr>
-          <p:cNvPr id="5" name="Text 3"/>
-          <p:cNvSpPr txBox="1"/>
-          <p:nvPr/>
-        </p:nvSpPr>
-        <p:spPr>
-          <a:xfrm>
-            <a:off x="548640" y="6400800"/>
-            <a:ext cx="10180015" cy="274320"/>
-          </a:xfrm>
-          <a:prstGeom prst="rect">
-            <a:avLst/>
-          </a:prstGeom>
-          <a:noFill/>
-          <a:ln/>
-        </p:spPr>
-        <p:txBody>
-          <a:bodyPr wrap="square" lIns="0" tIns="0" rIns="0" bIns="0" rtlCol="0" anchor="ctr"/>
-          <a:lstStyle/>
-          <a:p>
-            <a:pPr indent="0" marL="0">
-              <a:buNone/>
-            </a:pPr>
-            <a:r>
-              <a:rPr lang="en-US" sz="900" dirty="0">
-                <a:solidFill>
-                  <a:srgbClr val="4D5B69"/>
-                </a:solidFill>
-                <a:latin typeface="Calibri" pitchFamily="34" charset="0"/>
-                <a:ea typeface="Calibri" pitchFamily="34" charset="-122"/>
-                <a:cs typeface="Calibri" pitchFamily="34" charset="-120"/>
-              </a:rPr>
-              <a:t>SIR 2025-26 · All India · Varna Sri Raman · aggregates only; no names or EPIC numbers</a:t>
-            </a:r>
-            <a:endParaRPr lang="en-US" sz="900" dirty="0"/>
-          </a:p>
-        </p:txBody>
-      </p:sp>
-      <p:sp>
-        <p:nvSpPr>
-          <p:cNvPr id="6" name="Text 4"/>
-          <p:cNvSpPr txBox="1"/>
-          <p:nvPr/>
-        </p:nvSpPr>
-        <p:spPr>
-          <a:xfrm>
-            <a:off x="10911535" y="6400800"/>
-            <a:ext cx="731520" cy="274320"/>
-          </a:xfrm>
-          <a:prstGeom prst="rect">
-            <a:avLst/>
-          </a:prstGeom>
-          <a:noFill/>
-          <a:ln/>
-        </p:spPr>
-        <p:txBody>
-          <a:bodyPr wrap="square" lIns="0" tIns="0" rIns="0" bIns="0" rtlCol="0" anchor="ctr"/>
-          <a:lstStyle/>
-          <a:p>
-            <a:pPr algn="r" indent="0" marL="0">
-              <a:buNone/>
-            </a:pPr>
-            <a:r>
-              <a:rPr lang="en-US" sz="900" dirty="0">
-                <a:solidFill>
-                  <a:srgbClr val="4D5B69"/>
-                </a:solidFill>
-                <a:latin typeface="Calibri" pitchFamily="34" charset="0"/>
-                <a:ea typeface="Calibri" pitchFamily="34" charset="-122"/>
-                <a:cs typeface="Calibri" pitchFamily="34" charset="-120"/>
-              </a:rPr>
-              <a:t>13</a:t>
-            </a:r>
-            <a:endParaRPr lang="en-US" sz="900" dirty="0"/>
-          </a:p>
-        </p:txBody>
-      </p:sp>
-      <p:sp>
-        <p:nvSpPr>
-          <p:cNvPr id="7" name="Shape 5"/>
-          <p:cNvSpPr/>
-          <p:nvPr/>
-        </p:nvSpPr>
-        <p:spPr>
-          <a:xfrm>
-            <a:off x="0" y="6748272"/>
-            <a:ext cx="304792" cy="109728"/>
-          </a:xfrm>
-          <a:prstGeom prst="rect">
-            <a:avLst/>
-          </a:prstGeom>
-          <a:solidFill>
-            <a:srgbClr val="C0392B"/>
-          </a:solidFill>
-          <a:ln/>
-        </p:spPr>
-      </p:sp>
-      <p:sp>
-        <p:nvSpPr>
-          <p:cNvPr id="8" name="Shape 6"/>
-          <p:cNvSpPr/>
-          <p:nvPr/>
-        </p:nvSpPr>
-        <p:spPr>
-          <a:xfrm>
-            <a:off x="304792" y="6748272"/>
-            <a:ext cx="304792" cy="109728"/>
-          </a:xfrm>
-          <a:prstGeom prst="rect">
-            <a:avLst/>
-          </a:prstGeom>
-          <a:solidFill>
-            <a:srgbClr val="E67E22"/>
-          </a:solidFill>
-          <a:ln/>
-        </p:spPr>
-      </p:sp>
-      <p:sp>
-        <p:nvSpPr>
-          <p:cNvPr id="9" name="Shape 7"/>
-          <p:cNvSpPr/>
-          <p:nvPr/>
-        </p:nvSpPr>
-        <p:spPr>
-          <a:xfrm>
-            <a:off x="609585" y="6748272"/>
-            <a:ext cx="304792" cy="109728"/>
-          </a:xfrm>
-          <a:prstGeom prst="rect">
-            <a:avLst/>
-          </a:prstGeom>
-          <a:solidFill>
-            <a:srgbClr val="27AE60"/>
-          </a:solidFill>
-          <a:ln/>
-        </p:spPr>
-      </p:sp>
-      <p:sp>
-        <p:nvSpPr>
-          <p:cNvPr id="10" name="Shape 8"/>
-          <p:cNvSpPr/>
-          <p:nvPr/>
-        </p:nvSpPr>
-        <p:spPr>
-          <a:xfrm>
-            <a:off x="914377" y="6748272"/>
-            <a:ext cx="304792" cy="109728"/>
-          </a:xfrm>
-          <a:prstGeom prst="rect">
-            <a:avLst/>
-          </a:prstGeom>
-          <a:solidFill>
-            <a:srgbClr val="1F618D"/>
-          </a:solidFill>
-          <a:ln/>
-        </p:spPr>
-      </p:sp>
-      <p:sp>
-        <p:nvSpPr>
-          <p:cNvPr id="11" name="Shape 9"/>
-          <p:cNvSpPr/>
-          <p:nvPr/>
-        </p:nvSpPr>
-        <p:spPr>
-          <a:xfrm>
-            <a:off x="1219170" y="6748272"/>
-            <a:ext cx="304792" cy="109728"/>
-          </a:xfrm>
-          <a:prstGeom prst="rect">
-            <a:avLst/>
-          </a:prstGeom>
-          <a:solidFill>
-            <a:srgbClr val="8E44AD"/>
-          </a:solidFill>
-          <a:ln/>
-        </p:spPr>
-      </p:sp>
-      <p:sp>
-        <p:nvSpPr>
-          <p:cNvPr id="12" name="Shape 10"/>
-          <p:cNvSpPr/>
-          <p:nvPr/>
-        </p:nvSpPr>
-        <p:spPr>
-          <a:xfrm>
-            <a:off x="1523962" y="6748272"/>
-            <a:ext cx="304792" cy="109728"/>
-          </a:xfrm>
-          <a:prstGeom prst="rect">
-            <a:avLst/>
-          </a:prstGeom>
-          <a:solidFill>
-            <a:srgbClr val="C0392B"/>
-          </a:solidFill>
-          <a:ln/>
-        </p:spPr>
-      </p:sp>
-      <p:sp>
-        <p:nvSpPr>
-          <p:cNvPr id="13" name="Shape 11"/>
-          <p:cNvSpPr/>
-          <p:nvPr/>
-        </p:nvSpPr>
-        <p:spPr>
-          <a:xfrm>
-            <a:off x="1828754" y="6748272"/>
-            <a:ext cx="304792" cy="109728"/>
-          </a:xfrm>
-          <a:prstGeom prst="rect">
-            <a:avLst/>
-          </a:prstGeom>
-          <a:solidFill>
-            <a:srgbClr val="E67E22"/>
-          </a:solidFill>
-          <a:ln/>
-        </p:spPr>
-      </p:sp>
-      <p:sp>
-        <p:nvSpPr>
-          <p:cNvPr id="14" name="Shape 12"/>
-          <p:cNvSpPr/>
-          <p:nvPr/>
-        </p:nvSpPr>
-        <p:spPr>
-          <a:xfrm>
-            <a:off x="2133547" y="6748272"/>
-            <a:ext cx="304792" cy="109728"/>
-          </a:xfrm>
-          <a:prstGeom prst="rect">
-            <a:avLst/>
-          </a:prstGeom>
-          <a:solidFill>
-            <a:srgbClr val="27AE60"/>
-          </a:solidFill>
-          <a:ln/>
-        </p:spPr>
-      </p:sp>
-      <p:sp>
-        <p:nvSpPr>
-          <p:cNvPr id="15" name="Shape 13"/>
-          <p:cNvSpPr/>
-          <p:nvPr/>
-        </p:nvSpPr>
-        <p:spPr>
-          <a:xfrm>
-            <a:off x="2438339" y="6748272"/>
-            <a:ext cx="304792" cy="109728"/>
-          </a:xfrm>
-          <a:prstGeom prst="rect">
-            <a:avLst/>
-          </a:prstGeom>
-          <a:solidFill>
-            <a:srgbClr val="1F618D"/>
-          </a:solidFill>
-          <a:ln/>
-        </p:spPr>
-      </p:sp>
-      <p:sp>
-        <p:nvSpPr>
-          <p:cNvPr id="16" name="Shape 14"/>
-          <p:cNvSpPr/>
-          <p:nvPr/>
-        </p:nvSpPr>
-        <p:spPr>
-          <a:xfrm>
-            <a:off x="2743131" y="6748272"/>
-            <a:ext cx="304792" cy="109728"/>
-          </a:xfrm>
-          <a:prstGeom prst="rect">
-            <a:avLst/>
-          </a:prstGeom>
-          <a:solidFill>
-            <a:srgbClr val="8E44AD"/>
-          </a:solidFill>
-          <a:ln/>
-        </p:spPr>
-      </p:sp>
-      <p:sp>
-        <p:nvSpPr>
-          <p:cNvPr id="17" name="Shape 15"/>
-          <p:cNvSpPr/>
-          <p:nvPr/>
-        </p:nvSpPr>
-        <p:spPr>
-          <a:xfrm>
-            <a:off x="3047924" y="6748272"/>
-            <a:ext cx="304792" cy="109728"/>
-          </a:xfrm>
-          <a:prstGeom prst="rect">
-            <a:avLst/>
-          </a:prstGeom>
-          <a:solidFill>
-            <a:srgbClr val="C0392B"/>
-          </a:solidFill>
-          <a:ln/>
-        </p:spPr>
-      </p:sp>
-      <p:sp>
-        <p:nvSpPr>
-          <p:cNvPr id="18" name="Shape 16"/>
-          <p:cNvSpPr/>
-          <p:nvPr/>
-        </p:nvSpPr>
-        <p:spPr>
-          <a:xfrm>
-            <a:off x="3352716" y="6748272"/>
-            <a:ext cx="304792" cy="109728"/>
-          </a:xfrm>
-          <a:prstGeom prst="rect">
-            <a:avLst/>
-          </a:prstGeom>
-          <a:solidFill>
-            <a:srgbClr val="E67E22"/>
-          </a:solidFill>
-          <a:ln/>
-        </p:spPr>
-      </p:sp>
-      <p:sp>
-        <p:nvSpPr>
-          <p:cNvPr id="19" name="Shape 17"/>
-          <p:cNvSpPr/>
-          <p:nvPr/>
-        </p:nvSpPr>
-        <p:spPr>
-          <a:xfrm>
-            <a:off x="3657509" y="6748272"/>
-            <a:ext cx="304792" cy="109728"/>
-          </a:xfrm>
-          <a:prstGeom prst="rect">
-            <a:avLst/>
-          </a:prstGeom>
-          <a:solidFill>
-            <a:srgbClr val="27AE60"/>
-          </a:solidFill>
-          <a:ln/>
-        </p:spPr>
-      </p:sp>
-      <p:sp>
-        <p:nvSpPr>
-          <p:cNvPr id="20" name="Shape 18"/>
-          <p:cNvSpPr/>
-          <p:nvPr/>
-        </p:nvSpPr>
-        <p:spPr>
-          <a:xfrm>
-            <a:off x="3962301" y="6748272"/>
-            <a:ext cx="304792" cy="109728"/>
-          </a:xfrm>
-          <a:prstGeom prst="rect">
-            <a:avLst/>
-          </a:prstGeom>
-          <a:solidFill>
-            <a:srgbClr val="1F618D"/>
-          </a:solidFill>
-          <a:ln/>
-        </p:spPr>
-      </p:sp>
-      <p:sp>
-        <p:nvSpPr>
-          <p:cNvPr id="21" name="Shape 19"/>
-          <p:cNvSpPr/>
-          <p:nvPr/>
-        </p:nvSpPr>
-        <p:spPr>
-          <a:xfrm>
-            <a:off x="4267093" y="6748272"/>
-            <a:ext cx="304792" cy="109728"/>
-          </a:xfrm>
-          <a:prstGeom prst="rect">
-            <a:avLst/>
-          </a:prstGeom>
-          <a:solidFill>
-            <a:srgbClr val="8E44AD"/>
-          </a:solidFill>
-          <a:ln/>
-        </p:spPr>
-      </p:sp>
-      <p:sp>
-        <p:nvSpPr>
-          <p:cNvPr id="22" name="Shape 20"/>
-          <p:cNvSpPr/>
-          <p:nvPr/>
-        </p:nvSpPr>
-        <p:spPr>
-          <a:xfrm>
-            <a:off x="4571886" y="6748272"/>
-            <a:ext cx="304792" cy="109728"/>
-          </a:xfrm>
-          <a:prstGeom prst="rect">
-            <a:avLst/>
-          </a:prstGeom>
-          <a:solidFill>
-            <a:srgbClr val="C0392B"/>
-          </a:solidFill>
-          <a:ln/>
-        </p:spPr>
-      </p:sp>
-      <p:sp>
-        <p:nvSpPr>
-          <p:cNvPr id="23" name="Shape 21"/>
-          <p:cNvSpPr/>
-          <p:nvPr/>
-        </p:nvSpPr>
-        <p:spPr>
-          <a:xfrm>
-            <a:off x="4876678" y="6748272"/>
-            <a:ext cx="304792" cy="109728"/>
-          </a:xfrm>
-          <a:prstGeom prst="rect">
-            <a:avLst/>
-          </a:prstGeom>
-          <a:solidFill>
-            <a:srgbClr val="E67E22"/>
-          </a:solidFill>
-          <a:ln/>
-        </p:spPr>
-      </p:sp>
-      <p:sp>
-        <p:nvSpPr>
-          <p:cNvPr id="24" name="Shape 22"/>
-          <p:cNvSpPr/>
-          <p:nvPr/>
-        </p:nvSpPr>
-        <p:spPr>
-          <a:xfrm>
-            <a:off x="5181470" y="6748272"/>
-            <a:ext cx="304792" cy="109728"/>
-          </a:xfrm>
-          <a:prstGeom prst="rect">
-            <a:avLst/>
-          </a:prstGeom>
-          <a:solidFill>
-            <a:srgbClr val="27AE60"/>
-          </a:solidFill>
-          <a:ln/>
-        </p:spPr>
-      </p:sp>
-      <p:sp>
-        <p:nvSpPr>
-          <p:cNvPr id="25" name="Shape 23"/>
-          <p:cNvSpPr/>
-          <p:nvPr/>
-        </p:nvSpPr>
-        <p:spPr>
-          <a:xfrm>
-            <a:off x="5486263" y="6748272"/>
-            <a:ext cx="304792" cy="109728"/>
-          </a:xfrm>
-          <a:prstGeom prst="rect">
-            <a:avLst/>
-          </a:prstGeom>
-          <a:solidFill>
-            <a:srgbClr val="1F618D"/>
-          </a:solidFill>
-          <a:ln/>
-        </p:spPr>
-      </p:sp>
-      <p:sp>
-        <p:nvSpPr>
-          <p:cNvPr id="26" name="Shape 24"/>
-          <p:cNvSpPr/>
-          <p:nvPr/>
-        </p:nvSpPr>
-        <p:spPr>
-          <a:xfrm>
-            <a:off x="5791055" y="6748272"/>
-            <a:ext cx="304792" cy="109728"/>
-          </a:xfrm>
-          <a:prstGeom prst="rect">
-            <a:avLst/>
-          </a:prstGeom>
-          <a:solidFill>
-            <a:srgbClr val="8E44AD"/>
-          </a:solidFill>
-          <a:ln/>
-        </p:spPr>
-      </p:sp>
-      <p:sp>
-        <p:nvSpPr>
-          <p:cNvPr id="27" name="Shape 25"/>
-          <p:cNvSpPr/>
-          <p:nvPr/>
-        </p:nvSpPr>
-        <p:spPr>
-          <a:xfrm>
-            <a:off x="6095848" y="6748272"/>
-            <a:ext cx="304792" cy="109728"/>
-          </a:xfrm>
-          <a:prstGeom prst="rect">
-            <a:avLst/>
-          </a:prstGeom>
-          <a:solidFill>
-            <a:srgbClr val="C0392B"/>
-          </a:solidFill>
-          <a:ln/>
-        </p:spPr>
-      </p:sp>
-      <p:sp>
-        <p:nvSpPr>
-          <p:cNvPr id="28" name="Shape 26"/>
-          <p:cNvSpPr/>
-          <p:nvPr/>
-        </p:nvSpPr>
-        <p:spPr>
-          <a:xfrm>
-            <a:off x="6400640" y="6748272"/>
-            <a:ext cx="304792" cy="109728"/>
-          </a:xfrm>
-          <a:prstGeom prst="rect">
-            <a:avLst/>
-          </a:prstGeom>
-          <a:solidFill>
-            <a:srgbClr val="E67E22"/>
-          </a:solidFill>
-          <a:ln/>
-        </p:spPr>
-      </p:sp>
-      <p:sp>
-        <p:nvSpPr>
-          <p:cNvPr id="29" name="Shape 27"/>
-          <p:cNvSpPr/>
-          <p:nvPr/>
-        </p:nvSpPr>
-        <p:spPr>
-          <a:xfrm>
-            <a:off x="6705432" y="6748272"/>
-            <a:ext cx="304792" cy="109728"/>
-          </a:xfrm>
-          <a:prstGeom prst="rect">
-            <a:avLst/>
-          </a:prstGeom>
-          <a:solidFill>
-            <a:srgbClr val="27AE60"/>
-          </a:solidFill>
-          <a:ln/>
-        </p:spPr>
-      </p:sp>
-      <p:sp>
-        <p:nvSpPr>
-          <p:cNvPr id="30" name="Shape 28"/>
-          <p:cNvSpPr/>
-          <p:nvPr/>
-        </p:nvSpPr>
-        <p:spPr>
-          <a:xfrm>
-            <a:off x="7010225" y="6748272"/>
-            <a:ext cx="304792" cy="109728"/>
-          </a:xfrm>
-          <a:prstGeom prst="rect">
-            <a:avLst/>
-          </a:prstGeom>
-          <a:solidFill>
-            <a:srgbClr val="1F618D"/>
-          </a:solidFill>
-          <a:ln/>
-        </p:spPr>
-      </p:sp>
-      <p:sp>
-        <p:nvSpPr>
-          <p:cNvPr id="31" name="Shape 29"/>
-          <p:cNvSpPr/>
-          <p:nvPr/>
-        </p:nvSpPr>
-        <p:spPr>
-          <a:xfrm>
-            <a:off x="7315017" y="6748272"/>
-            <a:ext cx="304792" cy="109728"/>
-          </a:xfrm>
-          <a:prstGeom prst="rect">
-            <a:avLst/>
-          </a:prstGeom>
-          <a:solidFill>
-            <a:srgbClr val="8E44AD"/>
-          </a:solidFill>
-          <a:ln/>
-        </p:spPr>
-      </p:sp>
-      <p:sp>
-        <p:nvSpPr>
-          <p:cNvPr id="32" name="Shape 30"/>
-          <p:cNvSpPr/>
-          <p:nvPr/>
-        </p:nvSpPr>
-        <p:spPr>
-          <a:xfrm>
-            <a:off x="7619809" y="6748272"/>
-            <a:ext cx="304792" cy="109728"/>
-          </a:xfrm>
-          <a:prstGeom prst="rect">
-            <a:avLst/>
-          </a:prstGeom>
-          <a:solidFill>
-            <a:srgbClr val="C0392B"/>
-          </a:solidFill>
-          <a:ln/>
-        </p:spPr>
-      </p:sp>
-      <p:sp>
-        <p:nvSpPr>
-          <p:cNvPr id="33" name="Shape 31"/>
-          <p:cNvSpPr/>
-          <p:nvPr/>
-        </p:nvSpPr>
-        <p:spPr>
-          <a:xfrm>
-            <a:off x="7924602" y="6748272"/>
-            <a:ext cx="304792" cy="109728"/>
-          </a:xfrm>
-          <a:prstGeom prst="rect">
-            <a:avLst/>
-          </a:prstGeom>
-          <a:solidFill>
-            <a:srgbClr val="E67E22"/>
-          </a:solidFill>
-          <a:ln/>
-        </p:spPr>
-      </p:sp>
-      <p:sp>
-        <p:nvSpPr>
-          <p:cNvPr id="34" name="Shape 32"/>
-          <p:cNvSpPr/>
-          <p:nvPr/>
-        </p:nvSpPr>
-        <p:spPr>
-          <a:xfrm>
-            <a:off x="8229394" y="6748272"/>
-            <a:ext cx="304792" cy="109728"/>
-          </a:xfrm>
-          <a:prstGeom prst="rect">
-            <a:avLst/>
-          </a:prstGeom>
-          <a:solidFill>
-            <a:srgbClr val="27AE60"/>
-          </a:solidFill>
-          <a:ln/>
-        </p:spPr>
-      </p:sp>
-      <p:sp>
-        <p:nvSpPr>
-          <p:cNvPr id="35" name="Shape 33"/>
-          <p:cNvSpPr/>
-          <p:nvPr/>
-        </p:nvSpPr>
-        <p:spPr>
-          <a:xfrm>
-            <a:off x="8534187" y="6748272"/>
-            <a:ext cx="304792" cy="109728"/>
-          </a:xfrm>
-          <a:prstGeom prst="rect">
-            <a:avLst/>
-          </a:prstGeom>
-          <a:solidFill>
-            <a:srgbClr val="1F618D"/>
-          </a:solidFill>
-          <a:ln/>
-        </p:spPr>
-      </p:sp>
-      <p:sp>
-        <p:nvSpPr>
-          <p:cNvPr id="36" name="Shape 34"/>
-          <p:cNvSpPr/>
-          <p:nvPr/>
-        </p:nvSpPr>
-        <p:spPr>
-          <a:xfrm>
-            <a:off x="8838979" y="6748272"/>
-            <a:ext cx="304792" cy="109728"/>
-          </a:xfrm>
-          <a:prstGeom prst="rect">
-            <a:avLst/>
-          </a:prstGeom>
-          <a:solidFill>
-            <a:srgbClr val="8E44AD"/>
-          </a:solidFill>
-          <a:ln/>
-        </p:spPr>
-      </p:sp>
-      <p:sp>
-        <p:nvSpPr>
-          <p:cNvPr id="37" name="Shape 35"/>
-          <p:cNvSpPr/>
-          <p:nvPr/>
-        </p:nvSpPr>
-        <p:spPr>
-          <a:xfrm>
-            <a:off x="9143771" y="6748272"/>
-            <a:ext cx="304792" cy="109728"/>
-          </a:xfrm>
-          <a:prstGeom prst="rect">
-            <a:avLst/>
-          </a:prstGeom>
-          <a:solidFill>
-            <a:srgbClr val="C0392B"/>
-          </a:solidFill>
-          <a:ln/>
-        </p:spPr>
-      </p:sp>
-      <p:sp>
-        <p:nvSpPr>
-          <p:cNvPr id="38" name="Shape 36"/>
-          <p:cNvSpPr/>
-          <p:nvPr/>
-        </p:nvSpPr>
-        <p:spPr>
-          <a:xfrm>
-            <a:off x="9448564" y="6748272"/>
-            <a:ext cx="304792" cy="109728"/>
-          </a:xfrm>
-          <a:prstGeom prst="rect">
-            <a:avLst/>
-          </a:prstGeom>
-          <a:solidFill>
-            <a:srgbClr val="E67E22"/>
-          </a:solidFill>
-          <a:ln/>
-        </p:spPr>
-      </p:sp>
-      <p:sp>
-        <p:nvSpPr>
-          <p:cNvPr id="39" name="Shape 37"/>
-          <p:cNvSpPr/>
-          <p:nvPr/>
-        </p:nvSpPr>
-        <p:spPr>
-          <a:xfrm>
-            <a:off x="9753356" y="6748272"/>
-            <a:ext cx="304792" cy="109728"/>
-          </a:xfrm>
-          <a:prstGeom prst="rect">
-            <a:avLst/>
-          </a:prstGeom>
-          <a:solidFill>
-            <a:srgbClr val="27AE60"/>
-          </a:solidFill>
-          <a:ln/>
-        </p:spPr>
-      </p:sp>
-      <p:sp>
-        <p:nvSpPr>
-          <p:cNvPr id="40" name="Shape 38"/>
-          <p:cNvSpPr/>
-          <p:nvPr/>
-        </p:nvSpPr>
-        <p:spPr>
-          <a:xfrm>
-            <a:off x="10058149" y="6748272"/>
-            <a:ext cx="304792" cy="109728"/>
-          </a:xfrm>
-          <a:prstGeom prst="rect">
-            <a:avLst/>
-          </a:prstGeom>
-          <a:solidFill>
-            <a:srgbClr val="1F618D"/>
-          </a:solidFill>
-          <a:ln/>
-        </p:spPr>
-      </p:sp>
-      <p:sp>
-        <p:nvSpPr>
-          <p:cNvPr id="41" name="Shape 39"/>
-          <p:cNvSpPr/>
-          <p:nvPr/>
-        </p:nvSpPr>
-        <p:spPr>
-          <a:xfrm>
-            <a:off x="10362941" y="6748272"/>
-            <a:ext cx="304792" cy="109728"/>
-          </a:xfrm>
-          <a:prstGeom prst="rect">
-            <a:avLst/>
-          </a:prstGeom>
-          <a:solidFill>
-            <a:srgbClr val="8E44AD"/>
-          </a:solidFill>
-          <a:ln/>
-        </p:spPr>
-      </p:sp>
-      <p:sp>
-        <p:nvSpPr>
-          <p:cNvPr id="42" name="Shape 40"/>
-          <p:cNvSpPr/>
-          <p:nvPr/>
-        </p:nvSpPr>
-        <p:spPr>
-          <a:xfrm>
-            <a:off x="10667733" y="6748272"/>
-            <a:ext cx="304792" cy="109728"/>
-          </a:xfrm>
-          <a:prstGeom prst="rect">
-            <a:avLst/>
-          </a:prstGeom>
-          <a:solidFill>
-            <a:srgbClr val="C0392B"/>
-          </a:solidFill>
-          <a:ln/>
-        </p:spPr>
-      </p:sp>
-      <p:sp>
-        <p:nvSpPr>
-          <p:cNvPr id="43" name="Shape 41"/>
-          <p:cNvSpPr/>
-          <p:nvPr/>
-        </p:nvSpPr>
-        <p:spPr>
-          <a:xfrm>
-            <a:off x="10972526" y="6748272"/>
-            <a:ext cx="304792" cy="109728"/>
-          </a:xfrm>
-          <a:prstGeom prst="rect">
-            <a:avLst/>
-          </a:prstGeom>
-          <a:solidFill>
-            <a:srgbClr val="E67E22"/>
-          </a:solidFill>
-          <a:ln/>
-        </p:spPr>
-      </p:sp>
-      <p:sp>
-        <p:nvSpPr>
-          <p:cNvPr id="44" name="Shape 42"/>
-          <p:cNvSpPr/>
-          <p:nvPr/>
-        </p:nvSpPr>
-        <p:spPr>
-          <a:xfrm>
-            <a:off x="11277318" y="6748272"/>
-            <a:ext cx="304792" cy="109728"/>
-          </a:xfrm>
-          <a:prstGeom prst="rect">
-            <a:avLst/>
-          </a:prstGeom>
-          <a:solidFill>
-            <a:srgbClr val="27AE60"/>
-          </a:solidFill>
-          <a:ln/>
-        </p:spPr>
-      </p:sp>
-      <p:sp>
-        <p:nvSpPr>
-          <p:cNvPr id="45" name="Shape 43"/>
-          <p:cNvSpPr/>
-          <p:nvPr/>
-        </p:nvSpPr>
-        <p:spPr>
-          <a:xfrm>
-            <a:off x="11582110" y="6748272"/>
-            <a:ext cx="304792" cy="109728"/>
-          </a:xfrm>
-          <a:prstGeom prst="rect">
-            <a:avLst/>
-          </a:prstGeom>
-          <a:solidFill>
-            <a:srgbClr val="1F618D"/>
-          </a:solidFill>
-          <a:ln/>
-        </p:spPr>
-      </p:sp>
-      <p:sp>
-        <p:nvSpPr>
-          <p:cNvPr id="46" name="Shape 44"/>
-          <p:cNvSpPr/>
-          <p:nvPr/>
-        </p:nvSpPr>
-        <p:spPr>
-          <a:xfrm>
-            <a:off x="11886903" y="6748272"/>
-            <a:ext cx="304792" cy="109728"/>
-          </a:xfrm>
-          <a:prstGeom prst="rect">
-            <a:avLst/>
-          </a:prstGeom>
-          <a:solidFill>
-            <a:srgbClr val="8E44AD"/>
-          </a:solidFill>
-          <a:ln/>
-        </p:spPr>
-      </p:sp>
-      <p:sp>
-        <p:nvSpPr>
-          <p:cNvPr id="47" name="Shape 45"/>
-          <p:cNvSpPr/>
-          <p:nvPr/>
-        </p:nvSpPr>
-        <p:spPr>
-          <a:xfrm>
-            <a:off x="548640" y="1920240"/>
-            <a:ext cx="2602154" cy="1554480"/>
-          </a:xfrm>
-          <a:prstGeom prst="roundRect">
-            <a:avLst>
-              <a:gd name="adj" fmla="val 4706"/>
-            </a:avLst>
-          </a:prstGeom>
-          <a:solidFill>
-            <a:srgbClr val="F4F6F7"/>
-          </a:solidFill>
-          <a:ln/>
-        </p:spPr>
-      </p:sp>
-      <p:sp>
-        <p:nvSpPr>
-          <p:cNvPr id="48" name="Text 46"/>
-          <p:cNvSpPr txBox="1"/>
-          <p:nvPr/>
-        </p:nvSpPr>
-        <p:spPr>
-          <a:xfrm>
-            <a:off x="731520" y="2029968"/>
-            <a:ext cx="2236394" cy="746150"/>
-          </a:xfrm>
-          <a:prstGeom prst="rect">
-            <a:avLst/>
-          </a:prstGeom>
-          <a:noFill/>
-          <a:ln/>
-        </p:spPr>
-        <p:txBody>
-          <a:bodyPr wrap="square" lIns="0" tIns="0" rIns="0" bIns="0" rtlCol="0" anchor="b">
-            <a:normAutofit/>
-          </a:bodyPr>
-          <a:lstStyle/>
-          <a:p>
-            <a:pPr indent="0" marL="0">
-              <a:buNone/>
-            </a:pPr>
-            <a:r>
-              <a:rPr lang="en-US" sz="2800" b="1" dirty="0">
-                <a:solidFill>
-                  <a:srgbClr val="1F618D"/>
-                </a:solidFill>
-                <a:latin typeface="Cambria" pitchFamily="34" charset="0"/>
-                <a:ea typeface="Cambria" pitchFamily="34" charset="-122"/>
-                <a:cs typeface="Cambria" pitchFamily="34" charset="-120"/>
-              </a:rPr>
-              <a:t>6,62,063</a:t>
-            </a:r>
-            <a:endParaRPr lang="en-US" sz="2800" dirty="0"/>
-          </a:p>
-        </p:txBody>
-      </p:sp>
-      <p:sp>
-        <p:nvSpPr>
-          <p:cNvPr id="49" name="Text 47"/>
-          <p:cNvSpPr txBox="1"/>
-          <p:nvPr/>
-        </p:nvSpPr>
-        <p:spPr>
-          <a:xfrm>
-            <a:off x="731520" y="2794406"/>
-            <a:ext cx="2236394" cy="588874"/>
-          </a:xfrm>
-          <a:prstGeom prst="rect">
-            <a:avLst/>
-          </a:prstGeom>
-          <a:noFill/>
-          <a:ln/>
-        </p:spPr>
-        <p:txBody>
-          <a:bodyPr wrap="square" lIns="0" tIns="0" rIns="0" bIns="0" rtlCol="0" anchor="t">
-            <a:normAutofit/>
-          </a:bodyPr>
-          <a:lstStyle/>
-          <a:p>
-            <a:pPr indent="0" marL="0">
-              <a:buNone/>
-            </a:pPr>
-            <a:r>
-              <a:rPr lang="en-US" sz="1200" dirty="0">
-                <a:solidFill>
-                  <a:srgbClr val="4D5B69"/>
-                </a:solidFill>
-                <a:latin typeface="Calibri" pitchFamily="34" charset="0"/>
-                <a:ea typeface="Calibri" pitchFamily="34" charset="-122"/>
-                <a:cs typeface="Calibri" pitchFamily="34" charset="-120"/>
-              </a:rPr>
-              <a:t>electors struck off</a:t>
-            </a:r>
-            <a:endParaRPr lang="en-US" sz="1200" dirty="0"/>
-          </a:p>
-        </p:txBody>
-      </p:sp>
-      <p:sp>
-        <p:nvSpPr>
-          <p:cNvPr id="50" name="Shape 48"/>
-          <p:cNvSpPr/>
-          <p:nvPr/>
-        </p:nvSpPr>
-        <p:spPr>
-          <a:xfrm>
-            <a:off x="3379394" y="1920240"/>
-            <a:ext cx="2602154" cy="1554480"/>
-          </a:xfrm>
-          <a:prstGeom prst="roundRect">
-            <a:avLst>
-              <a:gd name="adj" fmla="val 4706"/>
-            </a:avLst>
-          </a:prstGeom>
-          <a:solidFill>
-            <a:srgbClr val="F4F6F7"/>
-          </a:solidFill>
-          <a:ln/>
-        </p:spPr>
-      </p:sp>
-      <p:sp>
-        <p:nvSpPr>
-          <p:cNvPr id="51" name="Text 49"/>
-          <p:cNvSpPr txBox="1"/>
-          <p:nvPr/>
-        </p:nvSpPr>
-        <p:spPr>
-          <a:xfrm>
-            <a:off x="3562274" y="2029968"/>
-            <a:ext cx="2236394" cy="746150"/>
-          </a:xfrm>
-          <a:prstGeom prst="rect">
-            <a:avLst/>
-          </a:prstGeom>
-          <a:noFill/>
-          <a:ln/>
-        </p:spPr>
-        <p:txBody>
-          <a:bodyPr wrap="square" lIns="0" tIns="0" rIns="0" bIns="0" rtlCol="0" anchor="b">
-            <a:normAutofit/>
-          </a:bodyPr>
-          <a:lstStyle/>
-          <a:p>
-            <a:pPr indent="0" marL="0">
-              <a:buNone/>
-            </a:pPr>
-            <a:r>
-              <a:rPr lang="en-US" sz="2800" b="1" dirty="0">
-                <a:solidFill>
-                  <a:srgbClr val="1F618D"/>
-                </a:solidFill>
-                <a:latin typeface="Cambria" pitchFamily="34" charset="0"/>
-                <a:ea typeface="Cambria" pitchFamily="34" charset="-122"/>
-                <a:cs typeface="Cambria" pitchFamily="34" charset="-120"/>
-              </a:rPr>
-              <a:t>40.0%</a:t>
-            </a:r>
-            <a:endParaRPr lang="en-US" sz="2800" dirty="0"/>
-          </a:p>
-        </p:txBody>
-      </p:sp>
-      <p:sp>
-        <p:nvSpPr>
-          <p:cNvPr id="52" name="Text 50"/>
-          <p:cNvSpPr txBox="1"/>
-          <p:nvPr/>
-        </p:nvSpPr>
-        <p:spPr>
-          <a:xfrm>
-            <a:off x="3562274" y="2794406"/>
-            <a:ext cx="2236394" cy="588874"/>
-          </a:xfrm>
-          <a:prstGeom prst="rect">
-            <a:avLst/>
-          </a:prstGeom>
-          <a:noFill/>
-          <a:ln/>
-        </p:spPr>
-        <p:txBody>
-          <a:bodyPr wrap="square" lIns="0" tIns="0" rIns="0" bIns="0" rtlCol="0" anchor="t">
-            <a:normAutofit/>
-          </a:bodyPr>
-          <a:lstStyle/>
-          <a:p>
-            <a:pPr indent="0" marL="0">
-              <a:buNone/>
-            </a:pPr>
-            <a:r>
-              <a:rPr lang="en-US" sz="1200" dirty="0">
-                <a:solidFill>
-                  <a:srgbClr val="4D5B69"/>
-                </a:solidFill>
-                <a:latin typeface="Calibri" pitchFamily="34" charset="0"/>
-                <a:ea typeface="Calibri" pitchFamily="34" charset="-122"/>
-                <a:cs typeface="Calibri" pitchFamily="34" charset="-120"/>
-              </a:rPr>
-              <a:t>of the pre-revision rolls</a:t>
-            </a:r>
-            <a:endParaRPr lang="en-US" sz="1200" dirty="0"/>
-          </a:p>
-        </p:txBody>
-      </p:sp>
-      <p:sp>
-        <p:nvSpPr>
-          <p:cNvPr id="53" name="Shape 51"/>
-          <p:cNvSpPr/>
-          <p:nvPr/>
-        </p:nvSpPr>
-        <p:spPr>
-          <a:xfrm>
-            <a:off x="6210148" y="1920240"/>
-            <a:ext cx="2602154" cy="1554480"/>
-          </a:xfrm>
-          <a:prstGeom prst="roundRect">
-            <a:avLst>
-              <a:gd name="adj" fmla="val 4706"/>
-            </a:avLst>
-          </a:prstGeom>
-          <a:solidFill>
-            <a:srgbClr val="F4F6F7"/>
-          </a:solidFill>
-          <a:ln/>
-        </p:spPr>
-      </p:sp>
-      <p:sp>
-        <p:nvSpPr>
-          <p:cNvPr id="54" name="Text 52"/>
-          <p:cNvSpPr txBox="1"/>
-          <p:nvPr/>
-        </p:nvSpPr>
-        <p:spPr>
-          <a:xfrm>
-            <a:off x="6393028" y="2029968"/>
-            <a:ext cx="2236394" cy="746150"/>
-          </a:xfrm>
-          <a:prstGeom prst="rect">
-            <a:avLst/>
-          </a:prstGeom>
-          <a:noFill/>
-          <a:ln/>
-        </p:spPr>
-        <p:txBody>
-          <a:bodyPr wrap="square" lIns="0" tIns="0" rIns="0" bIns="0" rtlCol="0" anchor="b">
-            <a:normAutofit/>
-          </a:bodyPr>
-          <a:lstStyle/>
-          <a:p>
-            <a:pPr indent="0" marL="0">
-              <a:buNone/>
-            </a:pPr>
-            <a:r>
-              <a:rPr lang="en-US" sz="2800" b="1" dirty="0">
-                <a:solidFill>
-                  <a:srgbClr val="1F618D"/>
-                </a:solidFill>
-                <a:latin typeface="Cambria" pitchFamily="34" charset="0"/>
-                <a:ea typeface="Cambria" pitchFamily="34" charset="-122"/>
-                <a:cs typeface="Cambria" pitchFamily="34" charset="-120"/>
-              </a:rPr>
-              <a:t>3,69,972</a:t>
-            </a:r>
-            <a:endParaRPr lang="en-US" sz="2800" dirty="0"/>
-          </a:p>
-        </p:txBody>
-      </p:sp>
-      <p:sp>
-        <p:nvSpPr>
-          <p:cNvPr id="55" name="Text 53"/>
-          <p:cNvSpPr txBox="1"/>
-          <p:nvPr/>
-        </p:nvSpPr>
-        <p:spPr>
-          <a:xfrm>
-            <a:off x="6393028" y="2794406"/>
-            <a:ext cx="2236394" cy="588874"/>
-          </a:xfrm>
-          <a:prstGeom prst="rect">
-            <a:avLst/>
-          </a:prstGeom>
-          <a:noFill/>
-          <a:ln/>
-        </p:spPr>
-        <p:txBody>
-          <a:bodyPr wrap="square" lIns="0" tIns="0" rIns="0" bIns="0" rtlCol="0" anchor="t">
-            <a:normAutofit/>
-          </a:bodyPr>
-          <a:lstStyle/>
-          <a:p>
-            <a:pPr indent="0" marL="0">
-              <a:buNone/>
-            </a:pPr>
-            <a:r>
-              <a:rPr lang="en-US" sz="1200" dirty="0">
-                <a:solidFill>
-                  <a:srgbClr val="4D5B69"/>
-                </a:solidFill>
-                <a:latin typeface="Calibri" pitchFamily="34" charset="0"/>
-                <a:ea typeface="Calibri" pitchFamily="34" charset="-122"/>
-                <a:cs typeface="Calibri" pitchFamily="34" charset="-120"/>
-              </a:rPr>
-              <a:t>kept but summoned to a hearing</a:t>
-            </a:r>
-            <a:endParaRPr lang="en-US" sz="1200" dirty="0"/>
-          </a:p>
-        </p:txBody>
-      </p:sp>
-      <p:sp>
-        <p:nvSpPr>
-          <p:cNvPr id="56" name="Shape 54"/>
-          <p:cNvSpPr/>
-          <p:nvPr/>
-        </p:nvSpPr>
-        <p:spPr>
-          <a:xfrm>
-            <a:off x="9040901" y="1920240"/>
-            <a:ext cx="2602154" cy="1554480"/>
-          </a:xfrm>
-          <a:prstGeom prst="roundRect">
-            <a:avLst>
-              <a:gd name="adj" fmla="val 4706"/>
-            </a:avLst>
-          </a:prstGeom>
-          <a:solidFill>
-            <a:srgbClr val="F4F6F7"/>
-          </a:solidFill>
-          <a:ln/>
-        </p:spPr>
-      </p:sp>
-      <p:sp>
-        <p:nvSpPr>
-          <p:cNvPr id="57" name="Text 55"/>
-          <p:cNvSpPr txBox="1"/>
-          <p:nvPr/>
-        </p:nvSpPr>
-        <p:spPr>
-          <a:xfrm>
-            <a:off x="9223781" y="2029968"/>
-            <a:ext cx="2236394" cy="746150"/>
-          </a:xfrm>
-          <a:prstGeom prst="rect">
-            <a:avLst/>
-          </a:prstGeom>
-          <a:noFill/>
-          <a:ln/>
-        </p:spPr>
-        <p:txBody>
-          <a:bodyPr wrap="square" lIns="0" tIns="0" rIns="0" bIns="0" rtlCol="0" anchor="b">
-            <a:normAutofit/>
-          </a:bodyPr>
-          <a:lstStyle/>
-          <a:p>
-            <a:pPr indent="0" marL="0">
-              <a:buNone/>
-            </a:pPr>
-            <a:r>
-              <a:rPr lang="en-US" sz="2800" b="1" dirty="0">
-                <a:solidFill>
-                  <a:srgbClr val="1F618D"/>
-                </a:solidFill>
-                <a:latin typeface="Cambria" pitchFamily="34" charset="0"/>
-                <a:ea typeface="Cambria" pitchFamily="34" charset="-122"/>
-                <a:cs typeface="Cambria" pitchFamily="34" charset="-120"/>
-              </a:rPr>
-              <a:t>74%</a:t>
-            </a:r>
-            <a:endParaRPr lang="en-US" sz="2800" dirty="0"/>
-          </a:p>
-        </p:txBody>
-      </p:sp>
-      <p:sp>
-        <p:nvSpPr>
-          <p:cNvPr id="58" name="Text 56"/>
-          <p:cNvSpPr txBox="1"/>
-          <p:nvPr/>
-        </p:nvSpPr>
-        <p:spPr>
-          <a:xfrm>
-            <a:off x="9223781" y="2794406"/>
-            <a:ext cx="2236394" cy="588874"/>
-          </a:xfrm>
-          <a:prstGeom prst="rect">
-            <a:avLst/>
-          </a:prstGeom>
-          <a:noFill/>
-          <a:ln/>
-        </p:spPr>
-        <p:txBody>
-          <a:bodyPr wrap="square" lIns="0" tIns="0" rIns="0" bIns="0" rtlCol="0" anchor="t">
-            <a:normAutofit/>
-          </a:bodyPr>
-          <a:lstStyle/>
-          <a:p>
-            <a:pPr indent="0" marL="0">
-              <a:buNone/>
-            </a:pPr>
-            <a:r>
-              <a:rPr lang="en-US" sz="1200" dirty="0">
-                <a:solidFill>
-                  <a:srgbClr val="4D5B69"/>
-                </a:solidFill>
-                <a:latin typeface="Calibri" pitchFamily="34" charset="0"/>
-                <a:ea typeface="Calibri" pitchFamily="34" charset="-122"/>
-                <a:cs typeface="Calibri" pitchFamily="34" charset="-120"/>
-              </a:rPr>
-              <a:t>of electors aged 80 and over struck off</a:t>
-            </a:r>
-            <a:endParaRPr lang="en-US" sz="1200" dirty="0"/>
-          </a:p>
-        </p:txBody>
-      </p:sp>
-      <p:sp>
-        <p:nvSpPr>
-          <p:cNvPr id="59" name="Text 57"/>
-          <p:cNvSpPr txBox="1"/>
-          <p:nvPr/>
-        </p:nvSpPr>
-        <p:spPr>
-          <a:xfrm>
-            <a:off x="548640" y="3840480"/>
-            <a:ext cx="11094415" cy="2377440"/>
-          </a:xfrm>
-          <a:prstGeom prst="rect">
-            <a:avLst/>
-          </a:prstGeom>
-          <a:noFill/>
-          <a:ln/>
-        </p:spPr>
-        <p:txBody>
-          <a:bodyPr wrap="square" lIns="0" tIns="0" rIns="0" bIns="0" rtlCol="0" anchor="t">
-            <a:normAutofit/>
-          </a:bodyPr>
-          <a:lstStyle/>
-          <a:p>
-            <a:pPr marL="342900" indent="-342900">
-              <a:spcAft>
-                <a:spcPts val="800"/>
-              </a:spcAft>
-              <a:buSzPct val="100000"/>
-              <a:buChar char="•"/>
-            </a:pPr>
-            <a:r>
-              <a:rPr lang="en-US" sz="1500" dirty="0">
-                <a:solidFill>
-                  <a:srgbClr val="1C2833"/>
-                </a:solidFill>
-                <a:latin typeface="Calibri" pitchFamily="34" charset="0"/>
-                <a:ea typeface="Calibri" pitchFamily="34" charset="-122"/>
-                <a:cs typeface="Calibri" pitchFamily="34" charset="-120"/>
-              </a:rPr>
-              <a:t>Reasons entered: permanently shifted 64.2%, untraceable or absent 20.8%, dead 8.7%, already enrolled 6.0%.</a:t>
-            </a:r>
-            <a:endParaRPr lang="en-US" sz="1500" dirty="0"/>
-          </a:p>
-          <a:p>
-            <a:pPr marL="342900" indent="-342900">
-              <a:spcAft>
-                <a:spcPts val="800"/>
-              </a:spcAft>
-              <a:buSzPct val="100000"/>
-              <a:buChar char="•"/>
-            </a:pPr>
-            <a:r>
-              <a:rPr lang="en-US" sz="1500" dirty="0">
-                <a:solidFill>
-                  <a:srgbClr val="1C2833"/>
-                </a:solidFill>
-                <a:latin typeface="Calibri" pitchFamily="34" charset="0"/>
-                <a:ea typeface="Calibri" pitchFamily="34" charset="-122"/>
-                <a:cs typeface="Calibri" pitchFamily="34" charset="-120"/>
-              </a:rPr>
-              <a:t>Struck off more names than every valid vote cast in 2023 in Yakutpura and Malakpet.</a:t>
-            </a:r>
-            <a:endParaRPr lang="en-US" sz="1500" dirty="0"/>
-          </a:p>
-          <a:p>
-            <a:pPr marL="342900" indent="-342900">
-              <a:spcAft>
-                <a:spcPts val="800"/>
-              </a:spcAft>
-              <a:buSzPct val="100000"/>
-              <a:buChar char="•"/>
-            </a:pPr>
-            <a:r>
-              <a:rPr lang="en-US" sz="1500" dirty="0">
-                <a:solidFill>
-                  <a:srgbClr val="1C2833"/>
-                </a:solidFill>
-                <a:latin typeface="Calibri" pitchFamily="34" charset="0"/>
-                <a:ea typeface="Calibri" pitchFamily="34" charset="-122"/>
-                <a:cs typeface="Calibri" pitchFamily="34" charset="-120"/>
-              </a:rPr>
-              <a:t>Electors with no link to the 2002 roll were struck off at 51.6%, against 25.3% for those with one.</a:t>
-            </a:r>
-            <a:endParaRPr lang="en-US" sz="1500" dirty="0"/>
-          </a:p>
-          <a:p>
-            <a:pPr marL="342900" indent="-342900">
-              <a:spcAft>
-                <a:spcPts val="800"/>
-              </a:spcAft>
-              <a:buSzPct val="100000"/>
-              <a:buChar char="•"/>
-            </a:pPr>
-            <a:r>
-              <a:rPr lang="en-US" sz="1500" dirty="0">
-                <a:solidFill>
-                  <a:srgbClr val="1C2833"/>
-                </a:solidFill>
-                <a:latin typeface="Calibri" pitchFamily="34" charset="0"/>
-                <a:ea typeface="Calibri" pitchFamily="34" charset="-122"/>
-                <a:cs typeface="Calibri" pitchFamily="34" charset="-120"/>
-              </a:rPr>
-              <a:t>The full Hyderabad report and deck are published separately.</a:t>
-            </a:r>
-            <a:endParaRPr lang="en-US" sz="1500" dirty="0"/>
-          </a:p>
-        </p:txBody>
-      </p:sp>
-    </p:spTree>
-  </p:cSld>
-  <p:clrMapOvr>
-    <a:masterClrMapping/>
-  </p:clrMapOvr>
-</p:sld>
-</file>
-
-<file path=ppt/slides/slide14.xml><?xml version="1.0" encoding="utf-8"?>
-<p:sld xmlns:a="http://schemas.openxmlformats.org/drawingml/2006/main" xmlns:r="http://schemas.openxmlformats.org/officeDocument/2006/relationships" xmlns:p="http://schemas.openxmlformats.org/presentationml/2006/main">
-  <p:cSld name="Slide 14">
-    <p:spTree>
-      <p:nvGrpSpPr>
-        <p:cNvPr id="1" name=""/>
-        <p:cNvGrpSpPr/>
-        <p:nvPr/>
-      </p:nvGrpSpPr>
-      <p:grpSpPr>
-        <a:xfrm>
-          <a:off x="0" y="0"/>
-          <a:ext cx="0" cy="0"/>
-          <a:chOff x="0" y="0"/>
-          <a:chExt cx="0" cy="0"/>
-        </a:xfrm>
-      </p:grpSpPr>
-      <p:sp>
-        <p:nvSpPr>
-          <p:cNvPr id="2" name="Text 0"/>
-          <p:cNvSpPr txBox="1"/>
-          <p:nvPr/>
-        </p:nvSpPr>
-        <p:spPr>
-          <a:xfrm>
-            <a:off x="548640" y="256032"/>
-            <a:ext cx="11094415" cy="274320"/>
-          </a:xfrm>
-          <a:prstGeom prst="rect">
-            <a:avLst/>
-          </a:prstGeom>
-          <a:noFill/>
-          <a:ln/>
-        </p:spPr>
-        <p:txBody>
-          <a:bodyPr wrap="square" lIns="0" tIns="0" rIns="0" bIns="0" rtlCol="0" anchor="ctr"/>
-          <a:lstStyle/>
-          <a:p>
-            <a:pPr indent="0" marL="0">
-              <a:buNone/>
-            </a:pPr>
-            <a:r>
-              <a:rPr lang="en-US" sz="1100" b="1" spc="200" kern="0" dirty="0">
-                <a:solidFill>
-                  <a:srgbClr val="1F618D"/>
-                </a:solidFill>
-                <a:latin typeface="Calibri" pitchFamily="34" charset="0"/>
-                <a:ea typeface="Calibri" pitchFamily="34" charset="-122"/>
-                <a:cs typeface="Calibri" pitchFamily="34" charset="-120"/>
-              </a:rPr>
               <a:t>WHAT THE ELECTION COMMISSION SHOULD DO</a:t>
             </a:r>
             <a:endParaRPr lang="en-US" sz="1100" dirty="0"/>
@@ -15489,7 +12219,7 @@
                 <a:ea typeface="Calibri" pitchFamily="34" charset="-122"/>
                 <a:cs typeface="Calibri" pitchFamily="34" charset="-120"/>
               </a:rPr>
-              <a:t>14</a:t>
+              <a:t>12</a:t>
             </a:r>
             <a:endParaRPr lang="en-US" sz="900" dirty="0"/>
           </a:p>
@@ -16437,9 +13167,9 @@
 </p:sld>
 </file>
 
-<file path=ppt/slides/slide15.xml><?xml version="1.0" encoding="utf-8"?>
+<file path=ppt/slides/slide13.xml><?xml version="1.0" encoding="utf-8"?>
 <p:sld xmlns:a="http://schemas.openxmlformats.org/drawingml/2006/main" xmlns:r="http://schemas.openxmlformats.org/officeDocument/2006/relationships" xmlns:p="http://schemas.openxmlformats.org/presentationml/2006/main">
-  <p:cSld name="Slide 15">
+  <p:cSld name="Slide 13">
     <p:spTree>
       <p:nvGrpSpPr>
         <p:cNvPr id="1" name=""/>
@@ -16606,7 +13336,7 @@
                 <a:ea typeface="Calibri" pitchFamily="34" charset="-122"/>
                 <a:cs typeface="Calibri" pitchFamily="34" charset="-120"/>
               </a:rPr>
-              <a:t>15</a:t>
+              <a:t>13</a:t>
             </a:r>
             <a:endParaRPr lang="en-US" sz="900" dirty="0"/>
           </a:p>
@@ -17535,7 +14265,7 @@
                 <a:ea typeface="Calibri" pitchFamily="34" charset="-122"/>
                 <a:cs typeface="Calibri" pitchFamily="34" charset="-120"/>
               </a:rPr>
-              <a:t>Bihar and Hyderabad findings are counted from the lists; their methods are in their own reports. No name, EPIC number or address is published.</a:t>
+              <a:t>No name, EPIC number or address is published.</a:t>
             </a:r>
             <a:endParaRPr lang="en-US" sz="1500" dirty="0"/>
           </a:p>
@@ -17549,9 +14279,9 @@
 </p:sld>
 </file>
 
-<file path=ppt/slides/slide16.xml><?xml version="1.0" encoding="utf-8"?>
+<file path=ppt/slides/slide14.xml><?xml version="1.0" encoding="utf-8"?>
 <p:sld xmlns:a="http://schemas.openxmlformats.org/drawingml/2006/main" xmlns:r="http://schemas.openxmlformats.org/officeDocument/2006/relationships" xmlns:p="http://schemas.openxmlformats.org/presentationml/2006/main">
-  <p:cSld name="Slide 16">
+  <p:cSld name="Slide 14">
     <p:bg>
       <p:bgPr>
         <a:solidFill>
@@ -17648,7 +14378,7 @@
                 <a:ea typeface="Calibri" pitchFamily="34" charset="-122"/>
                 <a:cs typeface="Calibri" pitchFamily="34" charset="-120"/>
               </a:rPr>
-              <a:t>The All India table with a source for every row, the Bihar and Hyderabad dashboards, and the three full reports are published online alongside this deck.</a:t>
+              <a:t>The All India table with a source for every row, and the full report, are published online alongside this deck.</a:t>
             </a:r>
             <a:endParaRPr lang="en-US" sz="1700" dirty="0"/>
           </a:p>
@@ -19394,27 +16124,7 @@
                 <a:ea typeface="Calibri" pitchFamily="34" charset="-122"/>
                 <a:cs typeface="Calibri" pitchFamily="34" charset="-120"/>
               </a:rPr>
-              <a:t>Bihar, from the lists   12–12</a:t>
-            </a:r>
-            <a:endParaRPr lang="en-US" sz="1700" dirty="0"/>
-          </a:p>
-          <a:p>
-            <a:pPr indent="0" marL="0">
-              <a:spcAft>
-                <a:spcPts val="1200"/>
-              </a:spcAft>
-              <a:buNone/>
-            </a:pPr>
-            <a:r>
-              <a:rPr lang="en-US" sz="1700" dirty="0">
-                <a:solidFill>
-                  <a:srgbClr val="1C2833"/>
-                </a:solidFill>
-                <a:latin typeface="Calibri" pitchFamily="34" charset="0"/>
-                <a:ea typeface="Calibri" pitchFamily="34" charset="-122"/>
-                <a:cs typeface="Calibri" pitchFamily="34" charset="-120"/>
-              </a:rPr>
-              <a:t>Hyderabad Old City, from the lists   13–13</a:t>
+              <a:t>What the Election Commission should do   12–12</a:t>
             </a:r>
             <a:endParaRPr lang="en-US" sz="1700" dirty="0"/>
           </a:p>
@@ -19456,27 +16166,7 @@
                 <a:ea typeface="Calibri" pitchFamily="34" charset="-122"/>
                 <a:cs typeface="Calibri" pitchFamily="34" charset="-120"/>
               </a:rPr>
-              <a:t>What the Election Commission should do   14–14</a:t>
-            </a:r>
-            <a:endParaRPr lang="en-US" sz="1700" dirty="0"/>
-          </a:p>
-          <a:p>
-            <a:pPr indent="0" marL="0">
-              <a:spcAft>
-                <a:spcPts val="1200"/>
-              </a:spcAft>
-              <a:buNone/>
-            </a:pPr>
-            <a:r>
-              <a:rPr lang="en-US" sz="1700" dirty="0">
-                <a:solidFill>
-                  <a:srgbClr val="1C2833"/>
-                </a:solidFill>
-                <a:latin typeface="Calibri" pitchFamily="34" charset="0"/>
-                <a:ea typeface="Calibri" pitchFamily="34" charset="-122"/>
-                <a:cs typeface="Calibri" pitchFamily="34" charset="-120"/>
-              </a:rPr>
-              <a:t>Method   15–16</a:t>
+              <a:t>Method   13–14</a:t>
             </a:r>
             <a:endParaRPr lang="en-US" sz="1700" dirty="0"/>
           </a:p>

</xml_diff>

<commit_message>
All India report and deck: All India only (#26)
The All India report (PDF and page) and deck now cover All India only.
The Bihar and Hyderabad parts are removed, since both have their own
reports and decks. The report is 8 pages and the deck 14 slides.
Translations updated; checks pass.

🤖 Generated with [Claude Code](https://claude.com/claude-code)

https://claude.ai/code/session_01FWx24PCx3Jw4SUDQC6oU7o

---
_Generated by [Claude
Code](https://claude.ai/code/session_01FWx24PCx3Jw4SUDQC6oU7o)_

Co-authored-by: Claude <noreply@anthropic.com>
</commit_message>
<xml_diff>
--- a/reports/sir-india-deck.pptx
+++ b/reports/sir-india-deck.pptx
@@ -19,11 +19,9 @@
     <p:sldId id="267" r:id="rId13"/>
     <p:sldId id="268" r:id="rId14"/>
     <p:sldId id="269" r:id="rId15"/>
-    <p:sldId id="270" r:id="rId16"/>
-    <p:sldId id="271" r:id="rId17"/>
   </p:sldIdLst>
   <p:notesMasterIdLst>
-    <p:notesMasterId r:id="rId18"/>
+    <p:notesMasterId r:id="rId16"/>
   </p:notesMasterIdLst>
   <p:sldSz cx="12192000" cy="6858000"/>
   <p:notesSz cx="6858000" cy="12192000"/>
@@ -3518,182 +3516,6 @@
 </p:notes>
 </file>
 
-<file path=ppt/notesSlides/notesSlide15.xml><?xml version="1.0" encoding="utf-8"?>
-<p:notes xmlns:a="http://schemas.openxmlformats.org/drawingml/2006/main" xmlns:r="http://schemas.openxmlformats.org/officeDocument/2006/relationships" xmlns:p="http://schemas.openxmlformats.org/presentationml/2006/main">
-  <p:cSld>
-    <p:spTree>
-      <p:nvGrpSpPr>
-        <p:cNvPr id="1" name=""/>
-        <p:cNvGrpSpPr/>
-        <p:nvPr/>
-      </p:nvGrpSpPr>
-      <p:grpSpPr>
-        <a:xfrm>
-          <a:off x="0" y="0"/>
-          <a:ext cx="0" cy="0"/>
-          <a:chOff x="0" y="0"/>
-          <a:chExt cx="0" cy="0"/>
-        </a:xfrm>
-      </p:grpSpPr>
-      <p:sp>
-        <p:nvSpPr>
-          <p:cNvPr id="2" name="Slide Image Placeholder 1"/>
-          <p:cNvSpPr>
-            <a:spLocks noGrp="1" noRot="1" noChangeAspect="1"/>
-          </p:cNvSpPr>
-          <p:nvPr>
-            <p:ph type="sldImg"/>
-          </p:nvPr>
-        </p:nvSpPr>
-        <p:spPr/>
-      </p:sp>
-      <p:sp>
-        <p:nvSpPr>
-          <p:cNvPr id="3" name="Notes Placeholder 2"/>
-          <p:cNvSpPr>
-            <a:spLocks noGrp="1"/>
-          </p:cNvSpPr>
-          <p:nvPr>
-            <p:ph type="body" idx="1"/>
-          </p:nvPr>
-        </p:nvSpPr>
-        <p:spPr/>
-        <p:txBody>
-          <a:bodyPr/>
-          <a:lstStyle/>
-          <a:p>
-            <a:r>
-              <a:rPr lang="en-US" dirty="0"/>
-              <a:t/>
-            </a:r>
-            <a:endParaRPr lang="en-US" dirty="0"/>
-          </a:p>
-        </p:txBody>
-      </p:sp>
-      <p:sp>
-        <p:nvSpPr>
-          <p:cNvPr id="4" name="Slide Number Placeholder 3"/>
-          <p:cNvSpPr>
-            <a:spLocks noGrp="1"/>
-          </p:cNvSpPr>
-          <p:nvPr>
-            <p:ph type="sldNum" sz="quarter" idx="10"/>
-          </p:nvPr>
-        </p:nvSpPr>
-        <p:spPr/>
-        <p:txBody>
-          <a:bodyPr/>
-          <a:lstStyle/>
-          <a:p>
-            <a:fld id="{F7021451-1387-4CA6-816F-3879F97B5CBC}" type="slidenum">
-              <a:rPr lang="en-US"/>
-              <a:t>15</a:t>
-            </a:fld>
-            <a:endParaRPr lang="en-US"/>
-          </a:p>
-        </p:txBody>
-      </p:sp>
-    </p:spTree>
-    <p:extLst>
-      <p:ext uri="{BB962C8B-B14F-4D97-AF65-F5344CB8AC3E}">
-        <p14:creationId xmlns:p14="http://schemas.microsoft.com/office/powerpoint/2010/main" val="1024086991"/>
-      </p:ext>
-    </p:extLst>
-  </p:cSld>
-  <p:clrMapOvr>
-    <a:masterClrMapping/>
-  </p:clrMapOvr>
-</p:notes>
-</file>
-
-<file path=ppt/notesSlides/notesSlide16.xml><?xml version="1.0" encoding="utf-8"?>
-<p:notes xmlns:a="http://schemas.openxmlformats.org/drawingml/2006/main" xmlns:r="http://schemas.openxmlformats.org/officeDocument/2006/relationships" xmlns:p="http://schemas.openxmlformats.org/presentationml/2006/main">
-  <p:cSld>
-    <p:spTree>
-      <p:nvGrpSpPr>
-        <p:cNvPr id="1" name=""/>
-        <p:cNvGrpSpPr/>
-        <p:nvPr/>
-      </p:nvGrpSpPr>
-      <p:grpSpPr>
-        <a:xfrm>
-          <a:off x="0" y="0"/>
-          <a:ext cx="0" cy="0"/>
-          <a:chOff x="0" y="0"/>
-          <a:chExt cx="0" cy="0"/>
-        </a:xfrm>
-      </p:grpSpPr>
-      <p:sp>
-        <p:nvSpPr>
-          <p:cNvPr id="2" name="Slide Image Placeholder 1"/>
-          <p:cNvSpPr>
-            <a:spLocks noGrp="1" noRot="1" noChangeAspect="1"/>
-          </p:cNvSpPr>
-          <p:nvPr>
-            <p:ph type="sldImg"/>
-          </p:nvPr>
-        </p:nvSpPr>
-        <p:spPr/>
-      </p:sp>
-      <p:sp>
-        <p:nvSpPr>
-          <p:cNvPr id="3" name="Notes Placeholder 2"/>
-          <p:cNvSpPr>
-            <a:spLocks noGrp="1"/>
-          </p:cNvSpPr>
-          <p:nvPr>
-            <p:ph type="body" idx="1"/>
-          </p:nvPr>
-        </p:nvSpPr>
-        <p:spPr/>
-        <p:txBody>
-          <a:bodyPr/>
-          <a:lstStyle/>
-          <a:p>
-            <a:r>
-              <a:rPr lang="en-US" dirty="0"/>
-              <a:t/>
-            </a:r>
-            <a:endParaRPr lang="en-US" dirty="0"/>
-          </a:p>
-        </p:txBody>
-      </p:sp>
-      <p:sp>
-        <p:nvSpPr>
-          <p:cNvPr id="4" name="Slide Number Placeholder 3"/>
-          <p:cNvSpPr>
-            <a:spLocks noGrp="1"/>
-          </p:cNvSpPr>
-          <p:nvPr>
-            <p:ph type="sldNum" sz="quarter" idx="10"/>
-          </p:nvPr>
-        </p:nvSpPr>
-        <p:spPr/>
-        <p:txBody>
-          <a:bodyPr/>
-          <a:lstStyle/>
-          <a:p>
-            <a:fld id="{F7021451-1387-4CA6-816F-3879F97B5CBC}" type="slidenum">
-              <a:rPr lang="en-US"/>
-              <a:t>16</a:t>
-            </a:fld>
-            <a:endParaRPr lang="en-US"/>
-          </a:p>
-        </p:txBody>
-      </p:sp>
-    </p:spTree>
-    <p:extLst>
-      <p:ext uri="{BB962C8B-B14F-4D97-AF65-F5344CB8AC3E}">
-        <p14:creationId xmlns:p14="http://schemas.microsoft.com/office/powerpoint/2010/main" val="1024086991"/>
-      </p:ext>
-    </p:extLst>
-  </p:cSld>
-  <p:clrMapOvr>
-    <a:masterClrMapping/>
-  </p:clrMapOvr>
-</p:notes>
-</file>
-
 <file path=ppt/notesSlides/notesSlide2.xml><?xml version="1.0" encoding="utf-8"?>
 <p:notes xmlns:a="http://schemas.openxmlformats.org/drawingml/2006/main" xmlns:r="http://schemas.openxmlformats.org/officeDocument/2006/relationships" xmlns:p="http://schemas.openxmlformats.org/presentationml/2006/main">
   <p:cSld>
@@ -4842,7 +4664,7 @@
                 <a:ea typeface="Calibri" pitchFamily="34" charset="-122"/>
                 <a:cs typeface="Calibri" pitchFamily="34" charset="-120"/>
               </a:rPr>
-              <a:t>The reason recorded for every removal, state by state, with the list-level findings for Bihar and Hyderabad Old City</a:t>
+              <a:t>The reason recorded for every removal, state by state: women among the removed, and what goes with the removal rate</a:t>
             </a:r>
             <a:endParaRPr lang="en-US" sz="1700" dirty="0"/>
           </a:p>
@@ -12278,3098 +12100,6 @@
                 <a:ea typeface="Calibri" pitchFamily="34" charset="-122"/>
                 <a:cs typeface="Calibri" pitchFamily="34" charset="-120"/>
               </a:rPr>
-              <a:t>BIHAR, FROM THE LISTS</a:t>
-            </a:r>
-            <a:endParaRPr lang="en-US" sz="1100" dirty="0"/>
-          </a:p>
-        </p:txBody>
-      </p:sp>
-      <p:sp>
-        <p:nvSpPr>
-          <p:cNvPr id="3" name="Text 1"/>
-          <p:cNvSpPr txBox="1"/>
-          <p:nvPr/>
-        </p:nvSpPr>
-        <p:spPr>
-          <a:xfrm>
-            <a:off x="548640" y="530352"/>
-            <a:ext cx="11094415" cy="914400"/>
-          </a:xfrm>
-          <a:prstGeom prst="rect">
-            <a:avLst/>
-          </a:prstGeom>
-          <a:noFill/>
-          <a:ln/>
-        </p:spPr>
-        <p:txBody>
-          <a:bodyPr wrap="square" lIns="0" tIns="0" rIns="0" bIns="0" rtlCol="0" anchor="t">
-            <a:normAutofit/>
-          </a:bodyPr>
-          <a:lstStyle/>
-          <a:p>
-            <a:pPr indent="0" marL="0">
-              <a:buNone/>
-            </a:pPr>
-            <a:r>
-              <a:rPr lang="en-US" sz="2700" b="1" dirty="0">
-                <a:solidFill>
-                  <a:srgbClr val="1F4E79"/>
-                </a:solidFill>
-                <a:latin typeface="Cambria" pitchFamily="34" charset="0"/>
-                <a:ea typeface="Cambria" pitchFamily="34" charset="-122"/>
-                <a:cs typeface="Cambria" pitchFamily="34" charset="-120"/>
-              </a:rPr>
-              <a:t>In Bihar, more names were removed than the 2025 winning margin in 174 of 243 seats</a:t>
-            </a:r>
-            <a:endParaRPr lang="en-US" sz="2700" dirty="0"/>
-          </a:p>
-        </p:txBody>
-      </p:sp>
-      <p:sp>
-        <p:nvSpPr>
-          <p:cNvPr id="4" name="Text 2"/>
-          <p:cNvSpPr txBox="1"/>
-          <p:nvPr/>
-        </p:nvSpPr>
-        <p:spPr>
-          <a:xfrm>
-            <a:off x="548640" y="1463040"/>
-            <a:ext cx="11094415" cy="365760"/>
-          </a:xfrm>
-          <a:prstGeom prst="rect">
-            <a:avLst/>
-          </a:prstGeom>
-          <a:noFill/>
-          <a:ln/>
-        </p:spPr>
-        <p:txBody>
-          <a:bodyPr wrap="square" lIns="0" tIns="0" rIns="0" bIns="0" rtlCol="0" anchor="t"/>
-          <a:lstStyle/>
-          <a:p>
-            <a:pPr indent="0" marL="0">
-              <a:buNone/>
-            </a:pPr>
-            <a:r>
-              <a:rPr lang="en-US" sz="1400" dirty="0">
-                <a:solidFill>
-                  <a:srgbClr val="4D5B69"/>
-                </a:solidFill>
-                <a:latin typeface="Calibri" pitchFamily="34" charset="0"/>
-                <a:ea typeface="Calibri" pitchFamily="34" charset="-122"/>
-                <a:cs typeface="Calibri" pitchFamily="34" charset="-120"/>
-              </a:rPr>
-              <a:t>The one state where the deletion lists could be counted name by name</a:t>
-            </a:r>
-            <a:endParaRPr lang="en-US" sz="1400" dirty="0"/>
-          </a:p>
-        </p:txBody>
-      </p:sp>
-      <p:sp>
-        <p:nvSpPr>
-          <p:cNvPr id="5" name="Text 3"/>
-          <p:cNvSpPr txBox="1"/>
-          <p:nvPr/>
-        </p:nvSpPr>
-        <p:spPr>
-          <a:xfrm>
-            <a:off x="548640" y="6400800"/>
-            <a:ext cx="10180015" cy="274320"/>
-          </a:xfrm>
-          <a:prstGeom prst="rect">
-            <a:avLst/>
-          </a:prstGeom>
-          <a:noFill/>
-          <a:ln/>
-        </p:spPr>
-        <p:txBody>
-          <a:bodyPr wrap="square" lIns="0" tIns="0" rIns="0" bIns="0" rtlCol="0" anchor="ctr"/>
-          <a:lstStyle/>
-          <a:p>
-            <a:pPr indent="0" marL="0">
-              <a:buNone/>
-            </a:pPr>
-            <a:r>
-              <a:rPr lang="en-US" sz="900" dirty="0">
-                <a:solidFill>
-                  <a:srgbClr val="4D5B69"/>
-                </a:solidFill>
-                <a:latin typeface="Calibri" pitchFamily="34" charset="0"/>
-                <a:ea typeface="Calibri" pitchFamily="34" charset="-122"/>
-                <a:cs typeface="Calibri" pitchFamily="34" charset="-120"/>
-              </a:rPr>
-              <a:t>SIR 2025-26 · All India · Varna Sri Raman · aggregates only; no names or EPIC numbers</a:t>
-            </a:r>
-            <a:endParaRPr lang="en-US" sz="900" dirty="0"/>
-          </a:p>
-        </p:txBody>
-      </p:sp>
-      <p:sp>
-        <p:nvSpPr>
-          <p:cNvPr id="6" name="Text 4"/>
-          <p:cNvSpPr txBox="1"/>
-          <p:nvPr/>
-        </p:nvSpPr>
-        <p:spPr>
-          <a:xfrm>
-            <a:off x="10911535" y="6400800"/>
-            <a:ext cx="731520" cy="274320"/>
-          </a:xfrm>
-          <a:prstGeom prst="rect">
-            <a:avLst/>
-          </a:prstGeom>
-          <a:noFill/>
-          <a:ln/>
-        </p:spPr>
-        <p:txBody>
-          <a:bodyPr wrap="square" lIns="0" tIns="0" rIns="0" bIns="0" rtlCol="0" anchor="ctr"/>
-          <a:lstStyle/>
-          <a:p>
-            <a:pPr algn="r" indent="0" marL="0">
-              <a:buNone/>
-            </a:pPr>
-            <a:r>
-              <a:rPr lang="en-US" sz="900" dirty="0">
-                <a:solidFill>
-                  <a:srgbClr val="4D5B69"/>
-                </a:solidFill>
-                <a:latin typeface="Calibri" pitchFamily="34" charset="0"/>
-                <a:ea typeface="Calibri" pitchFamily="34" charset="-122"/>
-                <a:cs typeface="Calibri" pitchFamily="34" charset="-120"/>
-              </a:rPr>
-              <a:t>12</a:t>
-            </a:r>
-            <a:endParaRPr lang="en-US" sz="900" dirty="0"/>
-          </a:p>
-        </p:txBody>
-      </p:sp>
-      <p:sp>
-        <p:nvSpPr>
-          <p:cNvPr id="7" name="Shape 5"/>
-          <p:cNvSpPr/>
-          <p:nvPr/>
-        </p:nvSpPr>
-        <p:spPr>
-          <a:xfrm>
-            <a:off x="0" y="6748272"/>
-            <a:ext cx="304792" cy="109728"/>
-          </a:xfrm>
-          <a:prstGeom prst="rect">
-            <a:avLst/>
-          </a:prstGeom>
-          <a:solidFill>
-            <a:srgbClr val="C0392B"/>
-          </a:solidFill>
-          <a:ln/>
-        </p:spPr>
-      </p:sp>
-      <p:sp>
-        <p:nvSpPr>
-          <p:cNvPr id="8" name="Shape 6"/>
-          <p:cNvSpPr/>
-          <p:nvPr/>
-        </p:nvSpPr>
-        <p:spPr>
-          <a:xfrm>
-            <a:off x="304792" y="6748272"/>
-            <a:ext cx="304792" cy="109728"/>
-          </a:xfrm>
-          <a:prstGeom prst="rect">
-            <a:avLst/>
-          </a:prstGeom>
-          <a:solidFill>
-            <a:srgbClr val="E67E22"/>
-          </a:solidFill>
-          <a:ln/>
-        </p:spPr>
-      </p:sp>
-      <p:sp>
-        <p:nvSpPr>
-          <p:cNvPr id="9" name="Shape 7"/>
-          <p:cNvSpPr/>
-          <p:nvPr/>
-        </p:nvSpPr>
-        <p:spPr>
-          <a:xfrm>
-            <a:off x="609585" y="6748272"/>
-            <a:ext cx="304792" cy="109728"/>
-          </a:xfrm>
-          <a:prstGeom prst="rect">
-            <a:avLst/>
-          </a:prstGeom>
-          <a:solidFill>
-            <a:srgbClr val="27AE60"/>
-          </a:solidFill>
-          <a:ln/>
-        </p:spPr>
-      </p:sp>
-      <p:sp>
-        <p:nvSpPr>
-          <p:cNvPr id="10" name="Shape 8"/>
-          <p:cNvSpPr/>
-          <p:nvPr/>
-        </p:nvSpPr>
-        <p:spPr>
-          <a:xfrm>
-            <a:off x="914377" y="6748272"/>
-            <a:ext cx="304792" cy="109728"/>
-          </a:xfrm>
-          <a:prstGeom prst="rect">
-            <a:avLst/>
-          </a:prstGeom>
-          <a:solidFill>
-            <a:srgbClr val="1F618D"/>
-          </a:solidFill>
-          <a:ln/>
-        </p:spPr>
-      </p:sp>
-      <p:sp>
-        <p:nvSpPr>
-          <p:cNvPr id="11" name="Shape 9"/>
-          <p:cNvSpPr/>
-          <p:nvPr/>
-        </p:nvSpPr>
-        <p:spPr>
-          <a:xfrm>
-            <a:off x="1219170" y="6748272"/>
-            <a:ext cx="304792" cy="109728"/>
-          </a:xfrm>
-          <a:prstGeom prst="rect">
-            <a:avLst/>
-          </a:prstGeom>
-          <a:solidFill>
-            <a:srgbClr val="8E44AD"/>
-          </a:solidFill>
-          <a:ln/>
-        </p:spPr>
-      </p:sp>
-      <p:sp>
-        <p:nvSpPr>
-          <p:cNvPr id="12" name="Shape 10"/>
-          <p:cNvSpPr/>
-          <p:nvPr/>
-        </p:nvSpPr>
-        <p:spPr>
-          <a:xfrm>
-            <a:off x="1523962" y="6748272"/>
-            <a:ext cx="304792" cy="109728"/>
-          </a:xfrm>
-          <a:prstGeom prst="rect">
-            <a:avLst/>
-          </a:prstGeom>
-          <a:solidFill>
-            <a:srgbClr val="C0392B"/>
-          </a:solidFill>
-          <a:ln/>
-        </p:spPr>
-      </p:sp>
-      <p:sp>
-        <p:nvSpPr>
-          <p:cNvPr id="13" name="Shape 11"/>
-          <p:cNvSpPr/>
-          <p:nvPr/>
-        </p:nvSpPr>
-        <p:spPr>
-          <a:xfrm>
-            <a:off x="1828754" y="6748272"/>
-            <a:ext cx="304792" cy="109728"/>
-          </a:xfrm>
-          <a:prstGeom prst="rect">
-            <a:avLst/>
-          </a:prstGeom>
-          <a:solidFill>
-            <a:srgbClr val="E67E22"/>
-          </a:solidFill>
-          <a:ln/>
-        </p:spPr>
-      </p:sp>
-      <p:sp>
-        <p:nvSpPr>
-          <p:cNvPr id="14" name="Shape 12"/>
-          <p:cNvSpPr/>
-          <p:nvPr/>
-        </p:nvSpPr>
-        <p:spPr>
-          <a:xfrm>
-            <a:off x="2133547" y="6748272"/>
-            <a:ext cx="304792" cy="109728"/>
-          </a:xfrm>
-          <a:prstGeom prst="rect">
-            <a:avLst/>
-          </a:prstGeom>
-          <a:solidFill>
-            <a:srgbClr val="27AE60"/>
-          </a:solidFill>
-          <a:ln/>
-        </p:spPr>
-      </p:sp>
-      <p:sp>
-        <p:nvSpPr>
-          <p:cNvPr id="15" name="Shape 13"/>
-          <p:cNvSpPr/>
-          <p:nvPr/>
-        </p:nvSpPr>
-        <p:spPr>
-          <a:xfrm>
-            <a:off x="2438339" y="6748272"/>
-            <a:ext cx="304792" cy="109728"/>
-          </a:xfrm>
-          <a:prstGeom prst="rect">
-            <a:avLst/>
-          </a:prstGeom>
-          <a:solidFill>
-            <a:srgbClr val="1F618D"/>
-          </a:solidFill>
-          <a:ln/>
-        </p:spPr>
-      </p:sp>
-      <p:sp>
-        <p:nvSpPr>
-          <p:cNvPr id="16" name="Shape 14"/>
-          <p:cNvSpPr/>
-          <p:nvPr/>
-        </p:nvSpPr>
-        <p:spPr>
-          <a:xfrm>
-            <a:off x="2743131" y="6748272"/>
-            <a:ext cx="304792" cy="109728"/>
-          </a:xfrm>
-          <a:prstGeom prst="rect">
-            <a:avLst/>
-          </a:prstGeom>
-          <a:solidFill>
-            <a:srgbClr val="8E44AD"/>
-          </a:solidFill>
-          <a:ln/>
-        </p:spPr>
-      </p:sp>
-      <p:sp>
-        <p:nvSpPr>
-          <p:cNvPr id="17" name="Shape 15"/>
-          <p:cNvSpPr/>
-          <p:nvPr/>
-        </p:nvSpPr>
-        <p:spPr>
-          <a:xfrm>
-            <a:off x="3047924" y="6748272"/>
-            <a:ext cx="304792" cy="109728"/>
-          </a:xfrm>
-          <a:prstGeom prst="rect">
-            <a:avLst/>
-          </a:prstGeom>
-          <a:solidFill>
-            <a:srgbClr val="C0392B"/>
-          </a:solidFill>
-          <a:ln/>
-        </p:spPr>
-      </p:sp>
-      <p:sp>
-        <p:nvSpPr>
-          <p:cNvPr id="18" name="Shape 16"/>
-          <p:cNvSpPr/>
-          <p:nvPr/>
-        </p:nvSpPr>
-        <p:spPr>
-          <a:xfrm>
-            <a:off x="3352716" y="6748272"/>
-            <a:ext cx="304792" cy="109728"/>
-          </a:xfrm>
-          <a:prstGeom prst="rect">
-            <a:avLst/>
-          </a:prstGeom>
-          <a:solidFill>
-            <a:srgbClr val="E67E22"/>
-          </a:solidFill>
-          <a:ln/>
-        </p:spPr>
-      </p:sp>
-      <p:sp>
-        <p:nvSpPr>
-          <p:cNvPr id="19" name="Shape 17"/>
-          <p:cNvSpPr/>
-          <p:nvPr/>
-        </p:nvSpPr>
-        <p:spPr>
-          <a:xfrm>
-            <a:off x="3657509" y="6748272"/>
-            <a:ext cx="304792" cy="109728"/>
-          </a:xfrm>
-          <a:prstGeom prst="rect">
-            <a:avLst/>
-          </a:prstGeom>
-          <a:solidFill>
-            <a:srgbClr val="27AE60"/>
-          </a:solidFill>
-          <a:ln/>
-        </p:spPr>
-      </p:sp>
-      <p:sp>
-        <p:nvSpPr>
-          <p:cNvPr id="20" name="Shape 18"/>
-          <p:cNvSpPr/>
-          <p:nvPr/>
-        </p:nvSpPr>
-        <p:spPr>
-          <a:xfrm>
-            <a:off x="3962301" y="6748272"/>
-            <a:ext cx="304792" cy="109728"/>
-          </a:xfrm>
-          <a:prstGeom prst="rect">
-            <a:avLst/>
-          </a:prstGeom>
-          <a:solidFill>
-            <a:srgbClr val="1F618D"/>
-          </a:solidFill>
-          <a:ln/>
-        </p:spPr>
-      </p:sp>
-      <p:sp>
-        <p:nvSpPr>
-          <p:cNvPr id="21" name="Shape 19"/>
-          <p:cNvSpPr/>
-          <p:nvPr/>
-        </p:nvSpPr>
-        <p:spPr>
-          <a:xfrm>
-            <a:off x="4267093" y="6748272"/>
-            <a:ext cx="304792" cy="109728"/>
-          </a:xfrm>
-          <a:prstGeom prst="rect">
-            <a:avLst/>
-          </a:prstGeom>
-          <a:solidFill>
-            <a:srgbClr val="8E44AD"/>
-          </a:solidFill>
-          <a:ln/>
-        </p:spPr>
-      </p:sp>
-      <p:sp>
-        <p:nvSpPr>
-          <p:cNvPr id="22" name="Shape 20"/>
-          <p:cNvSpPr/>
-          <p:nvPr/>
-        </p:nvSpPr>
-        <p:spPr>
-          <a:xfrm>
-            <a:off x="4571886" y="6748272"/>
-            <a:ext cx="304792" cy="109728"/>
-          </a:xfrm>
-          <a:prstGeom prst="rect">
-            <a:avLst/>
-          </a:prstGeom>
-          <a:solidFill>
-            <a:srgbClr val="C0392B"/>
-          </a:solidFill>
-          <a:ln/>
-        </p:spPr>
-      </p:sp>
-      <p:sp>
-        <p:nvSpPr>
-          <p:cNvPr id="23" name="Shape 21"/>
-          <p:cNvSpPr/>
-          <p:nvPr/>
-        </p:nvSpPr>
-        <p:spPr>
-          <a:xfrm>
-            <a:off x="4876678" y="6748272"/>
-            <a:ext cx="304792" cy="109728"/>
-          </a:xfrm>
-          <a:prstGeom prst="rect">
-            <a:avLst/>
-          </a:prstGeom>
-          <a:solidFill>
-            <a:srgbClr val="E67E22"/>
-          </a:solidFill>
-          <a:ln/>
-        </p:spPr>
-      </p:sp>
-      <p:sp>
-        <p:nvSpPr>
-          <p:cNvPr id="24" name="Shape 22"/>
-          <p:cNvSpPr/>
-          <p:nvPr/>
-        </p:nvSpPr>
-        <p:spPr>
-          <a:xfrm>
-            <a:off x="5181470" y="6748272"/>
-            <a:ext cx="304792" cy="109728"/>
-          </a:xfrm>
-          <a:prstGeom prst="rect">
-            <a:avLst/>
-          </a:prstGeom>
-          <a:solidFill>
-            <a:srgbClr val="27AE60"/>
-          </a:solidFill>
-          <a:ln/>
-        </p:spPr>
-      </p:sp>
-      <p:sp>
-        <p:nvSpPr>
-          <p:cNvPr id="25" name="Shape 23"/>
-          <p:cNvSpPr/>
-          <p:nvPr/>
-        </p:nvSpPr>
-        <p:spPr>
-          <a:xfrm>
-            <a:off x="5486263" y="6748272"/>
-            <a:ext cx="304792" cy="109728"/>
-          </a:xfrm>
-          <a:prstGeom prst="rect">
-            <a:avLst/>
-          </a:prstGeom>
-          <a:solidFill>
-            <a:srgbClr val="1F618D"/>
-          </a:solidFill>
-          <a:ln/>
-        </p:spPr>
-      </p:sp>
-      <p:sp>
-        <p:nvSpPr>
-          <p:cNvPr id="26" name="Shape 24"/>
-          <p:cNvSpPr/>
-          <p:nvPr/>
-        </p:nvSpPr>
-        <p:spPr>
-          <a:xfrm>
-            <a:off x="5791055" y="6748272"/>
-            <a:ext cx="304792" cy="109728"/>
-          </a:xfrm>
-          <a:prstGeom prst="rect">
-            <a:avLst/>
-          </a:prstGeom>
-          <a:solidFill>
-            <a:srgbClr val="8E44AD"/>
-          </a:solidFill>
-          <a:ln/>
-        </p:spPr>
-      </p:sp>
-      <p:sp>
-        <p:nvSpPr>
-          <p:cNvPr id="27" name="Shape 25"/>
-          <p:cNvSpPr/>
-          <p:nvPr/>
-        </p:nvSpPr>
-        <p:spPr>
-          <a:xfrm>
-            <a:off x="6095848" y="6748272"/>
-            <a:ext cx="304792" cy="109728"/>
-          </a:xfrm>
-          <a:prstGeom prst="rect">
-            <a:avLst/>
-          </a:prstGeom>
-          <a:solidFill>
-            <a:srgbClr val="C0392B"/>
-          </a:solidFill>
-          <a:ln/>
-        </p:spPr>
-      </p:sp>
-      <p:sp>
-        <p:nvSpPr>
-          <p:cNvPr id="28" name="Shape 26"/>
-          <p:cNvSpPr/>
-          <p:nvPr/>
-        </p:nvSpPr>
-        <p:spPr>
-          <a:xfrm>
-            <a:off x="6400640" y="6748272"/>
-            <a:ext cx="304792" cy="109728"/>
-          </a:xfrm>
-          <a:prstGeom prst="rect">
-            <a:avLst/>
-          </a:prstGeom>
-          <a:solidFill>
-            <a:srgbClr val="E67E22"/>
-          </a:solidFill>
-          <a:ln/>
-        </p:spPr>
-      </p:sp>
-      <p:sp>
-        <p:nvSpPr>
-          <p:cNvPr id="29" name="Shape 27"/>
-          <p:cNvSpPr/>
-          <p:nvPr/>
-        </p:nvSpPr>
-        <p:spPr>
-          <a:xfrm>
-            <a:off x="6705432" y="6748272"/>
-            <a:ext cx="304792" cy="109728"/>
-          </a:xfrm>
-          <a:prstGeom prst="rect">
-            <a:avLst/>
-          </a:prstGeom>
-          <a:solidFill>
-            <a:srgbClr val="27AE60"/>
-          </a:solidFill>
-          <a:ln/>
-        </p:spPr>
-      </p:sp>
-      <p:sp>
-        <p:nvSpPr>
-          <p:cNvPr id="30" name="Shape 28"/>
-          <p:cNvSpPr/>
-          <p:nvPr/>
-        </p:nvSpPr>
-        <p:spPr>
-          <a:xfrm>
-            <a:off x="7010225" y="6748272"/>
-            <a:ext cx="304792" cy="109728"/>
-          </a:xfrm>
-          <a:prstGeom prst="rect">
-            <a:avLst/>
-          </a:prstGeom>
-          <a:solidFill>
-            <a:srgbClr val="1F618D"/>
-          </a:solidFill>
-          <a:ln/>
-        </p:spPr>
-      </p:sp>
-      <p:sp>
-        <p:nvSpPr>
-          <p:cNvPr id="31" name="Shape 29"/>
-          <p:cNvSpPr/>
-          <p:nvPr/>
-        </p:nvSpPr>
-        <p:spPr>
-          <a:xfrm>
-            <a:off x="7315017" y="6748272"/>
-            <a:ext cx="304792" cy="109728"/>
-          </a:xfrm>
-          <a:prstGeom prst="rect">
-            <a:avLst/>
-          </a:prstGeom>
-          <a:solidFill>
-            <a:srgbClr val="8E44AD"/>
-          </a:solidFill>
-          <a:ln/>
-        </p:spPr>
-      </p:sp>
-      <p:sp>
-        <p:nvSpPr>
-          <p:cNvPr id="32" name="Shape 30"/>
-          <p:cNvSpPr/>
-          <p:nvPr/>
-        </p:nvSpPr>
-        <p:spPr>
-          <a:xfrm>
-            <a:off x="7619809" y="6748272"/>
-            <a:ext cx="304792" cy="109728"/>
-          </a:xfrm>
-          <a:prstGeom prst="rect">
-            <a:avLst/>
-          </a:prstGeom>
-          <a:solidFill>
-            <a:srgbClr val="C0392B"/>
-          </a:solidFill>
-          <a:ln/>
-        </p:spPr>
-      </p:sp>
-      <p:sp>
-        <p:nvSpPr>
-          <p:cNvPr id="33" name="Shape 31"/>
-          <p:cNvSpPr/>
-          <p:nvPr/>
-        </p:nvSpPr>
-        <p:spPr>
-          <a:xfrm>
-            <a:off x="7924602" y="6748272"/>
-            <a:ext cx="304792" cy="109728"/>
-          </a:xfrm>
-          <a:prstGeom prst="rect">
-            <a:avLst/>
-          </a:prstGeom>
-          <a:solidFill>
-            <a:srgbClr val="E67E22"/>
-          </a:solidFill>
-          <a:ln/>
-        </p:spPr>
-      </p:sp>
-      <p:sp>
-        <p:nvSpPr>
-          <p:cNvPr id="34" name="Shape 32"/>
-          <p:cNvSpPr/>
-          <p:nvPr/>
-        </p:nvSpPr>
-        <p:spPr>
-          <a:xfrm>
-            <a:off x="8229394" y="6748272"/>
-            <a:ext cx="304792" cy="109728"/>
-          </a:xfrm>
-          <a:prstGeom prst="rect">
-            <a:avLst/>
-          </a:prstGeom>
-          <a:solidFill>
-            <a:srgbClr val="27AE60"/>
-          </a:solidFill>
-          <a:ln/>
-        </p:spPr>
-      </p:sp>
-      <p:sp>
-        <p:nvSpPr>
-          <p:cNvPr id="35" name="Shape 33"/>
-          <p:cNvSpPr/>
-          <p:nvPr/>
-        </p:nvSpPr>
-        <p:spPr>
-          <a:xfrm>
-            <a:off x="8534187" y="6748272"/>
-            <a:ext cx="304792" cy="109728"/>
-          </a:xfrm>
-          <a:prstGeom prst="rect">
-            <a:avLst/>
-          </a:prstGeom>
-          <a:solidFill>
-            <a:srgbClr val="1F618D"/>
-          </a:solidFill>
-          <a:ln/>
-        </p:spPr>
-      </p:sp>
-      <p:sp>
-        <p:nvSpPr>
-          <p:cNvPr id="36" name="Shape 34"/>
-          <p:cNvSpPr/>
-          <p:nvPr/>
-        </p:nvSpPr>
-        <p:spPr>
-          <a:xfrm>
-            <a:off x="8838979" y="6748272"/>
-            <a:ext cx="304792" cy="109728"/>
-          </a:xfrm>
-          <a:prstGeom prst="rect">
-            <a:avLst/>
-          </a:prstGeom>
-          <a:solidFill>
-            <a:srgbClr val="8E44AD"/>
-          </a:solidFill>
-          <a:ln/>
-        </p:spPr>
-      </p:sp>
-      <p:sp>
-        <p:nvSpPr>
-          <p:cNvPr id="37" name="Shape 35"/>
-          <p:cNvSpPr/>
-          <p:nvPr/>
-        </p:nvSpPr>
-        <p:spPr>
-          <a:xfrm>
-            <a:off x="9143771" y="6748272"/>
-            <a:ext cx="304792" cy="109728"/>
-          </a:xfrm>
-          <a:prstGeom prst="rect">
-            <a:avLst/>
-          </a:prstGeom>
-          <a:solidFill>
-            <a:srgbClr val="C0392B"/>
-          </a:solidFill>
-          <a:ln/>
-        </p:spPr>
-      </p:sp>
-      <p:sp>
-        <p:nvSpPr>
-          <p:cNvPr id="38" name="Shape 36"/>
-          <p:cNvSpPr/>
-          <p:nvPr/>
-        </p:nvSpPr>
-        <p:spPr>
-          <a:xfrm>
-            <a:off x="9448564" y="6748272"/>
-            <a:ext cx="304792" cy="109728"/>
-          </a:xfrm>
-          <a:prstGeom prst="rect">
-            <a:avLst/>
-          </a:prstGeom>
-          <a:solidFill>
-            <a:srgbClr val="E67E22"/>
-          </a:solidFill>
-          <a:ln/>
-        </p:spPr>
-      </p:sp>
-      <p:sp>
-        <p:nvSpPr>
-          <p:cNvPr id="39" name="Shape 37"/>
-          <p:cNvSpPr/>
-          <p:nvPr/>
-        </p:nvSpPr>
-        <p:spPr>
-          <a:xfrm>
-            <a:off x="9753356" y="6748272"/>
-            <a:ext cx="304792" cy="109728"/>
-          </a:xfrm>
-          <a:prstGeom prst="rect">
-            <a:avLst/>
-          </a:prstGeom>
-          <a:solidFill>
-            <a:srgbClr val="27AE60"/>
-          </a:solidFill>
-          <a:ln/>
-        </p:spPr>
-      </p:sp>
-      <p:sp>
-        <p:nvSpPr>
-          <p:cNvPr id="40" name="Shape 38"/>
-          <p:cNvSpPr/>
-          <p:nvPr/>
-        </p:nvSpPr>
-        <p:spPr>
-          <a:xfrm>
-            <a:off x="10058149" y="6748272"/>
-            <a:ext cx="304792" cy="109728"/>
-          </a:xfrm>
-          <a:prstGeom prst="rect">
-            <a:avLst/>
-          </a:prstGeom>
-          <a:solidFill>
-            <a:srgbClr val="1F618D"/>
-          </a:solidFill>
-          <a:ln/>
-        </p:spPr>
-      </p:sp>
-      <p:sp>
-        <p:nvSpPr>
-          <p:cNvPr id="41" name="Shape 39"/>
-          <p:cNvSpPr/>
-          <p:nvPr/>
-        </p:nvSpPr>
-        <p:spPr>
-          <a:xfrm>
-            <a:off x="10362941" y="6748272"/>
-            <a:ext cx="304792" cy="109728"/>
-          </a:xfrm>
-          <a:prstGeom prst="rect">
-            <a:avLst/>
-          </a:prstGeom>
-          <a:solidFill>
-            <a:srgbClr val="8E44AD"/>
-          </a:solidFill>
-          <a:ln/>
-        </p:spPr>
-      </p:sp>
-      <p:sp>
-        <p:nvSpPr>
-          <p:cNvPr id="42" name="Shape 40"/>
-          <p:cNvSpPr/>
-          <p:nvPr/>
-        </p:nvSpPr>
-        <p:spPr>
-          <a:xfrm>
-            <a:off x="10667733" y="6748272"/>
-            <a:ext cx="304792" cy="109728"/>
-          </a:xfrm>
-          <a:prstGeom prst="rect">
-            <a:avLst/>
-          </a:prstGeom>
-          <a:solidFill>
-            <a:srgbClr val="C0392B"/>
-          </a:solidFill>
-          <a:ln/>
-        </p:spPr>
-      </p:sp>
-      <p:sp>
-        <p:nvSpPr>
-          <p:cNvPr id="43" name="Shape 41"/>
-          <p:cNvSpPr/>
-          <p:nvPr/>
-        </p:nvSpPr>
-        <p:spPr>
-          <a:xfrm>
-            <a:off x="10972526" y="6748272"/>
-            <a:ext cx="304792" cy="109728"/>
-          </a:xfrm>
-          <a:prstGeom prst="rect">
-            <a:avLst/>
-          </a:prstGeom>
-          <a:solidFill>
-            <a:srgbClr val="E67E22"/>
-          </a:solidFill>
-          <a:ln/>
-        </p:spPr>
-      </p:sp>
-      <p:sp>
-        <p:nvSpPr>
-          <p:cNvPr id="44" name="Shape 42"/>
-          <p:cNvSpPr/>
-          <p:nvPr/>
-        </p:nvSpPr>
-        <p:spPr>
-          <a:xfrm>
-            <a:off x="11277318" y="6748272"/>
-            <a:ext cx="304792" cy="109728"/>
-          </a:xfrm>
-          <a:prstGeom prst="rect">
-            <a:avLst/>
-          </a:prstGeom>
-          <a:solidFill>
-            <a:srgbClr val="27AE60"/>
-          </a:solidFill>
-          <a:ln/>
-        </p:spPr>
-      </p:sp>
-      <p:sp>
-        <p:nvSpPr>
-          <p:cNvPr id="45" name="Shape 43"/>
-          <p:cNvSpPr/>
-          <p:nvPr/>
-        </p:nvSpPr>
-        <p:spPr>
-          <a:xfrm>
-            <a:off x="11582110" y="6748272"/>
-            <a:ext cx="304792" cy="109728"/>
-          </a:xfrm>
-          <a:prstGeom prst="rect">
-            <a:avLst/>
-          </a:prstGeom>
-          <a:solidFill>
-            <a:srgbClr val="1F618D"/>
-          </a:solidFill>
-          <a:ln/>
-        </p:spPr>
-      </p:sp>
-      <p:sp>
-        <p:nvSpPr>
-          <p:cNvPr id="46" name="Shape 44"/>
-          <p:cNvSpPr/>
-          <p:nvPr/>
-        </p:nvSpPr>
-        <p:spPr>
-          <a:xfrm>
-            <a:off x="11886903" y="6748272"/>
-            <a:ext cx="304792" cy="109728"/>
-          </a:xfrm>
-          <a:prstGeom prst="rect">
-            <a:avLst/>
-          </a:prstGeom>
-          <a:solidFill>
-            <a:srgbClr val="8E44AD"/>
-          </a:solidFill>
-          <a:ln/>
-        </p:spPr>
-      </p:sp>
-      <p:sp>
-        <p:nvSpPr>
-          <p:cNvPr id="47" name="Shape 45"/>
-          <p:cNvSpPr/>
-          <p:nvPr/>
-        </p:nvSpPr>
-        <p:spPr>
-          <a:xfrm>
-            <a:off x="548640" y="1920240"/>
-            <a:ext cx="2602154" cy="1554480"/>
-          </a:xfrm>
-          <a:prstGeom prst="roundRect">
-            <a:avLst>
-              <a:gd name="adj" fmla="val 4706"/>
-            </a:avLst>
-          </a:prstGeom>
-          <a:solidFill>
-            <a:srgbClr val="F4F6F7"/>
-          </a:solidFill>
-          <a:ln/>
-        </p:spPr>
-      </p:sp>
-      <p:sp>
-        <p:nvSpPr>
-          <p:cNvPr id="48" name="Text 46"/>
-          <p:cNvSpPr txBox="1"/>
-          <p:nvPr/>
-        </p:nvSpPr>
-        <p:spPr>
-          <a:xfrm>
-            <a:off x="731520" y="2029968"/>
-            <a:ext cx="2236394" cy="746150"/>
-          </a:xfrm>
-          <a:prstGeom prst="rect">
-            <a:avLst/>
-          </a:prstGeom>
-          <a:noFill/>
-          <a:ln/>
-        </p:spPr>
-        <p:txBody>
-          <a:bodyPr wrap="square" lIns="0" tIns="0" rIns="0" bIns="0" rtlCol="0" anchor="b">
-            <a:normAutofit/>
-          </a:bodyPr>
-          <a:lstStyle/>
-          <a:p>
-            <a:pPr indent="0" marL="0">
-              <a:buNone/>
-            </a:pPr>
-            <a:r>
-              <a:rPr lang="en-US" sz="2800" b="1" dirty="0">
-                <a:solidFill>
-                  <a:srgbClr val="1F618D"/>
-                </a:solidFill>
-                <a:latin typeface="Cambria" pitchFamily="34" charset="0"/>
-                <a:ea typeface="Cambria" pitchFamily="34" charset="-122"/>
-                <a:cs typeface="Cambria" pitchFamily="34" charset="-120"/>
-              </a:rPr>
-              <a:t>69,10,559</a:t>
-            </a:r>
-            <a:endParaRPr lang="en-US" sz="2800" dirty="0"/>
-          </a:p>
-        </p:txBody>
-      </p:sp>
-      <p:sp>
-        <p:nvSpPr>
-          <p:cNvPr id="49" name="Text 47"/>
-          <p:cNvSpPr txBox="1"/>
-          <p:nvPr/>
-        </p:nvSpPr>
-        <p:spPr>
-          <a:xfrm>
-            <a:off x="731520" y="2794406"/>
-            <a:ext cx="2236394" cy="588874"/>
-          </a:xfrm>
-          <a:prstGeom prst="rect">
-            <a:avLst/>
-          </a:prstGeom>
-          <a:noFill/>
-          <a:ln/>
-        </p:spPr>
-        <p:txBody>
-          <a:bodyPr wrap="square" lIns="0" tIns="0" rIns="0" bIns="0" rtlCol="0" anchor="t">
-            <a:normAutofit/>
-          </a:bodyPr>
-          <a:lstStyle/>
-          <a:p>
-            <a:pPr indent="0" marL="0">
-              <a:buNone/>
-            </a:pPr>
-            <a:r>
-              <a:rPr lang="en-US" sz="1200" dirty="0">
-                <a:solidFill>
-                  <a:srgbClr val="4D5B69"/>
-                </a:solidFill>
-                <a:latin typeface="Calibri" pitchFamily="34" charset="0"/>
-                <a:ea typeface="Calibri" pitchFamily="34" charset="-122"/>
-                <a:cs typeface="Calibri" pitchFamily="34" charset="-120"/>
-              </a:rPr>
-              <a:t>names removed, both phases</a:t>
-            </a:r>
-            <a:endParaRPr lang="en-US" sz="1200" dirty="0"/>
-          </a:p>
-        </p:txBody>
-      </p:sp>
-      <p:sp>
-        <p:nvSpPr>
-          <p:cNvPr id="50" name="Shape 48"/>
-          <p:cNvSpPr/>
-          <p:nvPr/>
-        </p:nvSpPr>
-        <p:spPr>
-          <a:xfrm>
-            <a:off x="3379394" y="1920240"/>
-            <a:ext cx="2602154" cy="1554480"/>
-          </a:xfrm>
-          <a:prstGeom prst="roundRect">
-            <a:avLst>
-              <a:gd name="adj" fmla="val 4706"/>
-            </a:avLst>
-          </a:prstGeom>
-          <a:solidFill>
-            <a:srgbClr val="F4F6F7"/>
-          </a:solidFill>
-          <a:ln/>
-        </p:spPr>
-      </p:sp>
-      <p:sp>
-        <p:nvSpPr>
-          <p:cNvPr id="51" name="Text 49"/>
-          <p:cNvSpPr txBox="1"/>
-          <p:nvPr/>
-        </p:nvSpPr>
-        <p:spPr>
-          <a:xfrm>
-            <a:off x="3562274" y="2029968"/>
-            <a:ext cx="2236394" cy="746150"/>
-          </a:xfrm>
-          <a:prstGeom prst="rect">
-            <a:avLst/>
-          </a:prstGeom>
-          <a:noFill/>
-          <a:ln/>
-        </p:spPr>
-        <p:txBody>
-          <a:bodyPr wrap="square" lIns="0" tIns="0" rIns="0" bIns="0" rtlCol="0" anchor="b">
-            <a:normAutofit/>
-          </a:bodyPr>
-          <a:lstStyle/>
-          <a:p>
-            <a:pPr indent="0" marL="0">
-              <a:buNone/>
-            </a:pPr>
-            <a:r>
-              <a:rPr lang="en-US" sz="2800" b="1" dirty="0">
-                <a:solidFill>
-                  <a:srgbClr val="1F618D"/>
-                </a:solidFill>
-                <a:latin typeface="Cambria" pitchFamily="34" charset="0"/>
-                <a:ea typeface="Cambria" pitchFamily="34" charset="-122"/>
-                <a:cs typeface="Cambria" pitchFamily="34" charset="-120"/>
-              </a:rPr>
-              <a:t>174 of 243</a:t>
-            </a:r>
-            <a:endParaRPr lang="en-US" sz="2800" dirty="0"/>
-          </a:p>
-        </p:txBody>
-      </p:sp>
-      <p:sp>
-        <p:nvSpPr>
-          <p:cNvPr id="52" name="Text 50"/>
-          <p:cNvSpPr txBox="1"/>
-          <p:nvPr/>
-        </p:nvSpPr>
-        <p:spPr>
-          <a:xfrm>
-            <a:off x="3562274" y="2794406"/>
-            <a:ext cx="2236394" cy="588874"/>
-          </a:xfrm>
-          <a:prstGeom prst="rect">
-            <a:avLst/>
-          </a:prstGeom>
-          <a:noFill/>
-          <a:ln/>
-        </p:spPr>
-        <p:txBody>
-          <a:bodyPr wrap="square" lIns="0" tIns="0" rIns="0" bIns="0" rtlCol="0" anchor="t">
-            <a:normAutofit/>
-          </a:bodyPr>
-          <a:lstStyle/>
-          <a:p>
-            <a:pPr indent="0" marL="0">
-              <a:buNone/>
-            </a:pPr>
-            <a:r>
-              <a:rPr lang="en-US" sz="1200" dirty="0">
-                <a:solidFill>
-                  <a:srgbClr val="4D5B69"/>
-                </a:solidFill>
-                <a:latin typeface="Calibri" pitchFamily="34" charset="0"/>
-                <a:ea typeface="Calibri" pitchFamily="34" charset="-122"/>
-                <a:cs typeface="Calibri" pitchFamily="34" charset="-120"/>
-              </a:rPr>
-              <a:t>seats where removals exceed the margin</a:t>
-            </a:r>
-            <a:endParaRPr lang="en-US" sz="1200" dirty="0"/>
-          </a:p>
-        </p:txBody>
-      </p:sp>
-      <p:sp>
-        <p:nvSpPr>
-          <p:cNvPr id="53" name="Shape 51"/>
-          <p:cNvSpPr/>
-          <p:nvPr/>
-        </p:nvSpPr>
-        <p:spPr>
-          <a:xfrm>
-            <a:off x="6210148" y="1920240"/>
-            <a:ext cx="2602154" cy="1554480"/>
-          </a:xfrm>
-          <a:prstGeom prst="roundRect">
-            <a:avLst>
-              <a:gd name="adj" fmla="val 4706"/>
-            </a:avLst>
-          </a:prstGeom>
-          <a:solidFill>
-            <a:srgbClr val="F4F6F7"/>
-          </a:solidFill>
-          <a:ln/>
-        </p:spPr>
-      </p:sp>
-      <p:sp>
-        <p:nvSpPr>
-          <p:cNvPr id="54" name="Text 52"/>
-          <p:cNvSpPr txBox="1"/>
-          <p:nvPr/>
-        </p:nvSpPr>
-        <p:spPr>
-          <a:xfrm>
-            <a:off x="6393028" y="2029968"/>
-            <a:ext cx="2236394" cy="746150"/>
-          </a:xfrm>
-          <a:prstGeom prst="rect">
-            <a:avLst/>
-          </a:prstGeom>
-          <a:noFill/>
-          <a:ln/>
-        </p:spPr>
-        <p:txBody>
-          <a:bodyPr wrap="square" lIns="0" tIns="0" rIns="0" bIns="0" rtlCol="0" anchor="b">
-            <a:normAutofit/>
-          </a:bodyPr>
-          <a:lstStyle/>
-          <a:p>
-            <a:pPr indent="0" marL="0">
-              <a:buNone/>
-            </a:pPr>
-            <a:r>
-              <a:rPr lang="en-US" sz="2800" b="1" dirty="0">
-                <a:solidFill>
-                  <a:srgbClr val="1F618D"/>
-                </a:solidFill>
-                <a:latin typeface="Cambria" pitchFamily="34" charset="0"/>
-                <a:ea typeface="Cambria" pitchFamily="34" charset="-122"/>
-                <a:cs typeface="Cambria" pitchFamily="34" charset="-120"/>
-              </a:rPr>
-              <a:t>55.5%</a:t>
-            </a:r>
-            <a:endParaRPr lang="en-US" sz="2800" dirty="0"/>
-          </a:p>
-        </p:txBody>
-      </p:sp>
-      <p:sp>
-        <p:nvSpPr>
-          <p:cNvPr id="55" name="Text 53"/>
-          <p:cNvSpPr txBox="1"/>
-          <p:nvPr/>
-        </p:nvSpPr>
-        <p:spPr>
-          <a:xfrm>
-            <a:off x="6393028" y="2794406"/>
-            <a:ext cx="2236394" cy="588874"/>
-          </a:xfrm>
-          <a:prstGeom prst="rect">
-            <a:avLst/>
-          </a:prstGeom>
-          <a:noFill/>
-          <a:ln/>
-        </p:spPr>
-        <p:txBody>
-          <a:bodyPr wrap="square" lIns="0" tIns="0" rIns="0" bIns="0" rtlCol="0" anchor="t">
-            <a:normAutofit/>
-          </a:bodyPr>
-          <a:lstStyle/>
-          <a:p>
-            <a:pPr indent="0" marL="0">
-              <a:buNone/>
-            </a:pPr>
-            <a:r>
-              <a:rPr lang="en-US" sz="1200" dirty="0">
-                <a:solidFill>
-                  <a:srgbClr val="4D5B69"/>
-                </a:solidFill>
-                <a:latin typeface="Calibri" pitchFamily="34" charset="0"/>
-                <a:ea typeface="Calibri" pitchFamily="34" charset="-122"/>
-                <a:cs typeface="Calibri" pitchFamily="34" charset="-120"/>
-              </a:rPr>
-              <a:t>of the removed are women</a:t>
-            </a:r>
-            <a:endParaRPr lang="en-US" sz="1200" dirty="0"/>
-          </a:p>
-        </p:txBody>
-      </p:sp>
-      <p:sp>
-        <p:nvSpPr>
-          <p:cNvPr id="56" name="Shape 54"/>
-          <p:cNvSpPr/>
-          <p:nvPr/>
-        </p:nvSpPr>
-        <p:spPr>
-          <a:xfrm>
-            <a:off x="9040901" y="1920240"/>
-            <a:ext cx="2602154" cy="1554480"/>
-          </a:xfrm>
-          <a:prstGeom prst="roundRect">
-            <a:avLst>
-              <a:gd name="adj" fmla="val 4706"/>
-            </a:avLst>
-          </a:prstGeom>
-          <a:solidFill>
-            <a:srgbClr val="F4F6F7"/>
-          </a:solidFill>
-          <a:ln/>
-        </p:spPr>
-      </p:sp>
-      <p:sp>
-        <p:nvSpPr>
-          <p:cNvPr id="57" name="Text 55"/>
-          <p:cNvSpPr txBox="1"/>
-          <p:nvPr/>
-        </p:nvSpPr>
-        <p:spPr>
-          <a:xfrm>
-            <a:off x="9223781" y="2029968"/>
-            <a:ext cx="2236394" cy="746150"/>
-          </a:xfrm>
-          <a:prstGeom prst="rect">
-            <a:avLst/>
-          </a:prstGeom>
-          <a:noFill/>
-          <a:ln/>
-        </p:spPr>
-        <p:txBody>
-          <a:bodyPr wrap="square" lIns="0" tIns="0" rIns="0" bIns="0" rtlCol="0" anchor="b">
-            <a:normAutofit/>
-          </a:bodyPr>
-          <a:lstStyle/>
-          <a:p>
-            <a:pPr indent="0" marL="0">
-              <a:buNone/>
-            </a:pPr>
-            <a:r>
-              <a:rPr lang="en-US" sz="2800" b="1" dirty="0">
-                <a:solidFill>
-                  <a:srgbClr val="1F618D"/>
-                </a:solidFill>
-                <a:latin typeface="Cambria" pitchFamily="34" charset="0"/>
-                <a:ea typeface="Cambria" pitchFamily="34" charset="-122"/>
-                <a:cs typeface="Cambria" pitchFamily="34" charset="-120"/>
-              </a:rPr>
-              <a:t>20 seats</a:t>
-            </a:r>
-            <a:endParaRPr lang="en-US" sz="2800" dirty="0"/>
-          </a:p>
-        </p:txBody>
-      </p:sp>
-      <p:sp>
-        <p:nvSpPr>
-          <p:cNvPr id="58" name="Text 56"/>
-          <p:cNvSpPr txBox="1"/>
-          <p:nvPr/>
-        </p:nvSpPr>
-        <p:spPr>
-          <a:xfrm>
-            <a:off x="9223781" y="2794406"/>
-            <a:ext cx="2236394" cy="588874"/>
-          </a:xfrm>
-          <a:prstGeom prst="rect">
-            <a:avLst/>
-          </a:prstGeom>
-          <a:noFill/>
-          <a:ln/>
-        </p:spPr>
-        <p:txBody>
-          <a:bodyPr wrap="square" lIns="0" tIns="0" rIns="0" bIns="0" rtlCol="0" anchor="t">
-            <a:normAutofit/>
-          </a:bodyPr>
-          <a:lstStyle/>
-          <a:p>
-            <a:pPr indent="0" marL="0">
-              <a:buNone/>
-            </a:pPr>
-            <a:r>
-              <a:rPr lang="en-US" sz="1200" dirty="0">
-                <a:solidFill>
-                  <a:srgbClr val="4D5B69"/>
-                </a:solidFill>
-                <a:latin typeface="Calibri" pitchFamily="34" charset="0"/>
-                <a:ea typeface="Calibri" pitchFamily="34" charset="-122"/>
-                <a:cs typeface="Calibri" pitchFamily="34" charset="-120"/>
-              </a:rPr>
-              <a:t>where names marked absent alone exceed the margin</a:t>
-            </a:r>
-            <a:endParaRPr lang="en-US" sz="1200" dirty="0"/>
-          </a:p>
-        </p:txBody>
-      </p:sp>
-      <p:sp>
-        <p:nvSpPr>
-          <p:cNvPr id="59" name="Text 57"/>
-          <p:cNvSpPr txBox="1"/>
-          <p:nvPr/>
-        </p:nvSpPr>
-        <p:spPr>
-          <a:xfrm>
-            <a:off x="548640" y="3840480"/>
-            <a:ext cx="11094415" cy="2377440"/>
-          </a:xfrm>
-          <a:prstGeom prst="rect">
-            <a:avLst/>
-          </a:prstGeom>
-          <a:noFill/>
-          <a:ln/>
-        </p:spPr>
-        <p:txBody>
-          <a:bodyPr wrap="square" lIns="0" tIns="0" rIns="0" bIns="0" rtlCol="0" anchor="t">
-            <a:normAutofit/>
-          </a:bodyPr>
-          <a:lstStyle/>
-          <a:p>
-            <a:pPr marL="342900" indent="-342900">
-              <a:spcAft>
-                <a:spcPts val="800"/>
-              </a:spcAft>
-              <a:buSzPct val="100000"/>
-              <a:buChar char="•"/>
-            </a:pPr>
-            <a:r>
-              <a:rPr lang="en-US" sz="1500" dirty="0">
-                <a:solidFill>
-                  <a:srgbClr val="1C2833"/>
-                </a:solidFill>
-                <a:latin typeface="Calibri" pitchFamily="34" charset="0"/>
-                <a:ea typeface="Calibri" pitchFamily="34" charset="-122"/>
-                <a:cs typeface="Calibri" pitchFamily="34" charset="-120"/>
-              </a:rPr>
-              <a:t>Phase 1 reasons: shifted 40.5%, dead 34.0%, absent 14.8%, already enrolled 10.7%.</a:t>
-            </a:r>
-            <a:endParaRPr lang="en-US" sz="1500" dirty="0"/>
-          </a:p>
-          <a:p>
-            <a:pPr marL="342900" indent="-342900">
-              <a:spcAft>
-                <a:spcPts val="800"/>
-              </a:spcAft>
-              <a:buSzPct val="100000"/>
-              <a:buChar char="•"/>
-            </a:pPr>
-            <a:r>
-              <a:rPr lang="en-US" sz="1500" dirty="0">
-                <a:solidFill>
-                  <a:srgbClr val="1C2833"/>
-                </a:solidFill>
-                <a:latin typeface="Calibri" pitchFamily="34" charset="0"/>
-                <a:ea typeface="Calibri" pitchFamily="34" charset="-122"/>
-                <a:cs typeface="Calibri" pitchFamily="34" charset="-120"/>
-              </a:rPr>
-              <a:t>5,64,439 of the 7,20,543 more women than men removed in phase 1 were entered as shifted; 72.6% of those marked shifted aged 18 to 29 are women.</a:t>
-            </a:r>
-            <a:endParaRPr lang="en-US" sz="1500" dirty="0"/>
-          </a:p>
-          <a:p>
-            <a:pPr marL="342900" indent="-342900">
-              <a:spcAft>
-                <a:spcPts val="800"/>
-              </a:spcAft>
-              <a:buSzPct val="100000"/>
-              <a:buChar char="•"/>
-            </a:pPr>
-            <a:r>
-              <a:rPr lang="en-US" sz="1500" dirty="0">
-                <a:solidFill>
-                  <a:srgbClr val="1C2833"/>
-                </a:solidFill>
-                <a:latin typeface="Calibri" pitchFamily="34" charset="0"/>
-                <a:ea typeface="Calibri" pitchFamily="34" charset="-122"/>
-                <a:cs typeface="Calibri" pitchFamily="34" charset="-120"/>
-              </a:rPr>
-              <a:t>NDA seats lost 9.58 names per 100 electors against 8.79 in INDIA seats, by the 2020 winner.</a:t>
-            </a:r>
-            <a:endParaRPr lang="en-US" sz="1500" dirty="0"/>
-          </a:p>
-          <a:p>
-            <a:pPr marL="342900" indent="-342900">
-              <a:spcAft>
-                <a:spcPts val="800"/>
-              </a:spcAft>
-              <a:buSzPct val="100000"/>
-              <a:buChar char="•"/>
-            </a:pPr>
-            <a:r>
-              <a:rPr lang="en-US" sz="1500" dirty="0">
-                <a:solidFill>
-                  <a:srgbClr val="1C2833"/>
-                </a:solidFill>
-                <a:latin typeface="Calibri" pitchFamily="34" charset="0"/>
-                <a:ea typeface="Calibri" pitchFamily="34" charset="-122"/>
-                <a:cs typeface="Calibri" pitchFamily="34" charset="-120"/>
-              </a:rPr>
-              <a:t>The full Bihar report and deck, with a chapter for each district, are published separately.</a:t>
-            </a:r>
-            <a:endParaRPr lang="en-US" sz="1500" dirty="0"/>
-          </a:p>
-        </p:txBody>
-      </p:sp>
-    </p:spTree>
-  </p:cSld>
-  <p:clrMapOvr>
-    <a:masterClrMapping/>
-  </p:clrMapOvr>
-</p:sld>
-</file>
-
-<file path=ppt/slides/slide13.xml><?xml version="1.0" encoding="utf-8"?>
-<p:sld xmlns:a="http://schemas.openxmlformats.org/drawingml/2006/main" xmlns:r="http://schemas.openxmlformats.org/officeDocument/2006/relationships" xmlns:p="http://schemas.openxmlformats.org/presentationml/2006/main">
-  <p:cSld name="Slide 13">
-    <p:spTree>
-      <p:nvGrpSpPr>
-        <p:cNvPr id="1" name=""/>
-        <p:cNvGrpSpPr/>
-        <p:nvPr/>
-      </p:nvGrpSpPr>
-      <p:grpSpPr>
-        <a:xfrm>
-          <a:off x="0" y="0"/>
-          <a:ext cx="0" cy="0"/>
-          <a:chOff x="0" y="0"/>
-          <a:chExt cx="0" cy="0"/>
-        </a:xfrm>
-      </p:grpSpPr>
-      <p:sp>
-        <p:nvSpPr>
-          <p:cNvPr id="2" name="Text 0"/>
-          <p:cNvSpPr txBox="1"/>
-          <p:nvPr/>
-        </p:nvSpPr>
-        <p:spPr>
-          <a:xfrm>
-            <a:off x="548640" y="256032"/>
-            <a:ext cx="11094415" cy="274320"/>
-          </a:xfrm>
-          <a:prstGeom prst="rect">
-            <a:avLst/>
-          </a:prstGeom>
-          <a:noFill/>
-          <a:ln/>
-        </p:spPr>
-        <p:txBody>
-          <a:bodyPr wrap="square" lIns="0" tIns="0" rIns="0" bIns="0" rtlCol="0" anchor="ctr"/>
-          <a:lstStyle/>
-          <a:p>
-            <a:pPr indent="0" marL="0">
-              <a:buNone/>
-            </a:pPr>
-            <a:r>
-              <a:rPr lang="en-US" sz="1100" b="1" spc="200" kern="0" dirty="0">
-                <a:solidFill>
-                  <a:srgbClr val="1F618D"/>
-                </a:solidFill>
-                <a:latin typeface="Calibri" pitchFamily="34" charset="0"/>
-                <a:ea typeface="Calibri" pitchFamily="34" charset="-122"/>
-                <a:cs typeface="Calibri" pitchFamily="34" charset="-120"/>
-              </a:rPr>
-              <a:t>HYDERABAD OLD CITY, FROM THE LISTS</a:t>
-            </a:r>
-            <a:endParaRPr lang="en-US" sz="1100" dirty="0"/>
-          </a:p>
-        </p:txBody>
-      </p:sp>
-      <p:sp>
-        <p:nvSpPr>
-          <p:cNvPr id="3" name="Text 1"/>
-          <p:cNvSpPr txBox="1"/>
-          <p:nvPr/>
-        </p:nvSpPr>
-        <p:spPr>
-          <a:xfrm>
-            <a:off x="548640" y="530352"/>
-            <a:ext cx="11094415" cy="914400"/>
-          </a:xfrm>
-          <a:prstGeom prst="rect">
-            <a:avLst/>
-          </a:prstGeom>
-          <a:noFill/>
-          <a:ln/>
-        </p:spPr>
-        <p:txBody>
-          <a:bodyPr wrap="square" lIns="0" tIns="0" rIns="0" bIns="0" rtlCol="0" anchor="t">
-            <a:normAutofit/>
-          </a:bodyPr>
-          <a:lstStyle/>
-          <a:p>
-            <a:pPr indent="0" marL="0">
-              <a:buNone/>
-            </a:pPr>
-            <a:r>
-              <a:rPr lang="en-US" sz="2700" b="1" dirty="0">
-                <a:solidFill>
-                  <a:srgbClr val="1F4E79"/>
-                </a:solidFill>
-                <a:latin typeface="Cambria" pitchFamily="34" charset="0"/>
-                <a:ea typeface="Cambria" pitchFamily="34" charset="-122"/>
-                <a:cs typeface="Cambria" pitchFamily="34" charset="-120"/>
-              </a:rPr>
-              <a:t>40% of electors in five Old City seats were struck off, more than the 2023 margin in all 5</a:t>
-            </a:r>
-            <a:endParaRPr lang="en-US" sz="2700" dirty="0"/>
-          </a:p>
-        </p:txBody>
-      </p:sp>
-      <p:sp>
-        <p:nvSpPr>
-          <p:cNvPr id="4" name="Text 2"/>
-          <p:cNvSpPr txBox="1"/>
-          <p:nvPr/>
-        </p:nvSpPr>
-        <p:spPr>
-          <a:xfrm>
-            <a:off x="548640" y="1463040"/>
-            <a:ext cx="11094415" cy="365760"/>
-          </a:xfrm>
-          <a:prstGeom prst="rect">
-            <a:avLst/>
-          </a:prstGeom>
-          <a:noFill/>
-          <a:ln/>
-        </p:spPr>
-        <p:txBody>
-          <a:bodyPr wrap="square" lIns="0" tIns="0" rIns="0" bIns="0" rtlCol="0" anchor="t"/>
-          <a:lstStyle/>
-          <a:p>
-            <a:pPr indent="0" marL="0">
-              <a:buNone/>
-            </a:pPr>
-            <a:r>
-              <a:rPr lang="en-US" sz="1400" dirty="0">
-                <a:solidFill>
-                  <a:srgbClr val="4D5B69"/>
-                </a:solidFill>
-                <a:latin typeface="Calibri" pitchFamily="34" charset="0"/>
-                <a:ea typeface="Calibri" pitchFamily="34" charset="-122"/>
-                <a:cs typeface="Calibri" pitchFamily="34" charset="-120"/>
-              </a:rPr>
-              <a:t>Charminar, Yakutpura, Malakpet, Chandrayangutta and Bahadurpura; the lists hold every elector, so each group has a true rate</a:t>
-            </a:r>
-            <a:endParaRPr lang="en-US" sz="1400" dirty="0"/>
-          </a:p>
-        </p:txBody>
-      </p:sp>
-      <p:sp>
-        <p:nvSpPr>
-          <p:cNvPr id="5" name="Text 3"/>
-          <p:cNvSpPr txBox="1"/>
-          <p:nvPr/>
-        </p:nvSpPr>
-        <p:spPr>
-          <a:xfrm>
-            <a:off x="548640" y="6400800"/>
-            <a:ext cx="10180015" cy="274320"/>
-          </a:xfrm>
-          <a:prstGeom prst="rect">
-            <a:avLst/>
-          </a:prstGeom>
-          <a:noFill/>
-          <a:ln/>
-        </p:spPr>
-        <p:txBody>
-          <a:bodyPr wrap="square" lIns="0" tIns="0" rIns="0" bIns="0" rtlCol="0" anchor="ctr"/>
-          <a:lstStyle/>
-          <a:p>
-            <a:pPr indent="0" marL="0">
-              <a:buNone/>
-            </a:pPr>
-            <a:r>
-              <a:rPr lang="en-US" sz="900" dirty="0">
-                <a:solidFill>
-                  <a:srgbClr val="4D5B69"/>
-                </a:solidFill>
-                <a:latin typeface="Calibri" pitchFamily="34" charset="0"/>
-                <a:ea typeface="Calibri" pitchFamily="34" charset="-122"/>
-                <a:cs typeface="Calibri" pitchFamily="34" charset="-120"/>
-              </a:rPr>
-              <a:t>SIR 2025-26 · All India · Varna Sri Raman · aggregates only; no names or EPIC numbers</a:t>
-            </a:r>
-            <a:endParaRPr lang="en-US" sz="900" dirty="0"/>
-          </a:p>
-        </p:txBody>
-      </p:sp>
-      <p:sp>
-        <p:nvSpPr>
-          <p:cNvPr id="6" name="Text 4"/>
-          <p:cNvSpPr txBox="1"/>
-          <p:nvPr/>
-        </p:nvSpPr>
-        <p:spPr>
-          <a:xfrm>
-            <a:off x="10911535" y="6400800"/>
-            <a:ext cx="731520" cy="274320"/>
-          </a:xfrm>
-          <a:prstGeom prst="rect">
-            <a:avLst/>
-          </a:prstGeom>
-          <a:noFill/>
-          <a:ln/>
-        </p:spPr>
-        <p:txBody>
-          <a:bodyPr wrap="square" lIns="0" tIns="0" rIns="0" bIns="0" rtlCol="0" anchor="ctr"/>
-          <a:lstStyle/>
-          <a:p>
-            <a:pPr algn="r" indent="0" marL="0">
-              <a:buNone/>
-            </a:pPr>
-            <a:r>
-              <a:rPr lang="en-US" sz="900" dirty="0">
-                <a:solidFill>
-                  <a:srgbClr val="4D5B69"/>
-                </a:solidFill>
-                <a:latin typeface="Calibri" pitchFamily="34" charset="0"/>
-                <a:ea typeface="Calibri" pitchFamily="34" charset="-122"/>
-                <a:cs typeface="Calibri" pitchFamily="34" charset="-120"/>
-              </a:rPr>
-              <a:t>13</a:t>
-            </a:r>
-            <a:endParaRPr lang="en-US" sz="900" dirty="0"/>
-          </a:p>
-        </p:txBody>
-      </p:sp>
-      <p:sp>
-        <p:nvSpPr>
-          <p:cNvPr id="7" name="Shape 5"/>
-          <p:cNvSpPr/>
-          <p:nvPr/>
-        </p:nvSpPr>
-        <p:spPr>
-          <a:xfrm>
-            <a:off x="0" y="6748272"/>
-            <a:ext cx="304792" cy="109728"/>
-          </a:xfrm>
-          <a:prstGeom prst="rect">
-            <a:avLst/>
-          </a:prstGeom>
-          <a:solidFill>
-            <a:srgbClr val="C0392B"/>
-          </a:solidFill>
-          <a:ln/>
-        </p:spPr>
-      </p:sp>
-      <p:sp>
-        <p:nvSpPr>
-          <p:cNvPr id="8" name="Shape 6"/>
-          <p:cNvSpPr/>
-          <p:nvPr/>
-        </p:nvSpPr>
-        <p:spPr>
-          <a:xfrm>
-            <a:off x="304792" y="6748272"/>
-            <a:ext cx="304792" cy="109728"/>
-          </a:xfrm>
-          <a:prstGeom prst="rect">
-            <a:avLst/>
-          </a:prstGeom>
-          <a:solidFill>
-            <a:srgbClr val="E67E22"/>
-          </a:solidFill>
-          <a:ln/>
-        </p:spPr>
-      </p:sp>
-      <p:sp>
-        <p:nvSpPr>
-          <p:cNvPr id="9" name="Shape 7"/>
-          <p:cNvSpPr/>
-          <p:nvPr/>
-        </p:nvSpPr>
-        <p:spPr>
-          <a:xfrm>
-            <a:off x="609585" y="6748272"/>
-            <a:ext cx="304792" cy="109728"/>
-          </a:xfrm>
-          <a:prstGeom prst="rect">
-            <a:avLst/>
-          </a:prstGeom>
-          <a:solidFill>
-            <a:srgbClr val="27AE60"/>
-          </a:solidFill>
-          <a:ln/>
-        </p:spPr>
-      </p:sp>
-      <p:sp>
-        <p:nvSpPr>
-          <p:cNvPr id="10" name="Shape 8"/>
-          <p:cNvSpPr/>
-          <p:nvPr/>
-        </p:nvSpPr>
-        <p:spPr>
-          <a:xfrm>
-            <a:off x="914377" y="6748272"/>
-            <a:ext cx="304792" cy="109728"/>
-          </a:xfrm>
-          <a:prstGeom prst="rect">
-            <a:avLst/>
-          </a:prstGeom>
-          <a:solidFill>
-            <a:srgbClr val="1F618D"/>
-          </a:solidFill>
-          <a:ln/>
-        </p:spPr>
-      </p:sp>
-      <p:sp>
-        <p:nvSpPr>
-          <p:cNvPr id="11" name="Shape 9"/>
-          <p:cNvSpPr/>
-          <p:nvPr/>
-        </p:nvSpPr>
-        <p:spPr>
-          <a:xfrm>
-            <a:off x="1219170" y="6748272"/>
-            <a:ext cx="304792" cy="109728"/>
-          </a:xfrm>
-          <a:prstGeom prst="rect">
-            <a:avLst/>
-          </a:prstGeom>
-          <a:solidFill>
-            <a:srgbClr val="8E44AD"/>
-          </a:solidFill>
-          <a:ln/>
-        </p:spPr>
-      </p:sp>
-      <p:sp>
-        <p:nvSpPr>
-          <p:cNvPr id="12" name="Shape 10"/>
-          <p:cNvSpPr/>
-          <p:nvPr/>
-        </p:nvSpPr>
-        <p:spPr>
-          <a:xfrm>
-            <a:off x="1523962" y="6748272"/>
-            <a:ext cx="304792" cy="109728"/>
-          </a:xfrm>
-          <a:prstGeom prst="rect">
-            <a:avLst/>
-          </a:prstGeom>
-          <a:solidFill>
-            <a:srgbClr val="C0392B"/>
-          </a:solidFill>
-          <a:ln/>
-        </p:spPr>
-      </p:sp>
-      <p:sp>
-        <p:nvSpPr>
-          <p:cNvPr id="13" name="Shape 11"/>
-          <p:cNvSpPr/>
-          <p:nvPr/>
-        </p:nvSpPr>
-        <p:spPr>
-          <a:xfrm>
-            <a:off x="1828754" y="6748272"/>
-            <a:ext cx="304792" cy="109728"/>
-          </a:xfrm>
-          <a:prstGeom prst="rect">
-            <a:avLst/>
-          </a:prstGeom>
-          <a:solidFill>
-            <a:srgbClr val="E67E22"/>
-          </a:solidFill>
-          <a:ln/>
-        </p:spPr>
-      </p:sp>
-      <p:sp>
-        <p:nvSpPr>
-          <p:cNvPr id="14" name="Shape 12"/>
-          <p:cNvSpPr/>
-          <p:nvPr/>
-        </p:nvSpPr>
-        <p:spPr>
-          <a:xfrm>
-            <a:off x="2133547" y="6748272"/>
-            <a:ext cx="304792" cy="109728"/>
-          </a:xfrm>
-          <a:prstGeom prst="rect">
-            <a:avLst/>
-          </a:prstGeom>
-          <a:solidFill>
-            <a:srgbClr val="27AE60"/>
-          </a:solidFill>
-          <a:ln/>
-        </p:spPr>
-      </p:sp>
-      <p:sp>
-        <p:nvSpPr>
-          <p:cNvPr id="15" name="Shape 13"/>
-          <p:cNvSpPr/>
-          <p:nvPr/>
-        </p:nvSpPr>
-        <p:spPr>
-          <a:xfrm>
-            <a:off x="2438339" y="6748272"/>
-            <a:ext cx="304792" cy="109728"/>
-          </a:xfrm>
-          <a:prstGeom prst="rect">
-            <a:avLst/>
-          </a:prstGeom>
-          <a:solidFill>
-            <a:srgbClr val="1F618D"/>
-          </a:solidFill>
-          <a:ln/>
-        </p:spPr>
-      </p:sp>
-      <p:sp>
-        <p:nvSpPr>
-          <p:cNvPr id="16" name="Shape 14"/>
-          <p:cNvSpPr/>
-          <p:nvPr/>
-        </p:nvSpPr>
-        <p:spPr>
-          <a:xfrm>
-            <a:off x="2743131" y="6748272"/>
-            <a:ext cx="304792" cy="109728"/>
-          </a:xfrm>
-          <a:prstGeom prst="rect">
-            <a:avLst/>
-          </a:prstGeom>
-          <a:solidFill>
-            <a:srgbClr val="8E44AD"/>
-          </a:solidFill>
-          <a:ln/>
-        </p:spPr>
-      </p:sp>
-      <p:sp>
-        <p:nvSpPr>
-          <p:cNvPr id="17" name="Shape 15"/>
-          <p:cNvSpPr/>
-          <p:nvPr/>
-        </p:nvSpPr>
-        <p:spPr>
-          <a:xfrm>
-            <a:off x="3047924" y="6748272"/>
-            <a:ext cx="304792" cy="109728"/>
-          </a:xfrm>
-          <a:prstGeom prst="rect">
-            <a:avLst/>
-          </a:prstGeom>
-          <a:solidFill>
-            <a:srgbClr val="C0392B"/>
-          </a:solidFill>
-          <a:ln/>
-        </p:spPr>
-      </p:sp>
-      <p:sp>
-        <p:nvSpPr>
-          <p:cNvPr id="18" name="Shape 16"/>
-          <p:cNvSpPr/>
-          <p:nvPr/>
-        </p:nvSpPr>
-        <p:spPr>
-          <a:xfrm>
-            <a:off x="3352716" y="6748272"/>
-            <a:ext cx="304792" cy="109728"/>
-          </a:xfrm>
-          <a:prstGeom prst="rect">
-            <a:avLst/>
-          </a:prstGeom>
-          <a:solidFill>
-            <a:srgbClr val="E67E22"/>
-          </a:solidFill>
-          <a:ln/>
-        </p:spPr>
-      </p:sp>
-      <p:sp>
-        <p:nvSpPr>
-          <p:cNvPr id="19" name="Shape 17"/>
-          <p:cNvSpPr/>
-          <p:nvPr/>
-        </p:nvSpPr>
-        <p:spPr>
-          <a:xfrm>
-            <a:off x="3657509" y="6748272"/>
-            <a:ext cx="304792" cy="109728"/>
-          </a:xfrm>
-          <a:prstGeom prst="rect">
-            <a:avLst/>
-          </a:prstGeom>
-          <a:solidFill>
-            <a:srgbClr val="27AE60"/>
-          </a:solidFill>
-          <a:ln/>
-        </p:spPr>
-      </p:sp>
-      <p:sp>
-        <p:nvSpPr>
-          <p:cNvPr id="20" name="Shape 18"/>
-          <p:cNvSpPr/>
-          <p:nvPr/>
-        </p:nvSpPr>
-        <p:spPr>
-          <a:xfrm>
-            <a:off x="3962301" y="6748272"/>
-            <a:ext cx="304792" cy="109728"/>
-          </a:xfrm>
-          <a:prstGeom prst="rect">
-            <a:avLst/>
-          </a:prstGeom>
-          <a:solidFill>
-            <a:srgbClr val="1F618D"/>
-          </a:solidFill>
-          <a:ln/>
-        </p:spPr>
-      </p:sp>
-      <p:sp>
-        <p:nvSpPr>
-          <p:cNvPr id="21" name="Shape 19"/>
-          <p:cNvSpPr/>
-          <p:nvPr/>
-        </p:nvSpPr>
-        <p:spPr>
-          <a:xfrm>
-            <a:off x="4267093" y="6748272"/>
-            <a:ext cx="304792" cy="109728"/>
-          </a:xfrm>
-          <a:prstGeom prst="rect">
-            <a:avLst/>
-          </a:prstGeom>
-          <a:solidFill>
-            <a:srgbClr val="8E44AD"/>
-          </a:solidFill>
-          <a:ln/>
-        </p:spPr>
-      </p:sp>
-      <p:sp>
-        <p:nvSpPr>
-          <p:cNvPr id="22" name="Shape 20"/>
-          <p:cNvSpPr/>
-          <p:nvPr/>
-        </p:nvSpPr>
-        <p:spPr>
-          <a:xfrm>
-            <a:off x="4571886" y="6748272"/>
-            <a:ext cx="304792" cy="109728"/>
-          </a:xfrm>
-          <a:prstGeom prst="rect">
-            <a:avLst/>
-          </a:prstGeom>
-          <a:solidFill>
-            <a:srgbClr val="C0392B"/>
-          </a:solidFill>
-          <a:ln/>
-        </p:spPr>
-      </p:sp>
-      <p:sp>
-        <p:nvSpPr>
-          <p:cNvPr id="23" name="Shape 21"/>
-          <p:cNvSpPr/>
-          <p:nvPr/>
-        </p:nvSpPr>
-        <p:spPr>
-          <a:xfrm>
-            <a:off x="4876678" y="6748272"/>
-            <a:ext cx="304792" cy="109728"/>
-          </a:xfrm>
-          <a:prstGeom prst="rect">
-            <a:avLst/>
-          </a:prstGeom>
-          <a:solidFill>
-            <a:srgbClr val="E67E22"/>
-          </a:solidFill>
-          <a:ln/>
-        </p:spPr>
-      </p:sp>
-      <p:sp>
-        <p:nvSpPr>
-          <p:cNvPr id="24" name="Shape 22"/>
-          <p:cNvSpPr/>
-          <p:nvPr/>
-        </p:nvSpPr>
-        <p:spPr>
-          <a:xfrm>
-            <a:off x="5181470" y="6748272"/>
-            <a:ext cx="304792" cy="109728"/>
-          </a:xfrm>
-          <a:prstGeom prst="rect">
-            <a:avLst/>
-          </a:prstGeom>
-          <a:solidFill>
-            <a:srgbClr val="27AE60"/>
-          </a:solidFill>
-          <a:ln/>
-        </p:spPr>
-      </p:sp>
-      <p:sp>
-        <p:nvSpPr>
-          <p:cNvPr id="25" name="Shape 23"/>
-          <p:cNvSpPr/>
-          <p:nvPr/>
-        </p:nvSpPr>
-        <p:spPr>
-          <a:xfrm>
-            <a:off x="5486263" y="6748272"/>
-            <a:ext cx="304792" cy="109728"/>
-          </a:xfrm>
-          <a:prstGeom prst="rect">
-            <a:avLst/>
-          </a:prstGeom>
-          <a:solidFill>
-            <a:srgbClr val="1F618D"/>
-          </a:solidFill>
-          <a:ln/>
-        </p:spPr>
-      </p:sp>
-      <p:sp>
-        <p:nvSpPr>
-          <p:cNvPr id="26" name="Shape 24"/>
-          <p:cNvSpPr/>
-          <p:nvPr/>
-        </p:nvSpPr>
-        <p:spPr>
-          <a:xfrm>
-            <a:off x="5791055" y="6748272"/>
-            <a:ext cx="304792" cy="109728"/>
-          </a:xfrm>
-          <a:prstGeom prst="rect">
-            <a:avLst/>
-          </a:prstGeom>
-          <a:solidFill>
-            <a:srgbClr val="8E44AD"/>
-          </a:solidFill>
-          <a:ln/>
-        </p:spPr>
-      </p:sp>
-      <p:sp>
-        <p:nvSpPr>
-          <p:cNvPr id="27" name="Shape 25"/>
-          <p:cNvSpPr/>
-          <p:nvPr/>
-        </p:nvSpPr>
-        <p:spPr>
-          <a:xfrm>
-            <a:off x="6095848" y="6748272"/>
-            <a:ext cx="304792" cy="109728"/>
-          </a:xfrm>
-          <a:prstGeom prst="rect">
-            <a:avLst/>
-          </a:prstGeom>
-          <a:solidFill>
-            <a:srgbClr val="C0392B"/>
-          </a:solidFill>
-          <a:ln/>
-        </p:spPr>
-      </p:sp>
-      <p:sp>
-        <p:nvSpPr>
-          <p:cNvPr id="28" name="Shape 26"/>
-          <p:cNvSpPr/>
-          <p:nvPr/>
-        </p:nvSpPr>
-        <p:spPr>
-          <a:xfrm>
-            <a:off x="6400640" y="6748272"/>
-            <a:ext cx="304792" cy="109728"/>
-          </a:xfrm>
-          <a:prstGeom prst="rect">
-            <a:avLst/>
-          </a:prstGeom>
-          <a:solidFill>
-            <a:srgbClr val="E67E22"/>
-          </a:solidFill>
-          <a:ln/>
-        </p:spPr>
-      </p:sp>
-      <p:sp>
-        <p:nvSpPr>
-          <p:cNvPr id="29" name="Shape 27"/>
-          <p:cNvSpPr/>
-          <p:nvPr/>
-        </p:nvSpPr>
-        <p:spPr>
-          <a:xfrm>
-            <a:off x="6705432" y="6748272"/>
-            <a:ext cx="304792" cy="109728"/>
-          </a:xfrm>
-          <a:prstGeom prst="rect">
-            <a:avLst/>
-          </a:prstGeom>
-          <a:solidFill>
-            <a:srgbClr val="27AE60"/>
-          </a:solidFill>
-          <a:ln/>
-        </p:spPr>
-      </p:sp>
-      <p:sp>
-        <p:nvSpPr>
-          <p:cNvPr id="30" name="Shape 28"/>
-          <p:cNvSpPr/>
-          <p:nvPr/>
-        </p:nvSpPr>
-        <p:spPr>
-          <a:xfrm>
-            <a:off x="7010225" y="6748272"/>
-            <a:ext cx="304792" cy="109728"/>
-          </a:xfrm>
-          <a:prstGeom prst="rect">
-            <a:avLst/>
-          </a:prstGeom>
-          <a:solidFill>
-            <a:srgbClr val="1F618D"/>
-          </a:solidFill>
-          <a:ln/>
-        </p:spPr>
-      </p:sp>
-      <p:sp>
-        <p:nvSpPr>
-          <p:cNvPr id="31" name="Shape 29"/>
-          <p:cNvSpPr/>
-          <p:nvPr/>
-        </p:nvSpPr>
-        <p:spPr>
-          <a:xfrm>
-            <a:off x="7315017" y="6748272"/>
-            <a:ext cx="304792" cy="109728"/>
-          </a:xfrm>
-          <a:prstGeom prst="rect">
-            <a:avLst/>
-          </a:prstGeom>
-          <a:solidFill>
-            <a:srgbClr val="8E44AD"/>
-          </a:solidFill>
-          <a:ln/>
-        </p:spPr>
-      </p:sp>
-      <p:sp>
-        <p:nvSpPr>
-          <p:cNvPr id="32" name="Shape 30"/>
-          <p:cNvSpPr/>
-          <p:nvPr/>
-        </p:nvSpPr>
-        <p:spPr>
-          <a:xfrm>
-            <a:off x="7619809" y="6748272"/>
-            <a:ext cx="304792" cy="109728"/>
-          </a:xfrm>
-          <a:prstGeom prst="rect">
-            <a:avLst/>
-          </a:prstGeom>
-          <a:solidFill>
-            <a:srgbClr val="C0392B"/>
-          </a:solidFill>
-          <a:ln/>
-        </p:spPr>
-      </p:sp>
-      <p:sp>
-        <p:nvSpPr>
-          <p:cNvPr id="33" name="Shape 31"/>
-          <p:cNvSpPr/>
-          <p:nvPr/>
-        </p:nvSpPr>
-        <p:spPr>
-          <a:xfrm>
-            <a:off x="7924602" y="6748272"/>
-            <a:ext cx="304792" cy="109728"/>
-          </a:xfrm>
-          <a:prstGeom prst="rect">
-            <a:avLst/>
-          </a:prstGeom>
-          <a:solidFill>
-            <a:srgbClr val="E67E22"/>
-          </a:solidFill>
-          <a:ln/>
-        </p:spPr>
-      </p:sp>
-      <p:sp>
-        <p:nvSpPr>
-          <p:cNvPr id="34" name="Shape 32"/>
-          <p:cNvSpPr/>
-          <p:nvPr/>
-        </p:nvSpPr>
-        <p:spPr>
-          <a:xfrm>
-            <a:off x="8229394" y="6748272"/>
-            <a:ext cx="304792" cy="109728"/>
-          </a:xfrm>
-          <a:prstGeom prst="rect">
-            <a:avLst/>
-          </a:prstGeom>
-          <a:solidFill>
-            <a:srgbClr val="27AE60"/>
-          </a:solidFill>
-          <a:ln/>
-        </p:spPr>
-      </p:sp>
-      <p:sp>
-        <p:nvSpPr>
-          <p:cNvPr id="35" name="Shape 33"/>
-          <p:cNvSpPr/>
-          <p:nvPr/>
-        </p:nvSpPr>
-        <p:spPr>
-          <a:xfrm>
-            <a:off x="8534187" y="6748272"/>
-            <a:ext cx="304792" cy="109728"/>
-          </a:xfrm>
-          <a:prstGeom prst="rect">
-            <a:avLst/>
-          </a:prstGeom>
-          <a:solidFill>
-            <a:srgbClr val="1F618D"/>
-          </a:solidFill>
-          <a:ln/>
-        </p:spPr>
-      </p:sp>
-      <p:sp>
-        <p:nvSpPr>
-          <p:cNvPr id="36" name="Shape 34"/>
-          <p:cNvSpPr/>
-          <p:nvPr/>
-        </p:nvSpPr>
-        <p:spPr>
-          <a:xfrm>
-            <a:off x="8838979" y="6748272"/>
-            <a:ext cx="304792" cy="109728"/>
-          </a:xfrm>
-          <a:prstGeom prst="rect">
-            <a:avLst/>
-          </a:prstGeom>
-          <a:solidFill>
-            <a:srgbClr val="8E44AD"/>
-          </a:solidFill>
-          <a:ln/>
-        </p:spPr>
-      </p:sp>
-      <p:sp>
-        <p:nvSpPr>
-          <p:cNvPr id="37" name="Shape 35"/>
-          <p:cNvSpPr/>
-          <p:nvPr/>
-        </p:nvSpPr>
-        <p:spPr>
-          <a:xfrm>
-            <a:off x="9143771" y="6748272"/>
-            <a:ext cx="304792" cy="109728"/>
-          </a:xfrm>
-          <a:prstGeom prst="rect">
-            <a:avLst/>
-          </a:prstGeom>
-          <a:solidFill>
-            <a:srgbClr val="C0392B"/>
-          </a:solidFill>
-          <a:ln/>
-        </p:spPr>
-      </p:sp>
-      <p:sp>
-        <p:nvSpPr>
-          <p:cNvPr id="38" name="Shape 36"/>
-          <p:cNvSpPr/>
-          <p:nvPr/>
-        </p:nvSpPr>
-        <p:spPr>
-          <a:xfrm>
-            <a:off x="9448564" y="6748272"/>
-            <a:ext cx="304792" cy="109728"/>
-          </a:xfrm>
-          <a:prstGeom prst="rect">
-            <a:avLst/>
-          </a:prstGeom>
-          <a:solidFill>
-            <a:srgbClr val="E67E22"/>
-          </a:solidFill>
-          <a:ln/>
-        </p:spPr>
-      </p:sp>
-      <p:sp>
-        <p:nvSpPr>
-          <p:cNvPr id="39" name="Shape 37"/>
-          <p:cNvSpPr/>
-          <p:nvPr/>
-        </p:nvSpPr>
-        <p:spPr>
-          <a:xfrm>
-            <a:off x="9753356" y="6748272"/>
-            <a:ext cx="304792" cy="109728"/>
-          </a:xfrm>
-          <a:prstGeom prst="rect">
-            <a:avLst/>
-          </a:prstGeom>
-          <a:solidFill>
-            <a:srgbClr val="27AE60"/>
-          </a:solidFill>
-          <a:ln/>
-        </p:spPr>
-      </p:sp>
-      <p:sp>
-        <p:nvSpPr>
-          <p:cNvPr id="40" name="Shape 38"/>
-          <p:cNvSpPr/>
-          <p:nvPr/>
-        </p:nvSpPr>
-        <p:spPr>
-          <a:xfrm>
-            <a:off x="10058149" y="6748272"/>
-            <a:ext cx="304792" cy="109728"/>
-          </a:xfrm>
-          <a:prstGeom prst="rect">
-            <a:avLst/>
-          </a:prstGeom>
-          <a:solidFill>
-            <a:srgbClr val="1F618D"/>
-          </a:solidFill>
-          <a:ln/>
-        </p:spPr>
-      </p:sp>
-      <p:sp>
-        <p:nvSpPr>
-          <p:cNvPr id="41" name="Shape 39"/>
-          <p:cNvSpPr/>
-          <p:nvPr/>
-        </p:nvSpPr>
-        <p:spPr>
-          <a:xfrm>
-            <a:off x="10362941" y="6748272"/>
-            <a:ext cx="304792" cy="109728"/>
-          </a:xfrm>
-          <a:prstGeom prst="rect">
-            <a:avLst/>
-          </a:prstGeom>
-          <a:solidFill>
-            <a:srgbClr val="8E44AD"/>
-          </a:solidFill>
-          <a:ln/>
-        </p:spPr>
-      </p:sp>
-      <p:sp>
-        <p:nvSpPr>
-          <p:cNvPr id="42" name="Shape 40"/>
-          <p:cNvSpPr/>
-          <p:nvPr/>
-        </p:nvSpPr>
-        <p:spPr>
-          <a:xfrm>
-            <a:off x="10667733" y="6748272"/>
-            <a:ext cx="304792" cy="109728"/>
-          </a:xfrm>
-          <a:prstGeom prst="rect">
-            <a:avLst/>
-          </a:prstGeom>
-          <a:solidFill>
-            <a:srgbClr val="C0392B"/>
-          </a:solidFill>
-          <a:ln/>
-        </p:spPr>
-      </p:sp>
-      <p:sp>
-        <p:nvSpPr>
-          <p:cNvPr id="43" name="Shape 41"/>
-          <p:cNvSpPr/>
-          <p:nvPr/>
-        </p:nvSpPr>
-        <p:spPr>
-          <a:xfrm>
-            <a:off x="10972526" y="6748272"/>
-            <a:ext cx="304792" cy="109728"/>
-          </a:xfrm>
-          <a:prstGeom prst="rect">
-            <a:avLst/>
-          </a:prstGeom>
-          <a:solidFill>
-            <a:srgbClr val="E67E22"/>
-          </a:solidFill>
-          <a:ln/>
-        </p:spPr>
-      </p:sp>
-      <p:sp>
-        <p:nvSpPr>
-          <p:cNvPr id="44" name="Shape 42"/>
-          <p:cNvSpPr/>
-          <p:nvPr/>
-        </p:nvSpPr>
-        <p:spPr>
-          <a:xfrm>
-            <a:off x="11277318" y="6748272"/>
-            <a:ext cx="304792" cy="109728"/>
-          </a:xfrm>
-          <a:prstGeom prst="rect">
-            <a:avLst/>
-          </a:prstGeom>
-          <a:solidFill>
-            <a:srgbClr val="27AE60"/>
-          </a:solidFill>
-          <a:ln/>
-        </p:spPr>
-      </p:sp>
-      <p:sp>
-        <p:nvSpPr>
-          <p:cNvPr id="45" name="Shape 43"/>
-          <p:cNvSpPr/>
-          <p:nvPr/>
-        </p:nvSpPr>
-        <p:spPr>
-          <a:xfrm>
-            <a:off x="11582110" y="6748272"/>
-            <a:ext cx="304792" cy="109728"/>
-          </a:xfrm>
-          <a:prstGeom prst="rect">
-            <a:avLst/>
-          </a:prstGeom>
-          <a:solidFill>
-            <a:srgbClr val="1F618D"/>
-          </a:solidFill>
-          <a:ln/>
-        </p:spPr>
-      </p:sp>
-      <p:sp>
-        <p:nvSpPr>
-          <p:cNvPr id="46" name="Shape 44"/>
-          <p:cNvSpPr/>
-          <p:nvPr/>
-        </p:nvSpPr>
-        <p:spPr>
-          <a:xfrm>
-            <a:off x="11886903" y="6748272"/>
-            <a:ext cx="304792" cy="109728"/>
-          </a:xfrm>
-          <a:prstGeom prst="rect">
-            <a:avLst/>
-          </a:prstGeom>
-          <a:solidFill>
-            <a:srgbClr val="8E44AD"/>
-          </a:solidFill>
-          <a:ln/>
-        </p:spPr>
-      </p:sp>
-      <p:sp>
-        <p:nvSpPr>
-          <p:cNvPr id="47" name="Shape 45"/>
-          <p:cNvSpPr/>
-          <p:nvPr/>
-        </p:nvSpPr>
-        <p:spPr>
-          <a:xfrm>
-            <a:off x="548640" y="1920240"/>
-            <a:ext cx="2602154" cy="1554480"/>
-          </a:xfrm>
-          <a:prstGeom prst="roundRect">
-            <a:avLst>
-              <a:gd name="adj" fmla="val 4706"/>
-            </a:avLst>
-          </a:prstGeom>
-          <a:solidFill>
-            <a:srgbClr val="F4F6F7"/>
-          </a:solidFill>
-          <a:ln/>
-        </p:spPr>
-      </p:sp>
-      <p:sp>
-        <p:nvSpPr>
-          <p:cNvPr id="48" name="Text 46"/>
-          <p:cNvSpPr txBox="1"/>
-          <p:nvPr/>
-        </p:nvSpPr>
-        <p:spPr>
-          <a:xfrm>
-            <a:off x="731520" y="2029968"/>
-            <a:ext cx="2236394" cy="746150"/>
-          </a:xfrm>
-          <a:prstGeom prst="rect">
-            <a:avLst/>
-          </a:prstGeom>
-          <a:noFill/>
-          <a:ln/>
-        </p:spPr>
-        <p:txBody>
-          <a:bodyPr wrap="square" lIns="0" tIns="0" rIns="0" bIns="0" rtlCol="0" anchor="b">
-            <a:normAutofit/>
-          </a:bodyPr>
-          <a:lstStyle/>
-          <a:p>
-            <a:pPr indent="0" marL="0">
-              <a:buNone/>
-            </a:pPr>
-            <a:r>
-              <a:rPr lang="en-US" sz="2800" b="1" dirty="0">
-                <a:solidFill>
-                  <a:srgbClr val="1F618D"/>
-                </a:solidFill>
-                <a:latin typeface="Cambria" pitchFamily="34" charset="0"/>
-                <a:ea typeface="Cambria" pitchFamily="34" charset="-122"/>
-                <a:cs typeface="Cambria" pitchFamily="34" charset="-120"/>
-              </a:rPr>
-              <a:t>6,62,063</a:t>
-            </a:r>
-            <a:endParaRPr lang="en-US" sz="2800" dirty="0"/>
-          </a:p>
-        </p:txBody>
-      </p:sp>
-      <p:sp>
-        <p:nvSpPr>
-          <p:cNvPr id="49" name="Text 47"/>
-          <p:cNvSpPr txBox="1"/>
-          <p:nvPr/>
-        </p:nvSpPr>
-        <p:spPr>
-          <a:xfrm>
-            <a:off x="731520" y="2794406"/>
-            <a:ext cx="2236394" cy="588874"/>
-          </a:xfrm>
-          <a:prstGeom prst="rect">
-            <a:avLst/>
-          </a:prstGeom>
-          <a:noFill/>
-          <a:ln/>
-        </p:spPr>
-        <p:txBody>
-          <a:bodyPr wrap="square" lIns="0" tIns="0" rIns="0" bIns="0" rtlCol="0" anchor="t">
-            <a:normAutofit/>
-          </a:bodyPr>
-          <a:lstStyle/>
-          <a:p>
-            <a:pPr indent="0" marL="0">
-              <a:buNone/>
-            </a:pPr>
-            <a:r>
-              <a:rPr lang="en-US" sz="1200" dirty="0">
-                <a:solidFill>
-                  <a:srgbClr val="4D5B69"/>
-                </a:solidFill>
-                <a:latin typeface="Calibri" pitchFamily="34" charset="0"/>
-                <a:ea typeface="Calibri" pitchFamily="34" charset="-122"/>
-                <a:cs typeface="Calibri" pitchFamily="34" charset="-120"/>
-              </a:rPr>
-              <a:t>electors struck off</a:t>
-            </a:r>
-            <a:endParaRPr lang="en-US" sz="1200" dirty="0"/>
-          </a:p>
-        </p:txBody>
-      </p:sp>
-      <p:sp>
-        <p:nvSpPr>
-          <p:cNvPr id="50" name="Shape 48"/>
-          <p:cNvSpPr/>
-          <p:nvPr/>
-        </p:nvSpPr>
-        <p:spPr>
-          <a:xfrm>
-            <a:off x="3379394" y="1920240"/>
-            <a:ext cx="2602154" cy="1554480"/>
-          </a:xfrm>
-          <a:prstGeom prst="roundRect">
-            <a:avLst>
-              <a:gd name="adj" fmla="val 4706"/>
-            </a:avLst>
-          </a:prstGeom>
-          <a:solidFill>
-            <a:srgbClr val="F4F6F7"/>
-          </a:solidFill>
-          <a:ln/>
-        </p:spPr>
-      </p:sp>
-      <p:sp>
-        <p:nvSpPr>
-          <p:cNvPr id="51" name="Text 49"/>
-          <p:cNvSpPr txBox="1"/>
-          <p:nvPr/>
-        </p:nvSpPr>
-        <p:spPr>
-          <a:xfrm>
-            <a:off x="3562274" y="2029968"/>
-            <a:ext cx="2236394" cy="746150"/>
-          </a:xfrm>
-          <a:prstGeom prst="rect">
-            <a:avLst/>
-          </a:prstGeom>
-          <a:noFill/>
-          <a:ln/>
-        </p:spPr>
-        <p:txBody>
-          <a:bodyPr wrap="square" lIns="0" tIns="0" rIns="0" bIns="0" rtlCol="0" anchor="b">
-            <a:normAutofit/>
-          </a:bodyPr>
-          <a:lstStyle/>
-          <a:p>
-            <a:pPr indent="0" marL="0">
-              <a:buNone/>
-            </a:pPr>
-            <a:r>
-              <a:rPr lang="en-US" sz="2800" b="1" dirty="0">
-                <a:solidFill>
-                  <a:srgbClr val="1F618D"/>
-                </a:solidFill>
-                <a:latin typeface="Cambria" pitchFamily="34" charset="0"/>
-                <a:ea typeface="Cambria" pitchFamily="34" charset="-122"/>
-                <a:cs typeface="Cambria" pitchFamily="34" charset="-120"/>
-              </a:rPr>
-              <a:t>40.0%</a:t>
-            </a:r>
-            <a:endParaRPr lang="en-US" sz="2800" dirty="0"/>
-          </a:p>
-        </p:txBody>
-      </p:sp>
-      <p:sp>
-        <p:nvSpPr>
-          <p:cNvPr id="52" name="Text 50"/>
-          <p:cNvSpPr txBox="1"/>
-          <p:nvPr/>
-        </p:nvSpPr>
-        <p:spPr>
-          <a:xfrm>
-            <a:off x="3562274" y="2794406"/>
-            <a:ext cx="2236394" cy="588874"/>
-          </a:xfrm>
-          <a:prstGeom prst="rect">
-            <a:avLst/>
-          </a:prstGeom>
-          <a:noFill/>
-          <a:ln/>
-        </p:spPr>
-        <p:txBody>
-          <a:bodyPr wrap="square" lIns="0" tIns="0" rIns="0" bIns="0" rtlCol="0" anchor="t">
-            <a:normAutofit/>
-          </a:bodyPr>
-          <a:lstStyle/>
-          <a:p>
-            <a:pPr indent="0" marL="0">
-              <a:buNone/>
-            </a:pPr>
-            <a:r>
-              <a:rPr lang="en-US" sz="1200" dirty="0">
-                <a:solidFill>
-                  <a:srgbClr val="4D5B69"/>
-                </a:solidFill>
-                <a:latin typeface="Calibri" pitchFamily="34" charset="0"/>
-                <a:ea typeface="Calibri" pitchFamily="34" charset="-122"/>
-                <a:cs typeface="Calibri" pitchFamily="34" charset="-120"/>
-              </a:rPr>
-              <a:t>of the pre-revision rolls</a:t>
-            </a:r>
-            <a:endParaRPr lang="en-US" sz="1200" dirty="0"/>
-          </a:p>
-        </p:txBody>
-      </p:sp>
-      <p:sp>
-        <p:nvSpPr>
-          <p:cNvPr id="53" name="Shape 51"/>
-          <p:cNvSpPr/>
-          <p:nvPr/>
-        </p:nvSpPr>
-        <p:spPr>
-          <a:xfrm>
-            <a:off x="6210148" y="1920240"/>
-            <a:ext cx="2602154" cy="1554480"/>
-          </a:xfrm>
-          <a:prstGeom prst="roundRect">
-            <a:avLst>
-              <a:gd name="adj" fmla="val 4706"/>
-            </a:avLst>
-          </a:prstGeom>
-          <a:solidFill>
-            <a:srgbClr val="F4F6F7"/>
-          </a:solidFill>
-          <a:ln/>
-        </p:spPr>
-      </p:sp>
-      <p:sp>
-        <p:nvSpPr>
-          <p:cNvPr id="54" name="Text 52"/>
-          <p:cNvSpPr txBox="1"/>
-          <p:nvPr/>
-        </p:nvSpPr>
-        <p:spPr>
-          <a:xfrm>
-            <a:off x="6393028" y="2029968"/>
-            <a:ext cx="2236394" cy="746150"/>
-          </a:xfrm>
-          <a:prstGeom prst="rect">
-            <a:avLst/>
-          </a:prstGeom>
-          <a:noFill/>
-          <a:ln/>
-        </p:spPr>
-        <p:txBody>
-          <a:bodyPr wrap="square" lIns="0" tIns="0" rIns="0" bIns="0" rtlCol="0" anchor="b">
-            <a:normAutofit/>
-          </a:bodyPr>
-          <a:lstStyle/>
-          <a:p>
-            <a:pPr indent="0" marL="0">
-              <a:buNone/>
-            </a:pPr>
-            <a:r>
-              <a:rPr lang="en-US" sz="2800" b="1" dirty="0">
-                <a:solidFill>
-                  <a:srgbClr val="1F618D"/>
-                </a:solidFill>
-                <a:latin typeface="Cambria" pitchFamily="34" charset="0"/>
-                <a:ea typeface="Cambria" pitchFamily="34" charset="-122"/>
-                <a:cs typeface="Cambria" pitchFamily="34" charset="-120"/>
-              </a:rPr>
-              <a:t>3,69,972</a:t>
-            </a:r>
-            <a:endParaRPr lang="en-US" sz="2800" dirty="0"/>
-          </a:p>
-        </p:txBody>
-      </p:sp>
-      <p:sp>
-        <p:nvSpPr>
-          <p:cNvPr id="55" name="Text 53"/>
-          <p:cNvSpPr txBox="1"/>
-          <p:nvPr/>
-        </p:nvSpPr>
-        <p:spPr>
-          <a:xfrm>
-            <a:off x="6393028" y="2794406"/>
-            <a:ext cx="2236394" cy="588874"/>
-          </a:xfrm>
-          <a:prstGeom prst="rect">
-            <a:avLst/>
-          </a:prstGeom>
-          <a:noFill/>
-          <a:ln/>
-        </p:spPr>
-        <p:txBody>
-          <a:bodyPr wrap="square" lIns="0" tIns="0" rIns="0" bIns="0" rtlCol="0" anchor="t">
-            <a:normAutofit/>
-          </a:bodyPr>
-          <a:lstStyle/>
-          <a:p>
-            <a:pPr indent="0" marL="0">
-              <a:buNone/>
-            </a:pPr>
-            <a:r>
-              <a:rPr lang="en-US" sz="1200" dirty="0">
-                <a:solidFill>
-                  <a:srgbClr val="4D5B69"/>
-                </a:solidFill>
-                <a:latin typeface="Calibri" pitchFamily="34" charset="0"/>
-                <a:ea typeface="Calibri" pitchFamily="34" charset="-122"/>
-                <a:cs typeface="Calibri" pitchFamily="34" charset="-120"/>
-              </a:rPr>
-              <a:t>kept but summoned to a hearing</a:t>
-            </a:r>
-            <a:endParaRPr lang="en-US" sz="1200" dirty="0"/>
-          </a:p>
-        </p:txBody>
-      </p:sp>
-      <p:sp>
-        <p:nvSpPr>
-          <p:cNvPr id="56" name="Shape 54"/>
-          <p:cNvSpPr/>
-          <p:nvPr/>
-        </p:nvSpPr>
-        <p:spPr>
-          <a:xfrm>
-            <a:off x="9040901" y="1920240"/>
-            <a:ext cx="2602154" cy="1554480"/>
-          </a:xfrm>
-          <a:prstGeom prst="roundRect">
-            <a:avLst>
-              <a:gd name="adj" fmla="val 4706"/>
-            </a:avLst>
-          </a:prstGeom>
-          <a:solidFill>
-            <a:srgbClr val="F4F6F7"/>
-          </a:solidFill>
-          <a:ln/>
-        </p:spPr>
-      </p:sp>
-      <p:sp>
-        <p:nvSpPr>
-          <p:cNvPr id="57" name="Text 55"/>
-          <p:cNvSpPr txBox="1"/>
-          <p:nvPr/>
-        </p:nvSpPr>
-        <p:spPr>
-          <a:xfrm>
-            <a:off x="9223781" y="2029968"/>
-            <a:ext cx="2236394" cy="746150"/>
-          </a:xfrm>
-          <a:prstGeom prst="rect">
-            <a:avLst/>
-          </a:prstGeom>
-          <a:noFill/>
-          <a:ln/>
-        </p:spPr>
-        <p:txBody>
-          <a:bodyPr wrap="square" lIns="0" tIns="0" rIns="0" bIns="0" rtlCol="0" anchor="b">
-            <a:normAutofit/>
-          </a:bodyPr>
-          <a:lstStyle/>
-          <a:p>
-            <a:pPr indent="0" marL="0">
-              <a:buNone/>
-            </a:pPr>
-            <a:r>
-              <a:rPr lang="en-US" sz="2800" b="1" dirty="0">
-                <a:solidFill>
-                  <a:srgbClr val="1F618D"/>
-                </a:solidFill>
-                <a:latin typeface="Cambria" pitchFamily="34" charset="0"/>
-                <a:ea typeface="Cambria" pitchFamily="34" charset="-122"/>
-                <a:cs typeface="Cambria" pitchFamily="34" charset="-120"/>
-              </a:rPr>
-              <a:t>74%</a:t>
-            </a:r>
-            <a:endParaRPr lang="en-US" sz="2800" dirty="0"/>
-          </a:p>
-        </p:txBody>
-      </p:sp>
-      <p:sp>
-        <p:nvSpPr>
-          <p:cNvPr id="58" name="Text 56"/>
-          <p:cNvSpPr txBox="1"/>
-          <p:nvPr/>
-        </p:nvSpPr>
-        <p:spPr>
-          <a:xfrm>
-            <a:off x="9223781" y="2794406"/>
-            <a:ext cx="2236394" cy="588874"/>
-          </a:xfrm>
-          <a:prstGeom prst="rect">
-            <a:avLst/>
-          </a:prstGeom>
-          <a:noFill/>
-          <a:ln/>
-        </p:spPr>
-        <p:txBody>
-          <a:bodyPr wrap="square" lIns="0" tIns="0" rIns="0" bIns="0" rtlCol="0" anchor="t">
-            <a:normAutofit/>
-          </a:bodyPr>
-          <a:lstStyle/>
-          <a:p>
-            <a:pPr indent="0" marL="0">
-              <a:buNone/>
-            </a:pPr>
-            <a:r>
-              <a:rPr lang="en-US" sz="1200" dirty="0">
-                <a:solidFill>
-                  <a:srgbClr val="4D5B69"/>
-                </a:solidFill>
-                <a:latin typeface="Calibri" pitchFamily="34" charset="0"/>
-                <a:ea typeface="Calibri" pitchFamily="34" charset="-122"/>
-                <a:cs typeface="Calibri" pitchFamily="34" charset="-120"/>
-              </a:rPr>
-              <a:t>of electors aged 80 and over struck off</a:t>
-            </a:r>
-            <a:endParaRPr lang="en-US" sz="1200" dirty="0"/>
-          </a:p>
-        </p:txBody>
-      </p:sp>
-      <p:sp>
-        <p:nvSpPr>
-          <p:cNvPr id="59" name="Text 57"/>
-          <p:cNvSpPr txBox="1"/>
-          <p:nvPr/>
-        </p:nvSpPr>
-        <p:spPr>
-          <a:xfrm>
-            <a:off x="548640" y="3840480"/>
-            <a:ext cx="11094415" cy="2377440"/>
-          </a:xfrm>
-          <a:prstGeom prst="rect">
-            <a:avLst/>
-          </a:prstGeom>
-          <a:noFill/>
-          <a:ln/>
-        </p:spPr>
-        <p:txBody>
-          <a:bodyPr wrap="square" lIns="0" tIns="0" rIns="0" bIns="0" rtlCol="0" anchor="t">
-            <a:normAutofit/>
-          </a:bodyPr>
-          <a:lstStyle/>
-          <a:p>
-            <a:pPr marL="342900" indent="-342900">
-              <a:spcAft>
-                <a:spcPts val="800"/>
-              </a:spcAft>
-              <a:buSzPct val="100000"/>
-              <a:buChar char="•"/>
-            </a:pPr>
-            <a:r>
-              <a:rPr lang="en-US" sz="1500" dirty="0">
-                <a:solidFill>
-                  <a:srgbClr val="1C2833"/>
-                </a:solidFill>
-                <a:latin typeface="Calibri" pitchFamily="34" charset="0"/>
-                <a:ea typeface="Calibri" pitchFamily="34" charset="-122"/>
-                <a:cs typeface="Calibri" pitchFamily="34" charset="-120"/>
-              </a:rPr>
-              <a:t>Reasons entered: permanently shifted 64.2%, untraceable or absent 20.8%, dead 8.7%, already enrolled 6.0%.</a:t>
-            </a:r>
-            <a:endParaRPr lang="en-US" sz="1500" dirty="0"/>
-          </a:p>
-          <a:p>
-            <a:pPr marL="342900" indent="-342900">
-              <a:spcAft>
-                <a:spcPts val="800"/>
-              </a:spcAft>
-              <a:buSzPct val="100000"/>
-              <a:buChar char="•"/>
-            </a:pPr>
-            <a:r>
-              <a:rPr lang="en-US" sz="1500" dirty="0">
-                <a:solidFill>
-                  <a:srgbClr val="1C2833"/>
-                </a:solidFill>
-                <a:latin typeface="Calibri" pitchFamily="34" charset="0"/>
-                <a:ea typeface="Calibri" pitchFamily="34" charset="-122"/>
-                <a:cs typeface="Calibri" pitchFamily="34" charset="-120"/>
-              </a:rPr>
-              <a:t>Struck off more names than every valid vote cast in 2023 in Yakutpura and Malakpet.</a:t>
-            </a:r>
-            <a:endParaRPr lang="en-US" sz="1500" dirty="0"/>
-          </a:p>
-          <a:p>
-            <a:pPr marL="342900" indent="-342900">
-              <a:spcAft>
-                <a:spcPts val="800"/>
-              </a:spcAft>
-              <a:buSzPct val="100000"/>
-              <a:buChar char="•"/>
-            </a:pPr>
-            <a:r>
-              <a:rPr lang="en-US" sz="1500" dirty="0">
-                <a:solidFill>
-                  <a:srgbClr val="1C2833"/>
-                </a:solidFill>
-                <a:latin typeface="Calibri" pitchFamily="34" charset="0"/>
-                <a:ea typeface="Calibri" pitchFamily="34" charset="-122"/>
-                <a:cs typeface="Calibri" pitchFamily="34" charset="-120"/>
-              </a:rPr>
-              <a:t>Electors with no link to the 2002 roll were struck off at 51.6%, against 25.3% for those with one.</a:t>
-            </a:r>
-            <a:endParaRPr lang="en-US" sz="1500" dirty="0"/>
-          </a:p>
-          <a:p>
-            <a:pPr marL="342900" indent="-342900">
-              <a:spcAft>
-                <a:spcPts val="800"/>
-              </a:spcAft>
-              <a:buSzPct val="100000"/>
-              <a:buChar char="•"/>
-            </a:pPr>
-            <a:r>
-              <a:rPr lang="en-US" sz="1500" dirty="0">
-                <a:solidFill>
-                  <a:srgbClr val="1C2833"/>
-                </a:solidFill>
-                <a:latin typeface="Calibri" pitchFamily="34" charset="0"/>
-                <a:ea typeface="Calibri" pitchFamily="34" charset="-122"/>
-                <a:cs typeface="Calibri" pitchFamily="34" charset="-120"/>
-              </a:rPr>
-              <a:t>The full Hyderabad report and deck are published separately.</a:t>
-            </a:r>
-            <a:endParaRPr lang="en-US" sz="1500" dirty="0"/>
-          </a:p>
-        </p:txBody>
-      </p:sp>
-    </p:spTree>
-  </p:cSld>
-  <p:clrMapOvr>
-    <a:masterClrMapping/>
-  </p:clrMapOvr>
-</p:sld>
-</file>
-
-<file path=ppt/slides/slide14.xml><?xml version="1.0" encoding="utf-8"?>
-<p:sld xmlns:a="http://schemas.openxmlformats.org/drawingml/2006/main" xmlns:r="http://schemas.openxmlformats.org/officeDocument/2006/relationships" xmlns:p="http://schemas.openxmlformats.org/presentationml/2006/main">
-  <p:cSld name="Slide 14">
-    <p:spTree>
-      <p:nvGrpSpPr>
-        <p:cNvPr id="1" name=""/>
-        <p:cNvGrpSpPr/>
-        <p:nvPr/>
-      </p:nvGrpSpPr>
-      <p:grpSpPr>
-        <a:xfrm>
-          <a:off x="0" y="0"/>
-          <a:ext cx="0" cy="0"/>
-          <a:chOff x="0" y="0"/>
-          <a:chExt cx="0" cy="0"/>
-        </a:xfrm>
-      </p:grpSpPr>
-      <p:sp>
-        <p:nvSpPr>
-          <p:cNvPr id="2" name="Text 0"/>
-          <p:cNvSpPr txBox="1"/>
-          <p:nvPr/>
-        </p:nvSpPr>
-        <p:spPr>
-          <a:xfrm>
-            <a:off x="548640" y="256032"/>
-            <a:ext cx="11094415" cy="274320"/>
-          </a:xfrm>
-          <a:prstGeom prst="rect">
-            <a:avLst/>
-          </a:prstGeom>
-          <a:noFill/>
-          <a:ln/>
-        </p:spPr>
-        <p:txBody>
-          <a:bodyPr wrap="square" lIns="0" tIns="0" rIns="0" bIns="0" rtlCol="0" anchor="ctr"/>
-          <a:lstStyle/>
-          <a:p>
-            <a:pPr indent="0" marL="0">
-              <a:buNone/>
-            </a:pPr>
-            <a:r>
-              <a:rPr lang="en-US" sz="1100" b="1" spc="200" kern="0" dirty="0">
-                <a:solidFill>
-                  <a:srgbClr val="1F618D"/>
-                </a:solidFill>
-                <a:latin typeface="Calibri" pitchFamily="34" charset="0"/>
-                <a:ea typeface="Calibri" pitchFamily="34" charset="-122"/>
-                <a:cs typeface="Calibri" pitchFamily="34" charset="-120"/>
-              </a:rPr>
               <a:t>WHAT THE ELECTION COMMISSION SHOULD DO</a:t>
             </a:r>
             <a:endParaRPr lang="en-US" sz="1100" dirty="0"/>
@@ -15489,7 +12219,7 @@
                 <a:ea typeface="Calibri" pitchFamily="34" charset="-122"/>
                 <a:cs typeface="Calibri" pitchFamily="34" charset="-120"/>
               </a:rPr>
-              <a:t>14</a:t>
+              <a:t>12</a:t>
             </a:r>
             <a:endParaRPr lang="en-US" sz="900" dirty="0"/>
           </a:p>
@@ -16437,9 +13167,9 @@
 </p:sld>
 </file>
 
-<file path=ppt/slides/slide15.xml><?xml version="1.0" encoding="utf-8"?>
+<file path=ppt/slides/slide13.xml><?xml version="1.0" encoding="utf-8"?>
 <p:sld xmlns:a="http://schemas.openxmlformats.org/drawingml/2006/main" xmlns:r="http://schemas.openxmlformats.org/officeDocument/2006/relationships" xmlns:p="http://schemas.openxmlformats.org/presentationml/2006/main">
-  <p:cSld name="Slide 15">
+  <p:cSld name="Slide 13">
     <p:spTree>
       <p:nvGrpSpPr>
         <p:cNvPr id="1" name=""/>
@@ -16606,7 +13336,7 @@
                 <a:ea typeface="Calibri" pitchFamily="34" charset="-122"/>
                 <a:cs typeface="Calibri" pitchFamily="34" charset="-120"/>
               </a:rPr>
-              <a:t>15</a:t>
+              <a:t>13</a:t>
             </a:r>
             <a:endParaRPr lang="en-US" sz="900" dirty="0"/>
           </a:p>
@@ -17535,7 +14265,7 @@
                 <a:ea typeface="Calibri" pitchFamily="34" charset="-122"/>
                 <a:cs typeface="Calibri" pitchFamily="34" charset="-120"/>
               </a:rPr>
-              <a:t>Bihar and Hyderabad findings are counted from the lists; their methods are in their own reports. No name, EPIC number or address is published.</a:t>
+              <a:t>No name, EPIC number or address is published.</a:t>
             </a:r>
             <a:endParaRPr lang="en-US" sz="1500" dirty="0"/>
           </a:p>
@@ -17549,9 +14279,9 @@
 </p:sld>
 </file>
 
-<file path=ppt/slides/slide16.xml><?xml version="1.0" encoding="utf-8"?>
+<file path=ppt/slides/slide14.xml><?xml version="1.0" encoding="utf-8"?>
 <p:sld xmlns:a="http://schemas.openxmlformats.org/drawingml/2006/main" xmlns:r="http://schemas.openxmlformats.org/officeDocument/2006/relationships" xmlns:p="http://schemas.openxmlformats.org/presentationml/2006/main">
-  <p:cSld name="Slide 16">
+  <p:cSld name="Slide 14">
     <p:bg>
       <p:bgPr>
         <a:solidFill>
@@ -17648,7 +14378,7 @@
                 <a:ea typeface="Calibri" pitchFamily="34" charset="-122"/>
                 <a:cs typeface="Calibri" pitchFamily="34" charset="-120"/>
               </a:rPr>
-              <a:t>The All India table with a source for every row, the Bihar and Hyderabad dashboards, and the three full reports are published online alongside this deck.</a:t>
+              <a:t>The All India table with a source for every row, and the full report, are published online alongside this deck.</a:t>
             </a:r>
             <a:endParaRPr lang="en-US" sz="1700" dirty="0"/>
           </a:p>
@@ -19394,27 +16124,7 @@
                 <a:ea typeface="Calibri" pitchFamily="34" charset="-122"/>
                 <a:cs typeface="Calibri" pitchFamily="34" charset="-120"/>
               </a:rPr>
-              <a:t>Bihar, from the lists   12–12</a:t>
-            </a:r>
-            <a:endParaRPr lang="en-US" sz="1700" dirty="0"/>
-          </a:p>
-          <a:p>
-            <a:pPr indent="0" marL="0">
-              <a:spcAft>
-                <a:spcPts val="1200"/>
-              </a:spcAft>
-              <a:buNone/>
-            </a:pPr>
-            <a:r>
-              <a:rPr lang="en-US" sz="1700" dirty="0">
-                <a:solidFill>
-                  <a:srgbClr val="1C2833"/>
-                </a:solidFill>
-                <a:latin typeface="Calibri" pitchFamily="34" charset="0"/>
-                <a:ea typeface="Calibri" pitchFamily="34" charset="-122"/>
-                <a:cs typeface="Calibri" pitchFamily="34" charset="-120"/>
-              </a:rPr>
-              <a:t>Hyderabad Old City, from the lists   13–13</a:t>
+              <a:t>What the Election Commission should do   12–12</a:t>
             </a:r>
             <a:endParaRPr lang="en-US" sz="1700" dirty="0"/>
           </a:p>
@@ -19456,27 +16166,7 @@
                 <a:ea typeface="Calibri" pitchFamily="34" charset="-122"/>
                 <a:cs typeface="Calibri" pitchFamily="34" charset="-120"/>
               </a:rPr>
-              <a:t>What the Election Commission should do   14–14</a:t>
-            </a:r>
-            <a:endParaRPr lang="en-US" sz="1700" dirty="0"/>
-          </a:p>
-          <a:p>
-            <a:pPr indent="0" marL="0">
-              <a:spcAft>
-                <a:spcPts val="1200"/>
-              </a:spcAft>
-              <a:buNone/>
-            </a:pPr>
-            <a:r>
-              <a:rPr lang="en-US" sz="1700" dirty="0">
-                <a:solidFill>
-                  <a:srgbClr val="1C2833"/>
-                </a:solidFill>
-                <a:latin typeface="Calibri" pitchFamily="34" charset="0"/>
-                <a:ea typeface="Calibri" pitchFamily="34" charset="-122"/>
-                <a:cs typeface="Calibri" pitchFamily="34" charset="-120"/>
-              </a:rPr>
-              <a:t>Method   15–16</a:t>
+              <a:t>Method   13–14</a:t>
             </a:r>
             <a:endParaRPr lang="en-US" sz="1700" dirty="0"/>
           </a:p>

</xml_diff>

<commit_message>
Net change after the final rolls: 20 states and every Bihar seat
data/india/raw/final.csv records each published final roll with its source
and whether the figures add up; states that reported the net rise as
additions are marked net only. data/bihar/raw/final_roll_format4b.csv is the
Commission's Format 4B return; build_bihar_final.py checks every seat and the
press-note totals. New sections on the All India page, the Bihar results page
and FAQ, both method pages, both reports and both decks, in all four
languages.

Co-Authored-By: Claude Opus 5.5 <noreply@anthropic.com>
Claude-Session: https://claude.ai/code/session_01FWx24PCx3Jw4SUDQC6oU7o
</commit_message>
<xml_diff>
--- a/reports/sir-india-deck.pptx
+++ b/reports/sir-india-deck.pptx
@@ -21,9 +21,10 @@
     <p:sldId id="269" r:id="rId15"/>
     <p:sldId id="270" r:id="rId16"/>
     <p:sldId id="271" r:id="rId17"/>
+    <p:sldId id="272" r:id="rId18"/>
   </p:sldIdLst>
   <p:notesMasterIdLst>
-    <p:notesMasterId r:id="rId18"/>
+    <p:notesMasterId r:id="rId19"/>
   </p:notesMasterIdLst>
   <p:sldSz cx="12192000" cy="6858000"/>
   <p:notesSz cx="6858000" cy="12192000"/>
@@ -3175,6 +3176,538 @@
 </c:chartSpace>
 </file>
 
+<file path=ppt/charts/chart6.xml><?xml version="1.0" encoding="utf-8"?>
+<c:chartSpace xmlns:c="http://schemas.openxmlformats.org/drawingml/2006/chart" xmlns:a="http://schemas.openxmlformats.org/drawingml/2006/main" xmlns:r="http://schemas.openxmlformats.org/officeDocument/2006/relationships">
+  <c:date1904 val="0"/>
+  <c:roundedCorners val="1"/>
+  <c:chart>
+    <c:autoTitleDeleted val="1"/>
+    <c:plotArea>
+      <c:layout/>
+      <c:barChart>
+        <c:barDir val="bar"/>
+        <c:grouping val="clustered"/>
+        <c:varyColors val="0"/>
+        <c:ser>
+          <c:idx val="0"/>
+          <c:order val="0"/>
+          <c:tx>
+            <c:strRef>
+              <c:f>Sheet1!$B$1</c:f>
+              <c:strCache>
+                <c:ptCount val="1"/>
+                <c:pt idx="0">
+                  <c:v>Removed at the draft</c:v>
+                </c:pt>
+              </c:strCache>
+            </c:strRef>
+          </c:tx>
+          <c:spPr>
+            <a:solidFill>
+              <a:srgbClr val="95A5A6"/>
+            </a:solidFill>
+            <a:effectLst/>
+          </c:spPr>
+          <c:invertIfNegative val="0"/>
+          <c:dLbls>
+            <c:numFmt formatCode="#,##0" sourceLinked="0"/>
+            <c:txPr>
+              <a:bodyPr/>
+              <a:lstStyle/>
+              <a:p>
+                <a:pPr>
+                  <a:defRPr b="0" i="0" strike="noStrike" sz="1000" u="none">
+                    <a:solidFill>
+                      <a:srgbClr val="1C2833"/>
+                    </a:solidFill>
+                    <a:latin typeface="Calibri"/>
+                  </a:defRPr>
+                </a:pPr>
+              </a:p>
+            </c:txPr>
+            <c:showLegendKey val="0"/>
+            <c:showVal val="0"/>
+            <c:showCatName val="0"/>
+            <c:showSerName val="0"/>
+            <c:showPercent val="0"/>
+            <c:showBubbleSize val="0"/>
+            <c:showLeaderLines val="0"/>
+          </c:dLbls>
+          <c:cat>
+            <c:multiLvlStrRef>
+              <c:f>Sheet1!$A$2:$A$20</c:f>
+              <c:multiLvlStrCache>
+                <c:ptCount val="19"/>
+                <c:lvl>
+                  <c:pt idx="0">
+                    <c:v>Dadra and Nagar Haveli and Daman and Diu</c:v>
+                  </c:pt>
+                  <c:pt idx="1">
+                    <c:v>Arunachal Pradesh</c:v>
+                  </c:pt>
+                  <c:pt idx="2">
+                    <c:v>Andaman and Nicobar Islands</c:v>
+                  </c:pt>
+                  <c:pt idx="3">
+                    <c:v>West Bengal</c:v>
+                  </c:pt>
+                  <c:pt idx="4">
+                    <c:v>Gujarat</c:v>
+                  </c:pt>
+                  <c:pt idx="5">
+                    <c:v>Uttar Pradesh</c:v>
+                  </c:pt>
+                  <c:pt idx="6">
+                    <c:v>Chhattisgarh</c:v>
+                  </c:pt>
+                  <c:pt idx="7">
+                    <c:v>Tamil Nadu</c:v>
+                  </c:pt>
+                  <c:pt idx="8">
+                    <c:v>Sikkim</c:v>
+                  </c:pt>
+                  <c:pt idx="9">
+                    <c:v>Goa</c:v>
+                  </c:pt>
+                  <c:pt idx="10">
+                    <c:v>Puducherry</c:v>
+                  </c:pt>
+                  <c:pt idx="11">
+                    <c:v>Manipur</c:v>
+                  </c:pt>
+                  <c:pt idx="12">
+                    <c:v>Bihar</c:v>
+                  </c:pt>
+                  <c:pt idx="13">
+                    <c:v>Madhya Pradesh</c:v>
+                  </c:pt>
+                  <c:pt idx="14">
+                    <c:v>Rajasthan</c:v>
+                  </c:pt>
+                  <c:pt idx="15">
+                    <c:v>Odisha</c:v>
+                  </c:pt>
+                  <c:pt idx="16">
+                    <c:v>Mizoram</c:v>
+                  </c:pt>
+                  <c:pt idx="17">
+                    <c:v>Kerala</c:v>
+                  </c:pt>
+                  <c:pt idx="18">
+                    <c:v>Lakshadweep</c:v>
+                  </c:pt>
+                </c:lvl>
+              </c:multiLvlStrCache>
+            </c:multiLvlStrRef>
+          </c:cat>
+          <c:val>
+            <c:numRef>
+              <c:f>Sheet1!$B$2:$B$20</c:f>
+              <c:numCache>
+                <c:formatCode>General</c:formatCode>
+                <c:ptCount val="19"/>
+                <c:pt idx="0">
+                  <c:v>29.65</c:v>
+                </c:pt>
+                <c:pt idx="1">
+                  <c:v>19.09</c:v>
+                </c:pt>
+                <c:pt idx="2">
+                  <c:v>20.62</c:v>
+                </c:pt>
+                <c:pt idx="3">
+                  <c:v>7.6</c:v>
+                </c:pt>
+                <c:pt idx="4">
+                  <c:v>14.51</c:v>
+                </c:pt>
+                <c:pt idx="5">
+                  <c:v>18.72</c:v>
+                </c:pt>
+                <c:pt idx="6">
+                  <c:v>12.88</c:v>
+                </c:pt>
+                <c:pt idx="7">
+                  <c:v>15.19</c:v>
+                </c:pt>
+                <c:pt idx="8">
+                  <c:v>8.01</c:v>
+                </c:pt>
+                <c:pt idx="9">
+                  <c:v>8.44</c:v>
+                </c:pt>
+                <c:pt idx="10">
+                  <c:v>10.13</c:v>
+                </c:pt>
+                <c:pt idx="11">
+                  <c:v>7.58</c:v>
+                </c:pt>
+                <c:pt idx="12">
+                  <c:v>8.31</c:v>
+                </c:pt>
+                <c:pt idx="13">
+                  <c:v>7.45</c:v>
+                </c:pt>
+                <c:pt idx="14">
+                  <c:v>7.65</c:v>
+                </c:pt>
+                <c:pt idx="15">
+                  <c:v>6.03</c:v>
+                </c:pt>
+                <c:pt idx="16">
+                  <c:v>5.28</c:v>
+                </c:pt>
+                <c:pt idx="17">
+                  <c:v>8.65</c:v>
+                </c:pt>
+                <c:pt idx="18">
+                  <c:v>2.47</c:v>
+                </c:pt>
+              </c:numCache>
+            </c:numRef>
+          </c:val>
+        </c:ser>
+        <c:ser>
+          <c:idx val="1"/>
+          <c:order val="1"/>
+          <c:tx>
+            <c:strRef>
+              <c:f>Sheet1!$C$1</c:f>
+              <c:strCache>
+                <c:ptCount val="1"/>
+                <c:pt idx="0">
+                  <c:v>Net fall at the final roll</c:v>
+                </c:pt>
+              </c:strCache>
+            </c:strRef>
+          </c:tx>
+          <c:spPr>
+            <a:solidFill>
+              <a:srgbClr val="1F618D"/>
+            </a:solidFill>
+            <a:effectLst/>
+          </c:spPr>
+          <c:invertIfNegative val="0"/>
+          <c:dLbls>
+            <c:numFmt formatCode="#,##0" sourceLinked="0"/>
+            <c:txPr>
+              <a:bodyPr/>
+              <a:lstStyle/>
+              <a:p>
+                <a:pPr>
+                  <a:defRPr b="0" i="0" strike="noStrike" sz="1000" u="none">
+                    <a:solidFill>
+                      <a:srgbClr val="1C2833"/>
+                    </a:solidFill>
+                    <a:latin typeface="Calibri"/>
+                  </a:defRPr>
+                </a:pPr>
+              </a:p>
+            </c:txPr>
+            <c:showLegendKey val="0"/>
+            <c:showVal val="0"/>
+            <c:showCatName val="0"/>
+            <c:showSerName val="0"/>
+            <c:showPercent val="0"/>
+            <c:showBubbleSize val="0"/>
+            <c:showLeaderLines val="0"/>
+          </c:dLbls>
+          <c:cat>
+            <c:multiLvlStrRef>
+              <c:f>Sheet1!$A$2:$A$20</c:f>
+              <c:multiLvlStrCache>
+                <c:ptCount val="19"/>
+                <c:lvl>
+                  <c:pt idx="0">
+                    <c:v>Dadra and Nagar Haveli and Daman and Diu</c:v>
+                  </c:pt>
+                  <c:pt idx="1">
+                    <c:v>Arunachal Pradesh</c:v>
+                  </c:pt>
+                  <c:pt idx="2">
+                    <c:v>Andaman and Nicobar Islands</c:v>
+                  </c:pt>
+                  <c:pt idx="3">
+                    <c:v>West Bengal</c:v>
+                  </c:pt>
+                  <c:pt idx="4">
+                    <c:v>Gujarat</c:v>
+                  </c:pt>
+                  <c:pt idx="5">
+                    <c:v>Uttar Pradesh</c:v>
+                  </c:pt>
+                  <c:pt idx="6">
+                    <c:v>Chhattisgarh</c:v>
+                  </c:pt>
+                  <c:pt idx="7">
+                    <c:v>Tamil Nadu</c:v>
+                  </c:pt>
+                  <c:pt idx="8">
+                    <c:v>Sikkim</c:v>
+                  </c:pt>
+                  <c:pt idx="9">
+                    <c:v>Goa</c:v>
+                  </c:pt>
+                  <c:pt idx="10">
+                    <c:v>Puducherry</c:v>
+                  </c:pt>
+                  <c:pt idx="11">
+                    <c:v>Manipur</c:v>
+                  </c:pt>
+                  <c:pt idx="12">
+                    <c:v>Bihar</c:v>
+                  </c:pt>
+                  <c:pt idx="13">
+                    <c:v>Madhya Pradesh</c:v>
+                  </c:pt>
+                  <c:pt idx="14">
+                    <c:v>Rajasthan</c:v>
+                  </c:pt>
+                  <c:pt idx="15">
+                    <c:v>Odisha</c:v>
+                  </c:pt>
+                  <c:pt idx="16">
+                    <c:v>Mizoram</c:v>
+                  </c:pt>
+                  <c:pt idx="17">
+                    <c:v>Kerala</c:v>
+                  </c:pt>
+                  <c:pt idx="18">
+                    <c:v>Lakshadweep</c:v>
+                  </c:pt>
+                </c:lvl>
+              </c:multiLvlStrCache>
+            </c:multiLvlStrRef>
+          </c:cat>
+          <c:val>
+            <c:numRef>
+              <c:f>Sheet1!$C$2:$C$20</c:f>
+              <c:numCache>
+                <c:formatCode>General</c:formatCode>
+                <c:ptCount val="19"/>
+                <c:pt idx="0">
+                  <c:v>30.89</c:v>
+                </c:pt>
+                <c:pt idx="1">
+                  <c:v>21.57</c:v>
+                </c:pt>
+                <c:pt idx="2">
+                  <c:v>16.87</c:v>
+                </c:pt>
+                <c:pt idx="3">
+                  <c:v>15.9</c:v>
+                </c:pt>
+                <c:pt idx="4">
+                  <c:v>13.41</c:v>
+                </c:pt>
+                <c:pt idx="5">
+                  <c:v>13.26</c:v>
+                </c:pt>
+                <c:pt idx="6">
+                  <c:v>11.77</c:v>
+                </c:pt>
+                <c:pt idx="7">
+                  <c:v>11.55</c:v>
+                </c:pt>
+                <c:pt idx="8">
+                  <c:v>11.16</c:v>
+                </c:pt>
+                <c:pt idx="9">
+                  <c:v>10.76</c:v>
+                </c:pt>
+                <c:pt idx="10">
+                  <c:v>7.57</c:v>
+                </c:pt>
+                <c:pt idx="11">
+                  <c:v>6.33</c:v>
+                </c:pt>
+                <c:pt idx="12">
+                  <c:v>6.05</c:v>
+                </c:pt>
+                <c:pt idx="13">
+                  <c:v>5.97</c:v>
+                </c:pt>
+                <c:pt idx="14">
+                  <c:v>5.73</c:v>
+                </c:pt>
+                <c:pt idx="15">
+                  <c:v>5.29</c:v>
+                </c:pt>
+                <c:pt idx="16">
+                  <c:v>4.48</c:v>
+                </c:pt>
+                <c:pt idx="17">
+                  <c:v>3.22</c:v>
+                </c:pt>
+                <c:pt idx="18">
+                  <c:v>0.36</c:v>
+                </c:pt>
+              </c:numCache>
+            </c:numRef>
+          </c:val>
+        </c:ser>
+        <c:dLbls>
+          <c:numFmt formatCode="#,##0" sourceLinked="0"/>
+          <c:txPr>
+            <a:bodyPr/>
+            <a:lstStyle/>
+            <a:p>
+              <a:pPr>
+                <a:defRPr b="0" i="0" strike="noStrike" sz="1000" u="none">
+                  <a:solidFill>
+                    <a:srgbClr val="1C2833"/>
+                  </a:solidFill>
+                  <a:latin typeface="Calibri"/>
+                </a:defRPr>
+              </a:pPr>
+            </a:p>
+          </c:txPr>
+          <c:showLegendKey val="0"/>
+          <c:showVal val="0"/>
+          <c:showCatName val="0"/>
+          <c:showSerName val="0"/>
+          <c:showPercent val="0"/>
+          <c:showBubbleSize val="0"/>
+          <c:showLeaderLines val="0"/>
+        </c:dLbls>
+        <c:gapWidth val="150"/>
+        <c:overlap val="0"/>
+        <c:axId val="2094734554"/>
+        <c:axId val="2094734552"/>
+        <c:axId val="2094734556"/>
+      </c:barChart>
+      <c:catAx>
+        <c:axId val="2094734554"/>
+        <c:scaling>
+          <c:orientation val="minMax"/>
+        </c:scaling>
+        <c:delete val="0"/>
+        <c:axPos val="l"/>
+        <c:numFmt formatCode="General" sourceLinked="1"/>
+        <c:majorTickMark val="out"/>
+        <c:minorTickMark val="none"/>
+        <c:tickLblPos val="nextTo"/>
+        <c:spPr>
+          <a:ln w="12700" cap="flat">
+            <a:solidFill>
+              <a:srgbClr val="888888"/>
+            </a:solidFill>
+            <a:prstDash val="solid"/>
+            <a:round/>
+          </a:ln>
+        </c:spPr>
+        <c:txPr>
+          <a:bodyPr/>
+          <a:lstStyle/>
+          <a:p>
+            <a:pPr>
+              <a:defRPr sz="900" b="0" i="0" u="none" strike="noStrike">
+                <a:solidFill>
+                  <a:srgbClr val="4D5B69"/>
+                </a:solidFill>
+                <a:latin typeface="Calibri"/>
+              </a:defRPr>
+            </a:pPr>
+            <a:endParaRPr lang="en-US"/>
+          </a:p>
+        </c:txPr>
+        <c:crossAx val="2094734552"/>
+        <c:crosses val="autoZero"/>
+        <c:auto val="1"/>
+        <c:lblAlgn val="ctr"/>
+        <c:noMultiLvlLbl val="1"/>
+      </c:catAx>
+      <c:valAx>
+        <c:axId val="2094734552"/>
+        <c:scaling>
+          <c:orientation val="minMax"/>
+        </c:scaling>
+        <c:delete val="0"/>
+        <c:axPos val="b"/>
+        <c:majorGridlines>
+          <c:spPr>
+            <a:ln w="6350" cap="flat">
+              <a:solidFill>
+                <a:srgbClr val="E1E5E8"/>
+              </a:solidFill>
+              <a:prstDash val="solid"/>
+              <a:round/>
+            </a:ln>
+          </c:spPr>
+        </c:majorGridlines>
+        <c:numFmt formatCode="0" sourceLinked="0"/>
+        <c:majorTickMark val="out"/>
+        <c:minorTickMark val="none"/>
+        <c:tickLblPos val="low"/>
+        <c:spPr>
+          <a:ln w="12700" cap="flat">
+            <a:solidFill>
+              <a:srgbClr val="888888"/>
+            </a:solidFill>
+            <a:prstDash val="solid"/>
+            <a:round/>
+          </a:ln>
+        </c:spPr>
+        <c:txPr>
+          <a:bodyPr/>
+          <a:lstStyle/>
+          <a:p>
+            <a:pPr>
+              <a:defRPr sz="1000" b="0" i="0" u="none" strike="noStrike">
+                <a:solidFill>
+                  <a:srgbClr val="4D5B69"/>
+                </a:solidFill>
+                <a:latin typeface="Calibri"/>
+              </a:defRPr>
+            </a:pPr>
+            <a:endParaRPr lang="en-US"/>
+          </a:p>
+        </c:txPr>
+        <c:crossAx val="2094734554"/>
+        <c:crosses val="autoZero"/>
+        <c:crossBetween val="between"/>
+      </c:valAx>
+      <c:spPr>
+        <a:noFill/>
+        <a:ln>
+          <a:noFill/>
+        </a:ln>
+        <a:effectLst/>
+      </c:spPr>
+    </c:plotArea>
+    <c:legend>
+      <c:legendPos val="b"/>
+      <c:overlay val="0"/>
+      <c:txPr>
+        <a:bodyPr/>
+        <a:lstStyle/>
+        <a:p>
+          <a:pPr>
+            <a:defRPr sz="1100">
+              <a:latin typeface="Calibri"/>
+              <a:cs typeface="Calibri"/>
+            </a:defRPr>
+          </a:pPr>
+          <a:endParaRPr lang="en-US"/>
+        </a:p>
+      </c:txPr>
+    </c:legend>
+    <c:plotVisOnly val="1"/>
+    <c:dispBlanksAs val="span"/>
+  </c:chart>
+  <c:spPr>
+    <a:noFill/>
+    <a:ln>
+      <a:noFill/>
+    </a:ln>
+    <a:effectLst/>
+  </c:spPr>
+  <c:externalData r:id="rId1">
+    <c:autoUpdate val="0"/>
+  </c:externalData>
+</c:chartSpace>
+</file>
+
 <file path=ppt/notesMasters/notesMaster1.xml><?xml version="1.0" encoding="utf-8"?>
 <p:notesMaster xmlns:a="http://schemas.openxmlformats.org/drawingml/2006/main" xmlns:r="http://schemas.openxmlformats.org/officeDocument/2006/relationships" xmlns:p="http://schemas.openxmlformats.org/presentationml/2006/main">
   <p:cSld>
@@ -3922,7 +4455,7 @@
           <a:p>
             <a:r>
               <a:rPr lang="en-US" dirty="0"/>
-              <a:t/>
+              <a:t>Still to publish a final roll: Maharashtra, Karnataka, Telangana, Delhi, Andhra Pradesh, Jharkhand, Haryana, Punjab, Uttarakhand, Meghalaya, Nagaland. Removals after the draft carry no reason in any state except Bihar. Rank correlation between the removal rate at the draft and the share made up: -0.12, no relationship.</a:t>
             </a:r>
             <a:endParaRPr lang="en-US" dirty="0"/>
           </a:p>
@@ -4210,6 +4743,94 @@
             <a:fld id="{F7021451-1387-4CA6-816F-3879F97B5CBC}" type="slidenum">
               <a:rPr lang="en-US"/>
               <a:t>16</a:t>
+            </a:fld>
+            <a:endParaRPr lang="en-US"/>
+          </a:p>
+        </p:txBody>
+      </p:sp>
+    </p:spTree>
+    <p:extLst>
+      <p:ext uri="{BB962C8B-B14F-4D97-AF65-F5344CB8AC3E}">
+        <p14:creationId xmlns:p14="http://schemas.microsoft.com/office/powerpoint/2010/main" val="1024086991"/>
+      </p:ext>
+    </p:extLst>
+  </p:cSld>
+  <p:clrMapOvr>
+    <a:masterClrMapping/>
+  </p:clrMapOvr>
+</p:notes>
+</file>
+
+<file path=ppt/notesSlides/notesSlide17.xml><?xml version="1.0" encoding="utf-8"?>
+<p:notes xmlns:a="http://schemas.openxmlformats.org/drawingml/2006/main" xmlns:r="http://schemas.openxmlformats.org/officeDocument/2006/relationships" xmlns:p="http://schemas.openxmlformats.org/presentationml/2006/main">
+  <p:cSld>
+    <p:spTree>
+      <p:nvGrpSpPr>
+        <p:cNvPr id="1" name=""/>
+        <p:cNvGrpSpPr/>
+        <p:nvPr/>
+      </p:nvGrpSpPr>
+      <p:grpSpPr>
+        <a:xfrm>
+          <a:off x="0" y="0"/>
+          <a:ext cx="0" cy="0"/>
+          <a:chOff x="0" y="0"/>
+          <a:chExt cx="0" cy="0"/>
+        </a:xfrm>
+      </p:grpSpPr>
+      <p:sp>
+        <p:nvSpPr>
+          <p:cNvPr id="2" name="Slide Image Placeholder 1"/>
+          <p:cNvSpPr>
+            <a:spLocks noGrp="1" noRot="1" noChangeAspect="1"/>
+          </p:cNvSpPr>
+          <p:nvPr>
+            <p:ph type="sldImg"/>
+          </p:nvPr>
+        </p:nvSpPr>
+        <p:spPr/>
+      </p:sp>
+      <p:sp>
+        <p:nvSpPr>
+          <p:cNvPr id="3" name="Notes Placeholder 2"/>
+          <p:cNvSpPr>
+            <a:spLocks noGrp="1"/>
+          </p:cNvSpPr>
+          <p:nvPr>
+            <p:ph type="body" idx="1"/>
+          </p:nvPr>
+        </p:nvSpPr>
+        <p:spPr/>
+        <p:txBody>
+          <a:bodyPr/>
+          <a:lstStyle/>
+          <a:p>
+            <a:r>
+              <a:rPr lang="en-US" dirty="0"/>
+              <a:t/>
+            </a:r>
+            <a:endParaRPr lang="en-US" dirty="0"/>
+          </a:p>
+        </p:txBody>
+      </p:sp>
+      <p:sp>
+        <p:nvSpPr>
+          <p:cNvPr id="4" name="Slide Number Placeholder 3"/>
+          <p:cNvSpPr>
+            <a:spLocks noGrp="1"/>
+          </p:cNvSpPr>
+          <p:nvPr>
+            <p:ph type="sldNum" sz="quarter" idx="10"/>
+          </p:nvPr>
+        </p:nvSpPr>
+        <p:spPr/>
+        <p:txBody>
+          <a:bodyPr/>
+          <a:lstStyle/>
+          <a:p>
+            <a:fld id="{F7021451-1387-4CA6-816F-3879F97B5CBC}" type="slidenum">
+              <a:rPr lang="en-US"/>
+              <a:t>17</a:t>
             </a:fld>
             <a:endParaRPr lang="en-US"/>
           </a:p>
@@ -23027,7 +23648,7 @@
                 <a:ea typeface="Cambria" pitchFamily="34" charset="-122"/>
                 <a:cs typeface="Cambria" pitchFamily="34" charset="-120"/>
               </a:rPr>
-              <a:t>After the draft, 27.6 lakh more names were removed in 17 states, with no reason given</a:t>
+              <a:t>The final rolls made up 14.2% of the names left off the drafts in 20 states</a:t>
             </a:r>
             <a:endParaRPr lang="en-US" sz="2700" dirty="0"/>
           </a:p>
@@ -23066,7 +23687,7 @@
                 <a:ea typeface="Calibri" pitchFamily="34" charset="-122"/>
                 <a:cs typeface="Calibri" pitchFamily="34" charset="-120"/>
               </a:rPr>
-              <a:t>What the state figures show, and what they cannot</a:t>
+              <a:t>Removed at the draft, and the fall that remains at the final roll, per 100 electors on the roll before</a:t>
             </a:r>
             <a:endParaRPr lang="en-US" sz="1400" dirty="0"/>
           </a:p>
@@ -23950,38 +24571,32 @@
           <a:ln/>
         </p:spPr>
       </p:sp>
-      <p:sp>
-        <p:nvSpPr>
-          <p:cNvPr id="47" name="Shape 45"/>
-          <p:cNvSpPr/>
-          <p:nvPr/>
-        </p:nvSpPr>
-        <p:spPr>
-          <a:xfrm>
-            <a:off x="548640" y="1554480"/>
-            <a:ext cx="5440680" cy="1920240"/>
-          </a:xfrm>
-          <a:prstGeom prst="roundRect">
-            <a:avLst>
-              <a:gd name="adj" fmla="val 4762"/>
-            </a:avLst>
-          </a:prstGeom>
-          <a:solidFill>
-            <a:srgbClr val="EAF1F8"/>
-          </a:solidFill>
-          <a:ln/>
-        </p:spPr>
-      </p:sp>
-      <p:sp>
-        <p:nvSpPr>
-          <p:cNvPr id="48" name="Text 46"/>
+      <p:graphicFrame>
+        <p:nvGraphicFramePr>
+          <p:cNvPr id="47" name="Chart 0" descr=""/>
+          <p:cNvGraphicFramePr/>
+          <p:nvPr/>
+        </p:nvGraphicFramePr>
+        <p:xfrm>
+          <a:off x="548640" y="1920240"/>
+          <a:ext cx="7040880" cy="4343400"/>
+        </p:xfrm>
+        <a:graphic xmlns:a="http://schemas.openxmlformats.org/drawingml/2006/main">
+          <a:graphicData uri="http://schemas.openxmlformats.org/drawingml/2006/chart">
+            <c:chart xmlns:c="http://schemas.openxmlformats.org/drawingml/2006/chart" r:id="rId1"/>
+          </a:graphicData>
+        </a:graphic>
+      </p:graphicFrame>
+      <p:sp>
+        <p:nvSpPr>
+          <p:cNvPr id="48" name="Text 45"/>
           <p:cNvSpPr txBox="1"/>
           <p:nvPr/>
         </p:nvSpPr>
         <p:spPr>
           <a:xfrm>
-            <a:off x="777240" y="1719072"/>
-            <a:ext cx="4983480" cy="1591056"/>
+            <a:off x="7909560" y="2011680"/>
+            <a:ext cx="3733495" cy="4251960"/>
           </a:xfrm>
           <a:prstGeom prst="rect">
             <a:avLst/>
@@ -23995,11 +24610,15 @@
           </a:bodyPr>
           <a:lstStyle/>
           <a:p>
-            <a:pPr indent="0" marL="0">
-              <a:buNone/>
+            <a:pPr marL="342900" indent="-342900">
+              <a:spcAft>
+                <a:spcPts val="800"/>
+              </a:spcAft>
+              <a:buSzPct val="100000"/>
+              <a:buChar char="•"/>
             </a:pPr>
             <a:r>
-              <a:rPr lang="en-US" sz="1500" dirty="0">
+              <a:rPr lang="en-US" sz="1250" dirty="0">
                 <a:solidFill>
                   <a:srgbClr val="1C2833"/>
                 </a:solidFill>
@@ -24007,62 +24626,20 @@
                 <a:ea typeface="Calibri" pitchFamily="34" charset="-122"/>
                 <a:cs typeface="Calibri" pitchFamily="34" charset="-120"/>
               </a:rPr>
-              <a:t>They show how many names each state left off its draft roll and the reason its officers entered: dead, shifted or absent (with "others" where reported), or enrolled more than once.</a:t>
+              <a:t>The final rolls came out 1.06 crore larger than the drafts, against 7.49 crore left off them.</a:t>
             </a:r>
-            <a:endParaRPr lang="en-US" sz="1500" dirty="0"/>
+            <a:endParaRPr lang="en-US" sz="1250" dirty="0"/>
           </a:p>
-        </p:txBody>
-      </p:sp>
-      <p:sp>
-        <p:nvSpPr>
-          <p:cNvPr id="49" name="Shape 47"/>
-          <p:cNvSpPr/>
-          <p:nvPr/>
-        </p:nvSpPr>
-        <p:spPr>
-          <a:xfrm>
-            <a:off x="6199632" y="1554480"/>
-            <a:ext cx="5440680" cy="1920240"/>
-          </a:xfrm>
-          <a:prstGeom prst="roundRect">
-            <a:avLst>
-              <a:gd name="adj" fmla="val 4762"/>
-            </a:avLst>
-          </a:prstGeom>
-          <a:solidFill>
-            <a:srgbClr val="EAF1F8"/>
-          </a:solidFill>
-          <a:ln/>
-        </p:spPr>
-      </p:sp>
-      <p:sp>
-        <p:nvSpPr>
-          <p:cNvPr id="50" name="Text 48"/>
-          <p:cNvSpPr txBox="1"/>
-          <p:nvPr/>
-        </p:nvSpPr>
-        <p:spPr>
-          <a:xfrm>
-            <a:off x="6428232" y="1719072"/>
-            <a:ext cx="4983480" cy="1591056"/>
-          </a:xfrm>
-          <a:prstGeom prst="rect">
-            <a:avLst/>
-          </a:prstGeom>
-          <a:noFill/>
-          <a:ln/>
-        </p:spPr>
-        <p:txBody>
-          <a:bodyPr wrap="square" lIns="0" tIns="0" rIns="0" bIns="0" rtlCol="0" anchor="t">
-            <a:normAutofit/>
-          </a:bodyPr>
-          <a:lstStyle/>
           <a:p>
-            <a:pPr indent="0" marL="0">
-              <a:buNone/>
+            <a:pPr marL="342900" indent="-342900">
+              <a:spcAft>
+                <a:spcPts val="800"/>
+              </a:spcAft>
+              <a:buSzPct val="100000"/>
+              <a:buChar char="•"/>
             </a:pPr>
             <a:r>
-              <a:rPr lang="en-US" sz="1500" dirty="0">
+              <a:rPr lang="en-US" sz="1250" dirty="0">
                 <a:solidFill>
                   <a:srgbClr val="1C2833"/>
                 </a:solidFill>
@@ -24070,43 +24647,20 @@
                 <a:ea typeface="Calibri" pitchFamily="34" charset="-122"/>
                 <a:cs typeface="Calibri" pitchFamily="34" charset="-120"/>
               </a:rPr>
-              <a:t>They cannot show whether an entry was right, or break removals down by sex, age or booth. Outside Bihar they are the states' published totals, some rounded, gathered from press notes and reports.</a:t>
+              <a:t>West Bengal kept 60.1 lakh names off its final roll while they are decided; without them the rise is 22.2% of the fall.</a:t>
             </a:r>
-            <a:endParaRPr lang="en-US" sz="1500" dirty="0"/>
+            <a:endParaRPr lang="en-US" sz="1250" dirty="0"/>
           </a:p>
-        </p:txBody>
-      </p:sp>
-      <p:sp>
-        <p:nvSpPr>
-          <p:cNvPr id="51" name="Text 49"/>
-          <p:cNvSpPr txBox="1"/>
-          <p:nvPr/>
-        </p:nvSpPr>
-        <p:spPr>
-          <a:xfrm>
-            <a:off x="548640" y="3749040"/>
-            <a:ext cx="11094415" cy="2011680"/>
-          </a:xfrm>
-          <a:prstGeom prst="rect">
-            <a:avLst/>
-          </a:prstGeom>
-          <a:noFill/>
-          <a:ln/>
-        </p:spPr>
-        <p:txBody>
-          <a:bodyPr wrap="square" lIns="0" tIns="0" rIns="0" bIns="0" rtlCol="0" anchor="t">
-            <a:normAutofit/>
-          </a:bodyPr>
-          <a:lstStyle/>
           <a:p>
-            <a:pPr indent="0" marL="0">
+            <a:pPr marL="342900" indent="-342900">
               <a:spcAft>
                 <a:spcPts val="800"/>
               </a:spcAft>
-              <a:buNone/>
+              <a:buSzPct val="100000"/>
+              <a:buChar char="•"/>
             </a:pPr>
             <a:r>
-              <a:rPr lang="en-US" sz="1600" dirty="0">
+              <a:rPr lang="en-US" sz="1250" dirty="0">
                 <a:solidFill>
                   <a:srgbClr val="1C2833"/>
                 </a:solidFill>
@@ -24114,9 +24668,30 @@
                 <a:ea typeface="Calibri" pitchFamily="34" charset="-122"/>
                 <a:cs typeface="Calibri" pitchFamily="34" charset="-120"/>
               </a:rPr>
-              <a:t>Removals after the draft, at hearings and on objections, are outside every figure by reason, because no state has said why. Twelve phase 3 final rolls are still to come. The Election Commission has published no state table of its own.</a:t>
+              <a:t>The final roll is smaller than the draft in 5 states. The fall is 10.2 per 100 electors at the final roll, from 11.9 at the draft.</a:t>
             </a:r>
-            <a:endParaRPr lang="en-US" sz="1600" dirty="0"/>
+            <a:endParaRPr lang="en-US" sz="1250" dirty="0"/>
+          </a:p>
+          <a:p>
+            <a:pPr marL="342900" indent="-342900">
+              <a:spcAft>
+                <a:spcPts val="800"/>
+              </a:spcAft>
+              <a:buSzPct val="100000"/>
+              <a:buChar char="•"/>
+            </a:pPr>
+            <a:r>
+              <a:rPr lang="en-US" sz="1250" dirty="0">
+                <a:solidFill>
+                  <a:srgbClr val="1C2833"/>
+                </a:solidFill>
+                <a:latin typeface="Calibri" pitchFamily="34" charset="0"/>
+                <a:ea typeface="Calibri" pitchFamily="34" charset="-122"/>
+                <a:cs typeface="Calibri" pitchFamily="34" charset="-120"/>
+              </a:rPr>
+              <a:t>The rise counts new electors as well as names put back, so it is the most that can have been put back.</a:t>
+            </a:r>
+            <a:endParaRPr lang="en-US" sz="1250" dirty="0"/>
           </a:p>
         </p:txBody>
       </p:sp>
@@ -24178,6 +24753,1198 @@
                 <a:ea typeface="Calibri" pitchFamily="34" charset="-122"/>
                 <a:cs typeface="Calibri" pitchFamily="34" charset="-120"/>
               </a:rPr>
+              <a:t>ALL INDIA</a:t>
+            </a:r>
+            <a:endParaRPr lang="en-US" sz="1100" dirty="0"/>
+          </a:p>
+        </p:txBody>
+      </p:sp>
+      <p:sp>
+        <p:nvSpPr>
+          <p:cNvPr id="3" name="Text 1"/>
+          <p:cNvSpPr txBox="1"/>
+          <p:nvPr/>
+        </p:nvSpPr>
+        <p:spPr>
+          <a:xfrm>
+            <a:off x="548640" y="530352"/>
+            <a:ext cx="11094415" cy="914400"/>
+          </a:xfrm>
+          <a:prstGeom prst="rect">
+            <a:avLst/>
+          </a:prstGeom>
+          <a:noFill/>
+          <a:ln/>
+        </p:spPr>
+        <p:txBody>
+          <a:bodyPr wrap="square" lIns="0" tIns="0" rIns="0" bIns="0" rtlCol="0" anchor="t">
+            <a:normAutofit/>
+          </a:bodyPr>
+          <a:lstStyle/>
+          <a:p>
+            <a:pPr indent="0" marL="0">
+              <a:buNone/>
+            </a:pPr>
+            <a:r>
+              <a:rPr lang="en-US" sz="2700" b="1" dirty="0">
+                <a:solidFill>
+                  <a:srgbClr val="1F4E79"/>
+                </a:solidFill>
+                <a:latin typeface="Cambria" pitchFamily="34" charset="0"/>
+                <a:ea typeface="Cambria" pitchFamily="34" charset="-122"/>
+                <a:cs typeface="Cambria" pitchFamily="34" charset="-120"/>
+              </a:rPr>
+              <a:t>What the state figures show, and what they cannot</a:t>
+            </a:r>
+            <a:endParaRPr lang="en-US" sz="2700" dirty="0"/>
+          </a:p>
+        </p:txBody>
+      </p:sp>
+      <p:sp>
+        <p:nvSpPr>
+          <p:cNvPr id="4" name="Text 2"/>
+          <p:cNvSpPr txBox="1"/>
+          <p:nvPr/>
+        </p:nvSpPr>
+        <p:spPr>
+          <a:xfrm>
+            <a:off x="548640" y="1463040"/>
+            <a:ext cx="11094415" cy="365760"/>
+          </a:xfrm>
+          <a:prstGeom prst="rect">
+            <a:avLst/>
+          </a:prstGeom>
+          <a:noFill/>
+          <a:ln/>
+        </p:spPr>
+        <p:txBody>
+          <a:bodyPr wrap="square" lIns="0" tIns="0" rIns="0" bIns="0" rtlCol="0" anchor="t"/>
+          <a:lstStyle/>
+          <a:p>
+            <a:pPr indent="0" marL="0">
+              <a:buNone/>
+            </a:pPr>
+            <a:r>
+              <a:rPr lang="en-US" sz="1400" dirty="0">
+                <a:solidFill>
+                  <a:srgbClr val="4D5B69"/>
+                </a:solidFill>
+                <a:latin typeface="Calibri" pitchFamily="34" charset="0"/>
+                <a:ea typeface="Calibri" pitchFamily="34" charset="-122"/>
+                <a:cs typeface="Calibri" pitchFamily="34" charset="-120"/>
+              </a:rPr>
+              <a:t>The limits of totals published state by state</a:t>
+            </a:r>
+            <a:endParaRPr lang="en-US" sz="1400" dirty="0"/>
+          </a:p>
+        </p:txBody>
+      </p:sp>
+      <p:sp>
+        <p:nvSpPr>
+          <p:cNvPr id="5" name="Text 3"/>
+          <p:cNvSpPr txBox="1"/>
+          <p:nvPr/>
+        </p:nvSpPr>
+        <p:spPr>
+          <a:xfrm>
+            <a:off x="548640" y="6400800"/>
+            <a:ext cx="10180015" cy="274320"/>
+          </a:xfrm>
+          <a:prstGeom prst="rect">
+            <a:avLst/>
+          </a:prstGeom>
+          <a:noFill/>
+          <a:ln/>
+        </p:spPr>
+        <p:txBody>
+          <a:bodyPr wrap="square" lIns="0" tIns="0" rIns="0" bIns="0" rtlCol="0" anchor="ctr"/>
+          <a:lstStyle/>
+          <a:p>
+            <a:pPr indent="0" marL="0">
+              <a:buNone/>
+            </a:pPr>
+            <a:r>
+              <a:rPr lang="en-US" sz="900" dirty="0">
+                <a:solidFill>
+                  <a:srgbClr val="4D5B69"/>
+                </a:solidFill>
+                <a:latin typeface="Calibri" pitchFamily="34" charset="0"/>
+                <a:ea typeface="Calibri" pitchFamily="34" charset="-122"/>
+                <a:cs typeface="Calibri" pitchFamily="34" charset="-120"/>
+              </a:rPr>
+              <a:t>SIR 2025-26 · All India · Varna Sri Raman · aggregates only; no names or EPIC numbers</a:t>
+            </a:r>
+            <a:endParaRPr lang="en-US" sz="900" dirty="0"/>
+          </a:p>
+        </p:txBody>
+      </p:sp>
+      <p:sp>
+        <p:nvSpPr>
+          <p:cNvPr id="6" name="Text 4"/>
+          <p:cNvSpPr txBox="1"/>
+          <p:nvPr/>
+        </p:nvSpPr>
+        <p:spPr>
+          <a:xfrm>
+            <a:off x="10911535" y="6400800"/>
+            <a:ext cx="731520" cy="274320"/>
+          </a:xfrm>
+          <a:prstGeom prst="rect">
+            <a:avLst/>
+          </a:prstGeom>
+          <a:noFill/>
+          <a:ln/>
+        </p:spPr>
+        <p:txBody>
+          <a:bodyPr wrap="square" lIns="0" tIns="0" rIns="0" bIns="0" rtlCol="0" anchor="ctr"/>
+          <a:lstStyle/>
+          <a:p>
+            <a:pPr algn="r" indent="0" marL="0">
+              <a:buNone/>
+            </a:pPr>
+            <a:r>
+              <a:rPr lang="en-US" sz="900" dirty="0">
+                <a:solidFill>
+                  <a:srgbClr val="4D5B69"/>
+                </a:solidFill>
+                <a:latin typeface="Calibri" pitchFamily="34" charset="0"/>
+                <a:ea typeface="Calibri" pitchFamily="34" charset="-122"/>
+                <a:cs typeface="Calibri" pitchFamily="34" charset="-120"/>
+              </a:rPr>
+              <a:t>14</a:t>
+            </a:r>
+            <a:endParaRPr lang="en-US" sz="900" dirty="0"/>
+          </a:p>
+        </p:txBody>
+      </p:sp>
+      <p:sp>
+        <p:nvSpPr>
+          <p:cNvPr id="7" name="Shape 5"/>
+          <p:cNvSpPr/>
+          <p:nvPr/>
+        </p:nvSpPr>
+        <p:spPr>
+          <a:xfrm>
+            <a:off x="0" y="6748272"/>
+            <a:ext cx="304792" cy="109728"/>
+          </a:xfrm>
+          <a:prstGeom prst="rect">
+            <a:avLst/>
+          </a:prstGeom>
+          <a:solidFill>
+            <a:srgbClr val="C0392B"/>
+          </a:solidFill>
+          <a:ln/>
+        </p:spPr>
+      </p:sp>
+      <p:sp>
+        <p:nvSpPr>
+          <p:cNvPr id="8" name="Shape 6"/>
+          <p:cNvSpPr/>
+          <p:nvPr/>
+        </p:nvSpPr>
+        <p:spPr>
+          <a:xfrm>
+            <a:off x="304792" y="6748272"/>
+            <a:ext cx="304792" cy="109728"/>
+          </a:xfrm>
+          <a:prstGeom prst="rect">
+            <a:avLst/>
+          </a:prstGeom>
+          <a:solidFill>
+            <a:srgbClr val="E67E22"/>
+          </a:solidFill>
+          <a:ln/>
+        </p:spPr>
+      </p:sp>
+      <p:sp>
+        <p:nvSpPr>
+          <p:cNvPr id="9" name="Shape 7"/>
+          <p:cNvSpPr/>
+          <p:nvPr/>
+        </p:nvSpPr>
+        <p:spPr>
+          <a:xfrm>
+            <a:off x="609585" y="6748272"/>
+            <a:ext cx="304792" cy="109728"/>
+          </a:xfrm>
+          <a:prstGeom prst="rect">
+            <a:avLst/>
+          </a:prstGeom>
+          <a:solidFill>
+            <a:srgbClr val="27AE60"/>
+          </a:solidFill>
+          <a:ln/>
+        </p:spPr>
+      </p:sp>
+      <p:sp>
+        <p:nvSpPr>
+          <p:cNvPr id="10" name="Shape 8"/>
+          <p:cNvSpPr/>
+          <p:nvPr/>
+        </p:nvSpPr>
+        <p:spPr>
+          <a:xfrm>
+            <a:off x="914377" y="6748272"/>
+            <a:ext cx="304792" cy="109728"/>
+          </a:xfrm>
+          <a:prstGeom prst="rect">
+            <a:avLst/>
+          </a:prstGeom>
+          <a:solidFill>
+            <a:srgbClr val="1F618D"/>
+          </a:solidFill>
+          <a:ln/>
+        </p:spPr>
+      </p:sp>
+      <p:sp>
+        <p:nvSpPr>
+          <p:cNvPr id="11" name="Shape 9"/>
+          <p:cNvSpPr/>
+          <p:nvPr/>
+        </p:nvSpPr>
+        <p:spPr>
+          <a:xfrm>
+            <a:off x="1219170" y="6748272"/>
+            <a:ext cx="304792" cy="109728"/>
+          </a:xfrm>
+          <a:prstGeom prst="rect">
+            <a:avLst/>
+          </a:prstGeom>
+          <a:solidFill>
+            <a:srgbClr val="8E44AD"/>
+          </a:solidFill>
+          <a:ln/>
+        </p:spPr>
+      </p:sp>
+      <p:sp>
+        <p:nvSpPr>
+          <p:cNvPr id="12" name="Shape 10"/>
+          <p:cNvSpPr/>
+          <p:nvPr/>
+        </p:nvSpPr>
+        <p:spPr>
+          <a:xfrm>
+            <a:off x="1523962" y="6748272"/>
+            <a:ext cx="304792" cy="109728"/>
+          </a:xfrm>
+          <a:prstGeom prst="rect">
+            <a:avLst/>
+          </a:prstGeom>
+          <a:solidFill>
+            <a:srgbClr val="C0392B"/>
+          </a:solidFill>
+          <a:ln/>
+        </p:spPr>
+      </p:sp>
+      <p:sp>
+        <p:nvSpPr>
+          <p:cNvPr id="13" name="Shape 11"/>
+          <p:cNvSpPr/>
+          <p:nvPr/>
+        </p:nvSpPr>
+        <p:spPr>
+          <a:xfrm>
+            <a:off x="1828754" y="6748272"/>
+            <a:ext cx="304792" cy="109728"/>
+          </a:xfrm>
+          <a:prstGeom prst="rect">
+            <a:avLst/>
+          </a:prstGeom>
+          <a:solidFill>
+            <a:srgbClr val="E67E22"/>
+          </a:solidFill>
+          <a:ln/>
+        </p:spPr>
+      </p:sp>
+      <p:sp>
+        <p:nvSpPr>
+          <p:cNvPr id="14" name="Shape 12"/>
+          <p:cNvSpPr/>
+          <p:nvPr/>
+        </p:nvSpPr>
+        <p:spPr>
+          <a:xfrm>
+            <a:off x="2133547" y="6748272"/>
+            <a:ext cx="304792" cy="109728"/>
+          </a:xfrm>
+          <a:prstGeom prst="rect">
+            <a:avLst/>
+          </a:prstGeom>
+          <a:solidFill>
+            <a:srgbClr val="27AE60"/>
+          </a:solidFill>
+          <a:ln/>
+        </p:spPr>
+      </p:sp>
+      <p:sp>
+        <p:nvSpPr>
+          <p:cNvPr id="15" name="Shape 13"/>
+          <p:cNvSpPr/>
+          <p:nvPr/>
+        </p:nvSpPr>
+        <p:spPr>
+          <a:xfrm>
+            <a:off x="2438339" y="6748272"/>
+            <a:ext cx="304792" cy="109728"/>
+          </a:xfrm>
+          <a:prstGeom prst="rect">
+            <a:avLst/>
+          </a:prstGeom>
+          <a:solidFill>
+            <a:srgbClr val="1F618D"/>
+          </a:solidFill>
+          <a:ln/>
+        </p:spPr>
+      </p:sp>
+      <p:sp>
+        <p:nvSpPr>
+          <p:cNvPr id="16" name="Shape 14"/>
+          <p:cNvSpPr/>
+          <p:nvPr/>
+        </p:nvSpPr>
+        <p:spPr>
+          <a:xfrm>
+            <a:off x="2743131" y="6748272"/>
+            <a:ext cx="304792" cy="109728"/>
+          </a:xfrm>
+          <a:prstGeom prst="rect">
+            <a:avLst/>
+          </a:prstGeom>
+          <a:solidFill>
+            <a:srgbClr val="8E44AD"/>
+          </a:solidFill>
+          <a:ln/>
+        </p:spPr>
+      </p:sp>
+      <p:sp>
+        <p:nvSpPr>
+          <p:cNvPr id="17" name="Shape 15"/>
+          <p:cNvSpPr/>
+          <p:nvPr/>
+        </p:nvSpPr>
+        <p:spPr>
+          <a:xfrm>
+            <a:off x="3047924" y="6748272"/>
+            <a:ext cx="304792" cy="109728"/>
+          </a:xfrm>
+          <a:prstGeom prst="rect">
+            <a:avLst/>
+          </a:prstGeom>
+          <a:solidFill>
+            <a:srgbClr val="C0392B"/>
+          </a:solidFill>
+          <a:ln/>
+        </p:spPr>
+      </p:sp>
+      <p:sp>
+        <p:nvSpPr>
+          <p:cNvPr id="18" name="Shape 16"/>
+          <p:cNvSpPr/>
+          <p:nvPr/>
+        </p:nvSpPr>
+        <p:spPr>
+          <a:xfrm>
+            <a:off x="3352716" y="6748272"/>
+            <a:ext cx="304792" cy="109728"/>
+          </a:xfrm>
+          <a:prstGeom prst="rect">
+            <a:avLst/>
+          </a:prstGeom>
+          <a:solidFill>
+            <a:srgbClr val="E67E22"/>
+          </a:solidFill>
+          <a:ln/>
+        </p:spPr>
+      </p:sp>
+      <p:sp>
+        <p:nvSpPr>
+          <p:cNvPr id="19" name="Shape 17"/>
+          <p:cNvSpPr/>
+          <p:nvPr/>
+        </p:nvSpPr>
+        <p:spPr>
+          <a:xfrm>
+            <a:off x="3657509" y="6748272"/>
+            <a:ext cx="304792" cy="109728"/>
+          </a:xfrm>
+          <a:prstGeom prst="rect">
+            <a:avLst/>
+          </a:prstGeom>
+          <a:solidFill>
+            <a:srgbClr val="27AE60"/>
+          </a:solidFill>
+          <a:ln/>
+        </p:spPr>
+      </p:sp>
+      <p:sp>
+        <p:nvSpPr>
+          <p:cNvPr id="20" name="Shape 18"/>
+          <p:cNvSpPr/>
+          <p:nvPr/>
+        </p:nvSpPr>
+        <p:spPr>
+          <a:xfrm>
+            <a:off x="3962301" y="6748272"/>
+            <a:ext cx="304792" cy="109728"/>
+          </a:xfrm>
+          <a:prstGeom prst="rect">
+            <a:avLst/>
+          </a:prstGeom>
+          <a:solidFill>
+            <a:srgbClr val="1F618D"/>
+          </a:solidFill>
+          <a:ln/>
+        </p:spPr>
+      </p:sp>
+      <p:sp>
+        <p:nvSpPr>
+          <p:cNvPr id="21" name="Shape 19"/>
+          <p:cNvSpPr/>
+          <p:nvPr/>
+        </p:nvSpPr>
+        <p:spPr>
+          <a:xfrm>
+            <a:off x="4267093" y="6748272"/>
+            <a:ext cx="304792" cy="109728"/>
+          </a:xfrm>
+          <a:prstGeom prst="rect">
+            <a:avLst/>
+          </a:prstGeom>
+          <a:solidFill>
+            <a:srgbClr val="8E44AD"/>
+          </a:solidFill>
+          <a:ln/>
+        </p:spPr>
+      </p:sp>
+      <p:sp>
+        <p:nvSpPr>
+          <p:cNvPr id="22" name="Shape 20"/>
+          <p:cNvSpPr/>
+          <p:nvPr/>
+        </p:nvSpPr>
+        <p:spPr>
+          <a:xfrm>
+            <a:off x="4571886" y="6748272"/>
+            <a:ext cx="304792" cy="109728"/>
+          </a:xfrm>
+          <a:prstGeom prst="rect">
+            <a:avLst/>
+          </a:prstGeom>
+          <a:solidFill>
+            <a:srgbClr val="C0392B"/>
+          </a:solidFill>
+          <a:ln/>
+        </p:spPr>
+      </p:sp>
+      <p:sp>
+        <p:nvSpPr>
+          <p:cNvPr id="23" name="Shape 21"/>
+          <p:cNvSpPr/>
+          <p:nvPr/>
+        </p:nvSpPr>
+        <p:spPr>
+          <a:xfrm>
+            <a:off x="4876678" y="6748272"/>
+            <a:ext cx="304792" cy="109728"/>
+          </a:xfrm>
+          <a:prstGeom prst="rect">
+            <a:avLst/>
+          </a:prstGeom>
+          <a:solidFill>
+            <a:srgbClr val="E67E22"/>
+          </a:solidFill>
+          <a:ln/>
+        </p:spPr>
+      </p:sp>
+      <p:sp>
+        <p:nvSpPr>
+          <p:cNvPr id="24" name="Shape 22"/>
+          <p:cNvSpPr/>
+          <p:nvPr/>
+        </p:nvSpPr>
+        <p:spPr>
+          <a:xfrm>
+            <a:off x="5181470" y="6748272"/>
+            <a:ext cx="304792" cy="109728"/>
+          </a:xfrm>
+          <a:prstGeom prst="rect">
+            <a:avLst/>
+          </a:prstGeom>
+          <a:solidFill>
+            <a:srgbClr val="27AE60"/>
+          </a:solidFill>
+          <a:ln/>
+        </p:spPr>
+      </p:sp>
+      <p:sp>
+        <p:nvSpPr>
+          <p:cNvPr id="25" name="Shape 23"/>
+          <p:cNvSpPr/>
+          <p:nvPr/>
+        </p:nvSpPr>
+        <p:spPr>
+          <a:xfrm>
+            <a:off x="5486263" y="6748272"/>
+            <a:ext cx="304792" cy="109728"/>
+          </a:xfrm>
+          <a:prstGeom prst="rect">
+            <a:avLst/>
+          </a:prstGeom>
+          <a:solidFill>
+            <a:srgbClr val="1F618D"/>
+          </a:solidFill>
+          <a:ln/>
+        </p:spPr>
+      </p:sp>
+      <p:sp>
+        <p:nvSpPr>
+          <p:cNvPr id="26" name="Shape 24"/>
+          <p:cNvSpPr/>
+          <p:nvPr/>
+        </p:nvSpPr>
+        <p:spPr>
+          <a:xfrm>
+            <a:off x="5791055" y="6748272"/>
+            <a:ext cx="304792" cy="109728"/>
+          </a:xfrm>
+          <a:prstGeom prst="rect">
+            <a:avLst/>
+          </a:prstGeom>
+          <a:solidFill>
+            <a:srgbClr val="8E44AD"/>
+          </a:solidFill>
+          <a:ln/>
+        </p:spPr>
+      </p:sp>
+      <p:sp>
+        <p:nvSpPr>
+          <p:cNvPr id="27" name="Shape 25"/>
+          <p:cNvSpPr/>
+          <p:nvPr/>
+        </p:nvSpPr>
+        <p:spPr>
+          <a:xfrm>
+            <a:off x="6095848" y="6748272"/>
+            <a:ext cx="304792" cy="109728"/>
+          </a:xfrm>
+          <a:prstGeom prst="rect">
+            <a:avLst/>
+          </a:prstGeom>
+          <a:solidFill>
+            <a:srgbClr val="C0392B"/>
+          </a:solidFill>
+          <a:ln/>
+        </p:spPr>
+      </p:sp>
+      <p:sp>
+        <p:nvSpPr>
+          <p:cNvPr id="28" name="Shape 26"/>
+          <p:cNvSpPr/>
+          <p:nvPr/>
+        </p:nvSpPr>
+        <p:spPr>
+          <a:xfrm>
+            <a:off x="6400640" y="6748272"/>
+            <a:ext cx="304792" cy="109728"/>
+          </a:xfrm>
+          <a:prstGeom prst="rect">
+            <a:avLst/>
+          </a:prstGeom>
+          <a:solidFill>
+            <a:srgbClr val="E67E22"/>
+          </a:solidFill>
+          <a:ln/>
+        </p:spPr>
+      </p:sp>
+      <p:sp>
+        <p:nvSpPr>
+          <p:cNvPr id="29" name="Shape 27"/>
+          <p:cNvSpPr/>
+          <p:nvPr/>
+        </p:nvSpPr>
+        <p:spPr>
+          <a:xfrm>
+            <a:off x="6705432" y="6748272"/>
+            <a:ext cx="304792" cy="109728"/>
+          </a:xfrm>
+          <a:prstGeom prst="rect">
+            <a:avLst/>
+          </a:prstGeom>
+          <a:solidFill>
+            <a:srgbClr val="27AE60"/>
+          </a:solidFill>
+          <a:ln/>
+        </p:spPr>
+      </p:sp>
+      <p:sp>
+        <p:nvSpPr>
+          <p:cNvPr id="30" name="Shape 28"/>
+          <p:cNvSpPr/>
+          <p:nvPr/>
+        </p:nvSpPr>
+        <p:spPr>
+          <a:xfrm>
+            <a:off x="7010225" y="6748272"/>
+            <a:ext cx="304792" cy="109728"/>
+          </a:xfrm>
+          <a:prstGeom prst="rect">
+            <a:avLst/>
+          </a:prstGeom>
+          <a:solidFill>
+            <a:srgbClr val="1F618D"/>
+          </a:solidFill>
+          <a:ln/>
+        </p:spPr>
+      </p:sp>
+      <p:sp>
+        <p:nvSpPr>
+          <p:cNvPr id="31" name="Shape 29"/>
+          <p:cNvSpPr/>
+          <p:nvPr/>
+        </p:nvSpPr>
+        <p:spPr>
+          <a:xfrm>
+            <a:off x="7315017" y="6748272"/>
+            <a:ext cx="304792" cy="109728"/>
+          </a:xfrm>
+          <a:prstGeom prst="rect">
+            <a:avLst/>
+          </a:prstGeom>
+          <a:solidFill>
+            <a:srgbClr val="8E44AD"/>
+          </a:solidFill>
+          <a:ln/>
+        </p:spPr>
+      </p:sp>
+      <p:sp>
+        <p:nvSpPr>
+          <p:cNvPr id="32" name="Shape 30"/>
+          <p:cNvSpPr/>
+          <p:nvPr/>
+        </p:nvSpPr>
+        <p:spPr>
+          <a:xfrm>
+            <a:off x="7619809" y="6748272"/>
+            <a:ext cx="304792" cy="109728"/>
+          </a:xfrm>
+          <a:prstGeom prst="rect">
+            <a:avLst/>
+          </a:prstGeom>
+          <a:solidFill>
+            <a:srgbClr val="C0392B"/>
+          </a:solidFill>
+          <a:ln/>
+        </p:spPr>
+      </p:sp>
+      <p:sp>
+        <p:nvSpPr>
+          <p:cNvPr id="33" name="Shape 31"/>
+          <p:cNvSpPr/>
+          <p:nvPr/>
+        </p:nvSpPr>
+        <p:spPr>
+          <a:xfrm>
+            <a:off x="7924602" y="6748272"/>
+            <a:ext cx="304792" cy="109728"/>
+          </a:xfrm>
+          <a:prstGeom prst="rect">
+            <a:avLst/>
+          </a:prstGeom>
+          <a:solidFill>
+            <a:srgbClr val="E67E22"/>
+          </a:solidFill>
+          <a:ln/>
+        </p:spPr>
+      </p:sp>
+      <p:sp>
+        <p:nvSpPr>
+          <p:cNvPr id="34" name="Shape 32"/>
+          <p:cNvSpPr/>
+          <p:nvPr/>
+        </p:nvSpPr>
+        <p:spPr>
+          <a:xfrm>
+            <a:off x="8229394" y="6748272"/>
+            <a:ext cx="304792" cy="109728"/>
+          </a:xfrm>
+          <a:prstGeom prst="rect">
+            <a:avLst/>
+          </a:prstGeom>
+          <a:solidFill>
+            <a:srgbClr val="27AE60"/>
+          </a:solidFill>
+          <a:ln/>
+        </p:spPr>
+      </p:sp>
+      <p:sp>
+        <p:nvSpPr>
+          <p:cNvPr id="35" name="Shape 33"/>
+          <p:cNvSpPr/>
+          <p:nvPr/>
+        </p:nvSpPr>
+        <p:spPr>
+          <a:xfrm>
+            <a:off x="8534187" y="6748272"/>
+            <a:ext cx="304792" cy="109728"/>
+          </a:xfrm>
+          <a:prstGeom prst="rect">
+            <a:avLst/>
+          </a:prstGeom>
+          <a:solidFill>
+            <a:srgbClr val="1F618D"/>
+          </a:solidFill>
+          <a:ln/>
+        </p:spPr>
+      </p:sp>
+      <p:sp>
+        <p:nvSpPr>
+          <p:cNvPr id="36" name="Shape 34"/>
+          <p:cNvSpPr/>
+          <p:nvPr/>
+        </p:nvSpPr>
+        <p:spPr>
+          <a:xfrm>
+            <a:off x="8838979" y="6748272"/>
+            <a:ext cx="304792" cy="109728"/>
+          </a:xfrm>
+          <a:prstGeom prst="rect">
+            <a:avLst/>
+          </a:prstGeom>
+          <a:solidFill>
+            <a:srgbClr val="8E44AD"/>
+          </a:solidFill>
+          <a:ln/>
+        </p:spPr>
+      </p:sp>
+      <p:sp>
+        <p:nvSpPr>
+          <p:cNvPr id="37" name="Shape 35"/>
+          <p:cNvSpPr/>
+          <p:nvPr/>
+        </p:nvSpPr>
+        <p:spPr>
+          <a:xfrm>
+            <a:off x="9143771" y="6748272"/>
+            <a:ext cx="304792" cy="109728"/>
+          </a:xfrm>
+          <a:prstGeom prst="rect">
+            <a:avLst/>
+          </a:prstGeom>
+          <a:solidFill>
+            <a:srgbClr val="C0392B"/>
+          </a:solidFill>
+          <a:ln/>
+        </p:spPr>
+      </p:sp>
+      <p:sp>
+        <p:nvSpPr>
+          <p:cNvPr id="38" name="Shape 36"/>
+          <p:cNvSpPr/>
+          <p:nvPr/>
+        </p:nvSpPr>
+        <p:spPr>
+          <a:xfrm>
+            <a:off x="9448564" y="6748272"/>
+            <a:ext cx="304792" cy="109728"/>
+          </a:xfrm>
+          <a:prstGeom prst="rect">
+            <a:avLst/>
+          </a:prstGeom>
+          <a:solidFill>
+            <a:srgbClr val="E67E22"/>
+          </a:solidFill>
+          <a:ln/>
+        </p:spPr>
+      </p:sp>
+      <p:sp>
+        <p:nvSpPr>
+          <p:cNvPr id="39" name="Shape 37"/>
+          <p:cNvSpPr/>
+          <p:nvPr/>
+        </p:nvSpPr>
+        <p:spPr>
+          <a:xfrm>
+            <a:off x="9753356" y="6748272"/>
+            <a:ext cx="304792" cy="109728"/>
+          </a:xfrm>
+          <a:prstGeom prst="rect">
+            <a:avLst/>
+          </a:prstGeom>
+          <a:solidFill>
+            <a:srgbClr val="27AE60"/>
+          </a:solidFill>
+          <a:ln/>
+        </p:spPr>
+      </p:sp>
+      <p:sp>
+        <p:nvSpPr>
+          <p:cNvPr id="40" name="Shape 38"/>
+          <p:cNvSpPr/>
+          <p:nvPr/>
+        </p:nvSpPr>
+        <p:spPr>
+          <a:xfrm>
+            <a:off x="10058149" y="6748272"/>
+            <a:ext cx="304792" cy="109728"/>
+          </a:xfrm>
+          <a:prstGeom prst="rect">
+            <a:avLst/>
+          </a:prstGeom>
+          <a:solidFill>
+            <a:srgbClr val="1F618D"/>
+          </a:solidFill>
+          <a:ln/>
+        </p:spPr>
+      </p:sp>
+      <p:sp>
+        <p:nvSpPr>
+          <p:cNvPr id="41" name="Shape 39"/>
+          <p:cNvSpPr/>
+          <p:nvPr/>
+        </p:nvSpPr>
+        <p:spPr>
+          <a:xfrm>
+            <a:off x="10362941" y="6748272"/>
+            <a:ext cx="304792" cy="109728"/>
+          </a:xfrm>
+          <a:prstGeom prst="rect">
+            <a:avLst/>
+          </a:prstGeom>
+          <a:solidFill>
+            <a:srgbClr val="8E44AD"/>
+          </a:solidFill>
+          <a:ln/>
+        </p:spPr>
+      </p:sp>
+      <p:sp>
+        <p:nvSpPr>
+          <p:cNvPr id="42" name="Shape 40"/>
+          <p:cNvSpPr/>
+          <p:nvPr/>
+        </p:nvSpPr>
+        <p:spPr>
+          <a:xfrm>
+            <a:off x="10667733" y="6748272"/>
+            <a:ext cx="304792" cy="109728"/>
+          </a:xfrm>
+          <a:prstGeom prst="rect">
+            <a:avLst/>
+          </a:prstGeom>
+          <a:solidFill>
+            <a:srgbClr val="C0392B"/>
+          </a:solidFill>
+          <a:ln/>
+        </p:spPr>
+      </p:sp>
+      <p:sp>
+        <p:nvSpPr>
+          <p:cNvPr id="43" name="Shape 41"/>
+          <p:cNvSpPr/>
+          <p:nvPr/>
+        </p:nvSpPr>
+        <p:spPr>
+          <a:xfrm>
+            <a:off x="10972526" y="6748272"/>
+            <a:ext cx="304792" cy="109728"/>
+          </a:xfrm>
+          <a:prstGeom prst="rect">
+            <a:avLst/>
+          </a:prstGeom>
+          <a:solidFill>
+            <a:srgbClr val="E67E22"/>
+          </a:solidFill>
+          <a:ln/>
+        </p:spPr>
+      </p:sp>
+      <p:sp>
+        <p:nvSpPr>
+          <p:cNvPr id="44" name="Shape 42"/>
+          <p:cNvSpPr/>
+          <p:nvPr/>
+        </p:nvSpPr>
+        <p:spPr>
+          <a:xfrm>
+            <a:off x="11277318" y="6748272"/>
+            <a:ext cx="304792" cy="109728"/>
+          </a:xfrm>
+          <a:prstGeom prst="rect">
+            <a:avLst/>
+          </a:prstGeom>
+          <a:solidFill>
+            <a:srgbClr val="27AE60"/>
+          </a:solidFill>
+          <a:ln/>
+        </p:spPr>
+      </p:sp>
+      <p:sp>
+        <p:nvSpPr>
+          <p:cNvPr id="45" name="Shape 43"/>
+          <p:cNvSpPr/>
+          <p:nvPr/>
+        </p:nvSpPr>
+        <p:spPr>
+          <a:xfrm>
+            <a:off x="11582110" y="6748272"/>
+            <a:ext cx="304792" cy="109728"/>
+          </a:xfrm>
+          <a:prstGeom prst="rect">
+            <a:avLst/>
+          </a:prstGeom>
+          <a:solidFill>
+            <a:srgbClr val="1F618D"/>
+          </a:solidFill>
+          <a:ln/>
+        </p:spPr>
+      </p:sp>
+      <p:sp>
+        <p:nvSpPr>
+          <p:cNvPr id="46" name="Shape 44"/>
+          <p:cNvSpPr/>
+          <p:nvPr/>
+        </p:nvSpPr>
+        <p:spPr>
+          <a:xfrm>
+            <a:off x="11886903" y="6748272"/>
+            <a:ext cx="304792" cy="109728"/>
+          </a:xfrm>
+          <a:prstGeom prst="rect">
+            <a:avLst/>
+          </a:prstGeom>
+          <a:solidFill>
+            <a:srgbClr val="8E44AD"/>
+          </a:solidFill>
+          <a:ln/>
+        </p:spPr>
+      </p:sp>
+      <p:sp>
+        <p:nvSpPr>
+          <p:cNvPr id="47" name="Shape 45"/>
+          <p:cNvSpPr/>
+          <p:nvPr/>
+        </p:nvSpPr>
+        <p:spPr>
+          <a:xfrm>
+            <a:off x="548640" y="1554480"/>
+            <a:ext cx="5440680" cy="1920240"/>
+          </a:xfrm>
+          <a:prstGeom prst="roundRect">
+            <a:avLst>
+              <a:gd name="adj" fmla="val 4762"/>
+            </a:avLst>
+          </a:prstGeom>
+          <a:solidFill>
+            <a:srgbClr val="EAF1F8"/>
+          </a:solidFill>
+          <a:ln/>
+        </p:spPr>
+      </p:sp>
+      <p:sp>
+        <p:nvSpPr>
+          <p:cNvPr id="48" name="Text 46"/>
+          <p:cNvSpPr txBox="1"/>
+          <p:nvPr/>
+        </p:nvSpPr>
+        <p:spPr>
+          <a:xfrm>
+            <a:off x="777240" y="1719072"/>
+            <a:ext cx="4983480" cy="1591056"/>
+          </a:xfrm>
+          <a:prstGeom prst="rect">
+            <a:avLst/>
+          </a:prstGeom>
+          <a:noFill/>
+          <a:ln/>
+        </p:spPr>
+        <p:txBody>
+          <a:bodyPr wrap="square" lIns="0" tIns="0" rIns="0" bIns="0" rtlCol="0" anchor="t">
+            <a:normAutofit/>
+          </a:bodyPr>
+          <a:lstStyle/>
+          <a:p>
+            <a:pPr indent="0" marL="0">
+              <a:buNone/>
+            </a:pPr>
+            <a:r>
+              <a:rPr lang="en-US" sz="1500" dirty="0">
+                <a:solidFill>
+                  <a:srgbClr val="1C2833"/>
+                </a:solidFill>
+                <a:latin typeface="Calibri" pitchFamily="34" charset="0"/>
+                <a:ea typeface="Calibri" pitchFamily="34" charset="-122"/>
+                <a:cs typeface="Calibri" pitchFamily="34" charset="-120"/>
+              </a:rPr>
+              <a:t>They show how many names each state left off its draft roll and the reason its officers entered: dead, shifted or absent (with "others" where reported), or enrolled more than once, and for 20 states the final roll.</a:t>
+            </a:r>
+            <a:endParaRPr lang="en-US" sz="1500" dirty="0"/>
+          </a:p>
+        </p:txBody>
+      </p:sp>
+      <p:sp>
+        <p:nvSpPr>
+          <p:cNvPr id="49" name="Shape 47"/>
+          <p:cNvSpPr/>
+          <p:nvPr/>
+        </p:nvSpPr>
+        <p:spPr>
+          <a:xfrm>
+            <a:off x="6199632" y="1554480"/>
+            <a:ext cx="5440680" cy="1920240"/>
+          </a:xfrm>
+          <a:prstGeom prst="roundRect">
+            <a:avLst>
+              <a:gd name="adj" fmla="val 4762"/>
+            </a:avLst>
+          </a:prstGeom>
+          <a:solidFill>
+            <a:srgbClr val="EAF1F8"/>
+          </a:solidFill>
+          <a:ln/>
+        </p:spPr>
+      </p:sp>
+      <p:sp>
+        <p:nvSpPr>
+          <p:cNvPr id="50" name="Text 48"/>
+          <p:cNvSpPr txBox="1"/>
+          <p:nvPr/>
+        </p:nvSpPr>
+        <p:spPr>
+          <a:xfrm>
+            <a:off x="6428232" y="1719072"/>
+            <a:ext cx="4983480" cy="1591056"/>
+          </a:xfrm>
+          <a:prstGeom prst="rect">
+            <a:avLst/>
+          </a:prstGeom>
+          <a:noFill/>
+          <a:ln/>
+        </p:spPr>
+        <p:txBody>
+          <a:bodyPr wrap="square" lIns="0" tIns="0" rIns="0" bIns="0" rtlCol="0" anchor="t">
+            <a:normAutofit/>
+          </a:bodyPr>
+          <a:lstStyle/>
+          <a:p>
+            <a:pPr indent="0" marL="0">
+              <a:buNone/>
+            </a:pPr>
+            <a:r>
+              <a:rPr lang="en-US" sz="1500" dirty="0">
+                <a:solidFill>
+                  <a:srgbClr val="1C2833"/>
+                </a:solidFill>
+                <a:latin typeface="Calibri" pitchFamily="34" charset="0"/>
+                <a:ea typeface="Calibri" pitchFamily="34" charset="-122"/>
+                <a:cs typeface="Calibri" pitchFamily="34" charset="-120"/>
+              </a:rPr>
+              <a:t>They cannot show whether an entry was right, or break removals down by sex, age or booth. Outside Bihar they are the states' published totals, some rounded, gathered from press notes and reports.</a:t>
+            </a:r>
+            <a:endParaRPr lang="en-US" sz="1500" dirty="0"/>
+          </a:p>
+        </p:txBody>
+      </p:sp>
+      <p:sp>
+        <p:nvSpPr>
+          <p:cNvPr id="51" name="Text 49"/>
+          <p:cNvSpPr txBox="1"/>
+          <p:nvPr/>
+        </p:nvSpPr>
+        <p:spPr>
+          <a:xfrm>
+            <a:off x="548640" y="3749040"/>
+            <a:ext cx="11094415" cy="2011680"/>
+          </a:xfrm>
+          <a:prstGeom prst="rect">
+            <a:avLst/>
+          </a:prstGeom>
+          <a:noFill/>
+          <a:ln/>
+        </p:spPr>
+        <p:txBody>
+          <a:bodyPr wrap="square" lIns="0" tIns="0" rIns="0" bIns="0" rtlCol="0" anchor="t">
+            <a:normAutofit/>
+          </a:bodyPr>
+          <a:lstStyle/>
+          <a:p>
+            <a:pPr indent="0" marL="0">
+              <a:spcAft>
+                <a:spcPts val="800"/>
+              </a:spcAft>
+              <a:buNone/>
+            </a:pPr>
+            <a:r>
+              <a:rPr lang="en-US" sz="1600" dirty="0">
+                <a:solidFill>
+                  <a:srgbClr val="1C2833"/>
+                </a:solidFill>
+                <a:latin typeface="Calibri" pitchFamily="34" charset="0"/>
+                <a:ea typeface="Calibri" pitchFamily="34" charset="-122"/>
+                <a:cs typeface="Calibri" pitchFamily="34" charset="-120"/>
+              </a:rPr>
+              <a:t>Removals after the draft, at hearings and on objections, carry no reason outside Bihar, and no state has said how many of those added at the final roll had been removed at the draft. The Election Commission has published no state table of its own.</a:t>
+            </a:r>
+            <a:endParaRPr lang="en-US" sz="1600" dirty="0"/>
+          </a:p>
+        </p:txBody>
+      </p:sp>
+    </p:spTree>
+  </p:cSld>
+  <p:clrMapOvr>
+    <a:masterClrMapping/>
+  </p:clrMapOvr>
+</p:sld>
+</file>
+
+<file path=ppt/slides/slide15.xml><?xml version="1.0" encoding="utf-8"?>
+<p:sld xmlns:a="http://schemas.openxmlformats.org/drawingml/2006/main" xmlns:r="http://schemas.openxmlformats.org/officeDocument/2006/relationships" xmlns:p="http://schemas.openxmlformats.org/presentationml/2006/main">
+  <p:cSld name="Slide 15">
+    <p:spTree>
+      <p:nvGrpSpPr>
+        <p:cNvPr id="1" name=""/>
+        <p:cNvGrpSpPr/>
+        <p:nvPr/>
+      </p:nvGrpSpPr>
+      <p:grpSpPr>
+        <a:xfrm>
+          <a:off x="0" y="0"/>
+          <a:ext cx="0" cy="0"/>
+          <a:chOff x="0" y="0"/>
+          <a:chExt cx="0" cy="0"/>
+        </a:xfrm>
+      </p:grpSpPr>
+      <p:sp>
+        <p:nvSpPr>
+          <p:cNvPr id="2" name="Text 0"/>
+          <p:cNvSpPr txBox="1"/>
+          <p:nvPr/>
+        </p:nvSpPr>
+        <p:spPr>
+          <a:xfrm>
+            <a:off x="548640" y="256032"/>
+            <a:ext cx="11094415" cy="274320"/>
+          </a:xfrm>
+          <a:prstGeom prst="rect">
+            <a:avLst/>
+          </a:prstGeom>
+          <a:noFill/>
+          <a:ln/>
+        </p:spPr>
+        <p:txBody>
+          <a:bodyPr wrap="square" lIns="0" tIns="0" rIns="0" bIns="0" rtlCol="0" anchor="ctr"/>
+          <a:lstStyle/>
+          <a:p>
+            <a:pPr indent="0" marL="0">
+              <a:buNone/>
+            </a:pPr>
+            <a:r>
+              <a:rPr lang="en-US" sz="1100" b="1" spc="200" kern="0" dirty="0">
+                <a:solidFill>
+                  <a:srgbClr val="1F618D"/>
+                </a:solidFill>
+                <a:latin typeface="Calibri" pitchFamily="34" charset="0"/>
+                <a:ea typeface="Calibri" pitchFamily="34" charset="-122"/>
+                <a:cs typeface="Calibri" pitchFamily="34" charset="-120"/>
+              </a:rPr>
               <a:t>WHAT THE ELECTION COMMISSION SHOULD DO</a:t>
             </a:r>
             <a:endParaRPr lang="en-US" sz="1100" dirty="0"/>
@@ -24297,7 +26064,7 @@
                 <a:ea typeface="Calibri" pitchFamily="34" charset="-122"/>
                 <a:cs typeface="Calibri" pitchFamily="34" charset="-120"/>
               </a:rPr>
-              <a:t>14</a:t>
+              <a:t>15</a:t>
             </a:r>
             <a:endParaRPr lang="en-US" sz="900" dirty="0"/>
           </a:p>
@@ -25209,7 +26976,7 @@
                 <a:ea typeface="Calibri" pitchFamily="34" charset="-122"/>
                 <a:cs typeface="Calibri" pitchFamily="34" charset="-120"/>
               </a:rPr>
-              <a:t>Publish the outcome of every claim and objection, so that restorations can be set against removals.</a:t>
+              <a:t>Publish the outcome of every claim and objection, and say how many of those added at the final roll had been removed at the draft.</a:t>
             </a:r>
             <a:endParaRPr lang="en-US" sz="1700" dirty="0"/>
           </a:p>
@@ -25245,9 +27012,9 @@
 </p:sld>
 </file>
 
-<file path=ppt/slides/slide15.xml><?xml version="1.0" encoding="utf-8"?>
+<file path=ppt/slides/slide16.xml><?xml version="1.0" encoding="utf-8"?>
 <p:sld xmlns:a="http://schemas.openxmlformats.org/drawingml/2006/main" xmlns:r="http://schemas.openxmlformats.org/officeDocument/2006/relationships" xmlns:p="http://schemas.openxmlformats.org/presentationml/2006/main">
-  <p:cSld name="Slide 15">
+  <p:cSld name="Slide 16">
     <p:spTree>
       <p:nvGrpSpPr>
         <p:cNvPr id="1" name=""/>
@@ -25414,7 +27181,7 @@
                 <a:ea typeface="Calibri" pitchFamily="34" charset="-122"/>
                 <a:cs typeface="Calibri" pitchFamily="34" charset="-120"/>
               </a:rPr>
-              <a:t>15</a:t>
+              <a:t>16</a:t>
             </a:r>
             <a:endParaRPr lang="en-US" sz="900" dirty="0"/>
           </a:p>
@@ -26357,9 +28124,9 @@
 </p:sld>
 </file>
 
-<file path=ppt/slides/slide16.xml><?xml version="1.0" encoding="utf-8"?>
+<file path=ppt/slides/slide17.xml><?xml version="1.0" encoding="utf-8"?>
 <p:sld xmlns:a="http://schemas.openxmlformats.org/drawingml/2006/main" xmlns:r="http://schemas.openxmlformats.org/officeDocument/2006/relationships" xmlns:p="http://schemas.openxmlformats.org/presentationml/2006/main">
-  <p:cSld name="Slide 16">
+  <p:cSld name="Slide 17">
     <p:bg>
       <p:bgPr>
         <a:solidFill>
@@ -28182,7 +29949,7 @@
                 <a:ea typeface="Calibri" pitchFamily="34" charset="-122"/>
                 <a:cs typeface="Calibri" pitchFamily="34" charset="-120"/>
               </a:rPr>
-              <a:t>All India   3–13</a:t>
+              <a:t>All India   3–14</a:t>
             </a:r>
             <a:endParaRPr lang="en-US" sz="1700" dirty="0"/>
           </a:p>
@@ -28202,7 +29969,7 @@
                 <a:ea typeface="Calibri" pitchFamily="34" charset="-122"/>
                 <a:cs typeface="Calibri" pitchFamily="34" charset="-120"/>
               </a:rPr>
-              <a:t>What the Election Commission should do   14–14</a:t>
+              <a:t>What the Election Commission should do   15–15</a:t>
             </a:r>
             <a:endParaRPr lang="en-US" sz="1700" dirty="0"/>
           </a:p>
@@ -28244,7 +30011,7 @@
                 <a:ea typeface="Calibri" pitchFamily="34" charset="-122"/>
                 <a:cs typeface="Calibri" pitchFamily="34" charset="-120"/>
               </a:rPr>
-              <a:t>Method   15–16</a:t>
+              <a:t>Method   16–17</a:t>
             </a:r>
             <a:endParaRPr lang="en-US" sz="1700" dirty="0"/>
           </a:p>

</xml_diff>

<commit_message>
Replace Census 2011 baselines with recent surveys and projections
All India: literacy from PLFS 2023-24, spending per head from HCES 2023-24,
urban share projected to March 2026, Muslim, SC and ST shares and sex ratio
from NFHS-5. Migration stays on 2011, the only state-level source. A rerun on
the 2011 values is reported on the method page.

Bihar: district women's literacy and marriage before 18 from NFHS-5 replace
the 2011 literacy panels. District Muslim shares are also carried forward to
2025 at 2001-2011 growth rates (state 17.34%, against 17.70% in the 2023 caste
survey); the same eight districts stay more than a point above.

Co-Authored-By: Claude Opus 5.5 <noreply@anthropic.com>
Claude-Session: https://claude.ai/code/session_01FWx24PCx3Jw4SUDQC6oU7o
</commit_message>
<xml_diff>
--- a/reports/sir-india-deck.pptx
+++ b/reports/sir-india-deck.pptx
@@ -18723,7 +18723,7 @@
                 <a:ea typeface="Cambria" pitchFamily="34" charset="-122"/>
                 <a:cs typeface="Cambria" pitchFamily="34" charset="-120"/>
               </a:rPr>
-              <a:t>The removal rate goes with in-migration across all states (0.53), but only because of phase 3; in phase 2 it is 0.04</a:t>
+              <a:t>The removal rate goes most with living here, born elsewhere (0.53), and that comes from phase 3. In phase 2 it is 0.04</a:t>
             </a:r>
             <a:endParaRPr lang="en-US" sz="2700" dirty="0"/>
           </a:p>
@@ -18762,7 +18762,7 @@
                 <a:ea typeface="Calibri" pitchFamily="34" charset="-122"/>
                 <a:cs typeface="Calibri" pitchFamily="34" charset="-120"/>
               </a:rPr>
-              <a:t>Rank correlations across states with each state's removals per 100 electors; under 0.2 either way is read as none</a:t>
+              <a:t>Rank correlations across states with each state's removals per 100 electors. Under 0.2 either way is read as none</a:t>
             </a:r>
             <a:endParaRPr lang="en-US" sz="1400" dirty="0"/>
           </a:p>
@@ -19685,7 +19685,7 @@
                         <a:buNone/>
                       </a:pPr>
                       <a:r>
-                        <a:rPr lang="en-US" sz="1200" b="1" dirty="0">
+                        <a:rPr lang="en-US" sz="1050" b="1" dirty="0">
                           <a:solidFill>
                             <a:srgbClr val="FFFFFF"/>
                           </a:solidFill>
@@ -19695,7 +19695,7 @@
                         </a:rPr>
                         <a:t>Characteristic</a:t>
                       </a:r>
-                      <a:endParaRPr lang="en-US" sz="1200" dirty="0">
+                      <a:endParaRPr lang="en-US" sz="1050" dirty="0">
                         <a:latin typeface="Calibri" charset="0"/>
                         <a:ea typeface="Calibri" charset="0"/>
                         <a:cs typeface="Calibri" charset="0"/>
@@ -19753,7 +19753,7 @@
                         <a:buNone/>
                       </a:pPr>
                       <a:r>
-                        <a:rPr lang="en-US" sz="1200" b="1" dirty="0">
+                        <a:rPr lang="en-US" sz="1050" b="1" dirty="0">
                           <a:solidFill>
                             <a:srgbClr val="FFFFFF"/>
                           </a:solidFill>
@@ -19763,7 +19763,7 @@
                         </a:rPr>
                         <a:t>All states</a:t>
                       </a:r>
-                      <a:endParaRPr lang="en-US" sz="1200" dirty="0">
+                      <a:endParaRPr lang="en-US" sz="1050" dirty="0">
                         <a:latin typeface="Calibri" charset="0"/>
                         <a:ea typeface="Calibri" charset="0"/>
                         <a:cs typeface="Calibri" charset="0"/>
@@ -19821,7 +19821,7 @@
                         <a:buNone/>
                       </a:pPr>
                       <a:r>
-                        <a:rPr lang="en-US" sz="1200" b="1" dirty="0">
+                        <a:rPr lang="en-US" sz="1050" b="1" dirty="0">
                           <a:solidFill>
                             <a:srgbClr val="FFFFFF"/>
                           </a:solidFill>
@@ -19831,7 +19831,7 @@
                         </a:rPr>
                         <a:t>Phase 2</a:t>
                       </a:r>
-                      <a:endParaRPr lang="en-US" sz="1200" dirty="0">
+                      <a:endParaRPr lang="en-US" sz="1050" dirty="0">
                         <a:latin typeface="Calibri" charset="0"/>
                         <a:ea typeface="Calibri" charset="0"/>
                         <a:cs typeface="Calibri" charset="0"/>
@@ -19889,7 +19889,7 @@
                         <a:buNone/>
                       </a:pPr>
                       <a:r>
-                        <a:rPr lang="en-US" sz="1200" b="1" dirty="0">
+                        <a:rPr lang="en-US" sz="1050" b="1" dirty="0">
                           <a:solidFill>
                             <a:srgbClr val="FFFFFF"/>
                           </a:solidFill>
@@ -19899,7 +19899,7 @@
                         </a:rPr>
                         <a:t>Phase 3</a:t>
                       </a:r>
-                      <a:endParaRPr lang="en-US" sz="1200" dirty="0">
+                      <a:endParaRPr lang="en-US" sz="1050" dirty="0">
                         <a:latin typeface="Calibri" charset="0"/>
                         <a:ea typeface="Calibri" charset="0"/>
                         <a:cs typeface="Calibri" charset="0"/>
@@ -19957,7 +19957,7 @@
                         <a:buNone/>
                       </a:pPr>
                       <a:r>
-                        <a:rPr lang="en-US" sz="1200" b="1" dirty="0">
+                        <a:rPr lang="en-US" sz="1050" b="1" dirty="0">
                           <a:solidFill>
                             <a:srgbClr val="FFFFFF"/>
                           </a:solidFill>
@@ -19967,7 +19967,7 @@
                         </a:rPr>
                         <a:t>Share enrolled twice, larger states</a:t>
                       </a:r>
-                      <a:endParaRPr lang="en-US" sz="1200" dirty="0">
+                      <a:endParaRPr lang="en-US" sz="1050" dirty="0">
                         <a:latin typeface="Calibri" charset="0"/>
                         <a:ea typeface="Calibri" charset="0"/>
                         <a:cs typeface="Calibri" charset="0"/>
@@ -20027,7 +20027,7 @@
                         <a:buNone/>
                       </a:pPr>
                       <a:r>
-                        <a:rPr lang="en-US" sz="1200" dirty="0">
+                        <a:rPr lang="en-US" sz="1050" dirty="0">
                           <a:solidFill>
                             <a:srgbClr val="1C2833"/>
                           </a:solidFill>
@@ -20035,9 +20035,9 @@
                           <a:ea typeface="Calibri" pitchFamily="34" charset="-122"/>
                           <a:cs typeface="Calibri" pitchFamily="34" charset="-120"/>
                         </a:rPr>
-                        <a:t>Living here, born elsewhere</a:t>
+                        <a:t>Living here, born elsewhere (2011)</a:t>
                       </a:r>
-                      <a:endParaRPr lang="en-US" sz="1200" dirty="0">
+                      <a:endParaRPr lang="en-US" sz="1050" dirty="0">
                         <a:latin typeface="Calibri" charset="0"/>
                         <a:ea typeface="Calibri" charset="0"/>
                         <a:cs typeface="Calibri" charset="0"/>
@@ -20095,7 +20095,7 @@
                         <a:buNone/>
                       </a:pPr>
                       <a:r>
-                        <a:rPr lang="en-US" sz="1200" dirty="0">
+                        <a:rPr lang="en-US" sz="1050" dirty="0">
                           <a:solidFill>
                             <a:srgbClr val="1C2833"/>
                           </a:solidFill>
@@ -20105,7 +20105,7 @@
                         </a:rPr>
                         <a:t>0.53</a:t>
                       </a:r>
-                      <a:endParaRPr lang="en-US" sz="1200" dirty="0">
+                      <a:endParaRPr lang="en-US" sz="1050" dirty="0">
                         <a:latin typeface="Calibri" charset="0"/>
                         <a:ea typeface="Calibri" charset="0"/>
                         <a:cs typeface="Calibri" charset="0"/>
@@ -20163,7 +20163,7 @@
                         <a:buNone/>
                       </a:pPr>
                       <a:r>
-                        <a:rPr lang="en-US" sz="1200" dirty="0">
+                        <a:rPr lang="en-US" sz="1050" dirty="0">
                           <a:solidFill>
                             <a:srgbClr val="1C2833"/>
                           </a:solidFill>
@@ -20173,7 +20173,7 @@
                         </a:rPr>
                         <a:t>0.04</a:t>
                       </a:r>
-                      <a:endParaRPr lang="en-US" sz="1200" dirty="0">
+                      <a:endParaRPr lang="en-US" sz="1050" dirty="0">
                         <a:latin typeface="Calibri" charset="0"/>
                         <a:ea typeface="Calibri" charset="0"/>
                         <a:cs typeface="Calibri" charset="0"/>
@@ -20231,7 +20231,7 @@
                         <a:buNone/>
                       </a:pPr>
                       <a:r>
-                        <a:rPr lang="en-US" sz="1200" dirty="0">
+                        <a:rPr lang="en-US" sz="1050" dirty="0">
                           <a:solidFill>
                             <a:srgbClr val="1C2833"/>
                           </a:solidFill>
@@ -20241,7 +20241,7 @@
                         </a:rPr>
                         <a:t>0.68</a:t>
                       </a:r>
-                      <a:endParaRPr lang="en-US" sz="1200" dirty="0">
+                      <a:endParaRPr lang="en-US" sz="1050" dirty="0">
                         <a:latin typeface="Calibri" charset="0"/>
                         <a:ea typeface="Calibri" charset="0"/>
                         <a:cs typeface="Calibri" charset="0"/>
@@ -20299,7 +20299,7 @@
                         <a:buNone/>
                       </a:pPr>
                       <a:r>
-                        <a:rPr lang="en-US" sz="1200" dirty="0">
+                        <a:rPr lang="en-US" sz="1050" dirty="0">
                           <a:solidFill>
                             <a:srgbClr val="1C2833"/>
                           </a:solidFill>
@@ -20309,7 +20309,7 @@
                         </a:rPr>
                         <a:t>-0.26</a:t>
                       </a:r>
-                      <a:endParaRPr lang="en-US" sz="1200" dirty="0">
+                      <a:endParaRPr lang="en-US" sz="1050" dirty="0">
                         <a:latin typeface="Calibri" charset="0"/>
                         <a:ea typeface="Calibri" charset="0"/>
                         <a:cs typeface="Calibri" charset="0"/>
@@ -20369,7 +20369,7 @@
                         <a:buNone/>
                       </a:pPr>
                       <a:r>
-                        <a:rPr lang="en-US" sz="1200" dirty="0">
+                        <a:rPr lang="en-US" sz="1050" dirty="0">
                           <a:solidFill>
                             <a:srgbClr val="1C2833"/>
                           </a:solidFill>
@@ -20379,7 +20379,7 @@
                         </a:rPr>
                         <a:t>Income per head</a:t>
                       </a:r>
-                      <a:endParaRPr lang="en-US" sz="1200" dirty="0">
+                      <a:endParaRPr lang="en-US" sz="1050" dirty="0">
                         <a:latin typeface="Calibri" charset="0"/>
                         <a:ea typeface="Calibri" charset="0"/>
                         <a:cs typeface="Calibri" charset="0"/>
@@ -20437,7 +20437,7 @@
                         <a:buNone/>
                       </a:pPr>
                       <a:r>
-                        <a:rPr lang="en-US" sz="1200" dirty="0">
+                        <a:rPr lang="en-US" sz="1050" dirty="0">
                           <a:solidFill>
                             <a:srgbClr val="1C2833"/>
                           </a:solidFill>
@@ -20447,7 +20447,7 @@
                         </a:rPr>
                         <a:t>0.40</a:t>
                       </a:r>
-                      <a:endParaRPr lang="en-US" sz="1200" dirty="0">
+                      <a:endParaRPr lang="en-US" sz="1050" dirty="0">
                         <a:latin typeface="Calibri" charset="0"/>
                         <a:ea typeface="Calibri" charset="0"/>
                         <a:cs typeface="Calibri" charset="0"/>
@@ -20505,7 +20505,7 @@
                         <a:buNone/>
                       </a:pPr>
                       <a:r>
-                        <a:rPr lang="en-US" sz="1200" dirty="0">
+                        <a:rPr lang="en-US" sz="1050" dirty="0">
                           <a:solidFill>
                             <a:srgbClr val="1C2833"/>
                           </a:solidFill>
@@ -20515,7 +20515,7 @@
                         </a:rPr>
                         <a:t>0.17</a:t>
                       </a:r>
-                      <a:endParaRPr lang="en-US" sz="1200" dirty="0">
+                      <a:endParaRPr lang="en-US" sz="1050" dirty="0">
                         <a:latin typeface="Calibri" charset="0"/>
                         <a:ea typeface="Calibri" charset="0"/>
                         <a:cs typeface="Calibri" charset="0"/>
@@ -20573,7 +20573,7 @@
                         <a:buNone/>
                       </a:pPr>
                       <a:r>
-                        <a:rPr lang="en-US" sz="1200" dirty="0">
+                        <a:rPr lang="en-US" sz="1050" dirty="0">
                           <a:solidFill>
                             <a:srgbClr val="1C2833"/>
                           </a:solidFill>
@@ -20583,7 +20583,7 @@
                         </a:rPr>
                         <a:t>0.50</a:t>
                       </a:r>
-                      <a:endParaRPr lang="en-US" sz="1200" dirty="0">
+                      <a:endParaRPr lang="en-US" sz="1050" dirty="0">
                         <a:latin typeface="Calibri" charset="0"/>
                         <a:ea typeface="Calibri" charset="0"/>
                         <a:cs typeface="Calibri" charset="0"/>
@@ -20641,7 +20641,7 @@
                         <a:buNone/>
                       </a:pPr>
                       <a:r>
-                        <a:rPr lang="en-US" sz="1200" dirty="0">
+                        <a:rPr lang="en-US" sz="1050" dirty="0">
                           <a:solidFill>
                             <a:srgbClr val="1C2833"/>
                           </a:solidFill>
@@ -20651,7 +20651,7 @@
                         </a:rPr>
                         <a:t>-0.39</a:t>
                       </a:r>
-                      <a:endParaRPr lang="en-US" sz="1200" dirty="0">
+                      <a:endParaRPr lang="en-US" sz="1050" dirty="0">
                         <a:latin typeface="Calibri" charset="0"/>
                         <a:ea typeface="Calibri" charset="0"/>
                         <a:cs typeface="Calibri" charset="0"/>
@@ -20711,7 +20711,7 @@
                         <a:buNone/>
                       </a:pPr>
                       <a:r>
-                        <a:rPr lang="en-US" sz="1200" dirty="0">
+                        <a:rPr lang="en-US" sz="1050" dirty="0">
                           <a:solidFill>
                             <a:srgbClr val="1C2833"/>
                           </a:solidFill>
@@ -20719,9 +20719,9 @@
                           <a:ea typeface="Calibri" pitchFamily="34" charset="-122"/>
                           <a:cs typeface="Calibri" pitchFamily="34" charset="-120"/>
                         </a:rPr>
-                        <a:t>Urban share</a:t>
+                        <a:t>Urban spending per head</a:t>
                       </a:r>
-                      <a:endParaRPr lang="en-US" sz="1200" dirty="0">
+                      <a:endParaRPr lang="en-US" sz="1050" dirty="0">
                         <a:latin typeface="Calibri" charset="0"/>
                         <a:ea typeface="Calibri" charset="0"/>
                         <a:cs typeface="Calibri" charset="0"/>
@@ -20779,7 +20779,7 @@
                         <a:buNone/>
                       </a:pPr>
                       <a:r>
-                        <a:rPr lang="en-US" sz="1200" dirty="0">
+                        <a:rPr lang="en-US" sz="1050" dirty="0">
                           <a:solidFill>
                             <a:srgbClr val="1C2833"/>
                           </a:solidFill>
@@ -20787,9 +20787,9 @@
                           <a:ea typeface="Calibri" pitchFamily="34" charset="-122"/>
                           <a:cs typeface="Calibri" pitchFamily="34" charset="-120"/>
                         </a:rPr>
-                        <a:t>0.21</a:t>
+                        <a:t>0.27</a:t>
                       </a:r>
-                      <a:endParaRPr lang="en-US" sz="1200" dirty="0">
+                      <a:endParaRPr lang="en-US" sz="1050" dirty="0">
                         <a:latin typeface="Calibri" charset="0"/>
                         <a:ea typeface="Calibri" charset="0"/>
                         <a:cs typeface="Calibri" charset="0"/>
@@ -20847,7 +20847,7 @@
                         <a:buNone/>
                       </a:pPr>
                       <a:r>
-                        <a:rPr lang="en-US" sz="1200" dirty="0">
+                        <a:rPr lang="en-US" sz="1050" dirty="0">
                           <a:solidFill>
                             <a:srgbClr val="1C2833"/>
                           </a:solidFill>
@@ -20855,9 +20855,9 @@
                           <a:ea typeface="Calibri" pitchFamily="34" charset="-122"/>
                           <a:cs typeface="Calibri" pitchFamily="34" charset="-120"/>
                         </a:rPr>
-                        <a:t>-0.23</a:t>
+                        <a:t>0.28</a:t>
                       </a:r>
-                      <a:endParaRPr lang="en-US" sz="1200" dirty="0">
+                      <a:endParaRPr lang="en-US" sz="1050" dirty="0">
                         <a:latin typeface="Calibri" charset="0"/>
                         <a:ea typeface="Calibri" charset="0"/>
                         <a:cs typeface="Calibri" charset="0"/>
@@ -20915,7 +20915,7 @@
                         <a:buNone/>
                       </a:pPr>
                       <a:r>
-                        <a:rPr lang="en-US" sz="1200" dirty="0">
+                        <a:rPr lang="en-US" sz="1050" dirty="0">
                           <a:solidFill>
                             <a:srgbClr val="1C2833"/>
                           </a:solidFill>
@@ -20923,9 +20923,9 @@
                           <a:ea typeface="Calibri" pitchFamily="34" charset="-122"/>
                           <a:cs typeface="Calibri" pitchFamily="34" charset="-120"/>
                         </a:rPr>
-                        <a:t>0.52</a:t>
+                        <a:t>0.16</a:t>
                       </a:r>
-                      <a:endParaRPr lang="en-US" sz="1200" dirty="0">
+                      <a:endParaRPr lang="en-US" sz="1050" dirty="0">
                         <a:latin typeface="Calibri" charset="0"/>
                         <a:ea typeface="Calibri" charset="0"/>
                         <a:cs typeface="Calibri" charset="0"/>
@@ -20983,7 +20983,7 @@
                         <a:buNone/>
                       </a:pPr>
                       <a:r>
-                        <a:rPr lang="en-US" sz="1200" dirty="0">
+                        <a:rPr lang="en-US" sz="1050" dirty="0">
                           <a:solidFill>
                             <a:srgbClr val="1C2833"/>
                           </a:solidFill>
@@ -20991,9 +20991,9 @@
                           <a:ea typeface="Calibri" pitchFamily="34" charset="-122"/>
                           <a:cs typeface="Calibri" pitchFamily="34" charset="-120"/>
                         </a:rPr>
-                        <a:t>-0.58</a:t>
+                        <a:t>-0.32</a:t>
                       </a:r>
-                      <a:endParaRPr lang="en-US" sz="1200" dirty="0">
+                      <a:endParaRPr lang="en-US" sz="1050" dirty="0">
                         <a:latin typeface="Calibri" charset="0"/>
                         <a:ea typeface="Calibri" charset="0"/>
                         <a:cs typeface="Calibri" charset="0"/>
@@ -21053,7 +21053,7 @@
                         <a:buNone/>
                       </a:pPr>
                       <a:r>
-                        <a:rPr lang="en-US" sz="1200" dirty="0">
+                        <a:rPr lang="en-US" sz="1050" dirty="0">
                           <a:solidFill>
                             <a:srgbClr val="1C2833"/>
                           </a:solidFill>
@@ -21061,9 +21061,9 @@
                           <a:ea typeface="Calibri" pitchFamily="34" charset="-122"/>
                           <a:cs typeface="Calibri" pitchFamily="34" charset="-120"/>
                         </a:rPr>
-                        <a:t>Muslim share</a:t>
+                        <a:t>SC share of households</a:t>
                       </a:r>
-                      <a:endParaRPr lang="en-US" sz="1200" dirty="0">
+                      <a:endParaRPr lang="en-US" sz="1050" dirty="0">
                         <a:latin typeface="Calibri" charset="0"/>
                         <a:ea typeface="Calibri" charset="0"/>
                         <a:cs typeface="Calibri" charset="0"/>
@@ -21121,7 +21121,7 @@
                         <a:buNone/>
                       </a:pPr>
                       <a:r>
-                        <a:rPr lang="en-US" sz="1200" dirty="0">
+                        <a:rPr lang="en-US" sz="1050" dirty="0">
                           <a:solidFill>
                             <a:srgbClr val="1C2833"/>
                           </a:solidFill>
@@ -21129,9 +21129,9 @@
                           <a:ea typeface="Calibri" pitchFamily="34" charset="-122"/>
                           <a:cs typeface="Calibri" pitchFamily="34" charset="-120"/>
                         </a:rPr>
-                        <a:t>0.12</a:t>
+                        <a:t>0.19</a:t>
                       </a:r>
-                      <a:endParaRPr lang="en-US" sz="1200" dirty="0">
+                      <a:endParaRPr lang="en-US" sz="1050" dirty="0">
                         <a:latin typeface="Calibri" charset="0"/>
                         <a:ea typeface="Calibri" charset="0"/>
                         <a:cs typeface="Calibri" charset="0"/>
@@ -21189,7 +21189,7 @@
                         <a:buNone/>
                       </a:pPr>
                       <a:r>
-                        <a:rPr lang="en-US" sz="1200" dirty="0">
+                        <a:rPr lang="en-US" sz="1050" dirty="0">
                           <a:solidFill>
                             <a:srgbClr val="1C2833"/>
                           </a:solidFill>
@@ -21197,9 +21197,9 @@
                           <a:ea typeface="Calibri" pitchFamily="34" charset="-122"/>
                           <a:cs typeface="Calibri" pitchFamily="34" charset="-120"/>
                         </a:rPr>
-                        <a:t>-0.34</a:t>
+                        <a:t>0.01</a:t>
                       </a:r>
-                      <a:endParaRPr lang="en-US" sz="1200" dirty="0">
+                      <a:endParaRPr lang="en-US" sz="1050" dirty="0">
                         <a:latin typeface="Calibri" charset="0"/>
                         <a:ea typeface="Calibri" charset="0"/>
                         <a:cs typeface="Calibri" charset="0"/>
@@ -21257,7 +21257,7 @@
                         <a:buNone/>
                       </a:pPr>
                       <a:r>
-                        <a:rPr lang="en-US" sz="1200" dirty="0">
+                        <a:rPr lang="en-US" sz="1050" dirty="0">
                           <a:solidFill>
                             <a:srgbClr val="1C2833"/>
                           </a:solidFill>
@@ -21265,9 +21265,9 @@
                           <a:ea typeface="Calibri" pitchFamily="34" charset="-122"/>
                           <a:cs typeface="Calibri" pitchFamily="34" charset="-120"/>
                         </a:rPr>
-                        <a:t>0.53</a:t>
+                        <a:t>0.38</a:t>
                       </a:r>
-                      <a:endParaRPr lang="en-US" sz="1200" dirty="0">
+                      <a:endParaRPr lang="en-US" sz="1050" dirty="0">
                         <a:latin typeface="Calibri" charset="0"/>
                         <a:ea typeface="Calibri" charset="0"/>
                         <a:cs typeface="Calibri" charset="0"/>
@@ -21325,7 +21325,7 @@
                         <a:buNone/>
                       </a:pPr>
                       <a:r>
-                        <a:rPr lang="en-US" sz="1200" dirty="0">
+                        <a:rPr lang="en-US" sz="1050" dirty="0">
                           <a:solidFill>
                             <a:srgbClr val="1C2833"/>
                           </a:solidFill>
@@ -21333,9 +21333,9 @@
                           <a:ea typeface="Calibri" pitchFamily="34" charset="-122"/>
                           <a:cs typeface="Calibri" pitchFamily="34" charset="-120"/>
                         </a:rPr>
-                        <a:t>0.08</a:t>
+                        <a:t>-0.15</a:t>
                       </a:r>
-                      <a:endParaRPr lang="en-US" sz="1200" dirty="0">
+                      <a:endParaRPr lang="en-US" sz="1050" dirty="0">
                         <a:latin typeface="Calibri" charset="0"/>
                         <a:ea typeface="Calibri" charset="0"/>
                         <a:cs typeface="Calibri" charset="0"/>
@@ -21395,7 +21395,7 @@
                         <a:buNone/>
                       </a:pPr>
                       <a:r>
-                        <a:rPr lang="en-US" sz="1200" dirty="0">
+                        <a:rPr lang="en-US" sz="1050" dirty="0">
                           <a:solidFill>
                             <a:srgbClr val="1C2833"/>
                           </a:solidFill>
@@ -21403,9 +21403,9 @@
                           <a:ea typeface="Calibri" pitchFamily="34" charset="-122"/>
                           <a:cs typeface="Calibri" pitchFamily="34" charset="-120"/>
                         </a:rPr>
-                        <a:t>SC share</a:t>
+                        <a:t>Urban share</a:t>
                       </a:r>
-                      <a:endParaRPr lang="en-US" sz="1200" dirty="0">
+                      <a:endParaRPr lang="en-US" sz="1050" dirty="0">
                         <a:latin typeface="Calibri" charset="0"/>
                         <a:ea typeface="Calibri" charset="0"/>
                         <a:cs typeface="Calibri" charset="0"/>
@@ -21463,7 +21463,7 @@
                         <a:buNone/>
                       </a:pPr>
                       <a:r>
-                        <a:rPr lang="en-US" sz="1200" dirty="0">
+                        <a:rPr lang="en-US" sz="1050" dirty="0">
                           <a:solidFill>
                             <a:srgbClr val="1C2833"/>
                           </a:solidFill>
@@ -21471,9 +21471,9 @@
                           <a:ea typeface="Calibri" pitchFamily="34" charset="-122"/>
                           <a:cs typeface="Calibri" pitchFamily="34" charset="-120"/>
                         </a:rPr>
-                        <a:t>0.05</a:t>
+                        <a:t>0.09</a:t>
                       </a:r>
-                      <a:endParaRPr lang="en-US" sz="1200" dirty="0">
+                      <a:endParaRPr lang="en-US" sz="1050" dirty="0">
                         <a:latin typeface="Calibri" charset="0"/>
                         <a:ea typeface="Calibri" charset="0"/>
                         <a:cs typeface="Calibri" charset="0"/>
@@ -21531,7 +21531,7 @@
                         <a:buNone/>
                       </a:pPr>
                       <a:r>
-                        <a:rPr lang="en-US" sz="1200" dirty="0">
+                        <a:rPr lang="en-US" sz="1050" dirty="0">
                           <a:solidFill>
                             <a:srgbClr val="1C2833"/>
                           </a:solidFill>
@@ -21539,9 +21539,9 @@
                           <a:ea typeface="Calibri" pitchFamily="34" charset="-122"/>
                           <a:cs typeface="Calibri" pitchFamily="34" charset="-120"/>
                         </a:rPr>
-                        <a:t>0.03</a:t>
+                        <a:t>-0.24</a:t>
                       </a:r>
-                      <a:endParaRPr lang="en-US" sz="1200" dirty="0">
+                      <a:endParaRPr lang="en-US" sz="1050" dirty="0">
                         <a:latin typeface="Calibri" charset="0"/>
                         <a:ea typeface="Calibri" charset="0"/>
                         <a:cs typeface="Calibri" charset="0"/>
@@ -21599,7 +21599,7 @@
                         <a:buNone/>
                       </a:pPr>
                       <a:r>
-                        <a:rPr lang="en-US" sz="1200" dirty="0">
+                        <a:rPr lang="en-US" sz="1050" dirty="0">
                           <a:solidFill>
                             <a:srgbClr val="1C2833"/>
                           </a:solidFill>
@@ -21607,9 +21607,9 @@
                           <a:ea typeface="Calibri" pitchFamily="34" charset="-122"/>
                           <a:cs typeface="Calibri" pitchFamily="34" charset="-120"/>
                         </a:rPr>
-                        <a:t>0.06</a:t>
+                        <a:t>0.31</a:t>
                       </a:r>
-                      <a:endParaRPr lang="en-US" sz="1200" dirty="0">
+                      <a:endParaRPr lang="en-US" sz="1050" dirty="0">
                         <a:latin typeface="Calibri" charset="0"/>
                         <a:ea typeface="Calibri" charset="0"/>
                         <a:cs typeface="Calibri" charset="0"/>
@@ -21667,7 +21667,7 @@
                         <a:buNone/>
                       </a:pPr>
                       <a:r>
-                        <a:rPr lang="en-US" sz="1200" dirty="0">
+                        <a:rPr lang="en-US" sz="1050" dirty="0">
                           <a:solidFill>
                             <a:srgbClr val="1C2833"/>
                           </a:solidFill>
@@ -21675,9 +21675,9 @@
                           <a:ea typeface="Calibri" pitchFamily="34" charset="-122"/>
                           <a:cs typeface="Calibri" pitchFamily="34" charset="-120"/>
                         </a:rPr>
-                        <a:t>-0.18</a:t>
+                        <a:t>-0.57</a:t>
                       </a:r>
-                      <a:endParaRPr lang="en-US" sz="1200" dirty="0">
+                      <a:endParaRPr lang="en-US" sz="1050" dirty="0">
                         <a:latin typeface="Calibri" charset="0"/>
                         <a:ea typeface="Calibri" charset="0"/>
                         <a:cs typeface="Calibri" charset="0"/>
@@ -21737,7 +21737,7 @@
                         <a:buNone/>
                       </a:pPr>
                       <a:r>
-                        <a:rPr lang="en-US" sz="1200" dirty="0">
+                        <a:rPr lang="en-US" sz="1050" dirty="0">
                           <a:solidFill>
                             <a:srgbClr val="1C2833"/>
                           </a:solidFill>
@@ -21745,9 +21745,9 @@
                           <a:ea typeface="Calibri" pitchFamily="34" charset="-122"/>
                           <a:cs typeface="Calibri" pitchFamily="34" charset="-120"/>
                         </a:rPr>
-                        <a:t>Born here, living elsewhere</a:t>
+                        <a:t>Rural spending per head</a:t>
                       </a:r>
-                      <a:endParaRPr lang="en-US" sz="1200" dirty="0">
+                      <a:endParaRPr lang="en-US" sz="1050" dirty="0">
                         <a:latin typeface="Calibri" charset="0"/>
                         <a:ea typeface="Calibri" charset="0"/>
                         <a:cs typeface="Calibri" charset="0"/>
@@ -21805,7 +21805,7 @@
                         <a:buNone/>
                       </a:pPr>
                       <a:r>
-                        <a:rPr lang="en-US" sz="1200" dirty="0">
+                        <a:rPr lang="en-US" sz="1050" dirty="0">
                           <a:solidFill>
                             <a:srgbClr val="1C2833"/>
                           </a:solidFill>
@@ -21813,9 +21813,9 @@
                           <a:ea typeface="Calibri" pitchFamily="34" charset="-122"/>
                           <a:cs typeface="Calibri" pitchFamily="34" charset="-120"/>
                         </a:rPr>
-                        <a:t>0.03</a:t>
+                        <a:t>0.08</a:t>
                       </a:r>
-                      <a:endParaRPr lang="en-US" sz="1200" dirty="0">
+                      <a:endParaRPr lang="en-US" sz="1050" dirty="0">
                         <a:latin typeface="Calibri" charset="0"/>
                         <a:ea typeface="Calibri" charset="0"/>
                         <a:cs typeface="Calibri" charset="0"/>
@@ -21873,7 +21873,7 @@
                         <a:buNone/>
                       </a:pPr>
                       <a:r>
-                        <a:rPr lang="en-US" sz="1200" dirty="0">
+                        <a:rPr lang="en-US" sz="1050" dirty="0">
                           <a:solidFill>
                             <a:srgbClr val="1C2833"/>
                           </a:solidFill>
@@ -21881,9 +21881,9 @@
                           <a:ea typeface="Calibri" pitchFamily="34" charset="-122"/>
                           <a:cs typeface="Calibri" pitchFamily="34" charset="-120"/>
                         </a:rPr>
-                        <a:t>-0.30</a:t>
+                        <a:t>0.09</a:t>
                       </a:r>
-                      <a:endParaRPr lang="en-US" sz="1200" dirty="0">
+                      <a:endParaRPr lang="en-US" sz="1050" dirty="0">
                         <a:latin typeface="Calibri" charset="0"/>
                         <a:ea typeface="Calibri" charset="0"/>
                         <a:cs typeface="Calibri" charset="0"/>
@@ -21941,7 +21941,7 @@
                         <a:buNone/>
                       </a:pPr>
                       <a:r>
-                        <a:rPr lang="en-US" sz="1200" dirty="0">
+                        <a:rPr lang="en-US" sz="1050" dirty="0">
                           <a:solidFill>
                             <a:srgbClr val="1C2833"/>
                           </a:solidFill>
@@ -21949,9 +21949,9 @@
                           <a:ea typeface="Calibri" pitchFamily="34" charset="-122"/>
                           <a:cs typeface="Calibri" pitchFamily="34" charset="-120"/>
                         </a:rPr>
-                        <a:t>0.31</a:t>
+                        <a:t>0.08</a:t>
                       </a:r>
-                      <a:endParaRPr lang="en-US" sz="1200" dirty="0">
+                      <a:endParaRPr lang="en-US" sz="1050" dirty="0">
                         <a:latin typeface="Calibri" charset="0"/>
                         <a:ea typeface="Calibri" charset="0"/>
                         <a:cs typeface="Calibri" charset="0"/>
@@ -22009,7 +22009,7 @@
                         <a:buNone/>
                       </a:pPr>
                       <a:r>
-                        <a:rPr lang="en-US" sz="1200" dirty="0">
+                        <a:rPr lang="en-US" sz="1050" dirty="0">
                           <a:solidFill>
                             <a:srgbClr val="1C2833"/>
                           </a:solidFill>
@@ -22017,9 +22017,9 @@
                           <a:ea typeface="Calibri" pitchFamily="34" charset="-122"/>
                           <a:cs typeface="Calibri" pitchFamily="34" charset="-120"/>
                         </a:rPr>
-                        <a:t>0.24</a:t>
+                        <a:t>-0.34</a:t>
                       </a:r>
-                      <a:endParaRPr lang="en-US" sz="1200" dirty="0">
+                      <a:endParaRPr lang="en-US" sz="1050" dirty="0">
                         <a:latin typeface="Calibri" charset="0"/>
                         <a:ea typeface="Calibri" charset="0"/>
                         <a:cs typeface="Calibri" charset="0"/>
@@ -22079,7 +22079,7 @@
                         <a:buNone/>
                       </a:pPr>
                       <a:r>
-                        <a:rPr lang="en-US" sz="1200" dirty="0">
+                        <a:rPr lang="en-US" sz="1050" dirty="0">
                           <a:solidFill>
                             <a:srgbClr val="1C2833"/>
                           </a:solidFill>
@@ -22087,9 +22087,9 @@
                           <a:ea typeface="Calibri" pitchFamily="34" charset="-122"/>
                           <a:cs typeface="Calibri" pitchFamily="34" charset="-120"/>
                         </a:rPr>
-                        <a:t>Literacy</a:t>
+                        <a:t>Muslim share of households</a:t>
                       </a:r>
-                      <a:endParaRPr lang="en-US" sz="1200" dirty="0">
+                      <a:endParaRPr lang="en-US" sz="1050" dirty="0">
                         <a:latin typeface="Calibri" charset="0"/>
                         <a:ea typeface="Calibri" charset="0"/>
                         <a:cs typeface="Calibri" charset="0"/>
@@ -22147,7 +22147,7 @@
                         <a:buNone/>
                       </a:pPr>
                       <a:r>
-                        <a:rPr lang="en-US" sz="1200" dirty="0">
+                        <a:rPr lang="en-US" sz="1050" dirty="0">
                           <a:solidFill>
                             <a:srgbClr val="1C2833"/>
                           </a:solidFill>
@@ -22155,9 +22155,9 @@
                           <a:ea typeface="Calibri" pitchFamily="34" charset="-122"/>
                           <a:cs typeface="Calibri" pitchFamily="34" charset="-120"/>
                         </a:rPr>
-                        <a:t>-0.07</a:t>
+                        <a:t>0.08</a:t>
                       </a:r>
-                      <a:endParaRPr lang="en-US" sz="1200" dirty="0">
+                      <a:endParaRPr lang="en-US" sz="1050" dirty="0">
                         <a:latin typeface="Calibri" charset="0"/>
                         <a:ea typeface="Calibri" charset="0"/>
                         <a:cs typeface="Calibri" charset="0"/>
@@ -22215,7 +22215,7 @@
                         <a:buNone/>
                       </a:pPr>
                       <a:r>
-                        <a:rPr lang="en-US" sz="1200" dirty="0">
+                        <a:rPr lang="en-US" sz="1050" dirty="0">
                           <a:solidFill>
                             <a:srgbClr val="1C2833"/>
                           </a:solidFill>
@@ -22223,9 +22223,9 @@
                           <a:ea typeface="Calibri" pitchFamily="34" charset="-122"/>
                           <a:cs typeface="Calibri" pitchFamily="34" charset="-120"/>
                         </a:rPr>
-                        <a:t>-0.05</a:t>
+                        <a:t>-0.27</a:t>
                       </a:r>
-                      <a:endParaRPr lang="en-US" sz="1200" dirty="0">
+                      <a:endParaRPr lang="en-US" sz="1050" dirty="0">
                         <a:latin typeface="Calibri" charset="0"/>
                         <a:ea typeface="Calibri" charset="0"/>
                         <a:cs typeface="Calibri" charset="0"/>
@@ -22283,7 +22283,7 @@
                         <a:buNone/>
                       </a:pPr>
                       <a:r>
-                        <a:rPr lang="en-US" sz="1200" dirty="0">
+                        <a:rPr lang="en-US" sz="1050" dirty="0">
                           <a:solidFill>
                             <a:srgbClr val="1C2833"/>
                           </a:solidFill>
@@ -22291,9 +22291,9 @@
                           <a:ea typeface="Calibri" pitchFamily="34" charset="-122"/>
                           <a:cs typeface="Calibri" pitchFamily="34" charset="-120"/>
                         </a:rPr>
-                        <a:t>-0.04</a:t>
+                        <a:t>0.45</a:t>
                       </a:r>
-                      <a:endParaRPr lang="en-US" sz="1200" dirty="0">
+                      <a:endParaRPr lang="en-US" sz="1050" dirty="0">
                         <a:latin typeface="Calibri" charset="0"/>
                         <a:ea typeface="Calibri" charset="0"/>
                         <a:cs typeface="Calibri" charset="0"/>
@@ -22351,7 +22351,7 @@
                         <a:buNone/>
                       </a:pPr>
                       <a:r>
-                        <a:rPr lang="en-US" sz="1200" dirty="0">
+                        <a:rPr lang="en-US" sz="1050" dirty="0">
                           <a:solidFill>
                             <a:srgbClr val="1C2833"/>
                           </a:solidFill>
@@ -22359,9 +22359,9 @@
                           <a:ea typeface="Calibri" pitchFamily="34" charset="-122"/>
                           <a:cs typeface="Calibri" pitchFamily="34" charset="-120"/>
                         </a:rPr>
-                        <a:t>-0.78</a:t>
+                        <a:t>-0.02</a:t>
                       </a:r>
-                      <a:endParaRPr lang="en-US" sz="1200" dirty="0">
+                      <a:endParaRPr lang="en-US" sz="1050" dirty="0">
                         <a:latin typeface="Calibri" charset="0"/>
                         <a:ea typeface="Calibri" charset="0"/>
                         <a:cs typeface="Calibri" charset="0"/>
@@ -22421,7 +22421,7 @@
                         <a:buNone/>
                       </a:pPr>
                       <a:r>
-                        <a:rPr lang="en-US" sz="1200" dirty="0">
+                        <a:rPr lang="en-US" sz="1050" dirty="0">
                           <a:solidFill>
                             <a:srgbClr val="1C2833"/>
                           </a:solidFill>
@@ -22429,9 +22429,9 @@
                           <a:ea typeface="Calibri" pitchFamily="34" charset="-122"/>
                           <a:cs typeface="Calibri" pitchFamily="34" charset="-120"/>
                         </a:rPr>
-                        <a:t>Women's literacy</a:t>
+                        <a:t>Born here, living elsewhere (2011)</a:t>
                       </a:r>
-                      <a:endParaRPr lang="en-US" sz="1200" dirty="0">
+                      <a:endParaRPr lang="en-US" sz="1050" dirty="0">
                         <a:latin typeface="Calibri" charset="0"/>
                         <a:ea typeface="Calibri" charset="0"/>
                         <a:cs typeface="Calibri" charset="0"/>
@@ -22489,7 +22489,7 @@
                         <a:buNone/>
                       </a:pPr>
                       <a:r>
-                        <a:rPr lang="en-US" sz="1200" dirty="0">
+                        <a:rPr lang="en-US" sz="1050" dirty="0">
                           <a:solidFill>
                             <a:srgbClr val="1C2833"/>
                           </a:solidFill>
@@ -22497,9 +22497,9 @@
                           <a:ea typeface="Calibri" pitchFamily="34" charset="-122"/>
                           <a:cs typeface="Calibri" pitchFamily="34" charset="-120"/>
                         </a:rPr>
-                        <a:t>-0.14</a:t>
+                        <a:t>0.03</a:t>
                       </a:r>
-                      <a:endParaRPr lang="en-US" sz="1200" dirty="0">
+                      <a:endParaRPr lang="en-US" sz="1050" dirty="0">
                         <a:latin typeface="Calibri" charset="0"/>
                         <a:ea typeface="Calibri" charset="0"/>
                         <a:cs typeface="Calibri" charset="0"/>
@@ -22557,7 +22557,7 @@
                         <a:buNone/>
                       </a:pPr>
                       <a:r>
-                        <a:rPr lang="en-US" sz="1200" dirty="0">
+                        <a:rPr lang="en-US" sz="1050" dirty="0">
                           <a:solidFill>
                             <a:srgbClr val="1C2833"/>
                           </a:solidFill>
@@ -22565,9 +22565,9 @@
                           <a:ea typeface="Calibri" pitchFamily="34" charset="-122"/>
                           <a:cs typeface="Calibri" pitchFamily="34" charset="-120"/>
                         </a:rPr>
-                        <a:t>-0.09</a:t>
+                        <a:t>-0.30</a:t>
                       </a:r>
-                      <a:endParaRPr lang="en-US" sz="1200" dirty="0">
+                      <a:endParaRPr lang="en-US" sz="1050" dirty="0">
                         <a:latin typeface="Calibri" charset="0"/>
                         <a:ea typeface="Calibri" charset="0"/>
                         <a:cs typeface="Calibri" charset="0"/>
@@ -22625,7 +22625,7 @@
                         <a:buNone/>
                       </a:pPr>
                       <a:r>
-                        <a:rPr lang="en-US" sz="1200" dirty="0">
+                        <a:rPr lang="en-US" sz="1050" dirty="0">
                           <a:solidFill>
                             <a:srgbClr val="1C2833"/>
                           </a:solidFill>
@@ -22633,9 +22633,9 @@
                           <a:ea typeface="Calibri" pitchFamily="34" charset="-122"/>
                           <a:cs typeface="Calibri" pitchFamily="34" charset="-120"/>
                         </a:rPr>
-                        <a:t>-0.18</a:t>
+                        <a:t>0.31</a:t>
                       </a:r>
-                      <a:endParaRPr lang="en-US" sz="1200" dirty="0">
+                      <a:endParaRPr lang="en-US" sz="1050" dirty="0">
                         <a:latin typeface="Calibri" charset="0"/>
                         <a:ea typeface="Calibri" charset="0"/>
                         <a:cs typeface="Calibri" charset="0"/>
@@ -22693,7 +22693,7 @@
                         <a:buNone/>
                       </a:pPr>
                       <a:r>
-                        <a:rPr lang="en-US" sz="1200" dirty="0">
+                        <a:rPr lang="en-US" sz="1050" dirty="0">
                           <a:solidFill>
                             <a:srgbClr val="1C2833"/>
                           </a:solidFill>
@@ -22701,9 +22701,9 @@
                           <a:ea typeface="Calibri" pitchFamily="34" charset="-122"/>
                           <a:cs typeface="Calibri" pitchFamily="34" charset="-120"/>
                         </a:rPr>
-                        <a:t>-0.74</a:t>
+                        <a:t>0.24</a:t>
                       </a:r>
-                      <a:endParaRPr lang="en-US" sz="1200" dirty="0">
+                      <a:endParaRPr lang="en-US" sz="1050" dirty="0">
                         <a:latin typeface="Calibri" charset="0"/>
                         <a:ea typeface="Calibri" charset="0"/>
                         <a:cs typeface="Calibri" charset="0"/>
@@ -22763,7 +22763,7 @@
                         <a:buNone/>
                       </a:pPr>
                       <a:r>
-                        <a:rPr lang="en-US" sz="1200" dirty="0">
+                        <a:rPr lang="en-US" sz="1050" dirty="0">
                           <a:solidFill>
                             <a:srgbClr val="1C2833"/>
                           </a:solidFill>
@@ -22771,9 +22771,9 @@
                           <a:ea typeface="Calibri" pitchFamily="34" charset="-122"/>
                           <a:cs typeface="Calibri" pitchFamily="34" charset="-120"/>
                         </a:rPr>
-                        <a:t>Sex ratio</a:t>
+                        <a:t>Literacy</a:t>
                       </a:r>
-                      <a:endParaRPr lang="en-US" sz="1200" dirty="0">
+                      <a:endParaRPr lang="en-US" sz="1050" dirty="0">
                         <a:latin typeface="Calibri" charset="0"/>
                         <a:ea typeface="Calibri" charset="0"/>
                         <a:cs typeface="Calibri" charset="0"/>
@@ -22831,7 +22831,7 @@
                         <a:buNone/>
                       </a:pPr>
                       <a:r>
-                        <a:rPr lang="en-US" sz="1200" dirty="0">
+                        <a:rPr lang="en-US" sz="1050" dirty="0">
                           <a:solidFill>
                             <a:srgbClr val="1C2833"/>
                           </a:solidFill>
@@ -22839,9 +22839,9 @@
                           <a:ea typeface="Calibri" pitchFamily="34" charset="-122"/>
                           <a:cs typeface="Calibri" pitchFamily="34" charset="-120"/>
                         </a:rPr>
-                        <a:t>-0.31</a:t>
+                        <a:t>-0.11</a:t>
                       </a:r>
-                      <a:endParaRPr lang="en-US" sz="1200" dirty="0">
+                      <a:endParaRPr lang="en-US" sz="1050" dirty="0">
                         <a:latin typeface="Calibri" charset="0"/>
                         <a:ea typeface="Calibri" charset="0"/>
                         <a:cs typeface="Calibri" charset="0"/>
@@ -22899,7 +22899,7 @@
                         <a:buNone/>
                       </a:pPr>
                       <a:r>
-                        <a:rPr lang="en-US" sz="1200" dirty="0">
+                        <a:rPr lang="en-US" sz="1050" dirty="0">
                           <a:solidFill>
                             <a:srgbClr val="1C2833"/>
                           </a:solidFill>
@@ -22907,9 +22907,9 @@
                           <a:ea typeface="Calibri" pitchFamily="34" charset="-122"/>
                           <a:cs typeface="Calibri" pitchFamily="34" charset="-120"/>
                         </a:rPr>
-                        <a:t>-0.22</a:t>
+                        <a:t>-0.04</a:t>
                       </a:r>
-                      <a:endParaRPr lang="en-US" sz="1200" dirty="0">
+                      <a:endParaRPr lang="en-US" sz="1050" dirty="0">
                         <a:latin typeface="Calibri" charset="0"/>
                         <a:ea typeface="Calibri" charset="0"/>
                         <a:cs typeface="Calibri" charset="0"/>
@@ -22967,7 +22967,7 @@
                         <a:buNone/>
                       </a:pPr>
                       <a:r>
-                        <a:rPr lang="en-US" sz="1200" dirty="0">
+                        <a:rPr lang="en-US" sz="1050" dirty="0">
                           <a:solidFill>
                             <a:srgbClr val="1C2833"/>
                           </a:solidFill>
@@ -22975,9 +22975,9 @@
                           <a:ea typeface="Calibri" pitchFamily="34" charset="-122"/>
                           <a:cs typeface="Calibri" pitchFamily="34" charset="-120"/>
                         </a:rPr>
-                        <a:t>-0.46</a:t>
+                        <a:t>-0.19</a:t>
                       </a:r>
-                      <a:endParaRPr lang="en-US" sz="1200" dirty="0">
+                      <a:endParaRPr lang="en-US" sz="1050" dirty="0">
                         <a:latin typeface="Calibri" charset="0"/>
                         <a:ea typeface="Calibri" charset="0"/>
                         <a:cs typeface="Calibri" charset="0"/>
@@ -23035,7 +23035,7 @@
                         <a:buNone/>
                       </a:pPr>
                       <a:r>
-                        <a:rPr lang="en-US" sz="1200" dirty="0">
+                        <a:rPr lang="en-US" sz="1050" dirty="0">
                           <a:solidFill>
                             <a:srgbClr val="1C2833"/>
                           </a:solidFill>
@@ -23043,9 +23043,9 @@
                           <a:ea typeface="Calibri" pitchFamily="34" charset="-122"/>
                           <a:cs typeface="Calibri" pitchFamily="34" charset="-120"/>
                         </a:rPr>
-                        <a:t>0.10</a:t>
+                        <a:t>-0.68</a:t>
                       </a:r>
-                      <a:endParaRPr lang="en-US" sz="1200" dirty="0">
+                      <a:endParaRPr lang="en-US" sz="1050" dirty="0">
                         <a:latin typeface="Calibri" charset="0"/>
                         <a:ea typeface="Calibri" charset="0"/>
                         <a:cs typeface="Calibri" charset="0"/>
@@ -23105,7 +23105,7 @@
                         <a:buNone/>
                       </a:pPr>
                       <a:r>
-                        <a:rPr lang="en-US" sz="1200" dirty="0">
+                        <a:rPr lang="en-US" sz="1050" dirty="0">
                           <a:solidFill>
                             <a:srgbClr val="1C2833"/>
                           </a:solidFill>
@@ -23113,9 +23113,9 @@
                           <a:ea typeface="Calibri" pitchFamily="34" charset="-122"/>
                           <a:cs typeface="Calibri" pitchFamily="34" charset="-120"/>
                         </a:rPr>
-                        <a:t>ST share</a:t>
+                        <a:t>Women's literacy</a:t>
                       </a:r>
-                      <a:endParaRPr lang="en-US" sz="1200" dirty="0">
+                      <a:endParaRPr lang="en-US" sz="1050" dirty="0">
                         <a:latin typeface="Calibri" charset="0"/>
                         <a:ea typeface="Calibri" charset="0"/>
                         <a:cs typeface="Calibri" charset="0"/>
@@ -23173,7 +23173,7 @@
                         <a:buNone/>
                       </a:pPr>
                       <a:r>
-                        <a:rPr lang="en-US" sz="1200" dirty="0">
+                        <a:rPr lang="en-US" sz="1050" dirty="0">
                           <a:solidFill>
                             <a:srgbClr val="1C2833"/>
                           </a:solidFill>
@@ -23181,9 +23181,9 @@
                           <a:ea typeface="Calibri" pitchFamily="34" charset="-122"/>
                           <a:cs typeface="Calibri" pitchFamily="34" charset="-120"/>
                         </a:rPr>
-                        <a:t>-0.34</a:t>
+                        <a:t>-0.13</a:t>
                       </a:r>
-                      <a:endParaRPr lang="en-US" sz="1200" dirty="0">
+                      <a:endParaRPr lang="en-US" sz="1050" dirty="0">
                         <a:latin typeface="Calibri" charset="0"/>
                         <a:ea typeface="Calibri" charset="0"/>
                         <a:cs typeface="Calibri" charset="0"/>
@@ -23241,7 +23241,7 @@
                         <a:buNone/>
                       </a:pPr>
                       <a:r>
-                        <a:rPr lang="en-US" sz="1200" dirty="0">
+                        <a:rPr lang="en-US" sz="1050" dirty="0">
                           <a:solidFill>
                             <a:srgbClr val="1C2833"/>
                           </a:solidFill>
@@ -23249,9 +23249,9 @@
                           <a:ea typeface="Calibri" pitchFamily="34" charset="-122"/>
                           <a:cs typeface="Calibri" pitchFamily="34" charset="-120"/>
                         </a:rPr>
-                        <a:t>-0.48</a:t>
+                        <a:t>-0.10</a:t>
                       </a:r>
-                      <a:endParaRPr lang="en-US" sz="1200" dirty="0">
+                      <a:endParaRPr lang="en-US" sz="1050" dirty="0">
                         <a:latin typeface="Calibri" charset="0"/>
                         <a:ea typeface="Calibri" charset="0"/>
                         <a:cs typeface="Calibri" charset="0"/>
@@ -23309,7 +23309,7 @@
                         <a:buNone/>
                       </a:pPr>
                       <a:r>
-                        <a:rPr lang="en-US" sz="1200" dirty="0">
+                        <a:rPr lang="en-US" sz="1050" dirty="0">
                           <a:solidFill>
                             <a:srgbClr val="1C2833"/>
                           </a:solidFill>
@@ -23317,9 +23317,9 @@
                           <a:ea typeface="Calibri" pitchFamily="34" charset="-122"/>
                           <a:cs typeface="Calibri" pitchFamily="34" charset="-120"/>
                         </a:rPr>
-                        <a:t>-0.38</a:t>
+                        <a:t>-0.19</a:t>
                       </a:r>
-                      <a:endParaRPr lang="en-US" sz="1200" dirty="0">
+                      <a:endParaRPr lang="en-US" sz="1050" dirty="0">
                         <a:latin typeface="Calibri" charset="0"/>
                         <a:ea typeface="Calibri" charset="0"/>
                         <a:cs typeface="Calibri" charset="0"/>
@@ -23377,7 +23377,349 @@
                         <a:buNone/>
                       </a:pPr>
                       <a:r>
-                        <a:rPr lang="en-US" sz="1200" dirty="0">
+                        <a:rPr lang="en-US" sz="1050" dirty="0">
+                          <a:solidFill>
+                            <a:srgbClr val="1C2833"/>
+                          </a:solidFill>
+                          <a:latin typeface="Calibri" pitchFamily="34" charset="0"/>
+                          <a:ea typeface="Calibri" pitchFamily="34" charset="-122"/>
+                          <a:cs typeface="Calibri" pitchFamily="34" charset="-120"/>
+                        </a:rPr>
+                        <a:t>-0.70</a:t>
+                      </a:r>
+                      <a:endParaRPr lang="en-US" sz="1050" dirty="0">
+                        <a:latin typeface="Calibri" charset="0"/>
+                        <a:ea typeface="Calibri" charset="0"/>
+                        <a:cs typeface="Calibri" charset="0"/>
+                      </a:endParaRPr>
+                    </a:p>
+                  </a:txBody>
+                  <a:tcPr marL="45720" marR="45720" marT="45720" marB="45720">
+                    <a:lnL w="6350" cap="flat" cmpd="sng" algn="ctr">
+                      <a:solidFill>
+                        <a:srgbClr val="D5D8DC"/>
+                      </a:solidFill>
+                      <a:prstDash val="solid"/>
+                      <a:round/>
+                      <a:headEnd type="none" w="med" len="med"/>
+                      <a:tailEnd type="none" w="med" len="med"/>
+                    </a:lnL>
+                    <a:lnR w="6350" cap="flat" cmpd="sng" algn="ctr">
+                      <a:solidFill>
+                        <a:srgbClr val="D5D8DC"/>
+                      </a:solidFill>
+                      <a:prstDash val="solid"/>
+                      <a:round/>
+                      <a:headEnd type="none" w="med" len="med"/>
+                      <a:tailEnd type="none" w="med" len="med"/>
+                    </a:lnR>
+                    <a:lnT w="6350" cap="flat" cmpd="sng" algn="ctr">
+                      <a:solidFill>
+                        <a:srgbClr val="D5D8DC"/>
+                      </a:solidFill>
+                      <a:prstDash val="solid"/>
+                      <a:round/>
+                      <a:headEnd type="none" w="med" len="med"/>
+                      <a:tailEnd type="none" w="med" len="med"/>
+                    </a:lnT>
+                    <a:lnB w="6350" cap="flat" cmpd="sng" algn="ctr">
+                      <a:solidFill>
+                        <a:srgbClr val="D5D8DC"/>
+                      </a:solidFill>
+                      <a:prstDash val="solid"/>
+                      <a:round/>
+                      <a:headEnd type="none" w="med" len="med"/>
+                      <a:tailEnd type="none" w="med" len="med"/>
+                    </a:lnB>
+                    <a:solidFill>
+                      <a:srgbClr val="F4F6F7"/>
+                    </a:solidFill>
+                  </a:tcPr>
+                </a:tc>
+              </a:tr>
+              <a:tr h="256032">
+                <a:tc>
+                  <a:txBody>
+                    <a:bodyPr/>
+                    <a:lstStyle/>
+                    <a:p>
+                      <a:pPr algn="l" indent="0" marL="0">
+                        <a:buNone/>
+                      </a:pPr>
+                      <a:r>
+                        <a:rPr lang="en-US" sz="1050" dirty="0">
+                          <a:solidFill>
+                            <a:srgbClr val="1C2833"/>
+                          </a:solidFill>
+                          <a:latin typeface="Calibri" pitchFamily="34" charset="0"/>
+                          <a:ea typeface="Calibri" pitchFamily="34" charset="-122"/>
+                          <a:cs typeface="Calibri" pitchFamily="34" charset="-120"/>
+                        </a:rPr>
+                        <a:t>ST share of households</a:t>
+                      </a:r>
+                      <a:endParaRPr lang="en-US" sz="1050" dirty="0">
+                        <a:latin typeface="Calibri" charset="0"/>
+                        <a:ea typeface="Calibri" charset="0"/>
+                        <a:cs typeface="Calibri" charset="0"/>
+                      </a:endParaRPr>
+                    </a:p>
+                  </a:txBody>
+                  <a:tcPr marL="45720" marR="45720" marT="45720" marB="45720">
+                    <a:lnL w="6350" cap="flat" cmpd="sng" algn="ctr">
+                      <a:solidFill>
+                        <a:srgbClr val="D5D8DC"/>
+                      </a:solidFill>
+                      <a:prstDash val="solid"/>
+                      <a:round/>
+                      <a:headEnd type="none" w="med" len="med"/>
+                      <a:tailEnd type="none" w="med" len="med"/>
+                    </a:lnL>
+                    <a:lnR w="6350" cap="flat" cmpd="sng" algn="ctr">
+                      <a:solidFill>
+                        <a:srgbClr val="D5D8DC"/>
+                      </a:solidFill>
+                      <a:prstDash val="solid"/>
+                      <a:round/>
+                      <a:headEnd type="none" w="med" len="med"/>
+                      <a:tailEnd type="none" w="med" len="med"/>
+                    </a:lnR>
+                    <a:lnT w="6350" cap="flat" cmpd="sng" algn="ctr">
+                      <a:solidFill>
+                        <a:srgbClr val="D5D8DC"/>
+                      </a:solidFill>
+                      <a:prstDash val="solid"/>
+                      <a:round/>
+                      <a:headEnd type="none" w="med" len="med"/>
+                      <a:tailEnd type="none" w="med" len="med"/>
+                    </a:lnT>
+                    <a:lnB w="6350" cap="flat" cmpd="sng" algn="ctr">
+                      <a:solidFill>
+                        <a:srgbClr val="D5D8DC"/>
+                      </a:solidFill>
+                      <a:prstDash val="solid"/>
+                      <a:round/>
+                      <a:headEnd type="none" w="med" len="med"/>
+                      <a:tailEnd type="none" w="med" len="med"/>
+                    </a:lnB>
+                    <a:solidFill>
+                      <a:srgbClr val="FFFFFF"/>
+                    </a:solidFill>
+                  </a:tcPr>
+                </a:tc>
+                <a:tc>
+                  <a:txBody>
+                    <a:bodyPr/>
+                    <a:lstStyle/>
+                    <a:p>
+                      <a:pPr algn="r" indent="0" marL="0">
+                        <a:buNone/>
+                      </a:pPr>
+                      <a:r>
+                        <a:rPr lang="en-US" sz="1050" dirty="0">
+                          <a:solidFill>
+                            <a:srgbClr val="1C2833"/>
+                          </a:solidFill>
+                          <a:latin typeface="Calibri" pitchFamily="34" charset="0"/>
+                          <a:ea typeface="Calibri" pitchFamily="34" charset="-122"/>
+                          <a:cs typeface="Calibri" pitchFamily="34" charset="-120"/>
+                        </a:rPr>
+                        <a:t>-0.27</a:t>
+                      </a:r>
+                      <a:endParaRPr lang="en-US" sz="1050" dirty="0">
+                        <a:latin typeface="Calibri" charset="0"/>
+                        <a:ea typeface="Calibri" charset="0"/>
+                        <a:cs typeface="Calibri" charset="0"/>
+                      </a:endParaRPr>
+                    </a:p>
+                  </a:txBody>
+                  <a:tcPr marL="45720" marR="45720" marT="45720" marB="45720">
+                    <a:lnL w="6350" cap="flat" cmpd="sng" algn="ctr">
+                      <a:solidFill>
+                        <a:srgbClr val="D5D8DC"/>
+                      </a:solidFill>
+                      <a:prstDash val="solid"/>
+                      <a:round/>
+                      <a:headEnd type="none" w="med" len="med"/>
+                      <a:tailEnd type="none" w="med" len="med"/>
+                    </a:lnL>
+                    <a:lnR w="6350" cap="flat" cmpd="sng" algn="ctr">
+                      <a:solidFill>
+                        <a:srgbClr val="D5D8DC"/>
+                      </a:solidFill>
+                      <a:prstDash val="solid"/>
+                      <a:round/>
+                      <a:headEnd type="none" w="med" len="med"/>
+                      <a:tailEnd type="none" w="med" len="med"/>
+                    </a:lnR>
+                    <a:lnT w="6350" cap="flat" cmpd="sng" algn="ctr">
+                      <a:solidFill>
+                        <a:srgbClr val="D5D8DC"/>
+                      </a:solidFill>
+                      <a:prstDash val="solid"/>
+                      <a:round/>
+                      <a:headEnd type="none" w="med" len="med"/>
+                      <a:tailEnd type="none" w="med" len="med"/>
+                    </a:lnT>
+                    <a:lnB w="6350" cap="flat" cmpd="sng" algn="ctr">
+                      <a:solidFill>
+                        <a:srgbClr val="D5D8DC"/>
+                      </a:solidFill>
+                      <a:prstDash val="solid"/>
+                      <a:round/>
+                      <a:headEnd type="none" w="med" len="med"/>
+                      <a:tailEnd type="none" w="med" len="med"/>
+                    </a:lnB>
+                    <a:solidFill>
+                      <a:srgbClr val="FFFFFF"/>
+                    </a:solidFill>
+                  </a:tcPr>
+                </a:tc>
+                <a:tc>
+                  <a:txBody>
+                    <a:bodyPr/>
+                    <a:lstStyle/>
+                    <a:p>
+                      <a:pPr algn="r" indent="0" marL="0">
+                        <a:buNone/>
+                      </a:pPr>
+                      <a:r>
+                        <a:rPr lang="en-US" sz="1050" dirty="0">
+                          <a:solidFill>
+                            <a:srgbClr val="1C2833"/>
+                          </a:solidFill>
+                          <a:latin typeface="Calibri" pitchFamily="34" charset="0"/>
+                          <a:ea typeface="Calibri" pitchFamily="34" charset="-122"/>
+                          <a:cs typeface="Calibri" pitchFamily="34" charset="-120"/>
+                        </a:rPr>
+                        <a:t>-0.45</a:t>
+                      </a:r>
+                      <a:endParaRPr lang="en-US" sz="1050" dirty="0">
+                        <a:latin typeface="Calibri" charset="0"/>
+                        <a:ea typeface="Calibri" charset="0"/>
+                        <a:cs typeface="Calibri" charset="0"/>
+                      </a:endParaRPr>
+                    </a:p>
+                  </a:txBody>
+                  <a:tcPr marL="45720" marR="45720" marT="45720" marB="45720">
+                    <a:lnL w="6350" cap="flat" cmpd="sng" algn="ctr">
+                      <a:solidFill>
+                        <a:srgbClr val="D5D8DC"/>
+                      </a:solidFill>
+                      <a:prstDash val="solid"/>
+                      <a:round/>
+                      <a:headEnd type="none" w="med" len="med"/>
+                      <a:tailEnd type="none" w="med" len="med"/>
+                    </a:lnL>
+                    <a:lnR w="6350" cap="flat" cmpd="sng" algn="ctr">
+                      <a:solidFill>
+                        <a:srgbClr val="D5D8DC"/>
+                      </a:solidFill>
+                      <a:prstDash val="solid"/>
+                      <a:round/>
+                      <a:headEnd type="none" w="med" len="med"/>
+                      <a:tailEnd type="none" w="med" len="med"/>
+                    </a:lnR>
+                    <a:lnT w="6350" cap="flat" cmpd="sng" algn="ctr">
+                      <a:solidFill>
+                        <a:srgbClr val="D5D8DC"/>
+                      </a:solidFill>
+                      <a:prstDash val="solid"/>
+                      <a:round/>
+                      <a:headEnd type="none" w="med" len="med"/>
+                      <a:tailEnd type="none" w="med" len="med"/>
+                    </a:lnT>
+                    <a:lnB w="6350" cap="flat" cmpd="sng" algn="ctr">
+                      <a:solidFill>
+                        <a:srgbClr val="D5D8DC"/>
+                      </a:solidFill>
+                      <a:prstDash val="solid"/>
+                      <a:round/>
+                      <a:headEnd type="none" w="med" len="med"/>
+                      <a:tailEnd type="none" w="med" len="med"/>
+                    </a:lnB>
+                    <a:solidFill>
+                      <a:srgbClr val="FFFFFF"/>
+                    </a:solidFill>
+                  </a:tcPr>
+                </a:tc>
+                <a:tc>
+                  <a:txBody>
+                    <a:bodyPr/>
+                    <a:lstStyle/>
+                    <a:p>
+                      <a:pPr algn="r" indent="0" marL="0">
+                        <a:buNone/>
+                      </a:pPr>
+                      <a:r>
+                        <a:rPr lang="en-US" sz="1050" dirty="0">
+                          <a:solidFill>
+                            <a:srgbClr val="1C2833"/>
+                          </a:solidFill>
+                          <a:latin typeface="Calibri" pitchFamily="34" charset="0"/>
+                          <a:ea typeface="Calibri" pitchFamily="34" charset="-122"/>
+                          <a:cs typeface="Calibri" pitchFamily="34" charset="-120"/>
+                        </a:rPr>
+                        <a:t>-0.28</a:t>
+                      </a:r>
+                      <a:endParaRPr lang="en-US" sz="1050" dirty="0">
+                        <a:latin typeface="Calibri" charset="0"/>
+                        <a:ea typeface="Calibri" charset="0"/>
+                        <a:cs typeface="Calibri" charset="0"/>
+                      </a:endParaRPr>
+                    </a:p>
+                  </a:txBody>
+                  <a:tcPr marL="45720" marR="45720" marT="45720" marB="45720">
+                    <a:lnL w="6350" cap="flat" cmpd="sng" algn="ctr">
+                      <a:solidFill>
+                        <a:srgbClr val="D5D8DC"/>
+                      </a:solidFill>
+                      <a:prstDash val="solid"/>
+                      <a:round/>
+                      <a:headEnd type="none" w="med" len="med"/>
+                      <a:tailEnd type="none" w="med" len="med"/>
+                    </a:lnL>
+                    <a:lnR w="6350" cap="flat" cmpd="sng" algn="ctr">
+                      <a:solidFill>
+                        <a:srgbClr val="D5D8DC"/>
+                      </a:solidFill>
+                      <a:prstDash val="solid"/>
+                      <a:round/>
+                      <a:headEnd type="none" w="med" len="med"/>
+                      <a:tailEnd type="none" w="med" len="med"/>
+                    </a:lnR>
+                    <a:lnT w="6350" cap="flat" cmpd="sng" algn="ctr">
+                      <a:solidFill>
+                        <a:srgbClr val="D5D8DC"/>
+                      </a:solidFill>
+                      <a:prstDash val="solid"/>
+                      <a:round/>
+                      <a:headEnd type="none" w="med" len="med"/>
+                      <a:tailEnd type="none" w="med" len="med"/>
+                    </a:lnT>
+                    <a:lnB w="6350" cap="flat" cmpd="sng" algn="ctr">
+                      <a:solidFill>
+                        <a:srgbClr val="D5D8DC"/>
+                      </a:solidFill>
+                      <a:prstDash val="solid"/>
+                      <a:round/>
+                      <a:headEnd type="none" w="med" len="med"/>
+                      <a:tailEnd type="none" w="med" len="med"/>
+                    </a:lnB>
+                    <a:solidFill>
+                      <a:srgbClr val="FFFFFF"/>
+                    </a:solidFill>
+                  </a:tcPr>
+                </a:tc>
+                <a:tc>
+                  <a:txBody>
+                    <a:bodyPr/>
+                    <a:lstStyle/>
+                    <a:p>
+                      <a:pPr algn="r" indent="0" marL="0">
+                        <a:buNone/>
+                      </a:pPr>
+                      <a:r>
+                        <a:rPr lang="en-US" sz="1050" dirty="0">
                           <a:solidFill>
                             <a:srgbClr val="1C2833"/>
                           </a:solidFill>
@@ -23387,7 +23729,349 @@
                         </a:rPr>
                         <a:t>0.27</a:t>
                       </a:r>
-                      <a:endParaRPr lang="en-US" sz="1200" dirty="0">
+                      <a:endParaRPr lang="en-US" sz="1050" dirty="0">
+                        <a:latin typeface="Calibri" charset="0"/>
+                        <a:ea typeface="Calibri" charset="0"/>
+                        <a:cs typeface="Calibri" charset="0"/>
+                      </a:endParaRPr>
+                    </a:p>
+                  </a:txBody>
+                  <a:tcPr marL="45720" marR="45720" marT="45720" marB="45720">
+                    <a:lnL w="6350" cap="flat" cmpd="sng" algn="ctr">
+                      <a:solidFill>
+                        <a:srgbClr val="D5D8DC"/>
+                      </a:solidFill>
+                      <a:prstDash val="solid"/>
+                      <a:round/>
+                      <a:headEnd type="none" w="med" len="med"/>
+                      <a:tailEnd type="none" w="med" len="med"/>
+                    </a:lnL>
+                    <a:lnR w="6350" cap="flat" cmpd="sng" algn="ctr">
+                      <a:solidFill>
+                        <a:srgbClr val="D5D8DC"/>
+                      </a:solidFill>
+                      <a:prstDash val="solid"/>
+                      <a:round/>
+                      <a:headEnd type="none" w="med" len="med"/>
+                      <a:tailEnd type="none" w="med" len="med"/>
+                    </a:lnR>
+                    <a:lnT w="6350" cap="flat" cmpd="sng" algn="ctr">
+                      <a:solidFill>
+                        <a:srgbClr val="D5D8DC"/>
+                      </a:solidFill>
+                      <a:prstDash val="solid"/>
+                      <a:round/>
+                      <a:headEnd type="none" w="med" len="med"/>
+                      <a:tailEnd type="none" w="med" len="med"/>
+                    </a:lnT>
+                    <a:lnB w="6350" cap="flat" cmpd="sng" algn="ctr">
+                      <a:solidFill>
+                        <a:srgbClr val="D5D8DC"/>
+                      </a:solidFill>
+                      <a:prstDash val="solid"/>
+                      <a:round/>
+                      <a:headEnd type="none" w="med" len="med"/>
+                      <a:tailEnd type="none" w="med" len="med"/>
+                    </a:lnB>
+                    <a:solidFill>
+                      <a:srgbClr val="FFFFFF"/>
+                    </a:solidFill>
+                  </a:tcPr>
+                </a:tc>
+              </a:tr>
+              <a:tr h="256032">
+                <a:tc>
+                  <a:txBody>
+                    <a:bodyPr/>
+                    <a:lstStyle/>
+                    <a:p>
+                      <a:pPr algn="l" indent="0" marL="0">
+                        <a:buNone/>
+                      </a:pPr>
+                      <a:r>
+                        <a:rPr lang="en-US" sz="1050" dirty="0">
+                          <a:solidFill>
+                            <a:srgbClr val="1C2833"/>
+                          </a:solidFill>
+                          <a:latin typeface="Calibri" pitchFamily="34" charset="0"/>
+                          <a:ea typeface="Calibri" pitchFamily="34" charset="-122"/>
+                          <a:cs typeface="Calibri" pitchFamily="34" charset="-120"/>
+                        </a:rPr>
+                        <a:t>Sex ratio</a:t>
+                      </a:r>
+                      <a:endParaRPr lang="en-US" sz="1050" dirty="0">
+                        <a:latin typeface="Calibri" charset="0"/>
+                        <a:ea typeface="Calibri" charset="0"/>
+                        <a:cs typeface="Calibri" charset="0"/>
+                      </a:endParaRPr>
+                    </a:p>
+                  </a:txBody>
+                  <a:tcPr marL="45720" marR="45720" marT="45720" marB="45720">
+                    <a:lnL w="6350" cap="flat" cmpd="sng" algn="ctr">
+                      <a:solidFill>
+                        <a:srgbClr val="D5D8DC"/>
+                      </a:solidFill>
+                      <a:prstDash val="solid"/>
+                      <a:round/>
+                      <a:headEnd type="none" w="med" len="med"/>
+                      <a:tailEnd type="none" w="med" len="med"/>
+                    </a:lnL>
+                    <a:lnR w="6350" cap="flat" cmpd="sng" algn="ctr">
+                      <a:solidFill>
+                        <a:srgbClr val="D5D8DC"/>
+                      </a:solidFill>
+                      <a:prstDash val="solid"/>
+                      <a:round/>
+                      <a:headEnd type="none" w="med" len="med"/>
+                      <a:tailEnd type="none" w="med" len="med"/>
+                    </a:lnR>
+                    <a:lnT w="6350" cap="flat" cmpd="sng" algn="ctr">
+                      <a:solidFill>
+                        <a:srgbClr val="D5D8DC"/>
+                      </a:solidFill>
+                      <a:prstDash val="solid"/>
+                      <a:round/>
+                      <a:headEnd type="none" w="med" len="med"/>
+                      <a:tailEnd type="none" w="med" len="med"/>
+                    </a:lnT>
+                    <a:lnB w="6350" cap="flat" cmpd="sng" algn="ctr">
+                      <a:solidFill>
+                        <a:srgbClr val="D5D8DC"/>
+                      </a:solidFill>
+                      <a:prstDash val="solid"/>
+                      <a:round/>
+                      <a:headEnd type="none" w="med" len="med"/>
+                      <a:tailEnd type="none" w="med" len="med"/>
+                    </a:lnB>
+                    <a:solidFill>
+                      <a:srgbClr val="F4F6F7"/>
+                    </a:solidFill>
+                  </a:tcPr>
+                </a:tc>
+                <a:tc>
+                  <a:txBody>
+                    <a:bodyPr/>
+                    <a:lstStyle/>
+                    <a:p>
+                      <a:pPr algn="r" indent="0" marL="0">
+                        <a:buNone/>
+                      </a:pPr>
+                      <a:r>
+                        <a:rPr lang="en-US" sz="1050" dirty="0">
+                          <a:solidFill>
+                            <a:srgbClr val="1C2833"/>
+                          </a:solidFill>
+                          <a:latin typeface="Calibri" pitchFamily="34" charset="0"/>
+                          <a:ea typeface="Calibri" pitchFamily="34" charset="-122"/>
+                          <a:cs typeface="Calibri" pitchFamily="34" charset="-120"/>
+                        </a:rPr>
+                        <a:t>-0.46</a:t>
+                      </a:r>
+                      <a:endParaRPr lang="en-US" sz="1050" dirty="0">
+                        <a:latin typeface="Calibri" charset="0"/>
+                        <a:ea typeface="Calibri" charset="0"/>
+                        <a:cs typeface="Calibri" charset="0"/>
+                      </a:endParaRPr>
+                    </a:p>
+                  </a:txBody>
+                  <a:tcPr marL="45720" marR="45720" marT="45720" marB="45720">
+                    <a:lnL w="6350" cap="flat" cmpd="sng" algn="ctr">
+                      <a:solidFill>
+                        <a:srgbClr val="D5D8DC"/>
+                      </a:solidFill>
+                      <a:prstDash val="solid"/>
+                      <a:round/>
+                      <a:headEnd type="none" w="med" len="med"/>
+                      <a:tailEnd type="none" w="med" len="med"/>
+                    </a:lnL>
+                    <a:lnR w="6350" cap="flat" cmpd="sng" algn="ctr">
+                      <a:solidFill>
+                        <a:srgbClr val="D5D8DC"/>
+                      </a:solidFill>
+                      <a:prstDash val="solid"/>
+                      <a:round/>
+                      <a:headEnd type="none" w="med" len="med"/>
+                      <a:tailEnd type="none" w="med" len="med"/>
+                    </a:lnR>
+                    <a:lnT w="6350" cap="flat" cmpd="sng" algn="ctr">
+                      <a:solidFill>
+                        <a:srgbClr val="D5D8DC"/>
+                      </a:solidFill>
+                      <a:prstDash val="solid"/>
+                      <a:round/>
+                      <a:headEnd type="none" w="med" len="med"/>
+                      <a:tailEnd type="none" w="med" len="med"/>
+                    </a:lnT>
+                    <a:lnB w="6350" cap="flat" cmpd="sng" algn="ctr">
+                      <a:solidFill>
+                        <a:srgbClr val="D5D8DC"/>
+                      </a:solidFill>
+                      <a:prstDash val="solid"/>
+                      <a:round/>
+                      <a:headEnd type="none" w="med" len="med"/>
+                      <a:tailEnd type="none" w="med" len="med"/>
+                    </a:lnB>
+                    <a:solidFill>
+                      <a:srgbClr val="F4F6F7"/>
+                    </a:solidFill>
+                  </a:tcPr>
+                </a:tc>
+                <a:tc>
+                  <a:txBody>
+                    <a:bodyPr/>
+                    <a:lstStyle/>
+                    <a:p>
+                      <a:pPr algn="r" indent="0" marL="0">
+                        <a:buNone/>
+                      </a:pPr>
+                      <a:r>
+                        <a:rPr lang="en-US" sz="1050" dirty="0">
+                          <a:solidFill>
+                            <a:srgbClr val="1C2833"/>
+                          </a:solidFill>
+                          <a:latin typeface="Calibri" pitchFamily="34" charset="0"/>
+                          <a:ea typeface="Calibri" pitchFamily="34" charset="-122"/>
+                          <a:cs typeface="Calibri" pitchFamily="34" charset="-120"/>
+                        </a:rPr>
+                        <a:t>-0.36</a:t>
+                      </a:r>
+                      <a:endParaRPr lang="en-US" sz="1050" dirty="0">
+                        <a:latin typeface="Calibri" charset="0"/>
+                        <a:ea typeface="Calibri" charset="0"/>
+                        <a:cs typeface="Calibri" charset="0"/>
+                      </a:endParaRPr>
+                    </a:p>
+                  </a:txBody>
+                  <a:tcPr marL="45720" marR="45720" marT="45720" marB="45720">
+                    <a:lnL w="6350" cap="flat" cmpd="sng" algn="ctr">
+                      <a:solidFill>
+                        <a:srgbClr val="D5D8DC"/>
+                      </a:solidFill>
+                      <a:prstDash val="solid"/>
+                      <a:round/>
+                      <a:headEnd type="none" w="med" len="med"/>
+                      <a:tailEnd type="none" w="med" len="med"/>
+                    </a:lnL>
+                    <a:lnR w="6350" cap="flat" cmpd="sng" algn="ctr">
+                      <a:solidFill>
+                        <a:srgbClr val="D5D8DC"/>
+                      </a:solidFill>
+                      <a:prstDash val="solid"/>
+                      <a:round/>
+                      <a:headEnd type="none" w="med" len="med"/>
+                      <a:tailEnd type="none" w="med" len="med"/>
+                    </a:lnR>
+                    <a:lnT w="6350" cap="flat" cmpd="sng" algn="ctr">
+                      <a:solidFill>
+                        <a:srgbClr val="D5D8DC"/>
+                      </a:solidFill>
+                      <a:prstDash val="solid"/>
+                      <a:round/>
+                      <a:headEnd type="none" w="med" len="med"/>
+                      <a:tailEnd type="none" w="med" len="med"/>
+                    </a:lnT>
+                    <a:lnB w="6350" cap="flat" cmpd="sng" algn="ctr">
+                      <a:solidFill>
+                        <a:srgbClr val="D5D8DC"/>
+                      </a:solidFill>
+                      <a:prstDash val="solid"/>
+                      <a:round/>
+                      <a:headEnd type="none" w="med" len="med"/>
+                      <a:tailEnd type="none" w="med" len="med"/>
+                    </a:lnB>
+                    <a:solidFill>
+                      <a:srgbClr val="F4F6F7"/>
+                    </a:solidFill>
+                  </a:tcPr>
+                </a:tc>
+                <a:tc>
+                  <a:txBody>
+                    <a:bodyPr/>
+                    <a:lstStyle/>
+                    <a:p>
+                      <a:pPr algn="r" indent="0" marL="0">
+                        <a:buNone/>
+                      </a:pPr>
+                      <a:r>
+                        <a:rPr lang="en-US" sz="1050" dirty="0">
+                          <a:solidFill>
+                            <a:srgbClr val="1C2833"/>
+                          </a:solidFill>
+                          <a:latin typeface="Calibri" pitchFamily="34" charset="0"/>
+                          <a:ea typeface="Calibri" pitchFamily="34" charset="-122"/>
+                          <a:cs typeface="Calibri" pitchFamily="34" charset="-120"/>
+                        </a:rPr>
+                        <a:t>-0.47</a:t>
+                      </a:r>
+                      <a:endParaRPr lang="en-US" sz="1050" dirty="0">
+                        <a:latin typeface="Calibri" charset="0"/>
+                        <a:ea typeface="Calibri" charset="0"/>
+                        <a:cs typeface="Calibri" charset="0"/>
+                      </a:endParaRPr>
+                    </a:p>
+                  </a:txBody>
+                  <a:tcPr marL="45720" marR="45720" marT="45720" marB="45720">
+                    <a:lnL w="6350" cap="flat" cmpd="sng" algn="ctr">
+                      <a:solidFill>
+                        <a:srgbClr val="D5D8DC"/>
+                      </a:solidFill>
+                      <a:prstDash val="solid"/>
+                      <a:round/>
+                      <a:headEnd type="none" w="med" len="med"/>
+                      <a:tailEnd type="none" w="med" len="med"/>
+                    </a:lnL>
+                    <a:lnR w="6350" cap="flat" cmpd="sng" algn="ctr">
+                      <a:solidFill>
+                        <a:srgbClr val="D5D8DC"/>
+                      </a:solidFill>
+                      <a:prstDash val="solid"/>
+                      <a:round/>
+                      <a:headEnd type="none" w="med" len="med"/>
+                      <a:tailEnd type="none" w="med" len="med"/>
+                    </a:lnR>
+                    <a:lnT w="6350" cap="flat" cmpd="sng" algn="ctr">
+                      <a:solidFill>
+                        <a:srgbClr val="D5D8DC"/>
+                      </a:solidFill>
+                      <a:prstDash val="solid"/>
+                      <a:round/>
+                      <a:headEnd type="none" w="med" len="med"/>
+                      <a:tailEnd type="none" w="med" len="med"/>
+                    </a:lnT>
+                    <a:lnB w="6350" cap="flat" cmpd="sng" algn="ctr">
+                      <a:solidFill>
+                        <a:srgbClr val="D5D8DC"/>
+                      </a:solidFill>
+                      <a:prstDash val="solid"/>
+                      <a:round/>
+                      <a:headEnd type="none" w="med" len="med"/>
+                      <a:tailEnd type="none" w="med" len="med"/>
+                    </a:lnB>
+                    <a:solidFill>
+                      <a:srgbClr val="F4F6F7"/>
+                    </a:solidFill>
+                  </a:tcPr>
+                </a:tc>
+                <a:tc>
+                  <a:txBody>
+                    <a:bodyPr/>
+                    <a:lstStyle/>
+                    <a:p>
+                      <a:pPr algn="r" indent="0" marL="0">
+                        <a:buNone/>
+                      </a:pPr>
+                      <a:r>
+                        <a:rPr lang="en-US" sz="1050" dirty="0">
+                          <a:solidFill>
+                            <a:srgbClr val="1C2833"/>
+                          </a:solidFill>
+                          <a:latin typeface="Calibri" pitchFamily="34" charset="0"/>
+                          <a:ea typeface="Calibri" pitchFamily="34" charset="-122"/>
+                          <a:cs typeface="Calibri" pitchFamily="34" charset="-120"/>
+                        </a:rPr>
+                        <a:t>0.28</a:t>
+                      </a:r>
+                      <a:endParaRPr lang="en-US" sz="1050" dirty="0">
                         <a:latin typeface="Calibri" charset="0"/>
                         <a:ea typeface="Calibri" charset="0"/>
                         <a:cs typeface="Calibri" charset="0"/>
@@ -23480,7 +24164,7 @@
                 <a:ea typeface="Calibri" pitchFamily="34" charset="-122"/>
                 <a:cs typeface="Calibri" pitchFamily="34" charset="-120"/>
               </a:rPr>
-              <a:t>In phase 3 income, urban share, migration and the Muslim share rise together, because the large destination states are revised alongside the North-East. 15 states cannot separate them.</a:t>
+              <a:t>In phase 3 income, migration and the Muslim share rise together, because the big states that draw migrants were revised with the North-East. 15 states cannot tell them apart.</a:t>
             </a:r>
             <a:endParaRPr lang="en-US" sz="1250" dirty="0"/>
           </a:p>
@@ -23501,7 +24185,28 @@
                 <a:ea typeface="Calibri" pitchFamily="34" charset="-122"/>
                 <a:cs typeface="Calibri" pitchFamily="34" charset="-120"/>
               </a:rPr>
-              <a:t>Muslim share: 0.12 across all states, -0.34 in phase 2. No consistent relationship.</a:t>
+              <a:t>The same way in both phases: st share of households (-0.45, -0.28) and sex ratio (-0.36, -0.47).</a:t>
+            </a:r>
+            <a:endParaRPr lang="en-US" sz="1250" dirty="0"/>
+          </a:p>
+          <a:p>
+            <a:pPr marL="342900" indent="-342900">
+              <a:spcAft>
+                <a:spcPts val="800"/>
+              </a:spcAft>
+              <a:buSzPct val="100000"/>
+              <a:buChar char="•"/>
+            </a:pPr>
+            <a:r>
+              <a:rPr lang="en-US" sz="1250" dirty="0">
+                <a:solidFill>
+                  <a:srgbClr val="1C2833"/>
+                </a:solidFill>
+                <a:latin typeface="Calibri" pitchFamily="34" charset="0"/>
+                <a:ea typeface="Calibri" pitchFamily="34" charset="-122"/>
+                <a:cs typeface="Calibri" pitchFamily="34" charset="-120"/>
+              </a:rPr>
+              <a:t>Muslim share of households: 0.08 across all states, -0.27 in phase 2, 0.45 in phase 3. No consistent relationship.</a:t>
             </a:r>
             <a:endParaRPr lang="en-US" sz="1250" dirty="0"/>
           </a:p>

</xml_diff>

<commit_message>
Tamil Nadu pages (Tamil dictionary still to come); West Bengal primary figures
Adds the Tamil Nadu analysis: removals by district and constituency with the
reason recorded, the final roll, and the 2026 result, built from the CEO's
and the Election Commission's own tables by scripts/build_tamilnadu.py and
checked by check_data.py. Pages: overview, elections, FAQ, method.

The translation collector and checks now take the analysis folders from
site/places.json, so a new place is collected without editing them.

The West Bengal rows of the All India tables now use the CEO's press note
PN-05-2026, to the elector, for the reasons and for removals by sex.
Reports and decks rebuilt.

Not for merge until assets/i18n/ta.js covers the new keys.

Co-Authored-By: Claude Opus 5.5 <noreply@anthropic.com>
Claude-Session: https://claude.ai/code/session_01FWx24PCx3Jw4SUDQC6oU7o
</commit_message>
<xml_diff>
--- a/reports/sir-india-deck.pptx
+++ b/reports/sir-india-deck.pptx
@@ -2293,7 +2293,7 @@
                   <c:v>55.28</c:v>
                 </c:pt>
                 <c:pt idx="5">
-                  <c:v>56.11</c:v>
+                  <c:v>56.1</c:v>
                 </c:pt>
                 <c:pt idx="6">
                   <c:v>64.93</c:v>
@@ -2520,7 +2520,7 @@
                   <c:v>10.69</c:v>
                 </c:pt>
                 <c:pt idx="5">
-                  <c:v>2.37</c:v>
+                  <c:v>2.38</c:v>
                 </c:pt>
                 <c:pt idx="6">
                   <c:v>6.35</c:v>
@@ -2870,7 +2870,7 @@
                   <c:v>51.67</c:v>
                 </c:pt>
                 <c:pt idx="5">
-                  <c:v>49.24</c:v>
+                  <c:v>49.23</c:v>
                 </c:pt>
                 <c:pt idx="6">
                   <c:v>48.59</c:v>
@@ -2995,7 +2995,7 @@
                   <c:v>55.32</c:v>
                 </c:pt>
                 <c:pt idx="5">
-                  <c:v>53.61</c:v>
+                  <c:v>53.53</c:v>
                 </c:pt>
                 <c:pt idx="6">
                   <c:v>55.33</c:v>
@@ -13221,17 +13221,6 @@
                       <a:pPr algn="l" indent="0" marL="0">
                         <a:buNone/>
                       </a:pPr>
-                      <a:r>
-                        <a:rPr lang="en-US" sz="1100" dirty="0">
-                          <a:solidFill>
-                            <a:srgbClr val="1C2833"/>
-                          </a:solidFill>
-                          <a:latin typeface="Calibri" pitchFamily="34" charset="0"/>
-                          <a:ea typeface="Calibri" pitchFamily="34" charset="-122"/>
-                          <a:cs typeface="Calibri" pitchFamily="34" charset="-120"/>
-                        </a:rPr>
-                        <a:t>rounded</a:t>
-                      </a:r>
                       <a:endParaRPr lang="en-US" sz="1100" dirty="0">
                         <a:latin typeface="Calibri" charset="0"/>
                         <a:ea typeface="Calibri" charset="0"/>
@@ -39105,7 +39094,7 @@
                 <a:ea typeface="Calibri" pitchFamily="34" charset="-122"/>
                 <a:cs typeface="Calibri" pitchFamily="34" charset="-120"/>
               </a:rPr>
-              <a:t>The All India figures are each state's Chief Electoral Officer's figures at the draft roll. Press notes were read directly for Lakshadweep, Meghalaya, Arunachal Pradesh, Manipur and Nagaland, and the rest are as reported in the press, each linked on the method page and in the downloadable table.</a:t>
+              <a:t>The All India figures are each state's Chief Electoral Officer's figures at the draft roll. Press notes were read directly for Tamil Nadu, West Bengal, Lakshadweep, Meghalaya, Arunachal Pradesh, Manipur and Nagaland, and the rest are as reported in the press, each linked on the method page and in the downloadable table.</a:t>
             </a:r>
             <a:endParaRPr lang="en-US" sz="1500" dirty="0"/>
           </a:p>

</xml_diff>

<commit_message>
Rebuild the reports and slide decks from the current data
Co-Authored-By: Claude Opus 5.5 <noreply@anthropic.com>
Claude-Session: https://claude.ai/code/session_01FWx24PCx3Jw4SUDQC6oU7o
</commit_message>
<xml_diff>
--- a/reports/sir-india-deck.pptx
+++ b/reports/sir-india-deck.pptx
@@ -993,7 +993,7 @@
                   <c:v>0</c:v>
                 </c:pt>
                 <c:pt idx="1">
-                  <c:v>0.3</c:v>
+                  <c:v>0.4</c:v>
                 </c:pt>
                 <c:pt idx="2">
                   <c:v>12.1</c:v>
@@ -1676,7 +1676,7 @@
                   <c:v>7.6</c:v>
                 </c:pt>
                 <c:pt idx="6">
-                  <c:v>7.65</c:v>
+                  <c:v>7.66</c:v>
                 </c:pt>
                 <c:pt idx="7">
                   <c:v>7.68</c:v>
@@ -3350,7 +3350,7 @@
                   <c:v>7.45</c:v>
                 </c:pt>
                 <c:pt idx="14">
-                  <c:v>7.65</c:v>
+                  <c:v>7.66</c:v>
                 </c:pt>
                 <c:pt idx="15">
                   <c:v>6.03</c:v>
@@ -3529,7 +3529,7 @@
                   <c:v>5.97</c:v>
                 </c:pt>
                 <c:pt idx="14">
-                  <c:v>5.73</c:v>
+                  <c:v>5.74</c:v>
                 </c:pt>
                 <c:pt idx="15">
                   <c:v>5.29</c:v>
@@ -15609,7 +15609,7 @@
                           <a:ea typeface="Calibri" pitchFamily="34" charset="-122"/>
                           <a:cs typeface="Calibri" pitchFamily="34" charset="-120"/>
                         </a:rPr>
-                        <a:t>41,79,000</a:t>
+                        <a:t>41,84,891</a:t>
                       </a:r>
                       <a:endParaRPr lang="en-US" sz="1100" dirty="0">
                         <a:latin typeface="Calibri" charset="0"/>
@@ -39094,7 +39094,7 @@
                 <a:ea typeface="Calibri" pitchFamily="34" charset="-122"/>
                 <a:cs typeface="Calibri" pitchFamily="34" charset="-120"/>
               </a:rPr>
-              <a:t>The All India figures are each state's Chief Electoral Officer's figures at the draft roll. Press notes were read directly for Tamil Nadu, West Bengal, Lakshadweep, Meghalaya, Arunachal Pradesh, Manipur and Nagaland, and the rest are as reported in the press, each linked on the method page and in the downloadable table.</a:t>
+              <a:t>The All India figures are each state's Chief Electoral Officer's figures at the draft roll. Press notes were read directly for Tamil Nadu, West Bengal, Rajasthan, Lakshadweep, Karnataka, Meghalaya, Arunachal Pradesh, Manipur and Nagaland, and the rest are as reported in the press, each linked on the method page and in the downloadable table.</a:t>
             </a:r>
             <a:endParaRPr lang="en-US" sz="1500" dirty="0"/>
           </a:p>

</xml_diff>

<commit_message>
Rebuild the reports and slide decks from the current data (#61)
This rebuilds the three reports and decks with
`scripts/reports/build.sh`: All India, Bihar and Hyderabad, each as a
PDF, a web page and a PowerPoint. The figures follow the current data.
The only visible change is the All India phase figure, which now uses
the Rajasthan and Karnataka state rows taken from their CEO press notes.
Bihar and Hyderabad are unchanged apart from regeneration. After the
build I re-ran `stamp.py`, `build_site --check` and `check_data`, and
all pass.

🤖 Generated with [Claude Code](https://claude.com/claude-code)

https://claude.ai/code/session_01FWx24PCx3Jw4SUDQC6oU7o

---
_Generated by [Claude
Code](https://claude.ai/code/session_01FWx24PCx3Jw4SUDQC6oU7o)_

Co-authored-by: Claude <noreply@anthropic.com>
</commit_message>
<xml_diff>
--- a/reports/sir-india-deck.pptx
+++ b/reports/sir-india-deck.pptx
@@ -993,7 +993,7 @@
                   <c:v>0</c:v>
                 </c:pt>
                 <c:pt idx="1">
-                  <c:v>0.3</c:v>
+                  <c:v>0.4</c:v>
                 </c:pt>
                 <c:pt idx="2">
                   <c:v>12.1</c:v>
@@ -1676,7 +1676,7 @@
                   <c:v>7.6</c:v>
                 </c:pt>
                 <c:pt idx="6">
-                  <c:v>7.65</c:v>
+                  <c:v>7.66</c:v>
                 </c:pt>
                 <c:pt idx="7">
                   <c:v>7.68</c:v>
@@ -3350,7 +3350,7 @@
                   <c:v>7.45</c:v>
                 </c:pt>
                 <c:pt idx="14">
-                  <c:v>7.65</c:v>
+                  <c:v>7.66</c:v>
                 </c:pt>
                 <c:pt idx="15">
                   <c:v>6.03</c:v>
@@ -3529,7 +3529,7 @@
                   <c:v>5.97</c:v>
                 </c:pt>
                 <c:pt idx="14">
-                  <c:v>5.73</c:v>
+                  <c:v>5.74</c:v>
                 </c:pt>
                 <c:pt idx="15">
                   <c:v>5.29</c:v>
@@ -15609,7 +15609,7 @@
                           <a:ea typeface="Calibri" pitchFamily="34" charset="-122"/>
                           <a:cs typeface="Calibri" pitchFamily="34" charset="-120"/>
                         </a:rPr>
-                        <a:t>41,79,000</a:t>
+                        <a:t>41,84,891</a:t>
                       </a:r>
                       <a:endParaRPr lang="en-US" sz="1100" dirty="0">
                         <a:latin typeface="Calibri" charset="0"/>
@@ -39094,7 +39094,7 @@
                 <a:ea typeface="Calibri" pitchFamily="34" charset="-122"/>
                 <a:cs typeface="Calibri" pitchFamily="34" charset="-120"/>
               </a:rPr>
-              <a:t>The All India figures are each state's Chief Electoral Officer's figures at the draft roll. Press notes were read directly for Tamil Nadu, West Bengal, Lakshadweep, Meghalaya, Arunachal Pradesh, Manipur and Nagaland, and the rest are as reported in the press, each linked on the method page and in the downloadable table.</a:t>
+              <a:t>The All India figures are each state's Chief Electoral Officer's figures at the draft roll. Press notes were read directly for Tamil Nadu, West Bengal, Rajasthan, Lakshadweep, Karnataka, Meghalaya, Arunachal Pradesh, Manipur and Nagaland, and the rest are as reported in the press, each linked on the method page and in the downloadable table.</a:t>
             </a:r>
             <a:endParaRPr lang="en-US" sz="1500" dirty="0"/>
           </a:p>

</xml_diff>